<commit_message>
SSLC r2: remove SSLC debts at face ($500K) from all outputs
Per John 10/10: SSLC debts NOT assumed by Exos at close.

Changes:
- Assumptions!B14 = 0 (was $500K)
- ① $4.36M → $3.86M | ② $5.36M → $4.86M
- ③ LOW/BASE/HIGH: $6.31M/$7.885M/$9.46M → $5.81M/$7.385M/$8.96M
- ④ hold to 2031: $12.0M/$15.8M/$19.4M → $11.5M/$15.3M/$18.9M
- Earn-out totals unchanged ($950K/$2,525K/$4,100K = ③ - ②)

Artifacts updated: xlsx model, r2 pptx deck, offer summary docx,
briefing email docx. Scripts updated in parallel (do NOT re-run model script).
</commit_message>
<xml_diff>
--- a/drafts/Exos_SSLC_Board_Offer_Overview_2026-10-10_r2.pptx
+++ b/drafts/Exos_SSLC_Board_Offer_Overview_2026-10-10_r2.pptx
@@ -863,7 +863,7 @@
           <a:p>
             <a:r>
               <a:rPr lang="en-US" dirty="0"/>
-              <a:t>All three scenarios (Low/Base/High) have identical at-close values: ① $4.36M, ② $5.36M with stock. The $4.36M breaks down as: $2.51M cash + $60K transaction costs + $790K stake credit (non-cash) + ~$500K SSLC debts at face + $500K WC bridge. The $1.0M EAI units are issued at financing close, not at board acceptance, and count toward the Rule 504 $10M rolling cap.</a:t>
+              <a:t>All three scenarios (Low/Base/High) have identical at-close values: ① $3.86M, ② $4.86M with stock. The $3.86M breaks down as: $2.51M cash + $60K transaction costs + $790K stake credit (non-cash) + $500K WC bridge. The $1.0M EAI units are issued at financing close, not at board acceptance, and count toward the Rule 504 $10M rolling cap.</a:t>
             </a:r>
             <a:endParaRPr lang="en-US" dirty="0"/>
           </a:p>
@@ -1039,7 +1039,7 @@
           <a:p>
             <a:r>
               <a:rPr lang="en-US" dirty="0"/>
-              <a:t>③ 5-yr total is ② ($5.36M) + earn-outs. Low = $6.31M / Base = $7.885M (shown as $7.9M) / High = $9.46M (shown as $9.5M). These are rounded for board presentation. ④ TOTAL IF STOCK HELD TO 2031: Low $12.0M / Base $15.8M / High $19.4M — this replaces and is not additive to ③. It assumes RTO completion, ~30% dilution, and management-projected valuations. Forward-looking statements subject to SEC Rule 10b-5. The chart shows the year-by-year compensation build from close through FY31.</a:t>
+              <a:t>③ 5-yr total is ② ($4.86M) + earn-outs. Low = $5.81M / Base = $7.385M (shown as $7.4M) / High = $8.96M (shown as $9.0M). These are rounded for board presentation. ④ TOTAL IF STOCK HELD TO 2031: Low $11.5M / Base $15.3M / High $18.9M — this replaces and is not additive to ③. It assumes RTO completion, ~30% dilution, and management-projected valuations. Forward-looking statements subject to SEC Rule 10b-5. The chart shows the year-by-year compensation build from close through FY31.</a:t>
             </a:r>
             <a:endParaRPr lang="en-US" dirty="0"/>
           </a:p>
@@ -4001,6 +4001,10 @@
           </a:solidFill>
           <a:ln/>
         </p:spPr>
+        <p:txBody>
+          <a:bodyPr/>
+          <a:p/>
+        </p:txBody>
       </p:sp>
       <p:sp>
         <p:nvSpPr>
@@ -4026,6 +4030,10 @@
             <a:prstDash val="solid"/>
           </a:ln>
         </p:spPr>
+        <p:txBody>
+          <a:bodyPr/>
+          <a:p/>
+        </p:txBody>
       </p:sp>
       <p:sp>
         <p:nvSpPr>
@@ -4123,6 +4131,10 @@
             <a:prstDash val="solid"/>
           </a:ln>
         </p:spPr>
+        <p:txBody>
+          <a:bodyPr/>
+          <a:p/>
+        </p:txBody>
       </p:sp>
       <p:sp>
         <p:nvSpPr>
@@ -4220,6 +4232,10 @@
             <a:prstDash val="solid"/>
           </a:ln>
         </p:spPr>
+        <p:txBody>
+          <a:bodyPr/>
+          <a:p/>
+        </p:txBody>
       </p:sp>
       <p:sp>
         <p:nvSpPr>
@@ -4317,77 +4333,9 @@
             <a:prstDash val="solid"/>
           </a:ln>
         </p:spPr>
-      </p:sp>
-      <p:sp>
-        <p:nvSpPr>
-          <p:cNvPr id="14" name="Text 12"/>
-          <p:cNvSpPr txBox="1"/>
-          <p:nvPr/>
-        </p:nvSpPr>
-        <p:spPr>
-          <a:xfrm>
-            <a:off x="1005840" y="2304288"/>
-            <a:ext cx="3657600" cy="347472"/>
-          </a:xfrm>
-          <a:prstGeom prst="rect">
-            <a:avLst/>
-          </a:prstGeom>
-          <a:noFill/>
-          <a:ln/>
-        </p:spPr>
-        <p:txBody>
-          <a:bodyPr wrap="square" rtlCol="0" anchor="ctr"/>
-          <a:lstStyle/>
-          <a:p>
-            <a:pPr indent="0" marL="0">
-              <a:buNone/>
-            </a:pPr>
-            <a:r>
-              <a:rPr lang="en-US" sz="1300" dirty="0">
-                <a:solidFill>
-                  <a:srgbClr val="CCCCCC"/>
-                </a:solidFill>
-              </a:rPr>
-              <a:t>SSLC debts paid at face</a:t>
-            </a:r>
-            <a:endParaRPr lang="en-US" sz="1300" dirty="0"/>
-          </a:p>
-        </p:txBody>
-      </p:sp>
-      <p:sp>
-        <p:nvSpPr>
-          <p:cNvPr id="15" name="Text 13"/>
-          <p:cNvSpPr txBox="1"/>
-          <p:nvPr/>
-        </p:nvSpPr>
-        <p:spPr>
-          <a:xfrm>
-            <a:off x="5486400" y="2304288"/>
-            <a:ext cx="1005840" cy="347472"/>
-          </a:xfrm>
-          <a:prstGeom prst="rect">
-            <a:avLst/>
-          </a:prstGeom>
-          <a:noFill/>
-          <a:ln/>
-        </p:spPr>
-        <p:txBody>
-          <a:bodyPr wrap="square" rtlCol="0" anchor="ctr"/>
-          <a:lstStyle/>
-          <a:p>
-            <a:pPr algn="r" indent="0" marL="0">
-              <a:buNone/>
-            </a:pPr>
-            <a:r>
-              <a:rPr lang="en-US" sz="1300" b="1" dirty="0">
-                <a:solidFill>
-                  <a:srgbClr val="FFFFFF"/>
-                </a:solidFill>
-              </a:rPr>
-              <a:t>~$500K</a:t>
-            </a:r>
-            <a:endParaRPr lang="en-US" sz="1300" dirty="0"/>
-          </a:p>
+        <p:txBody>
+          <a:bodyPr/>
+          <a:p/>
         </p:txBody>
       </p:sp>
       <p:sp>
@@ -4414,6 +4362,10 @@
             <a:prstDash val="solid"/>
           </a:ln>
         </p:spPr>
+        <p:txBody>
+          <a:bodyPr/>
+          <a:p/>
+        </p:txBody>
       </p:sp>
       <p:sp>
         <p:nvSpPr>
@@ -4511,6 +4463,10 @@
             <a:prstDash val="solid"/>
           </a:ln>
         </p:spPr>
+        <p:txBody>
+          <a:bodyPr/>
+          <a:p/>
+        </p:txBody>
       </p:sp>
       <p:sp>
         <p:nvSpPr>
@@ -4542,7 +4498,7 @@
                   <a:srgbClr val="F26A21"/>
                 </a:solidFill>
               </a:rPr>
-              <a:t>① Cash &amp; debt relief at close — target by Feb 15th</a:t>
+              <a:t>① Cash at close — target by Feb 15th</a:t>
             </a:r>
             <a:endParaRPr lang="en-US" sz="1300" dirty="0"/>
           </a:p>
@@ -4578,7 +4534,7 @@
                   <a:srgbClr val="F26A21"/>
                 </a:solidFill>
               </a:rPr>
-              <a:t>$4.36M</a:t>
+              <a:t>$3.86M</a:t>
             </a:r>
             <a:endParaRPr lang="en-US" sz="1800" dirty="0"/>
           </a:p>
@@ -4608,6 +4564,10 @@
             <a:prstDash val="solid"/>
           </a:ln>
         </p:spPr>
+        <p:txBody>
+          <a:bodyPr/>
+          <a:p/>
+        </p:txBody>
       </p:sp>
       <p:sp>
         <p:nvSpPr>
@@ -4705,6 +4665,10 @@
             <a:prstDash val="solid"/>
           </a:ln>
         </p:spPr>
+        <p:txBody>
+          <a:bodyPr/>
+          <a:p/>
+        </p:txBody>
       </p:sp>
       <p:sp>
         <p:nvSpPr>
@@ -4772,7 +4736,7 @@
                   <a:srgbClr val="2ECC71"/>
                 </a:solidFill>
               </a:rPr>
-              <a:t>$5.36M</a:t>
+              <a:t>$4.86M</a:t>
             </a:r>
             <a:endParaRPr lang="en-US" sz="2000" dirty="0"/>
           </a:p>
@@ -8739,6 +8703,10 @@
           </a:solidFill>
           <a:ln/>
         </p:spPr>
+        <p:txBody>
+          <a:bodyPr/>
+          <a:p/>
+        </p:txBody>
       </p:sp>
       <p:sp>
         <p:nvSpPr>
@@ -8800,6 +8768,10 @@
             <a:prstDash val="solid"/>
           </a:ln>
         </p:spPr>
+        <p:txBody>
+          <a:bodyPr/>
+          <a:p/>
+        </p:txBody>
       </p:sp>
       <p:sp>
         <p:nvSpPr>
@@ -8867,7 +8839,7 @@
                   <a:srgbClr val="2ECC71"/>
                 </a:solidFill>
               </a:rPr>
-              <a:t>$6.3M</a:t>
+              <a:t>$5.8M</a:t>
             </a:r>
             <a:endParaRPr lang="en-US" sz="2600" dirty="0"/>
           </a:p>
@@ -8892,6 +8864,10 @@
           </a:solidFill>
           <a:ln/>
         </p:spPr>
+        <p:txBody>
+          <a:bodyPr/>
+          <a:p/>
+        </p:txBody>
       </p:sp>
       <p:sp>
         <p:nvSpPr>
@@ -8953,6 +8929,10 @@
             <a:prstDash val="solid"/>
           </a:ln>
         </p:spPr>
+        <p:txBody>
+          <a:bodyPr/>
+          <a:p/>
+        </p:txBody>
       </p:sp>
       <p:sp>
         <p:nvSpPr>
@@ -9020,7 +9000,7 @@
                   <a:srgbClr val="2ECC71"/>
                 </a:solidFill>
               </a:rPr>
-              <a:t>$7.9M</a:t>
+              <a:t>$7.4M</a:t>
             </a:r>
             <a:endParaRPr lang="en-US" sz="2600" dirty="0"/>
           </a:p>
@@ -9045,6 +9025,10 @@
           </a:solidFill>
           <a:ln/>
         </p:spPr>
+        <p:txBody>
+          <a:bodyPr/>
+          <a:p/>
+        </p:txBody>
       </p:sp>
       <p:sp>
         <p:nvSpPr>
@@ -9106,6 +9090,10 @@
             <a:prstDash val="solid"/>
           </a:ln>
         </p:spPr>
+        <p:txBody>
+          <a:bodyPr/>
+          <a:p/>
+        </p:txBody>
       </p:sp>
       <p:sp>
         <p:nvSpPr>
@@ -9173,7 +9161,7 @@
                   <a:srgbClr val="2ECC71"/>
                 </a:solidFill>
               </a:rPr>
-              <a:t>$9.5M</a:t>
+              <a:t>$9.0M</a:t>
             </a:r>
             <a:endParaRPr lang="en-US" sz="2600" dirty="0"/>
           </a:p>
@@ -9198,6 +9186,10 @@
           </a:solidFill>
           <a:ln/>
         </p:spPr>
+        <p:txBody>
+          <a:bodyPr/>
+          <a:p/>
+        </p:txBody>
       </p:sp>
       <p:sp>
         <p:nvSpPr>
@@ -9257,6 +9249,10 @@
             <a:prstDash val="solid"/>
           </a:ln>
         </p:spPr>
+        <p:txBody>
+          <a:bodyPr/>
+          <a:p/>
+        </p:txBody>
       </p:sp>
       <p:sp>
         <p:nvSpPr>
@@ -9318,6 +9314,10 @@
             <a:prstDash val="solid"/>
           </a:ln>
         </p:spPr>
+        <p:txBody>
+          <a:bodyPr/>
+          <a:p/>
+        </p:txBody>
       </p:sp>
       <p:sp>
         <p:nvSpPr>
@@ -9385,7 +9385,7 @@
                   <a:srgbClr val="F26A21"/>
                 </a:solidFill>
               </a:rPr>
-              <a:t>$12.0M</a:t>
+              <a:t>$11.5M</a:t>
             </a:r>
             <a:endParaRPr lang="en-US" sz="2200" dirty="0"/>
           </a:p>
@@ -9410,6 +9410,10 @@
           </a:solidFill>
           <a:ln/>
         </p:spPr>
+        <p:txBody>
+          <a:bodyPr/>
+          <a:p/>
+        </p:txBody>
       </p:sp>
       <p:sp>
         <p:nvSpPr>
@@ -9471,6 +9475,10 @@
             <a:prstDash val="solid"/>
           </a:ln>
         </p:spPr>
+        <p:txBody>
+          <a:bodyPr/>
+          <a:p/>
+        </p:txBody>
       </p:sp>
       <p:sp>
         <p:nvSpPr>
@@ -9538,7 +9546,7 @@
                   <a:srgbClr val="F26A21"/>
                 </a:solidFill>
               </a:rPr>
-              <a:t>$15.8M</a:t>
+              <a:t>$15.3M</a:t>
             </a:r>
             <a:endParaRPr lang="en-US" sz="2200" dirty="0"/>
           </a:p>
@@ -9563,6 +9571,10 @@
           </a:solidFill>
           <a:ln/>
         </p:spPr>
+        <p:txBody>
+          <a:bodyPr/>
+          <a:p/>
+        </p:txBody>
       </p:sp>
       <p:sp>
         <p:nvSpPr>
@@ -9624,6 +9636,10 @@
             <a:prstDash val="solid"/>
           </a:ln>
         </p:spPr>
+        <p:txBody>
+          <a:bodyPr/>
+          <a:p/>
+        </p:txBody>
       </p:sp>
       <p:sp>
         <p:nvSpPr>
@@ -9691,7 +9707,7 @@
                   <a:srgbClr val="F26A21"/>
                 </a:solidFill>
               </a:rPr>
-              <a:t>$19.4M</a:t>
+              <a:t>$18.9M</a:t>
             </a:r>
             <a:endParaRPr lang="en-US" sz="2200" dirty="0"/>
           </a:p>
@@ -9716,6 +9732,10 @@
           </a:solidFill>
           <a:ln/>
         </p:spPr>
+        <p:txBody>
+          <a:bodyPr/>
+          <a:p/>
+        </p:txBody>
       </p:sp>
       <p:sp>
         <p:nvSpPr>
@@ -9796,6 +9816,10 @@
           </a:solidFill>
           <a:ln/>
         </p:spPr>
+        <p:txBody>
+          <a:bodyPr/>
+          <a:p/>
+        </p:txBody>
       </p:sp>
       <p:sp>
         <p:nvSpPr>
@@ -11189,6 +11213,10 @@
           </a:solidFill>
           <a:ln/>
         </p:spPr>
+        <p:txBody>
+          <a:bodyPr/>
+          <a:p/>
+        </p:txBody>
       </p:sp>
       <p:sp>
         <p:nvSpPr>
@@ -11214,6 +11242,10 @@
             <a:prstDash val="solid"/>
           </a:ln>
         </p:spPr>
+        <p:txBody>
+          <a:bodyPr/>
+          <a:p/>
+        </p:txBody>
       </p:sp>
       <p:sp>
         <p:nvSpPr>
@@ -11311,6 +11343,10 @@
             <a:prstDash val="solid"/>
           </a:ln>
         </p:spPr>
+        <p:txBody>
+          <a:bodyPr/>
+          <a:p/>
+        </p:txBody>
       </p:sp>
       <p:sp>
         <p:nvSpPr>
@@ -11408,77 +11444,9 @@
             <a:prstDash val="solid"/>
           </a:ln>
         </p:spPr>
-      </p:sp>
-      <p:sp>
-        <p:nvSpPr>
-          <p:cNvPr id="11" name="Text 9"/>
-          <p:cNvSpPr txBox="1"/>
-          <p:nvPr/>
-        </p:nvSpPr>
-        <p:spPr>
-          <a:xfrm>
-            <a:off x="548640" y="1719072"/>
-            <a:ext cx="5303520" cy="292608"/>
-          </a:xfrm>
-          <a:prstGeom prst="rect">
-            <a:avLst/>
-          </a:prstGeom>
-          <a:noFill/>
-          <a:ln/>
-        </p:spPr>
-        <p:txBody>
-          <a:bodyPr wrap="square" rtlCol="0" anchor="ctr"/>
-          <a:lstStyle/>
-          <a:p>
-            <a:pPr indent="0" marL="0">
-              <a:buNone/>
-            </a:pPr>
-            <a:r>
-              <a:rPr lang="en-US" sz="1200" b="1" dirty="0">
-                <a:solidFill>
-                  <a:srgbClr val="FFFFFF"/>
-                </a:solidFill>
-              </a:rPr>
-              <a:t>SSLC debts paid at face (~$500K, to verify)</a:t>
-            </a:r>
-            <a:endParaRPr lang="en-US" sz="1200" dirty="0"/>
-          </a:p>
-        </p:txBody>
-      </p:sp>
-      <p:sp>
-        <p:nvSpPr>
-          <p:cNvPr id="12" name="Text 10"/>
-          <p:cNvSpPr txBox="1"/>
-          <p:nvPr/>
-        </p:nvSpPr>
-        <p:spPr>
-          <a:xfrm>
-            <a:off x="5989320" y="1719072"/>
-            <a:ext cx="2606040" cy="292608"/>
-          </a:xfrm>
-          <a:prstGeom prst="rect">
-            <a:avLst/>
-          </a:prstGeom>
-          <a:noFill/>
-          <a:ln/>
-        </p:spPr>
-        <p:txBody>
-          <a:bodyPr wrap="square" rtlCol="0" anchor="ctr"/>
-          <a:lstStyle/>
-          <a:p>
-            <a:pPr algn="r" indent="0" marL="0">
-              <a:buNone/>
-            </a:pPr>
-            <a:r>
-              <a:rPr lang="en-US" sz="1000" dirty="0">
-                <a:solidFill>
-                  <a:srgbClr val="888888"/>
-                </a:solidFill>
-              </a:rPr>
-              <a:t>at financing close (target Feb 15th)</a:t>
-            </a:r>
-            <a:endParaRPr lang="en-US" sz="1000" dirty="0"/>
-          </a:p>
+        <p:txBody>
+          <a:bodyPr/>
+          <a:p/>
         </p:txBody>
       </p:sp>
       <p:sp>
@@ -11505,6 +11473,10 @@
             <a:prstDash val="solid"/>
           </a:ln>
         </p:spPr>
+        <p:txBody>
+          <a:bodyPr/>
+          <a:p/>
+        </p:txBody>
       </p:sp>
       <p:sp>
         <p:nvSpPr>
@@ -11602,6 +11574,10 @@
             <a:prstDash val="solid"/>
           </a:ln>
         </p:spPr>
+        <p:txBody>
+          <a:bodyPr/>
+          <a:p/>
+        </p:txBody>
       </p:sp>
       <p:sp>
         <p:nvSpPr>
@@ -11699,6 +11675,10 @@
             <a:prstDash val="solid"/>
           </a:ln>
         </p:spPr>
+        <p:txBody>
+          <a:bodyPr/>
+          <a:p/>
+        </p:txBody>
       </p:sp>
       <p:sp>
         <p:nvSpPr>
@@ -11796,6 +11776,10 @@
             <a:prstDash val="solid"/>
           </a:ln>
         </p:spPr>
+        <p:txBody>
+          <a:bodyPr/>
+          <a:p/>
+        </p:txBody>
       </p:sp>
       <p:sp>
         <p:nvSpPr>
@@ -11893,6 +11877,10 @@
             <a:prstDash val="solid"/>
           </a:ln>
         </p:spPr>
+        <p:txBody>
+          <a:bodyPr/>
+          <a:p/>
+        </p:txBody>
       </p:sp>
       <p:sp>
         <p:nvSpPr>
@@ -11990,6 +11978,10 @@
             <a:prstDash val="solid"/>
           </a:ln>
         </p:spPr>
+        <p:txBody>
+          <a:bodyPr/>
+          <a:p/>
+        </p:txBody>
       </p:sp>
       <p:sp>
         <p:nvSpPr>

</xml_diff>

<commit_message>
deck r2: insert slide 4 'SSLC Capital & Debt' + regenerate PDF
New slide 4 after 'Where SSLC Stands Today':
- Left panel: equity paid-in capital (,014,465 total; Exos 18.06%/,572)
  + accumulated deficit −,571,013 + total equity −,403,075 (10/2)
- Right panel: loans & notes ,027,783 (Microcosm ,429, Bookstore
  ,582, SBA EIDL ,072, Wertz ,500, Exos ,200)
- Bottom band: unbooked facility-cost offset (~K est. 2yr; 50% →
  net creditor ~K; K billed-ahead disputed)
- Footnote + speaker notes citing QB 8/21 and 10/2/2026
- Mirror in scripts/build_sslc_board_deck.js

Source: drafts/SSLC_QB_Equity_Debt_Microcosm_Facility_2026-10-10.xlsx
MC task #2414 | John Quinn 2026-10-10
</commit_message>
<xml_diff>
--- a/drafts/Exos_SSLC_Board_Offer_Overview_2026-10-10_r2.pptx
+++ b/drafts/Exos_SSLC_Board_Offer_Overview_2026-10-10_r2.pptx
@@ -8,6 +8,7 @@
     <p:sldId id="256" r:id="rId2"/>
     <p:sldId id="257" r:id="rId3"/>
     <p:sldId id="258" r:id="rId4"/>
+    <p:sldId id="266" r:id="rId17"/>
     <p:sldId id="259" r:id="rId5"/>
     <p:sldId id="260" r:id="rId6"/>
     <p:sldId id="261" r:id="rId7"/>
@@ -641,6 +642,128 @@
 </p:notes>
 </file>
 
+<file path=ppt/notesSlides/notesSlide11.xml><?xml version="1.0" encoding="utf-8"?>
+<p:notes xmlns:a="http://schemas.openxmlformats.org/drawingml/2006/main" xmlns:p="http://schemas.openxmlformats.org/presentationml/2006/main" xmlns:r="http://schemas.openxmlformats.org/officeDocument/2006/relationships">
+  <p:cSld>
+    <p:spTree>
+      <p:nvGrpSpPr>
+        <p:cNvPr id="1" name=""/>
+        <p:cNvGrpSpPr/>
+        <p:nvPr/>
+      </p:nvGrpSpPr>
+      <p:grpSpPr>
+        <a:xfrm>
+          <a:off x="0" y="0"/>
+          <a:ext cx="0" cy="0"/>
+          <a:chOff x="0" y="0"/>
+          <a:chExt cx="0" cy="0"/>
+        </a:xfrm>
+      </p:grpSpPr>
+      <p:sp>
+        <p:nvSpPr>
+          <p:cNvPr id="2" name="Slide Image Placeholder 1"/>
+          <p:cNvSpPr>
+            <a:spLocks noGrp="1"/>
+          </p:cNvSpPr>
+          <p:nvPr>
+            <p:ph type="sldImg" idx="2"/>
+          </p:nvPr>
+        </p:nvSpPr>
+        <p:spPr/>
+      </p:sp>
+      <p:sp>
+        <p:nvSpPr>
+          <p:cNvPr id="3" name="Notes Placeholder 2"/>
+          <p:cNvSpPr>
+            <a:spLocks noGrp="1"/>
+          </p:cNvSpPr>
+          <p:nvPr>
+            <p:ph type="body" idx="3" sz="quarter"/>
+          </p:nvPr>
+        </p:nvSpPr>
+        <p:spPr/>
+        <p:txBody>
+          <a:bodyPr/>
+          <a:lstStyle/>
+          <a:p>
+            <a:r>
+              <a:t>Sources:</a:t>
+            </a:r>
+            <a:br/>
+            <a:r>
+              <a:t>  Equity: QB Balance Sheet 8/21/2026 (data-room/SSLC/2026-7_BS_8-21-26.pdf). Total paid-in $1,014,465; Exos paid $789,572 per AAA Oct 2023.</a:t>
+            </a:r>
+            <a:br/>
+            <a:r>
+              <a:t>  Accum. deficit −$2,571,012.99 per QB BS 8/21/2026.</a:t>
+            </a:r>
+            <a:br/>
+            <a:r>
+              <a:t>  Total equity −$1,403,075 per Board Package 10/6/2026.</a:t>
+            </a:r>
+            <a:br/>
+            <a:r>
+              <a:t>  Debt: Board Package 10/6/2026 + QB BS 8/21. Total loans &amp; notes $1,027,783 confirmed.</a:t>
+            </a:r>
+            <a:br/>
+            <a:r>
+              <a:t>  Facility costs: QB P&amp;L FY26 CONFIRMED $353,978; FY27 Jul–Aug21 $32,860 (partial).</a:t>
+            </a:r>
+            <a:br/>
+            <a:r>
+              <a:t>  2-yr ~$967K estimate uses FY26 monthly rate ~$29.5K/mo for the remainder; CAVEAT: FY25 not on disk.</a:t>
+            </a:r>
+            <a:br/>
+            <a:r>
+              <a:t>  Microcosm offset: 50% share is MANAGEMENT ASSUMPTION — no written cost-sharing agreement found.</a:t>
+            </a:r>
+            <a:br/>
+            <a:r>
+              <a:t>  Must verify: (1) SSLC paid 100% of costs, (2) written agreement, (3) Microcosm's share allocation.</a:t>
+            </a:r>
+            <a:br/>
+            <a:r>
+              <a:t>  At 50% share offset ~$483K &gt; Due-to-Microcosm $451K → net creditor ~$32K.</a:t>
+            </a:r>
+            <a:br/>
+            <a:r>
+              <a:t>  At 40%: net-owe ~$65K; at 60%: net creditor ~$129K.</a:t>
+            </a:r>
+            <a:br/>
+            <a:r>
+              <a:t>  $864K billed-ahead balance: from QB FY27 Q1 actual. Nature disputed; full QB access requested.</a:t>
+            </a:r>
+            <a:br/>
+            <a:r>
+              <a:t>  CAUTION: Do not represent offset as a verified legal claim without written agreement.</a:t>
+            </a:r>
+            <a:br/>
+            <a:r>
+              <a:t>Source file: drafts/SSLC_QB_Equity_Debt_Microcosm_Facility_2026-10-10.xlsx</a:t>
+            </a:r>
+          </a:p>
+        </p:txBody>
+      </p:sp>
+      <p:sp>
+        <p:nvSpPr>
+          <p:cNvPr id="4" name="Slide Number Placeholder 3"/>
+          <p:cNvSpPr>
+            <a:spLocks noGrp="1"/>
+          </p:cNvSpPr>
+          <p:nvPr>
+            <p:ph type="sldNum" idx="5" sz="quarter"/>
+          </p:nvPr>
+        </p:nvSpPr>
+        <p:spPr/>
+      </p:sp>
+    </p:spTree>
+  </p:cSld>
+  <p:clrMapOvr>
+    <a:masterClrMapping/>
+  </p:clrMapOvr>
+</p:notes>
+</file>
+
 <file path=ppt/notesSlides/notesSlide2.xml><?xml version="1.0" encoding="utf-8"?>
 <p:notes xmlns:a="http://schemas.openxmlformats.org/drawingml/2006/main" xmlns:r="http://schemas.openxmlformats.org/officeDocument/2006/relationships" xmlns:p="http://schemas.openxmlformats.org/presentationml/2006/main">
   <p:cSld>
@@ -2901,6 +3024,1781 @@
               <a:t>The Board is asked to confirm §3 exclusivity. Questions and open items welcome.</a:t>
             </a:r>
             <a:endParaRPr lang="en-US" sz="1300" dirty="0"/>
+          </a:p>
+        </p:txBody>
+      </p:sp>
+    </p:spTree>
+  </p:cSld>
+  <p:clrMapOvr>
+    <a:masterClrMapping/>
+  </p:clrMapOvr>
+</p:sld>
+</file>
+
+<file path=ppt/slides/slide11.xml><?xml version="1.0" encoding="utf-8"?>
+<p:sld xmlns:a="http://schemas.openxmlformats.org/drawingml/2006/main" xmlns:p="http://schemas.openxmlformats.org/presentationml/2006/main" xmlns:r="http://schemas.openxmlformats.org/officeDocument/2006/relationships">
+  <p:cSld>
+    <p:bg>
+      <p:bgPr>
+        <a:solidFill>
+          <a:srgbClr val="111111"/>
+        </a:solidFill>
+        <a:effectLst/>
+      </p:bgPr>
+    </p:bg>
+    <p:spTree>
+      <p:nvGrpSpPr>
+        <p:cNvPr id="1" name=""/>
+        <p:cNvGrpSpPr/>
+        <p:nvPr/>
+      </p:nvGrpSpPr>
+      <p:grpSpPr/>
+      <p:sp>
+        <p:nvSpPr>
+          <p:cNvPr id="2" name="Rectangle 1"/>
+          <p:cNvSpPr/>
+          <p:nvPr/>
+        </p:nvSpPr>
+        <p:spPr>
+          <a:xfrm>
+            <a:off x="0" y="0"/>
+            <a:ext cx="9144000" cy="50292"/>
+          </a:xfrm>
+          <a:prstGeom prst="rect">
+            <a:avLst/>
+          </a:prstGeom>
+          <a:solidFill>
+            <a:srgbClr val="F26A21"/>
+          </a:solidFill>
+          <a:ln>
+            <a:noFill/>
+          </a:ln>
+        </p:spPr>
+        <p:style>
+          <a:lnRef idx="1">
+            <a:schemeClr val="accent1"/>
+          </a:lnRef>
+          <a:fillRef idx="3">
+            <a:schemeClr val="accent1"/>
+          </a:fillRef>
+          <a:effectRef idx="2">
+            <a:schemeClr val="accent1"/>
+          </a:effectRef>
+          <a:fontRef idx="minor">
+            <a:schemeClr val="lt1"/>
+          </a:fontRef>
+        </p:style>
+        <p:txBody>
+          <a:bodyPr rtlCol="0" anchor="ctr"/>
+          <a:lstStyle/>
+          <a:p>
+            <a:pPr algn="ctr"/>
+          </a:p>
+        </p:txBody>
+      </p:sp>
+      <p:sp>
+        <p:nvSpPr>
+          <p:cNvPr id="3" name="TextBox 2"/>
+          <p:cNvSpPr txBox="1"/>
+          <p:nvPr/>
+        </p:nvSpPr>
+        <p:spPr>
+          <a:xfrm>
+            <a:off x="228600" y="64008"/>
+            <a:ext cx="8686800" cy="457200"/>
+          </a:xfrm>
+          <a:prstGeom prst="rect">
+            <a:avLst/>
+          </a:prstGeom>
+          <a:noFill/>
+        </p:spPr>
+        <p:txBody>
+          <a:bodyPr wrap="square">
+            <a:spAutoFit/>
+          </a:bodyPr>
+          <a:lstStyle/>
+          <a:p>
+            <a:pPr algn="l"/>
+            <a:r>
+              <a:rPr sz="2000" b="1" i="0">
+                <a:solidFill>
+                  <a:srgbClr val="FFFFFF"/>
+                </a:solidFill>
+                <a:latin typeface="Cambria"/>
+              </a:rPr>
+              <a:t>SSLC Capital &amp; Debt: What's on the Books</a:t>
+            </a:r>
+          </a:p>
+        </p:txBody>
+      </p:sp>
+      <p:sp>
+        <p:nvSpPr>
+          <p:cNvPr id="4" name="Rectangle 3"/>
+          <p:cNvSpPr/>
+          <p:nvPr/>
+        </p:nvSpPr>
+        <p:spPr>
+          <a:xfrm>
+            <a:off x="109728" y="594360"/>
+            <a:ext cx="4160520" cy="2999232"/>
+          </a:xfrm>
+          <a:prstGeom prst="rect">
+            <a:avLst/>
+          </a:prstGeom>
+          <a:solidFill>
+            <a:srgbClr val="222222"/>
+          </a:solidFill>
+          <a:ln>
+            <a:noFill/>
+          </a:ln>
+        </p:spPr>
+        <p:style>
+          <a:lnRef idx="1">
+            <a:schemeClr val="accent1"/>
+          </a:lnRef>
+          <a:fillRef idx="3">
+            <a:schemeClr val="accent1"/>
+          </a:fillRef>
+          <a:effectRef idx="2">
+            <a:schemeClr val="accent1"/>
+          </a:effectRef>
+          <a:fontRef idx="minor">
+            <a:schemeClr val="lt1"/>
+          </a:fontRef>
+        </p:style>
+        <p:txBody>
+          <a:bodyPr rtlCol="0" anchor="ctr"/>
+          <a:lstStyle/>
+          <a:p>
+            <a:pPr algn="ctr"/>
+          </a:p>
+        </p:txBody>
+      </p:sp>
+      <p:sp>
+        <p:nvSpPr>
+          <p:cNvPr id="5" name="Rectangle 4"/>
+          <p:cNvSpPr/>
+          <p:nvPr/>
+        </p:nvSpPr>
+        <p:spPr>
+          <a:xfrm>
+            <a:off x="4407408" y="594360"/>
+            <a:ext cx="4617720" cy="2999232"/>
+          </a:xfrm>
+          <a:prstGeom prst="rect">
+            <a:avLst/>
+          </a:prstGeom>
+          <a:solidFill>
+            <a:srgbClr val="222222"/>
+          </a:solidFill>
+          <a:ln>
+            <a:noFill/>
+          </a:ln>
+        </p:spPr>
+        <p:style>
+          <a:lnRef idx="1">
+            <a:schemeClr val="accent1"/>
+          </a:lnRef>
+          <a:fillRef idx="3">
+            <a:schemeClr val="accent1"/>
+          </a:fillRef>
+          <a:effectRef idx="2">
+            <a:schemeClr val="accent1"/>
+          </a:effectRef>
+          <a:fontRef idx="minor">
+            <a:schemeClr val="lt1"/>
+          </a:fontRef>
+        </p:style>
+        <p:txBody>
+          <a:bodyPr rtlCol="0" anchor="ctr"/>
+          <a:lstStyle/>
+          <a:p>
+            <a:pPr algn="ctr"/>
+          </a:p>
+        </p:txBody>
+      </p:sp>
+      <p:sp>
+        <p:nvSpPr>
+          <p:cNvPr id="6" name="Rectangle 5"/>
+          <p:cNvSpPr/>
+          <p:nvPr/>
+        </p:nvSpPr>
+        <p:spPr>
+          <a:xfrm>
+            <a:off x="109728" y="594360"/>
+            <a:ext cx="4160520" cy="246888"/>
+          </a:xfrm>
+          <a:prstGeom prst="rect">
+            <a:avLst/>
+          </a:prstGeom>
+          <a:solidFill>
+            <a:srgbClr val="1A1A1A"/>
+          </a:solidFill>
+          <a:ln>
+            <a:noFill/>
+          </a:ln>
+        </p:spPr>
+        <p:style>
+          <a:lnRef idx="1">
+            <a:schemeClr val="accent1"/>
+          </a:lnRef>
+          <a:fillRef idx="3">
+            <a:schemeClr val="accent1"/>
+          </a:fillRef>
+          <a:effectRef idx="2">
+            <a:schemeClr val="accent1"/>
+          </a:effectRef>
+          <a:fontRef idx="minor">
+            <a:schemeClr val="lt1"/>
+          </a:fontRef>
+        </p:style>
+        <p:txBody>
+          <a:bodyPr rtlCol="0" anchor="ctr"/>
+          <a:lstStyle/>
+          <a:p>
+            <a:pPr algn="ctr"/>
+          </a:p>
+        </p:txBody>
+      </p:sp>
+      <p:sp>
+        <p:nvSpPr>
+          <p:cNvPr id="7" name="Rectangle 6"/>
+          <p:cNvSpPr/>
+          <p:nvPr/>
+        </p:nvSpPr>
+        <p:spPr>
+          <a:xfrm>
+            <a:off x="4407408" y="594360"/>
+            <a:ext cx="4617720" cy="246888"/>
+          </a:xfrm>
+          <a:prstGeom prst="rect">
+            <a:avLst/>
+          </a:prstGeom>
+          <a:solidFill>
+            <a:srgbClr val="1A1A1A"/>
+          </a:solidFill>
+          <a:ln>
+            <a:noFill/>
+          </a:ln>
+        </p:spPr>
+        <p:style>
+          <a:lnRef idx="1">
+            <a:schemeClr val="accent1"/>
+          </a:lnRef>
+          <a:fillRef idx="3">
+            <a:schemeClr val="accent1"/>
+          </a:fillRef>
+          <a:effectRef idx="2">
+            <a:schemeClr val="accent1"/>
+          </a:effectRef>
+          <a:fontRef idx="minor">
+            <a:schemeClr val="lt1"/>
+          </a:fontRef>
+        </p:style>
+        <p:txBody>
+          <a:bodyPr rtlCol="0" anchor="ctr"/>
+          <a:lstStyle/>
+          <a:p>
+            <a:pPr algn="ctr"/>
+          </a:p>
+        </p:txBody>
+      </p:sp>
+      <p:sp>
+        <p:nvSpPr>
+          <p:cNvPr id="8" name="Rectangle 7"/>
+          <p:cNvSpPr/>
+          <p:nvPr/>
+        </p:nvSpPr>
+        <p:spPr>
+          <a:xfrm>
+            <a:off x="109728" y="594360"/>
+            <a:ext cx="36576" cy="246888"/>
+          </a:xfrm>
+          <a:prstGeom prst="rect">
+            <a:avLst/>
+          </a:prstGeom>
+          <a:solidFill>
+            <a:srgbClr val="F26A21"/>
+          </a:solidFill>
+          <a:ln>
+            <a:noFill/>
+          </a:ln>
+        </p:spPr>
+        <p:style>
+          <a:lnRef idx="1">
+            <a:schemeClr val="accent1"/>
+          </a:lnRef>
+          <a:fillRef idx="3">
+            <a:schemeClr val="accent1"/>
+          </a:fillRef>
+          <a:effectRef idx="2">
+            <a:schemeClr val="accent1"/>
+          </a:effectRef>
+          <a:fontRef idx="minor">
+            <a:schemeClr val="lt1"/>
+          </a:fontRef>
+        </p:style>
+        <p:txBody>
+          <a:bodyPr rtlCol="0" anchor="ctr"/>
+          <a:lstStyle/>
+          <a:p>
+            <a:pPr algn="ctr"/>
+          </a:p>
+        </p:txBody>
+      </p:sp>
+      <p:sp>
+        <p:nvSpPr>
+          <p:cNvPr id="9" name="Rectangle 8"/>
+          <p:cNvSpPr/>
+          <p:nvPr/>
+        </p:nvSpPr>
+        <p:spPr>
+          <a:xfrm>
+            <a:off x="4407408" y="594360"/>
+            <a:ext cx="36576" cy="246888"/>
+          </a:xfrm>
+          <a:prstGeom prst="rect">
+            <a:avLst/>
+          </a:prstGeom>
+          <a:solidFill>
+            <a:srgbClr val="F26A21"/>
+          </a:solidFill>
+          <a:ln>
+            <a:noFill/>
+          </a:ln>
+        </p:spPr>
+        <p:style>
+          <a:lnRef idx="1">
+            <a:schemeClr val="accent1"/>
+          </a:lnRef>
+          <a:fillRef idx="3">
+            <a:schemeClr val="accent1"/>
+          </a:fillRef>
+          <a:effectRef idx="2">
+            <a:schemeClr val="accent1"/>
+          </a:effectRef>
+          <a:fontRef idx="minor">
+            <a:schemeClr val="lt1"/>
+          </a:fontRef>
+        </p:style>
+        <p:txBody>
+          <a:bodyPr rtlCol="0" anchor="ctr"/>
+          <a:lstStyle/>
+          <a:p>
+            <a:pPr algn="ctr"/>
+          </a:p>
+        </p:txBody>
+      </p:sp>
+      <p:sp>
+        <p:nvSpPr>
+          <p:cNvPr id="10" name="TextBox 9"/>
+          <p:cNvSpPr txBox="1"/>
+          <p:nvPr/>
+        </p:nvSpPr>
+        <p:spPr>
+          <a:xfrm>
+            <a:off x="201168" y="640080"/>
+            <a:ext cx="4023359" cy="182880"/>
+          </a:xfrm>
+          <a:prstGeom prst="rect">
+            <a:avLst/>
+          </a:prstGeom>
+          <a:noFill/>
+        </p:spPr>
+        <p:txBody>
+          <a:bodyPr wrap="square">
+            <a:spAutoFit/>
+          </a:bodyPr>
+          <a:lstStyle/>
+          <a:p>
+            <a:pPr algn="l"/>
+            <a:r>
+              <a:rPr sz="850" b="1" i="0">
+                <a:solidFill>
+                  <a:srgbClr val="F26A21"/>
+                </a:solidFill>
+                <a:latin typeface="Calibri"/>
+              </a:rPr>
+              <a:t>WHAT INVESTORS PAID IN</a:t>
+            </a:r>
+          </a:p>
+        </p:txBody>
+      </p:sp>
+      <p:sp>
+        <p:nvSpPr>
+          <p:cNvPr id="11" name="TextBox 10"/>
+          <p:cNvSpPr txBox="1"/>
+          <p:nvPr/>
+        </p:nvSpPr>
+        <p:spPr>
+          <a:xfrm>
+            <a:off x="4498848" y="640080"/>
+            <a:ext cx="4480559" cy="182880"/>
+          </a:xfrm>
+          <a:prstGeom prst="rect">
+            <a:avLst/>
+          </a:prstGeom>
+          <a:noFill/>
+        </p:spPr>
+        <p:txBody>
+          <a:bodyPr wrap="square">
+            <a:spAutoFit/>
+          </a:bodyPr>
+          <a:lstStyle/>
+          <a:p>
+            <a:pPr algn="l"/>
+            <a:r>
+              <a:rPr sz="850" b="1" i="0">
+                <a:solidFill>
+                  <a:srgbClr val="F26A21"/>
+                </a:solidFill>
+                <a:latin typeface="Calibri"/>
+              </a:rPr>
+              <a:t>WHAT SSLC OWES  (10/2/2026)</a:t>
+            </a:r>
+          </a:p>
+        </p:txBody>
+      </p:sp>
+      <p:sp>
+        <p:nvSpPr>
+          <p:cNvPr id="12" name="TextBox 11"/>
+          <p:cNvSpPr txBox="1"/>
+          <p:nvPr/>
+        </p:nvSpPr>
+        <p:spPr>
+          <a:xfrm>
+            <a:off x="219456" y="914400"/>
+            <a:ext cx="2514600" cy="205740"/>
+          </a:xfrm>
+          <a:prstGeom prst="rect">
+            <a:avLst/>
+          </a:prstGeom>
+          <a:noFill/>
+        </p:spPr>
+        <p:txBody>
+          <a:bodyPr wrap="square">
+            <a:spAutoFit/>
+          </a:bodyPr>
+          <a:lstStyle/>
+          <a:p>
+            <a:pPr algn="l"/>
+            <a:r>
+              <a:rPr sz="800" b="0" i="0">
+                <a:solidFill>
+                  <a:srgbClr val="CCCCCC"/>
+                </a:solidFill>
+                <a:latin typeface="Calibri"/>
+              </a:rPr>
+              <a:t>Common stock (Acct 3010)</a:t>
+            </a:r>
+          </a:p>
+        </p:txBody>
+      </p:sp>
+      <p:sp>
+        <p:nvSpPr>
+          <p:cNvPr id="13" name="TextBox 12"/>
+          <p:cNvSpPr txBox="1"/>
+          <p:nvPr/>
+        </p:nvSpPr>
+        <p:spPr>
+          <a:xfrm>
+            <a:off x="2642616" y="914400"/>
+            <a:ext cx="1481328" cy="205740"/>
+          </a:xfrm>
+          <a:prstGeom prst="rect">
+            <a:avLst/>
+          </a:prstGeom>
+          <a:noFill/>
+        </p:spPr>
+        <p:txBody>
+          <a:bodyPr wrap="square">
+            <a:spAutoFit/>
+          </a:bodyPr>
+          <a:lstStyle/>
+          <a:p>
+            <a:pPr algn="r"/>
+            <a:r>
+              <a:rPr sz="900" b="0" i="0">
+                <a:solidFill>
+                  <a:srgbClr val="CCCCCC"/>
+                </a:solidFill>
+                <a:latin typeface="Calibri"/>
+              </a:rPr>
+              <a:t>$1,010,423</a:t>
+            </a:r>
+          </a:p>
+        </p:txBody>
+      </p:sp>
+      <p:sp>
+        <p:nvSpPr>
+          <p:cNvPr id="14" name="TextBox 13"/>
+          <p:cNvSpPr txBox="1"/>
+          <p:nvPr/>
+        </p:nvSpPr>
+        <p:spPr>
+          <a:xfrm>
+            <a:off x="219456" y="1138428"/>
+            <a:ext cx="2514600" cy="205740"/>
+          </a:xfrm>
+          <a:prstGeom prst="rect">
+            <a:avLst/>
+          </a:prstGeom>
+          <a:noFill/>
+        </p:spPr>
+        <p:txBody>
+          <a:bodyPr wrap="square">
+            <a:spAutoFit/>
+          </a:bodyPr>
+          <a:lstStyle/>
+          <a:p>
+            <a:pPr algn="l"/>
+            <a:r>
+              <a:rPr sz="800" b="0" i="0">
+                <a:solidFill>
+                  <a:srgbClr val="CCCCCC"/>
+                </a:solidFill>
+                <a:latin typeface="Calibri"/>
+              </a:rPr>
+              <a:t>APIC (Acct 3020)</a:t>
+            </a:r>
+          </a:p>
+        </p:txBody>
+      </p:sp>
+      <p:sp>
+        <p:nvSpPr>
+          <p:cNvPr id="15" name="TextBox 14"/>
+          <p:cNvSpPr txBox="1"/>
+          <p:nvPr/>
+        </p:nvSpPr>
+        <p:spPr>
+          <a:xfrm>
+            <a:off x="2642616" y="1138428"/>
+            <a:ext cx="1481328" cy="205740"/>
+          </a:xfrm>
+          <a:prstGeom prst="rect">
+            <a:avLst/>
+          </a:prstGeom>
+          <a:noFill/>
+        </p:spPr>
+        <p:txBody>
+          <a:bodyPr wrap="square">
+            <a:spAutoFit/>
+          </a:bodyPr>
+          <a:lstStyle/>
+          <a:p>
+            <a:pPr algn="r"/>
+            <a:r>
+              <a:rPr sz="900" b="0" i="0">
+                <a:solidFill>
+                  <a:srgbClr val="CCCCCC"/>
+                </a:solidFill>
+                <a:latin typeface="Calibri"/>
+              </a:rPr>
+              <a:t>$4,042</a:t>
+            </a:r>
+          </a:p>
+        </p:txBody>
+      </p:sp>
+      <p:sp>
+        <p:nvSpPr>
+          <p:cNvPr id="16" name="Rectangle 15"/>
+          <p:cNvSpPr/>
+          <p:nvPr/>
+        </p:nvSpPr>
+        <p:spPr>
+          <a:xfrm>
+            <a:off x="219456" y="1435608"/>
+            <a:ext cx="3931920" cy="13716"/>
+          </a:xfrm>
+          <a:prstGeom prst="rect">
+            <a:avLst/>
+          </a:prstGeom>
+          <a:solidFill>
+            <a:srgbClr val="888888"/>
+          </a:solidFill>
+          <a:ln>
+            <a:noFill/>
+          </a:ln>
+        </p:spPr>
+        <p:style>
+          <a:lnRef idx="1">
+            <a:schemeClr val="accent1"/>
+          </a:lnRef>
+          <a:fillRef idx="3">
+            <a:schemeClr val="accent1"/>
+          </a:fillRef>
+          <a:effectRef idx="2">
+            <a:schemeClr val="accent1"/>
+          </a:effectRef>
+          <a:fontRef idx="minor">
+            <a:schemeClr val="lt1"/>
+          </a:fontRef>
+        </p:style>
+        <p:txBody>
+          <a:bodyPr rtlCol="0" anchor="ctr"/>
+          <a:lstStyle/>
+          <a:p>
+            <a:pPr algn="ctr"/>
+          </a:p>
+        </p:txBody>
+      </p:sp>
+      <p:sp>
+        <p:nvSpPr>
+          <p:cNvPr id="17" name="TextBox 16"/>
+          <p:cNvSpPr txBox="1"/>
+          <p:nvPr/>
+        </p:nvSpPr>
+        <p:spPr>
+          <a:xfrm>
+            <a:off x="219456" y="1586484"/>
+            <a:ext cx="2514600" cy="205740"/>
+          </a:xfrm>
+          <a:prstGeom prst="rect">
+            <a:avLst/>
+          </a:prstGeom>
+          <a:noFill/>
+        </p:spPr>
+        <p:txBody>
+          <a:bodyPr wrap="square">
+            <a:spAutoFit/>
+          </a:bodyPr>
+          <a:lstStyle/>
+          <a:p>
+            <a:pPr algn="l"/>
+            <a:r>
+              <a:rPr sz="800" b="0" i="0">
+                <a:solidFill>
+                  <a:srgbClr val="CCCCCC"/>
+                </a:solidFill>
+                <a:latin typeface="Calibri"/>
+              </a:rPr>
+              <a:t>Total paid-in capital</a:t>
+            </a:r>
+          </a:p>
+        </p:txBody>
+      </p:sp>
+      <p:sp>
+        <p:nvSpPr>
+          <p:cNvPr id="18" name="TextBox 17"/>
+          <p:cNvSpPr txBox="1"/>
+          <p:nvPr/>
+        </p:nvSpPr>
+        <p:spPr>
+          <a:xfrm>
+            <a:off x="2642616" y="1586484"/>
+            <a:ext cx="1481328" cy="205740"/>
+          </a:xfrm>
+          <a:prstGeom prst="rect">
+            <a:avLst/>
+          </a:prstGeom>
+          <a:noFill/>
+        </p:spPr>
+        <p:txBody>
+          <a:bodyPr wrap="square">
+            <a:spAutoFit/>
+          </a:bodyPr>
+          <a:lstStyle/>
+          <a:p>
+            <a:pPr algn="r"/>
+            <a:r>
+              <a:rPr sz="900" b="1" i="0">
+                <a:solidFill>
+                  <a:srgbClr val="FFFFFF"/>
+                </a:solidFill>
+                <a:latin typeface="Calibri"/>
+              </a:rPr>
+              <a:t>$1,014,465</a:t>
+            </a:r>
+          </a:p>
+        </p:txBody>
+      </p:sp>
+      <p:sp>
+        <p:nvSpPr>
+          <p:cNvPr id="19" name="TextBox 18"/>
+          <p:cNvSpPr txBox="1"/>
+          <p:nvPr/>
+        </p:nvSpPr>
+        <p:spPr>
+          <a:xfrm>
+            <a:off x="219456" y="1810512"/>
+            <a:ext cx="2514600" cy="205740"/>
+          </a:xfrm>
+          <a:prstGeom prst="rect">
+            <a:avLst/>
+          </a:prstGeom>
+          <a:noFill/>
+        </p:spPr>
+        <p:txBody>
+          <a:bodyPr wrap="square">
+            <a:spAutoFit/>
+          </a:bodyPr>
+          <a:lstStyle/>
+          <a:p>
+            <a:pPr algn="l"/>
+            <a:r>
+              <a:rPr sz="800" b="0" i="0">
+                <a:solidFill>
+                  <a:srgbClr val="CCCCCC"/>
+                </a:solidFill>
+                <a:latin typeface="Calibri"/>
+              </a:rPr>
+              <a:t>Exos: 18.06% → $789,572</a:t>
+            </a:r>
+          </a:p>
+        </p:txBody>
+      </p:sp>
+      <p:sp>
+        <p:nvSpPr>
+          <p:cNvPr id="20" name="TextBox 19"/>
+          <p:cNvSpPr txBox="1"/>
+          <p:nvPr/>
+        </p:nvSpPr>
+        <p:spPr>
+          <a:xfrm>
+            <a:off x="2642616" y="1810512"/>
+            <a:ext cx="1481328" cy="205740"/>
+          </a:xfrm>
+          <a:prstGeom prst="rect">
+            <a:avLst/>
+          </a:prstGeom>
+          <a:noFill/>
+        </p:spPr>
+        <p:txBody>
+          <a:bodyPr wrap="square">
+            <a:spAutoFit/>
+          </a:bodyPr>
+          <a:lstStyle/>
+          <a:p>
+            <a:pPr algn="r"/>
+            <a:r>
+              <a:rPr sz="900" b="1" i="0">
+                <a:solidFill>
+                  <a:srgbClr val="F26A21"/>
+                </a:solidFill>
+                <a:latin typeface="Calibri"/>
+              </a:rPr>
+              <a:t>~78% of above</a:t>
+            </a:r>
+          </a:p>
+        </p:txBody>
+      </p:sp>
+      <p:sp>
+        <p:nvSpPr>
+          <p:cNvPr id="21" name="Rectangle 20"/>
+          <p:cNvSpPr/>
+          <p:nvPr/>
+        </p:nvSpPr>
+        <p:spPr>
+          <a:xfrm>
+            <a:off x="219456" y="2107692"/>
+            <a:ext cx="3931920" cy="13716"/>
+          </a:xfrm>
+          <a:prstGeom prst="rect">
+            <a:avLst/>
+          </a:prstGeom>
+          <a:solidFill>
+            <a:srgbClr val="888888"/>
+          </a:solidFill>
+          <a:ln>
+            <a:noFill/>
+          </a:ln>
+        </p:spPr>
+        <p:style>
+          <a:lnRef idx="1">
+            <a:schemeClr val="accent1"/>
+          </a:lnRef>
+          <a:fillRef idx="3">
+            <a:schemeClr val="accent1"/>
+          </a:fillRef>
+          <a:effectRef idx="2">
+            <a:schemeClr val="accent1"/>
+          </a:effectRef>
+          <a:fontRef idx="minor">
+            <a:schemeClr val="lt1"/>
+          </a:fontRef>
+        </p:style>
+        <p:txBody>
+          <a:bodyPr rtlCol="0" anchor="ctr"/>
+          <a:lstStyle/>
+          <a:p>
+            <a:pPr algn="ctr"/>
+          </a:p>
+        </p:txBody>
+      </p:sp>
+      <p:sp>
+        <p:nvSpPr>
+          <p:cNvPr id="22" name="TextBox 21"/>
+          <p:cNvSpPr txBox="1"/>
+          <p:nvPr/>
+        </p:nvSpPr>
+        <p:spPr>
+          <a:xfrm>
+            <a:off x="219456" y="2258568"/>
+            <a:ext cx="2514600" cy="205740"/>
+          </a:xfrm>
+          <a:prstGeom prst="rect">
+            <a:avLst/>
+          </a:prstGeom>
+          <a:noFill/>
+        </p:spPr>
+        <p:txBody>
+          <a:bodyPr wrap="square">
+            <a:spAutoFit/>
+          </a:bodyPr>
+          <a:lstStyle/>
+          <a:p>
+            <a:pPr algn="l"/>
+            <a:r>
+              <a:rPr sz="800" b="0" i="0">
+                <a:solidFill>
+                  <a:srgbClr val="CCCCCC"/>
+                </a:solidFill>
+                <a:latin typeface="Calibri"/>
+              </a:rPr>
+              <a:t>Accum. deficit (thru FY26)</a:t>
+            </a:r>
+          </a:p>
+        </p:txBody>
+      </p:sp>
+      <p:sp>
+        <p:nvSpPr>
+          <p:cNvPr id="23" name="TextBox 22"/>
+          <p:cNvSpPr txBox="1"/>
+          <p:nvPr/>
+        </p:nvSpPr>
+        <p:spPr>
+          <a:xfrm>
+            <a:off x="2642616" y="2258568"/>
+            <a:ext cx="1481328" cy="205740"/>
+          </a:xfrm>
+          <a:prstGeom prst="rect">
+            <a:avLst/>
+          </a:prstGeom>
+          <a:noFill/>
+        </p:spPr>
+        <p:txBody>
+          <a:bodyPr wrap="square">
+            <a:spAutoFit/>
+          </a:bodyPr>
+          <a:lstStyle/>
+          <a:p>
+            <a:pPr algn="r"/>
+            <a:r>
+              <a:rPr sz="900" b="1" i="0">
+                <a:solidFill>
+                  <a:srgbClr val="FF6666"/>
+                </a:solidFill>
+                <a:latin typeface="Calibri"/>
+              </a:rPr>
+              <a:t>−$2,571,013</a:t>
+            </a:r>
+          </a:p>
+        </p:txBody>
+      </p:sp>
+      <p:sp>
+        <p:nvSpPr>
+          <p:cNvPr id="24" name="TextBox 23"/>
+          <p:cNvSpPr txBox="1"/>
+          <p:nvPr/>
+        </p:nvSpPr>
+        <p:spPr>
+          <a:xfrm>
+            <a:off x="219456" y="2482596"/>
+            <a:ext cx="2514600" cy="205740"/>
+          </a:xfrm>
+          <a:prstGeom prst="rect">
+            <a:avLst/>
+          </a:prstGeom>
+          <a:noFill/>
+        </p:spPr>
+        <p:txBody>
+          <a:bodyPr wrap="square">
+            <a:spAutoFit/>
+          </a:bodyPr>
+          <a:lstStyle/>
+          <a:p>
+            <a:pPr algn="l"/>
+            <a:r>
+              <a:rPr sz="800" b="0" i="0">
+                <a:solidFill>
+                  <a:srgbClr val="CCCCCC"/>
+                </a:solidFill>
+                <a:latin typeface="Calibri"/>
+              </a:rPr>
+              <a:t>Total equity (10/2/2026)</a:t>
+            </a:r>
+          </a:p>
+        </p:txBody>
+      </p:sp>
+      <p:sp>
+        <p:nvSpPr>
+          <p:cNvPr id="25" name="TextBox 24"/>
+          <p:cNvSpPr txBox="1"/>
+          <p:nvPr/>
+        </p:nvSpPr>
+        <p:spPr>
+          <a:xfrm>
+            <a:off x="2642616" y="2482596"/>
+            <a:ext cx="1481328" cy="205740"/>
+          </a:xfrm>
+          <a:prstGeom prst="rect">
+            <a:avLst/>
+          </a:prstGeom>
+          <a:noFill/>
+        </p:spPr>
+        <p:txBody>
+          <a:bodyPr wrap="square">
+            <a:spAutoFit/>
+          </a:bodyPr>
+          <a:lstStyle/>
+          <a:p>
+            <a:pPr algn="r"/>
+            <a:r>
+              <a:rPr sz="900" b="1" i="0">
+                <a:solidFill>
+                  <a:srgbClr val="FF6666"/>
+                </a:solidFill>
+                <a:latin typeface="Calibri"/>
+              </a:rPr>
+              <a:t>−$1,403,075</a:t>
+            </a:r>
+          </a:p>
+        </p:txBody>
+      </p:sp>
+      <p:sp>
+        <p:nvSpPr>
+          <p:cNvPr id="26" name="TextBox 25"/>
+          <p:cNvSpPr txBox="1"/>
+          <p:nvPr/>
+        </p:nvSpPr>
+        <p:spPr>
+          <a:xfrm>
+            <a:off x="4517136" y="914400"/>
+            <a:ext cx="2926080" cy="205740"/>
+          </a:xfrm>
+          <a:prstGeom prst="rect">
+            <a:avLst/>
+          </a:prstGeom>
+          <a:noFill/>
+        </p:spPr>
+        <p:txBody>
+          <a:bodyPr wrap="square">
+            <a:spAutoFit/>
+          </a:bodyPr>
+          <a:lstStyle/>
+          <a:p>
+            <a:pPr algn="l"/>
+            <a:r>
+              <a:rPr sz="800" b="0" i="0">
+                <a:solidFill>
+                  <a:srgbClr val="CCCCCC"/>
+                </a:solidFill>
+                <a:latin typeface="Calibri"/>
+              </a:rPr>
+              <a:t>Loans &amp; notes (total)</a:t>
+            </a:r>
+          </a:p>
+        </p:txBody>
+      </p:sp>
+      <p:sp>
+        <p:nvSpPr>
+          <p:cNvPr id="27" name="TextBox 26"/>
+          <p:cNvSpPr txBox="1"/>
+          <p:nvPr/>
+        </p:nvSpPr>
+        <p:spPr>
+          <a:xfrm>
+            <a:off x="7351775" y="914400"/>
+            <a:ext cx="1527047" cy="205740"/>
+          </a:xfrm>
+          <a:prstGeom prst="rect">
+            <a:avLst/>
+          </a:prstGeom>
+          <a:noFill/>
+        </p:spPr>
+        <p:txBody>
+          <a:bodyPr wrap="square">
+            <a:spAutoFit/>
+          </a:bodyPr>
+          <a:lstStyle/>
+          <a:p>
+            <a:pPr algn="r"/>
+            <a:r>
+              <a:rPr sz="1000" b="1" i="0">
+                <a:solidFill>
+                  <a:srgbClr val="FFFFFF"/>
+                </a:solidFill>
+                <a:latin typeface="Calibri"/>
+              </a:rPr>
+              <a:t>$1,027,783</a:t>
+            </a:r>
+          </a:p>
+        </p:txBody>
+      </p:sp>
+      <p:sp>
+        <p:nvSpPr>
+          <p:cNvPr id="28" name="Rectangle 27"/>
+          <p:cNvSpPr/>
+          <p:nvPr/>
+        </p:nvSpPr>
+        <p:spPr>
+          <a:xfrm>
+            <a:off x="4517136" y="1211580"/>
+            <a:ext cx="4389120" cy="13716"/>
+          </a:xfrm>
+          <a:prstGeom prst="rect">
+            <a:avLst/>
+          </a:prstGeom>
+          <a:solidFill>
+            <a:srgbClr val="888888"/>
+          </a:solidFill>
+          <a:ln>
+            <a:noFill/>
+          </a:ln>
+        </p:spPr>
+        <p:style>
+          <a:lnRef idx="1">
+            <a:schemeClr val="accent1"/>
+          </a:lnRef>
+          <a:fillRef idx="3">
+            <a:schemeClr val="accent1"/>
+          </a:fillRef>
+          <a:effectRef idx="2">
+            <a:schemeClr val="accent1"/>
+          </a:effectRef>
+          <a:fontRef idx="minor">
+            <a:schemeClr val="lt1"/>
+          </a:fontRef>
+        </p:style>
+        <p:txBody>
+          <a:bodyPr rtlCol="0" anchor="ctr"/>
+          <a:lstStyle/>
+          <a:p>
+            <a:pPr algn="ctr"/>
+          </a:p>
+        </p:txBody>
+      </p:sp>
+      <p:sp>
+        <p:nvSpPr>
+          <p:cNvPr id="29" name="TextBox 28"/>
+          <p:cNvSpPr txBox="1"/>
+          <p:nvPr/>
+        </p:nvSpPr>
+        <p:spPr>
+          <a:xfrm>
+            <a:off x="4517136" y="1362456"/>
+            <a:ext cx="2926080" cy="205740"/>
+          </a:xfrm>
+          <a:prstGeom prst="rect">
+            <a:avLst/>
+          </a:prstGeom>
+          <a:noFill/>
+        </p:spPr>
+        <p:txBody>
+          <a:bodyPr wrap="square">
+            <a:spAutoFit/>
+          </a:bodyPr>
+          <a:lstStyle/>
+          <a:p>
+            <a:pPr algn="l"/>
+            <a:r>
+              <a:rPr sz="800" b="0" i="0">
+                <a:solidFill>
+                  <a:srgbClr val="CCCCCC"/>
+                </a:solidFill>
+                <a:latin typeface="Calibri"/>
+              </a:rPr>
+              <a:t>Due to Microcosm (Acct 2385)</a:t>
+            </a:r>
+          </a:p>
+        </p:txBody>
+      </p:sp>
+      <p:sp>
+        <p:nvSpPr>
+          <p:cNvPr id="30" name="TextBox 29"/>
+          <p:cNvSpPr txBox="1"/>
+          <p:nvPr/>
+        </p:nvSpPr>
+        <p:spPr>
+          <a:xfrm>
+            <a:off x="7351775" y="1362456"/>
+            <a:ext cx="1527047" cy="205740"/>
+          </a:xfrm>
+          <a:prstGeom prst="rect">
+            <a:avLst/>
+          </a:prstGeom>
+          <a:noFill/>
+        </p:spPr>
+        <p:txBody>
+          <a:bodyPr wrap="square">
+            <a:spAutoFit/>
+          </a:bodyPr>
+          <a:lstStyle/>
+          <a:p>
+            <a:pPr algn="r"/>
+            <a:r>
+              <a:rPr sz="900" b="1" i="0">
+                <a:solidFill>
+                  <a:srgbClr val="FF6666"/>
+                </a:solidFill>
+                <a:latin typeface="Calibri"/>
+              </a:rPr>
+              <a:t>$451,429</a:t>
+            </a:r>
+          </a:p>
+        </p:txBody>
+      </p:sp>
+      <p:sp>
+        <p:nvSpPr>
+          <p:cNvPr id="31" name="TextBox 30"/>
+          <p:cNvSpPr txBox="1"/>
+          <p:nvPr/>
+        </p:nvSpPr>
+        <p:spPr>
+          <a:xfrm>
+            <a:off x="4517136" y="1586484"/>
+            <a:ext cx="2926080" cy="205740"/>
+          </a:xfrm>
+          <a:prstGeom prst="rect">
+            <a:avLst/>
+          </a:prstGeom>
+          <a:noFill/>
+        </p:spPr>
+        <p:txBody>
+          <a:bodyPr wrap="square">
+            <a:spAutoFit/>
+          </a:bodyPr>
+          <a:lstStyle/>
+          <a:p>
+            <a:pPr algn="l"/>
+            <a:r>
+              <a:rPr sz="800" b="0" i="0">
+                <a:solidFill>
+                  <a:srgbClr val="CCCCCC"/>
+                </a:solidFill>
+                <a:latin typeface="Calibri"/>
+              </a:rPr>
+              <a:t>Notes Payable – Bookstore</a:t>
+            </a:r>
+          </a:p>
+        </p:txBody>
+      </p:sp>
+      <p:sp>
+        <p:nvSpPr>
+          <p:cNvPr id="32" name="TextBox 31"/>
+          <p:cNvSpPr txBox="1"/>
+          <p:nvPr/>
+        </p:nvSpPr>
+        <p:spPr>
+          <a:xfrm>
+            <a:off x="7351775" y="1586484"/>
+            <a:ext cx="1527047" cy="205740"/>
+          </a:xfrm>
+          <a:prstGeom prst="rect">
+            <a:avLst/>
+          </a:prstGeom>
+          <a:noFill/>
+        </p:spPr>
+        <p:txBody>
+          <a:bodyPr wrap="square">
+            <a:spAutoFit/>
+          </a:bodyPr>
+          <a:lstStyle/>
+          <a:p>
+            <a:pPr algn="r"/>
+            <a:r>
+              <a:rPr sz="900" b="1" i="0">
+                <a:solidFill>
+                  <a:srgbClr val="FF6666"/>
+                </a:solidFill>
+                <a:latin typeface="Calibri"/>
+              </a:rPr>
+              <a:t>$320,582</a:t>
+            </a:r>
+          </a:p>
+        </p:txBody>
+      </p:sp>
+      <p:sp>
+        <p:nvSpPr>
+          <p:cNvPr id="33" name="TextBox 32"/>
+          <p:cNvSpPr txBox="1"/>
+          <p:nvPr/>
+        </p:nvSpPr>
+        <p:spPr>
+          <a:xfrm>
+            <a:off x="4517136" y="1810512"/>
+            <a:ext cx="2926080" cy="205740"/>
+          </a:xfrm>
+          <a:prstGeom prst="rect">
+            <a:avLst/>
+          </a:prstGeom>
+          <a:noFill/>
+        </p:spPr>
+        <p:txBody>
+          <a:bodyPr wrap="square">
+            <a:spAutoFit/>
+          </a:bodyPr>
+          <a:lstStyle/>
+          <a:p>
+            <a:pPr algn="l"/>
+            <a:r>
+              <a:rPr sz="800" b="0" i="0">
+                <a:solidFill>
+                  <a:srgbClr val="CCCCCC"/>
+                </a:solidFill>
+                <a:latin typeface="Calibri"/>
+              </a:rPr>
+              <a:t>SBA EIDL (Acct 2712)</a:t>
+            </a:r>
+          </a:p>
+        </p:txBody>
+      </p:sp>
+      <p:sp>
+        <p:nvSpPr>
+          <p:cNvPr id="34" name="TextBox 33"/>
+          <p:cNvSpPr txBox="1"/>
+          <p:nvPr/>
+        </p:nvSpPr>
+        <p:spPr>
+          <a:xfrm>
+            <a:off x="7351775" y="1810512"/>
+            <a:ext cx="1527047" cy="205740"/>
+          </a:xfrm>
+          <a:prstGeom prst="rect">
+            <a:avLst/>
+          </a:prstGeom>
+          <a:noFill/>
+        </p:spPr>
+        <p:txBody>
+          <a:bodyPr wrap="square">
+            <a:spAutoFit/>
+          </a:bodyPr>
+          <a:lstStyle/>
+          <a:p>
+            <a:pPr algn="r"/>
+            <a:r>
+              <a:rPr sz="900" b="1" i="0">
+                <a:solidFill>
+                  <a:srgbClr val="FF6666"/>
+                </a:solidFill>
+                <a:latin typeface="Calibri"/>
+              </a:rPr>
+              <a:t>$132,072</a:t>
+            </a:r>
+          </a:p>
+        </p:txBody>
+      </p:sp>
+      <p:sp>
+        <p:nvSpPr>
+          <p:cNvPr id="35" name="TextBox 34"/>
+          <p:cNvSpPr txBox="1"/>
+          <p:nvPr/>
+        </p:nvSpPr>
+        <p:spPr>
+          <a:xfrm>
+            <a:off x="4517136" y="2034540"/>
+            <a:ext cx="2926080" cy="205740"/>
+          </a:xfrm>
+          <a:prstGeom prst="rect">
+            <a:avLst/>
+          </a:prstGeom>
+          <a:noFill/>
+        </p:spPr>
+        <p:txBody>
+          <a:bodyPr wrap="square">
+            <a:spAutoFit/>
+          </a:bodyPr>
+          <a:lstStyle/>
+          <a:p>
+            <a:pPr algn="l"/>
+            <a:r>
+              <a:rPr sz="800" b="0" i="0">
+                <a:solidFill>
+                  <a:srgbClr val="CCCCCC"/>
+                </a:solidFill>
+                <a:latin typeface="Calibri"/>
+              </a:rPr>
+              <a:t>Wertz loan (Acct 2714)</a:t>
+            </a:r>
+          </a:p>
+        </p:txBody>
+      </p:sp>
+      <p:sp>
+        <p:nvSpPr>
+          <p:cNvPr id="36" name="TextBox 35"/>
+          <p:cNvSpPr txBox="1"/>
+          <p:nvPr/>
+        </p:nvSpPr>
+        <p:spPr>
+          <a:xfrm>
+            <a:off x="7351775" y="2034540"/>
+            <a:ext cx="1527047" cy="205740"/>
+          </a:xfrm>
+          <a:prstGeom prst="rect">
+            <a:avLst/>
+          </a:prstGeom>
+          <a:noFill/>
+        </p:spPr>
+        <p:txBody>
+          <a:bodyPr wrap="square">
+            <a:spAutoFit/>
+          </a:bodyPr>
+          <a:lstStyle/>
+          <a:p>
+            <a:pPr algn="r"/>
+            <a:r>
+              <a:rPr sz="900" b="1" i="0">
+                <a:solidFill>
+                  <a:srgbClr val="FF6666"/>
+                </a:solidFill>
+                <a:latin typeface="Calibri"/>
+              </a:rPr>
+              <a:t>$92,500</a:t>
+            </a:r>
+          </a:p>
+        </p:txBody>
+      </p:sp>
+      <p:sp>
+        <p:nvSpPr>
+          <p:cNvPr id="37" name="TextBox 36"/>
+          <p:cNvSpPr txBox="1"/>
+          <p:nvPr/>
+        </p:nvSpPr>
+        <p:spPr>
+          <a:xfrm>
+            <a:off x="4517136" y="2258568"/>
+            <a:ext cx="2926080" cy="205740"/>
+          </a:xfrm>
+          <a:prstGeom prst="rect">
+            <a:avLst/>
+          </a:prstGeom>
+          <a:noFill/>
+        </p:spPr>
+        <p:txBody>
+          <a:bodyPr wrap="square">
+            <a:spAutoFit/>
+          </a:bodyPr>
+          <a:lstStyle/>
+          <a:p>
+            <a:pPr algn="l"/>
+            <a:r>
+              <a:rPr sz="800" b="0" i="0">
+                <a:solidFill>
+                  <a:srgbClr val="CCCCCC"/>
+                </a:solidFill>
+                <a:latin typeface="Calibri"/>
+              </a:rPr>
+              <a:t>Exos loan (11%, Acct 2720)</a:t>
+            </a:r>
+          </a:p>
+        </p:txBody>
+      </p:sp>
+      <p:sp>
+        <p:nvSpPr>
+          <p:cNvPr id="38" name="TextBox 37"/>
+          <p:cNvSpPr txBox="1"/>
+          <p:nvPr/>
+        </p:nvSpPr>
+        <p:spPr>
+          <a:xfrm>
+            <a:off x="7351775" y="2258568"/>
+            <a:ext cx="1527047" cy="205740"/>
+          </a:xfrm>
+          <a:prstGeom prst="rect">
+            <a:avLst/>
+          </a:prstGeom>
+          <a:noFill/>
+        </p:spPr>
+        <p:txBody>
+          <a:bodyPr wrap="square">
+            <a:spAutoFit/>
+          </a:bodyPr>
+          <a:lstStyle/>
+          <a:p>
+            <a:pPr algn="r"/>
+            <a:r>
+              <a:rPr sz="900" b="1" i="0">
+                <a:solidFill>
+                  <a:srgbClr val="F26A21"/>
+                </a:solidFill>
+                <a:latin typeface="Calibri"/>
+              </a:rPr>
+              <a:t>$31,200</a:t>
+            </a:r>
+          </a:p>
+        </p:txBody>
+      </p:sp>
+      <p:sp>
+        <p:nvSpPr>
+          <p:cNvPr id="39" name="Rectangle 38"/>
+          <p:cNvSpPr/>
+          <p:nvPr/>
+        </p:nvSpPr>
+        <p:spPr>
+          <a:xfrm>
+            <a:off x="4517136" y="2555748"/>
+            <a:ext cx="4389120" cy="13716"/>
+          </a:xfrm>
+          <a:prstGeom prst="rect">
+            <a:avLst/>
+          </a:prstGeom>
+          <a:solidFill>
+            <a:srgbClr val="888888"/>
+          </a:solidFill>
+          <a:ln>
+            <a:noFill/>
+          </a:ln>
+        </p:spPr>
+        <p:style>
+          <a:lnRef idx="1">
+            <a:schemeClr val="accent1"/>
+          </a:lnRef>
+          <a:fillRef idx="3">
+            <a:schemeClr val="accent1"/>
+          </a:fillRef>
+          <a:effectRef idx="2">
+            <a:schemeClr val="accent1"/>
+          </a:effectRef>
+          <a:fontRef idx="minor">
+            <a:schemeClr val="lt1"/>
+          </a:fontRef>
+        </p:style>
+        <p:txBody>
+          <a:bodyPr rtlCol="0" anchor="ctr"/>
+          <a:lstStyle/>
+          <a:p>
+            <a:pPr algn="ctr"/>
+          </a:p>
+        </p:txBody>
+      </p:sp>
+      <p:sp>
+        <p:nvSpPr>
+          <p:cNvPr id="40" name="TextBox 39"/>
+          <p:cNvSpPr txBox="1"/>
+          <p:nvPr/>
+        </p:nvSpPr>
+        <p:spPr>
+          <a:xfrm>
+            <a:off x="4517136" y="2482596"/>
+            <a:ext cx="2926080" cy="205740"/>
+          </a:xfrm>
+          <a:prstGeom prst="rect">
+            <a:avLst/>
+          </a:prstGeom>
+          <a:noFill/>
+        </p:spPr>
+        <p:txBody>
+          <a:bodyPr wrap="square">
+            <a:spAutoFit/>
+          </a:bodyPr>
+          <a:lstStyle/>
+          <a:p>
+            <a:pPr algn="l"/>
+            <a:r>
+              <a:rPr sz="800" b="0" i="0">
+                <a:solidFill>
+                  <a:srgbClr val="CCCCCC"/>
+                </a:solidFill>
+                <a:latin typeface="Calibri"/>
+              </a:rPr>
+              <a:t>Total liabilities (10/2)</a:t>
+            </a:r>
+          </a:p>
+        </p:txBody>
+      </p:sp>
+      <p:sp>
+        <p:nvSpPr>
+          <p:cNvPr id="41" name="TextBox 40"/>
+          <p:cNvSpPr txBox="1"/>
+          <p:nvPr/>
+        </p:nvSpPr>
+        <p:spPr>
+          <a:xfrm>
+            <a:off x="7351775" y="2482596"/>
+            <a:ext cx="1527047" cy="205740"/>
+          </a:xfrm>
+          <a:prstGeom prst="rect">
+            <a:avLst/>
+          </a:prstGeom>
+          <a:noFill/>
+        </p:spPr>
+        <p:txBody>
+          <a:bodyPr wrap="square">
+            <a:spAutoFit/>
+          </a:bodyPr>
+          <a:lstStyle/>
+          <a:p>
+            <a:pPr algn="r"/>
+            <a:r>
+              <a:rPr sz="900" b="1" i="0">
+                <a:solidFill>
+                  <a:srgbClr val="FF6666"/>
+                </a:solidFill>
+                <a:latin typeface="Calibri"/>
+              </a:rPr>
+              <a:t>$1,275,622</a:t>
+            </a:r>
+          </a:p>
+        </p:txBody>
+      </p:sp>
+      <p:sp>
+        <p:nvSpPr>
+          <p:cNvPr id="42" name="Rectangle 41"/>
+          <p:cNvSpPr/>
+          <p:nvPr/>
+        </p:nvSpPr>
+        <p:spPr>
+          <a:xfrm>
+            <a:off x="109728" y="3643884"/>
+            <a:ext cx="8924544" cy="749808"/>
+          </a:xfrm>
+          <a:prstGeom prst="rect">
+            <a:avLst/>
+          </a:prstGeom>
+          <a:solidFill>
+            <a:srgbClr val="1E1400"/>
+          </a:solidFill>
+          <a:ln>
+            <a:noFill/>
+          </a:ln>
+        </p:spPr>
+        <p:style>
+          <a:lnRef idx="1">
+            <a:schemeClr val="accent1"/>
+          </a:lnRef>
+          <a:fillRef idx="3">
+            <a:schemeClr val="accent1"/>
+          </a:fillRef>
+          <a:effectRef idx="2">
+            <a:schemeClr val="accent1"/>
+          </a:effectRef>
+          <a:fontRef idx="minor">
+            <a:schemeClr val="lt1"/>
+          </a:fontRef>
+        </p:style>
+        <p:txBody>
+          <a:bodyPr rtlCol="0" anchor="ctr"/>
+          <a:lstStyle/>
+          <a:p>
+            <a:pPr algn="ctr"/>
+          </a:p>
+        </p:txBody>
+      </p:sp>
+      <p:sp>
+        <p:nvSpPr>
+          <p:cNvPr id="43" name="Rectangle 42"/>
+          <p:cNvSpPr/>
+          <p:nvPr/>
+        </p:nvSpPr>
+        <p:spPr>
+          <a:xfrm>
+            <a:off x="109728" y="3643884"/>
+            <a:ext cx="50292" cy="749808"/>
+          </a:xfrm>
+          <a:prstGeom prst="rect">
+            <a:avLst/>
+          </a:prstGeom>
+          <a:solidFill>
+            <a:srgbClr val="F26A21"/>
+          </a:solidFill>
+          <a:ln>
+            <a:noFill/>
+          </a:ln>
+        </p:spPr>
+        <p:style>
+          <a:lnRef idx="1">
+            <a:schemeClr val="accent1"/>
+          </a:lnRef>
+          <a:fillRef idx="3">
+            <a:schemeClr val="accent1"/>
+          </a:fillRef>
+          <a:effectRef idx="2">
+            <a:schemeClr val="accent1"/>
+          </a:effectRef>
+          <a:fontRef idx="minor">
+            <a:schemeClr val="lt1"/>
+          </a:fontRef>
+        </p:style>
+        <p:txBody>
+          <a:bodyPr rtlCol="0" anchor="ctr"/>
+          <a:lstStyle/>
+          <a:p>
+            <a:pPr algn="ctr"/>
+          </a:p>
+        </p:txBody>
+      </p:sp>
+      <p:sp>
+        <p:nvSpPr>
+          <p:cNvPr id="44" name="TextBox 43"/>
+          <p:cNvSpPr txBox="1"/>
+          <p:nvPr/>
+        </p:nvSpPr>
+        <p:spPr>
+          <a:xfrm>
+            <a:off x="219456" y="3680459"/>
+            <a:ext cx="8686800" cy="173736"/>
+          </a:xfrm>
+          <a:prstGeom prst="rect">
+            <a:avLst/>
+          </a:prstGeom>
+          <a:noFill/>
+        </p:spPr>
+        <p:txBody>
+          <a:bodyPr wrap="square">
+            <a:spAutoFit/>
+          </a:bodyPr>
+          <a:lstStyle/>
+          <a:p>
+            <a:pPr algn="l"/>
+            <a:r>
+              <a:rPr sz="800" b="1" i="0">
+                <a:solidFill>
+                  <a:srgbClr val="F26A21"/>
+                </a:solidFill>
+                <a:latin typeface="Calibri"/>
+              </a:rPr>
+              <a:t>UNBOOKED OFFSET  (illustrative — no written cost-sharing agreement on file)</a:t>
+            </a:r>
+          </a:p>
+        </p:txBody>
+      </p:sp>
+      <p:sp>
+        <p:nvSpPr>
+          <p:cNvPr id="45" name="TextBox 44"/>
+          <p:cNvSpPr txBox="1"/>
+          <p:nvPr/>
+        </p:nvSpPr>
+        <p:spPr>
+          <a:xfrm>
+            <a:off x="219456" y="3890772"/>
+            <a:ext cx="8686800" cy="457200"/>
+          </a:xfrm>
+          <a:prstGeom prst="rect">
+            <a:avLst/>
+          </a:prstGeom>
+          <a:noFill/>
+        </p:spPr>
+        <p:txBody>
+          <a:bodyPr wrap="square">
+            <a:spAutoFit/>
+          </a:bodyPr>
+          <a:lstStyle/>
+          <a:p>
+            <a:pPr algn="l"/>
+            <a:r>
+              <a:rPr sz="750" b="0" i="0">
+                <a:solidFill>
+                  <a:srgbClr val="CCCCCC"/>
+                </a:solidFill>
+                <a:latin typeface="Calibri"/>
+              </a:rPr>
+              <a:t>SSLC has paid ~100% of shared Torrance facility costs: ~$354K in FY26 (rent $294K + utilities $31K + other), ~$967K est. Jan 2024–Oct 2026.  At a 50% Microcosm share (illustrative) → ~$483K offsets $451K due to Microcosm = SSLC net creditor ~$32K.  "$864K 'billed-ahead' balance disputed; under review (full QuickBooks access requested)."</a:t>
+            </a:r>
+          </a:p>
+        </p:txBody>
+      </p:sp>
+      <p:sp>
+        <p:nvSpPr>
+          <p:cNvPr id="46" name="TextBox 45"/>
+          <p:cNvSpPr txBox="1"/>
+          <p:nvPr/>
+        </p:nvSpPr>
+        <p:spPr>
+          <a:xfrm>
+            <a:off x="228600" y="4416552"/>
+            <a:ext cx="8229600" cy="155448"/>
+          </a:xfrm>
+          <a:prstGeom prst="rect">
+            <a:avLst/>
+          </a:prstGeom>
+          <a:noFill/>
+        </p:spPr>
+        <p:txBody>
+          <a:bodyPr wrap="square">
+            <a:spAutoFit/>
+          </a:bodyPr>
+          <a:lstStyle/>
+          <a:p>
+            <a:pPr algn="l"/>
+            <a:r>
+              <a:rPr sz="700" b="0" i="1">
+                <a:solidFill>
+                  <a:srgbClr val="888888"/>
+                </a:solidFill>
+                <a:latin typeface="Calibri"/>
+              </a:rPr>
+              <a:t>per SSLC QuickBooks 8/21 and 10/2/2026; Microcosm offset illustrative</a:t>
+            </a:r>
+          </a:p>
+        </p:txBody>
+      </p:sp>
+      <p:sp>
+        <p:nvSpPr>
+          <p:cNvPr id="47" name="TextBox 46"/>
+          <p:cNvSpPr txBox="1"/>
+          <p:nvPr/>
+        </p:nvSpPr>
+        <p:spPr>
+          <a:xfrm>
+            <a:off x="1554480" y="4809744"/>
+            <a:ext cx="6035040" cy="201168"/>
+          </a:xfrm>
+          <a:prstGeom prst="rect">
+            <a:avLst/>
+          </a:prstGeom>
+          <a:noFill/>
+        </p:spPr>
+        <p:txBody>
+          <a:bodyPr wrap="square">
+            <a:spAutoFit/>
+          </a:bodyPr>
+          <a:lstStyle/>
+          <a:p>
+            <a:pPr algn="ctr"/>
+            <a:r>
+              <a:rPr sz="700" b="0" i="1">
+                <a:solidFill>
+                  <a:srgbClr val="888888"/>
+                </a:solidFill>
+                <a:latin typeface="Calibri"/>
+              </a:rPr>
+              <a:t>DRAFT — NEGOTIATING TERMS</a:t>
+            </a:r>
+          </a:p>
+        </p:txBody>
+      </p:sp>
+      <p:sp>
+        <p:nvSpPr>
+          <p:cNvPr id="48" name="TextBox 47"/>
+          <p:cNvSpPr txBox="1"/>
+          <p:nvPr/>
+        </p:nvSpPr>
+        <p:spPr>
+          <a:xfrm>
+            <a:off x="7772400" y="4809744"/>
+            <a:ext cx="1143000" cy="201168"/>
+          </a:xfrm>
+          <a:prstGeom prst="rect">
+            <a:avLst/>
+          </a:prstGeom>
+          <a:noFill/>
+        </p:spPr>
+        <p:txBody>
+          <a:bodyPr wrap="square">
+            <a:spAutoFit/>
+          </a:bodyPr>
+          <a:lstStyle/>
+          <a:p>
+            <a:pPr algn="r"/>
+            <a:r>
+              <a:rPr sz="700" b="0" i="1">
+                <a:solidFill>
+                  <a:srgbClr val="888888"/>
+                </a:solidFill>
+                <a:latin typeface="Calibri"/>
+              </a:rPr>
+              <a:t>CONFIDENTIAL</a:t>
+            </a:r>
           </a:p>
         </p:txBody>
       </p:sp>

</xml_diff>

<commit_message>
deck r2: Motion 2 deadline Oct 15; rebuild board package
Slide 11 Motion 2: added 'Access to be granted no later than
October 15, 2026.' in orange bold below the NDA line.

Board package rebuilt with current QB access letter
(DRAFT banner stripped; Oct 15 deadline text per updated letter).

MC task #2414 | John Quinn 2026-10-10
</commit_message>
<xml_diff>
--- a/drafts/Exos_SSLC_Board_Offer_Overview_2026-10-10_r2.pptx
+++ b/drafts/Exos_SSLC_Board_Offer_Overview_2026-10-10_r2.pptx
@@ -3839,6 +3839,17 @@
               <a:t>confirmatory diligence.  Confidential under the 7/27/2021 NDA.</a:t>
             </a:r>
           </a:p>
+          <a:p>
+            <a:r>
+              <a:rPr lang="en-US" sz="800" b="1" dirty="0">
+                <a:solidFill>
+                  <a:srgbClr val="F26A21"/>
+                </a:solidFill>
+                <a:latin typeface="Calibri"/>
+              </a:rPr>
+              <a:t>Access to be granted no later than October 15, 2026.</a:t>
+            </a:r>
+          </a:p>
         </p:txBody>
       </p:sp>
       <p:sp>

</xml_diff>

<commit_message>
SSLC board package: add Motion 3 (AR Unbilled correction), renumber ERP→Motion 4, four-motions everywhere, QB letter sentence, cover rebuild
- Slide 11: insert Motion 3 (direct A La Carte + Singer Lewak / Welch & Co. to reconcile Acct 1110 AR Unbilled $942K + Acct 2380 Deposits $120K within 5 days, tank-by-tank recon IM-109/122/134 EXOS-133 + corrected BS to all directors); renumber ERP/MRP consent → Motion 4
- Slides 2 + 12: 'three motions' → 'four motions'; Motion 1–4 listed in detail box; 'Motions 1–3' → '1–4'
- QB access letter: add sentence re: Board directing accounting firm to correct accounts within 5 days
- Board package cover: updated contents description to reference four motions
- Board package (v4): cover + 12-slide deck + offer summary + clean QB letter (17pp)
- Grep validation: zero banned strings (198K / 198419 / cancel / 864062 / 864K / 'three motions' / 'Motions 1–3')
</commit_message>
<xml_diff>
--- a/drafts/Exos_SSLC_Board_Offer_Overview_2026-10-10_r2.pptx
+++ b/drafts/Exos_SSLC_Board_Offer_Overview_2026-10-10_r2.pptx
@@ -600,7 +600,7 @@
           <a:lstStyle/>
           <a:p>
             <a:r>
-              <a:t>The three actions needed today: (1) confirm §3 exclusivity — starts the 90-day window; (2) grant full read-only QB access for reconciliation of the $864K balance and facility costs; (3) consent to ERP/inventory evaluation using the same data. All confidential under the 7/27/2021 NDA. Once Motion 1 is confirmed, the 90-day exclusivity period begins. Financing close target: Feb 15th.</a:t>
+              <a:t>Four actions needed today: (1) confirm §3 exclusivity — starts 90-day window; (2) grant full read-only QB access (Oct 15 deadline); (3) direct accounting firm to correct AR Unbilled + Deposits within 5 days; (4) consent to ERP/MRP evaluation. All confidential under the 7/27/2021 NDA. Financing close target: Feb 15th.</a:t>
             </a:r>
             <a:endParaRPr lang="en-US" dirty="0"/>
           </a:p>
@@ -793,27 +793,32 @@
           <a:lstStyle/>
           <a:p>
             <a:r>
-              <a:t>Three separate motions for the SSLC Board:</a:t>
+              <a:t>Four motions for the SSLC Board:</a:t>
             </a:r>
             <a:br/>
             <a:br/>
             <a:r>
-              <a:t>Motion 1: §3 exclusivity confirmation under May 2025 Asset Acquisition Agreement. 90-day period begins on board approval; extension not unreasonably withheld. This is the gate for diligence, definitive agreement, and financing close.</a:t>
+              <a:t>Motion 1: §3 exclusivity — 90-day period begins on board approval (May 2025 AAA).</a:t>
             </a:r>
             <a:br/>
             <a:br/>
             <a:r>
-              <a:t>Motion 2: Full read-only QB Online access — accountant or all-access user — for John Quinn and one Exos finance reviewer. Legal basis: Cal. Corp. Code §1602 (director inspection right) + AAA §4 confirmatory diligence. Confidential under the 7/27/2021 NDA. Purpose: reconcile the $864K 'billed-ahead' balance (FY27 Q1 QB) and verify the shared Microcosm facility-cost offset before close.</a:t>
+              <a:t>Motion 2: Full read-only QB Online access for John Quinn + one Exos finance reviewer. Cal. Corp. Code §1602 + AAA §4. NDA-confidential. Oct 15, 2026 deadline.</a:t>
             </a:r>
             <a:br/>
             <a:br/>
             <a:r>
-              <a:t>Motion 3 (separate): Consent to Exos using the same QB data to evaluate its ERP/MRP and inventory systems for the combined operation. Evaluation only — no obligation to implement. Confidential under the NDA.</a:t>
+              <a:t>Motion 3: Direct A La Carte Solutions (bookkeeper) + Singer Lewak / Welch &amp; Co. to reconcile and correct Acct 1110 AR Unbilled ($942,177) and Acct 2380 Deposits ($120,000) within 5 days. Must clear completed/shipped tank billings, post missing Jul–Sep 2026 revenue-recognition entries, tank-by-tank reconciliation (IM-109/122/134, EXOS-133), corrected balance sheet delivered to all directors.</a:t>
             </a:r>
             <a:br/>
             <a:br/>
             <a:r>
-              <a:t>Governance: John Quinn is an interested director (Exos is the offeror and Quinn holds an Exos loan to SSLC). He abstains on all three motions; each is decided by the disinterested directors.</a:t>
+              <a:t>Motion 4 (separate): Consent to Exos using QB data to evaluate ERP/MRP and inventory systems for combined operation. Evaluation only; NDA-confidential.</a:t>
+            </a:r>
+            <a:br/>
+            <a:br/>
+            <a:r>
+              <a:t>Governance: John Quinn abstains as interested director (Exos is offeror; Quinn holds Exos loan to SSLC).</a:t>
             </a:r>
           </a:p>
         </p:txBody>
@@ -883,23 +888,27 @@
           <a:lstStyle/>
           <a:p>
             <a:r>
-              <a:t>The three actions requested of the SSLC board at this meeting:</a:t>
+              <a:t>Four actions requested of the SSLC board:</a:t>
             </a:r>
             <a:br/>
             <a:r>
-              <a:t>  Motion 1: Confirm §3 exclusivity under the May 2025 Asset Acquisition Agreement. 90-day period begins on approval.</a:t>
+              <a:t>  Motion 1: Confirm §3 exclusivity. 90-day period begins on approval.</a:t>
             </a:r>
             <a:br/>
             <a:r>
-              <a:t>  Motion 2: Grant full read-only QuickBooks Online access to John Quinn and Exos's finance reviewer to reconcile the $864K 'billed-ahead' balance and shared-facility costs. Basis: Cal. Corp. Code §1602 inspection right + AAA confirmatory diligence. Confidential under the 7/27/2021 NDA.</a:t>
+              <a:t>  Motion 2: Grant full read-only QB Online access (Oct 15 deadline). §1602 + AAA §4. NDA.</a:t>
             </a:r>
             <a:br/>
             <a:r>
-              <a:t>  Motion 3: Consent to Exos using the same QB data to evaluate its in-house ERP/MRP and inventory systems for the combined operation. Confidential under the NDA.</a:t>
+              <a:t>  Motion 3: Direct A La Carte Solutions + outside CPAs to reconcile and correct AR Unbilled ($942K) and Deposits ($120K) within 5 days.</a:t>
             </a:r>
             <a:br/>
             <a:r>
-              <a:t>Governance: John Quinn abstains on all motions as an interested director.</a:t>
+              <a:t>  Motion 4: Consent to ERP/MRP &amp; inventory evaluation using QB data. NDA.</a:t>
+            </a:r>
+            <a:br/>
+            <a:r>
+              <a:t>Governance: John Quinn abstains as interested director.</a:t>
             </a:r>
             <a:endParaRPr lang="en-US" dirty="0"/>
           </a:p>
@@ -3305,7 +3314,7 @@
         <p:spPr>
           <a:xfrm>
             <a:off x="228600" y="457200"/>
-            <a:ext cx="1371600" cy="36576"/>
+            <a:ext cx="1371600" cy="32004"/>
           </a:xfrm>
           <a:prstGeom prst="rect">
             <a:avLst/>
@@ -3347,8 +3356,8 @@
         </p:nvSpPr>
         <p:spPr>
           <a:xfrm>
-            <a:off x="182880" y="530352"/>
-            <a:ext cx="8778240" cy="1261872"/>
+            <a:off x="182880" y="512064"/>
+            <a:ext cx="8778240" cy="896112"/>
           </a:xfrm>
           <a:prstGeom prst="rect">
             <a:avLst/>
@@ -3390,8 +3399,8 @@
         </p:nvSpPr>
         <p:spPr>
           <a:xfrm>
-            <a:off x="182880" y="530352"/>
-            <a:ext cx="50292" cy="1261872"/>
+            <a:off x="182880" y="512064"/>
+            <a:ext cx="50292" cy="896112"/>
           </a:xfrm>
           <a:prstGeom prst="rect">
             <a:avLst/>
@@ -3427,216 +3436,20 @@
       </p:sp>
       <p:sp>
         <p:nvSpPr>
-          <p:cNvPr id="7" name="TextBox 6"/>
-          <p:cNvSpPr txBox="1"/>
-          <p:nvPr/>
-        </p:nvSpPr>
-        <p:spPr>
-          <a:xfrm>
-            <a:off x="274320" y="603503"/>
-            <a:ext cx="457200" cy="457200"/>
-          </a:xfrm>
-          <a:prstGeom prst="rect">
-            <a:avLst/>
-          </a:prstGeom>
-          <a:noFill/>
-        </p:spPr>
-        <p:txBody>
-          <a:bodyPr wrap="square">
-            <a:spAutoFit/>
-          </a:bodyPr>
-          <a:lstStyle/>
-          <a:p>
-            <a:pPr algn="l"/>
-            <a:r>
-              <a:rPr sz="2600" b="1" i="0">
-                <a:solidFill>
-                  <a:srgbClr val="F26A21"/>
-                </a:solidFill>
-                <a:latin typeface="Cambria"/>
-              </a:rPr>
-              <a:t>1</a:t>
-            </a:r>
-          </a:p>
-        </p:txBody>
-      </p:sp>
-      <p:sp>
-        <p:nvSpPr>
-          <p:cNvPr id="8" name="TextBox 7"/>
-          <p:cNvSpPr txBox="1"/>
-          <p:nvPr/>
-        </p:nvSpPr>
-        <p:spPr>
-          <a:xfrm>
-            <a:off x="804672" y="612647"/>
-            <a:ext cx="6583680" cy="274320"/>
-          </a:xfrm>
-          <a:prstGeom prst="rect">
-            <a:avLst/>
-          </a:prstGeom>
-          <a:noFill/>
-        </p:spPr>
-        <p:txBody>
-          <a:bodyPr wrap="square">
-            <a:spAutoFit/>
-          </a:bodyPr>
-          <a:lstStyle/>
-          <a:p>
-            <a:pPr algn="l"/>
-            <a:r>
-              <a:rPr sz="1100" b="1" i="0">
-                <a:solidFill>
-                  <a:srgbClr val="FFFFFF"/>
-                </a:solidFill>
-                <a:latin typeface="Calibri"/>
-              </a:rPr>
-              <a:t>Confirm §3 Exclusivity (May 2025 Asset Acquisition Agreement)</a:t>
-            </a:r>
-          </a:p>
-        </p:txBody>
-      </p:sp>
-      <p:sp>
-        <p:nvSpPr>
-          <p:cNvPr id="9" name="TextBox 8"/>
-          <p:cNvSpPr txBox="1"/>
-          <p:nvPr/>
-        </p:nvSpPr>
-        <p:spPr>
-          <a:xfrm>
-            <a:off x="804672" y="914400"/>
-            <a:ext cx="6217920" cy="786383"/>
-          </a:xfrm>
-          <a:prstGeom prst="rect">
-            <a:avLst/>
-          </a:prstGeom>
-          <a:noFill/>
-        </p:spPr>
-        <p:txBody>
-          <a:bodyPr wrap="square">
-            <a:spAutoFit/>
-          </a:bodyPr>
-          <a:lstStyle/>
-          <a:p>
-            <a:r>
-              <a:rPr sz="800">
-                <a:solidFill>
-                  <a:srgbClr val="CCCCCC"/>
-                </a:solidFill>
-                <a:latin typeface="Calibri"/>
-              </a:rPr>
-              <a:t>Approve a 90-day exclusivity period beginning on the date of this approval.</a:t>
-            </a:r>
-          </a:p>
-          <a:p>
-            <a:r>
-              <a:rPr sz="800">
-                <a:solidFill>
-                  <a:srgbClr val="CCCCCC"/>
-                </a:solidFill>
-                <a:latin typeface="Calibri"/>
-              </a:rPr>
-              <a:t>Extension not unreasonably withheld (per §3). Allows both parties to proceed to</a:t>
-            </a:r>
-          </a:p>
-          <a:p>
-            <a:r>
-              <a:rPr sz="800">
-                <a:solidFill>
-                  <a:srgbClr val="CCCCCC"/>
-                </a:solidFill>
-                <a:latin typeface="Calibri"/>
-              </a:rPr>
-              <a:t>diligence, definitive agreement, and financing close (target: Feb 15th, 2027).</a:t>
-            </a:r>
-          </a:p>
-        </p:txBody>
-      </p:sp>
-      <p:sp>
-        <p:nvSpPr>
-          <p:cNvPr id="10" name="TextBox 9"/>
-          <p:cNvSpPr txBox="1"/>
-          <p:nvPr/>
-        </p:nvSpPr>
-        <p:spPr>
-          <a:xfrm>
-            <a:off x="7452359" y="713232"/>
-            <a:ext cx="1371600" cy="256032"/>
-          </a:xfrm>
-          <a:prstGeom prst="rect">
-            <a:avLst/>
-          </a:prstGeom>
-          <a:noFill/>
-        </p:spPr>
-        <p:txBody>
-          <a:bodyPr wrap="square">
-            <a:spAutoFit/>
-          </a:bodyPr>
-          <a:lstStyle/>
-          <a:p>
-            <a:pPr algn="l"/>
-            <a:r>
-              <a:rPr sz="900" b="0" i="0">
-                <a:solidFill>
-                  <a:srgbClr val="44BB44"/>
-                </a:solidFill>
-                <a:latin typeface="Calibri"/>
-              </a:rPr>
-              <a:t>☐  Approve</a:t>
-            </a:r>
-          </a:p>
-        </p:txBody>
-      </p:sp>
-      <p:sp>
-        <p:nvSpPr>
-          <p:cNvPr id="11" name="TextBox 10"/>
-          <p:cNvSpPr txBox="1"/>
-          <p:nvPr/>
-        </p:nvSpPr>
-        <p:spPr>
-          <a:xfrm>
-            <a:off x="7452359" y="969264"/>
-            <a:ext cx="1371600" cy="256032"/>
-          </a:xfrm>
-          <a:prstGeom prst="rect">
-            <a:avLst/>
-          </a:prstGeom>
-          <a:noFill/>
-        </p:spPr>
-        <p:txBody>
-          <a:bodyPr wrap="square">
-            <a:spAutoFit/>
-          </a:bodyPr>
-          <a:lstStyle/>
-          <a:p>
-            <a:pPr algn="l"/>
-            <a:r>
-              <a:rPr sz="900" b="0" i="0">
-                <a:solidFill>
-                  <a:srgbClr val="FF6666"/>
-                </a:solidFill>
-                <a:latin typeface="Calibri"/>
-              </a:rPr>
-              <a:t>☐  Decline</a:t>
-            </a:r>
-          </a:p>
-        </p:txBody>
-      </p:sp>
-      <p:sp>
-        <p:nvSpPr>
-          <p:cNvPr id="12" name="Rectangle 11"/>
+          <p:cNvPr id="7" name="Rectangle 6"/>
           <p:cNvSpPr/>
           <p:nvPr/>
         </p:nvSpPr>
         <p:spPr>
           <a:xfrm>
-            <a:off x="182880" y="1847088"/>
-            <a:ext cx="8778240" cy="1261872"/>
-          </a:xfrm>
-          <a:prstGeom prst="rect">
-            <a:avLst/>
-          </a:prstGeom>
-          <a:solidFill>
-            <a:srgbClr val="1E1E1E"/>
+            <a:off x="182880" y="512064"/>
+            <a:ext cx="8778240" cy="233172"/>
+          </a:xfrm>
+          <a:prstGeom prst="rect">
+            <a:avLst/>
+          </a:prstGeom>
+          <a:solidFill>
+            <a:srgbClr val="1A1A1A"/>
           </a:solidFill>
           <a:ln>
             <a:noFill/>
@@ -3666,14 +3479,14 @@
       </p:sp>
       <p:sp>
         <p:nvSpPr>
-          <p:cNvPr id="13" name="Rectangle 12"/>
+          <p:cNvPr id="8" name="Rectangle 7"/>
           <p:cNvSpPr/>
           <p:nvPr/>
         </p:nvSpPr>
         <p:spPr>
           <a:xfrm>
-            <a:off x="182880" y="1847088"/>
-            <a:ext cx="50292" cy="1261872"/>
+            <a:off x="182880" y="512064"/>
+            <a:ext cx="50292" cy="233172"/>
           </a:xfrm>
           <a:prstGeom prst="rect">
             <a:avLst/>
@@ -3709,14 +3522,14 @@
       </p:sp>
       <p:sp>
         <p:nvSpPr>
-          <p:cNvPr id="14" name="TextBox 13"/>
-          <p:cNvSpPr txBox="1"/>
-          <p:nvPr/>
-        </p:nvSpPr>
-        <p:spPr>
-          <a:xfrm>
-            <a:off x="274320" y="1920240"/>
-            <a:ext cx="457200" cy="457200"/>
+          <p:cNvPr id="9" name="TextBox 8"/>
+          <p:cNvSpPr txBox="1"/>
+          <p:nvPr/>
+        </p:nvSpPr>
+        <p:spPr>
+          <a:xfrm>
+            <a:off x="265176" y="539496"/>
+            <a:ext cx="411480" cy="196596"/>
           </a:xfrm>
           <a:prstGeom prst="rect">
             <a:avLst/>
@@ -3731,27 +3544,27 @@
           <a:p>
             <a:pPr algn="l"/>
             <a:r>
-              <a:rPr sz="2600" b="1" i="0">
+              <a:rPr sz="2200" b="1" i="0">
                 <a:solidFill>
                   <a:srgbClr val="F26A21"/>
                 </a:solidFill>
                 <a:latin typeface="Cambria"/>
               </a:rPr>
-              <a:t>2</a:t>
-            </a:r>
-          </a:p>
-        </p:txBody>
-      </p:sp>
-      <p:sp>
-        <p:nvSpPr>
-          <p:cNvPr id="15" name="TextBox 14"/>
-          <p:cNvSpPr txBox="1"/>
-          <p:nvPr/>
-        </p:nvSpPr>
-        <p:spPr>
-          <a:xfrm>
-            <a:off x="804672" y="1929384"/>
-            <a:ext cx="6583680" cy="274320"/>
+              <a:t>1</a:t>
+            </a:r>
+          </a:p>
+        </p:txBody>
+      </p:sp>
+      <p:sp>
+        <p:nvSpPr>
+          <p:cNvPr id="10" name="TextBox 9"/>
+          <p:cNvSpPr txBox="1"/>
+          <p:nvPr/>
+        </p:nvSpPr>
+        <p:spPr>
+          <a:xfrm>
+            <a:off x="731520" y="548640"/>
+            <a:ext cx="6629400" cy="178308"/>
           </a:xfrm>
           <a:prstGeom prst="rect">
             <a:avLst/>
@@ -3766,27 +3579,27 @@
           <a:p>
             <a:pPr algn="l"/>
             <a:r>
-              <a:rPr sz="1100" b="1" i="0">
+              <a:rPr sz="950" b="1" i="0">
                 <a:solidFill>
                   <a:srgbClr val="FFFFFF"/>
                 </a:solidFill>
                 <a:latin typeface="Calibri"/>
               </a:rPr>
-              <a:t>Grant Full Read-Only QuickBooks Online Access for Diligence</a:t>
-            </a:r>
-          </a:p>
-        </p:txBody>
-      </p:sp>
-      <p:sp>
-        <p:nvSpPr>
-          <p:cNvPr id="16" name="TextBox 15"/>
-          <p:cNvSpPr txBox="1"/>
-          <p:nvPr/>
-        </p:nvSpPr>
-        <p:spPr>
-          <a:xfrm>
-            <a:off x="804672" y="2231136"/>
-            <a:ext cx="6217920" cy="786383"/>
+              <a:t>Confirm §3 Exclusivity (May 2025 Asset Acquisition Agreement)</a:t>
+            </a:r>
+          </a:p>
+        </p:txBody>
+      </p:sp>
+      <p:sp>
+        <p:nvSpPr>
+          <p:cNvPr id="11" name="TextBox 10"/>
+          <p:cNvSpPr txBox="1"/>
+          <p:nvPr/>
+        </p:nvSpPr>
+        <p:spPr>
+          <a:xfrm>
+            <a:off x="7516367" y="530352"/>
+            <a:ext cx="1371600" cy="201168"/>
           </a:xfrm>
           <a:prstGeom prst="rect">
             <a:avLst/>
@@ -3799,72 +3612,29 @@
           </a:bodyPr>
           <a:lstStyle/>
           <a:p>
-            <a:r>
-              <a:rPr sz="800">
-                <a:solidFill>
-                  <a:srgbClr val="CCCCCC"/>
+            <a:pPr algn="l"/>
+            <a:r>
+              <a:rPr sz="850" b="0" i="0">
+                <a:solidFill>
+                  <a:srgbClr val="44BB44"/>
                 </a:solidFill>
                 <a:latin typeface="Calibri"/>
               </a:rPr>
-              <a:t>Authorize an all-access or accountant user for John Quinn and one Exos finance reviewer.</a:t>
-            </a:r>
-          </a:p>
-          <a:p>
-            <a:r>
-              <a:rPr sz="800">
-                <a:solidFill>
-                  <a:srgbClr val="CCCCCC"/>
-                </a:solidFill>
-                <a:latin typeface="Calibri"/>
-              </a:rPr>
-              <a:t>Purpose: reconcile the $942K "billed-ahead" balance and shared-facility costs (Microcosm</a:t>
-            </a:r>
-          </a:p>
-          <a:p>
-            <a:r>
-              <a:rPr sz="800">
-                <a:solidFill>
-                  <a:srgbClr val="CCCCCC"/>
-                </a:solidFill>
-                <a:latin typeface="Calibri"/>
-              </a:rPr>
-              <a:t>offset) before close.  Basis: Cal. Corp. Code §1602 director inspection right + AAA §4</a:t>
-            </a:r>
-          </a:p>
-          <a:p>
-            <a:r>
-              <a:rPr sz="800">
-                <a:solidFill>
-                  <a:srgbClr val="CCCCCC"/>
-                </a:solidFill>
-                <a:latin typeface="Calibri"/>
-              </a:rPr>
-              <a:t>confirmatory diligence.  Confidential under the 7/27/2021 NDA.</a:t>
-            </a:r>
-          </a:p>
-          <a:p>
-            <a:r>
-              <a:rPr lang="en-US" sz="800" b="1" dirty="0">
-                <a:solidFill>
-                  <a:srgbClr val="F26A21"/>
-                </a:solidFill>
-                <a:latin typeface="Calibri"/>
-              </a:rPr>
-              <a:t>Access to be granted no later than October 15, 2026.</a:t>
-            </a:r>
-          </a:p>
-        </p:txBody>
-      </p:sp>
-      <p:sp>
-        <p:nvSpPr>
-          <p:cNvPr id="17" name="TextBox 16"/>
-          <p:cNvSpPr txBox="1"/>
-          <p:nvPr/>
-        </p:nvSpPr>
-        <p:spPr>
-          <a:xfrm>
-            <a:off x="7452359" y="2029968"/>
-            <a:ext cx="1371600" cy="256032"/>
+              <a:t>☐  Approve</a:t>
+            </a:r>
+          </a:p>
+        </p:txBody>
+      </p:sp>
+      <p:sp>
+        <p:nvSpPr>
+          <p:cNvPr id="12" name="TextBox 11"/>
+          <p:cNvSpPr txBox="1"/>
+          <p:nvPr/>
+        </p:nvSpPr>
+        <p:spPr>
+          <a:xfrm>
+            <a:off x="7516367" y="676656"/>
+            <a:ext cx="1371600" cy="201168"/>
           </a:xfrm>
           <a:prstGeom prst="rect">
             <a:avLst/>
@@ -3879,27 +3649,27 @@
           <a:p>
             <a:pPr algn="l"/>
             <a:r>
-              <a:rPr sz="900" b="0" i="0">
-                <a:solidFill>
-                  <a:srgbClr val="44BB44"/>
+              <a:rPr sz="850" b="0" i="0">
+                <a:solidFill>
+                  <a:srgbClr val="FF6666"/>
                 </a:solidFill>
                 <a:latin typeface="Calibri"/>
               </a:rPr>
-              <a:t>☐  Approve</a:t>
-            </a:r>
-          </a:p>
-        </p:txBody>
-      </p:sp>
-      <p:sp>
-        <p:nvSpPr>
-          <p:cNvPr id="18" name="TextBox 17"/>
-          <p:cNvSpPr txBox="1"/>
-          <p:nvPr/>
-        </p:nvSpPr>
-        <p:spPr>
-          <a:xfrm>
-            <a:off x="7452359" y="2286000"/>
-            <a:ext cx="1371600" cy="256032"/>
+              <a:t>☐  Decline</a:t>
+            </a:r>
+          </a:p>
+        </p:txBody>
+      </p:sp>
+      <p:sp>
+        <p:nvSpPr>
+          <p:cNvPr id="13" name="TextBox 12"/>
+          <p:cNvSpPr txBox="1"/>
+          <p:nvPr/>
+        </p:nvSpPr>
+        <p:spPr>
+          <a:xfrm>
+            <a:off x="731520" y="781812"/>
+            <a:ext cx="6629400" cy="608076"/>
           </a:xfrm>
           <a:prstGeom prst="rect">
             <a:avLst/>
@@ -3912,29 +3682,50 @@
           </a:bodyPr>
           <a:lstStyle/>
           <a:p>
-            <a:pPr algn="l"/>
-            <a:r>
-              <a:rPr sz="900" b="0" i="0">
-                <a:solidFill>
-                  <a:srgbClr val="FF6666"/>
+            <a:r>
+              <a:rPr sz="750" b="0">
+                <a:solidFill>
+                  <a:srgbClr val="CCCCCC"/>
                 </a:solidFill>
                 <a:latin typeface="Calibri"/>
               </a:rPr>
-              <a:t>☐  Decline</a:t>
-            </a:r>
-          </a:p>
-        </p:txBody>
-      </p:sp>
-      <p:sp>
-        <p:nvSpPr>
-          <p:cNvPr id="19" name="Rectangle 18"/>
+              <a:t>Approve a 90-day exclusivity period beginning on the date of this approval.</a:t>
+            </a:r>
+          </a:p>
+          <a:p>
+            <a:r>
+              <a:rPr sz="750" b="0">
+                <a:solidFill>
+                  <a:srgbClr val="CCCCCC"/>
+                </a:solidFill>
+                <a:latin typeface="Calibri"/>
+              </a:rPr>
+              <a:t>Extension not unreasonably withheld (per §3). Allows both parties to proceed to</a:t>
+            </a:r>
+          </a:p>
+          <a:p>
+            <a:r>
+              <a:rPr sz="750" b="0">
+                <a:solidFill>
+                  <a:srgbClr val="CCCCCC"/>
+                </a:solidFill>
+                <a:latin typeface="Calibri"/>
+              </a:rPr>
+              <a:t>diligence, definitive agreement, and financing close (target: Feb 15th, 2027).</a:t>
+            </a:r>
+          </a:p>
+        </p:txBody>
+      </p:sp>
+      <p:sp>
+        <p:nvSpPr>
+          <p:cNvPr id="14" name="Rectangle 13"/>
           <p:cNvSpPr/>
           <p:nvPr/>
         </p:nvSpPr>
         <p:spPr>
           <a:xfrm>
-            <a:off x="182880" y="3163824"/>
-            <a:ext cx="8778240" cy="1097280"/>
+            <a:off x="182880" y="1444752"/>
+            <a:ext cx="8778240" cy="987552"/>
           </a:xfrm>
           <a:prstGeom prst="rect">
             <a:avLst/>
@@ -3970,14 +3761,14 @@
       </p:sp>
       <p:sp>
         <p:nvSpPr>
-          <p:cNvPr id="20" name="Rectangle 19"/>
+          <p:cNvPr id="15" name="Rectangle 14"/>
           <p:cNvSpPr/>
           <p:nvPr/>
         </p:nvSpPr>
         <p:spPr>
           <a:xfrm>
-            <a:off x="182880" y="3163824"/>
-            <a:ext cx="50292" cy="1097280"/>
+            <a:off x="182880" y="1444752"/>
+            <a:ext cx="50292" cy="987552"/>
           </a:xfrm>
           <a:prstGeom prst="rect">
             <a:avLst/>
@@ -4013,216 +3804,20 @@
       </p:sp>
       <p:sp>
         <p:nvSpPr>
-          <p:cNvPr id="21" name="TextBox 20"/>
-          <p:cNvSpPr txBox="1"/>
-          <p:nvPr/>
-        </p:nvSpPr>
-        <p:spPr>
-          <a:xfrm>
-            <a:off x="274320" y="3236976"/>
-            <a:ext cx="457200" cy="457200"/>
-          </a:xfrm>
-          <a:prstGeom prst="rect">
-            <a:avLst/>
-          </a:prstGeom>
-          <a:noFill/>
-        </p:spPr>
-        <p:txBody>
-          <a:bodyPr wrap="square">
-            <a:spAutoFit/>
-          </a:bodyPr>
-          <a:lstStyle/>
-          <a:p>
-            <a:pPr algn="l"/>
-            <a:r>
-              <a:rPr sz="2600" b="1" i="0">
-                <a:solidFill>
-                  <a:srgbClr val="F26A21"/>
-                </a:solidFill>
-                <a:latin typeface="Cambria"/>
-              </a:rPr>
-              <a:t>3</a:t>
-            </a:r>
-          </a:p>
-        </p:txBody>
-      </p:sp>
-      <p:sp>
-        <p:nvSpPr>
-          <p:cNvPr id="22" name="TextBox 21"/>
-          <p:cNvSpPr txBox="1"/>
-          <p:nvPr/>
-        </p:nvSpPr>
-        <p:spPr>
-          <a:xfrm>
-            <a:off x="804672" y="3246120"/>
-            <a:ext cx="6583680" cy="274320"/>
-          </a:xfrm>
-          <a:prstGeom prst="rect">
-            <a:avLst/>
-          </a:prstGeom>
-          <a:noFill/>
-        </p:spPr>
-        <p:txBody>
-          <a:bodyPr wrap="square">
-            <a:spAutoFit/>
-          </a:bodyPr>
-          <a:lstStyle/>
-          <a:p>
-            <a:pPr algn="l"/>
-            <a:r>
-              <a:rPr sz="1100" b="1" i="0">
-                <a:solidFill>
-                  <a:srgbClr val="FFFFFF"/>
-                </a:solidFill>
-                <a:latin typeface="Calibri"/>
-              </a:rPr>
-              <a:t>Consent to ERP/MRP &amp; Inventory Evaluation (Separate Motion)</a:t>
-            </a:r>
-          </a:p>
-        </p:txBody>
-      </p:sp>
-      <p:sp>
-        <p:nvSpPr>
-          <p:cNvPr id="23" name="TextBox 22"/>
-          <p:cNvSpPr txBox="1"/>
-          <p:nvPr/>
-        </p:nvSpPr>
-        <p:spPr>
-          <a:xfrm>
-            <a:off x="804672" y="3547872"/>
-            <a:ext cx="6217920" cy="621792"/>
-          </a:xfrm>
-          <a:prstGeom prst="rect">
-            <a:avLst/>
-          </a:prstGeom>
-          <a:noFill/>
-        </p:spPr>
-        <p:txBody>
-          <a:bodyPr wrap="square">
-            <a:spAutoFit/>
-          </a:bodyPr>
-          <a:lstStyle/>
-          <a:p>
-            <a:r>
-              <a:rPr sz="800">
-                <a:solidFill>
-                  <a:srgbClr val="CCCCCC"/>
-                </a:solidFill>
-                <a:latin typeface="Calibri"/>
-              </a:rPr>
-              <a:t>Authorize Exos to use the same QB data to evaluate its in-house ERP/MRP and inventory</a:t>
-            </a:r>
-          </a:p>
-          <a:p>
-            <a:r>
-              <a:rPr sz="800">
-                <a:solidFill>
-                  <a:srgbClr val="CCCCCC"/>
-                </a:solidFill>
-                <a:latin typeface="Calibri"/>
-              </a:rPr>
-              <a:t>systems for the combined operation.  Confidential under the NDA.</a:t>
-            </a:r>
-          </a:p>
-          <a:p>
-            <a:r>
-              <a:rPr sz="800">
-                <a:solidFill>
-                  <a:srgbClr val="CCCCCC"/>
-                </a:solidFill>
-                <a:latin typeface="Calibri"/>
-              </a:rPr>
-              <a:t>Does not create any obligation to implement; evaluation only.</a:t>
-            </a:r>
-          </a:p>
-        </p:txBody>
-      </p:sp>
-      <p:sp>
-        <p:nvSpPr>
-          <p:cNvPr id="24" name="TextBox 23"/>
-          <p:cNvSpPr txBox="1"/>
-          <p:nvPr/>
-        </p:nvSpPr>
-        <p:spPr>
-          <a:xfrm>
-            <a:off x="7452359" y="3346704"/>
-            <a:ext cx="1371600" cy="256032"/>
-          </a:xfrm>
-          <a:prstGeom prst="rect">
-            <a:avLst/>
-          </a:prstGeom>
-          <a:noFill/>
-        </p:spPr>
-        <p:txBody>
-          <a:bodyPr wrap="square">
-            <a:spAutoFit/>
-          </a:bodyPr>
-          <a:lstStyle/>
-          <a:p>
-            <a:pPr algn="l"/>
-            <a:r>
-              <a:rPr sz="900" b="0" i="0">
-                <a:solidFill>
-                  <a:srgbClr val="44BB44"/>
-                </a:solidFill>
-                <a:latin typeface="Calibri"/>
-              </a:rPr>
-              <a:t>☐  Approve</a:t>
-            </a:r>
-          </a:p>
-        </p:txBody>
-      </p:sp>
-      <p:sp>
-        <p:nvSpPr>
-          <p:cNvPr id="25" name="TextBox 24"/>
-          <p:cNvSpPr txBox="1"/>
-          <p:nvPr/>
-        </p:nvSpPr>
-        <p:spPr>
-          <a:xfrm>
-            <a:off x="7452359" y="3602736"/>
-            <a:ext cx="1371600" cy="256032"/>
-          </a:xfrm>
-          <a:prstGeom prst="rect">
-            <a:avLst/>
-          </a:prstGeom>
-          <a:noFill/>
-        </p:spPr>
-        <p:txBody>
-          <a:bodyPr wrap="square">
-            <a:spAutoFit/>
-          </a:bodyPr>
-          <a:lstStyle/>
-          <a:p>
-            <a:pPr algn="l"/>
-            <a:r>
-              <a:rPr sz="900" b="0" i="0">
-                <a:solidFill>
-                  <a:srgbClr val="FF6666"/>
-                </a:solidFill>
-                <a:latin typeface="Calibri"/>
-              </a:rPr>
-              <a:t>☐  Decline</a:t>
-            </a:r>
-          </a:p>
-        </p:txBody>
-      </p:sp>
-      <p:sp>
-        <p:nvSpPr>
-          <p:cNvPr id="26" name="Rectangle 25"/>
+          <p:cNvPr id="16" name="Rectangle 15"/>
           <p:cNvSpPr/>
           <p:nvPr/>
         </p:nvSpPr>
         <p:spPr>
           <a:xfrm>
-            <a:off x="182880" y="4325112"/>
-            <a:ext cx="8778240" cy="201168"/>
-          </a:xfrm>
-          <a:prstGeom prst="rect">
-            <a:avLst/>
-          </a:prstGeom>
-          <a:solidFill>
-            <a:srgbClr val="1A0A00"/>
+            <a:off x="182880" y="1444752"/>
+            <a:ext cx="8778240" cy="233172"/>
+          </a:xfrm>
+          <a:prstGeom prst="rect">
+            <a:avLst/>
+          </a:prstGeom>
+          <a:solidFill>
+            <a:srgbClr val="1A1A1A"/>
           </a:solidFill>
           <a:ln>
             <a:noFill/>
@@ -4252,14 +3847,57 @@
       </p:sp>
       <p:sp>
         <p:nvSpPr>
-          <p:cNvPr id="27" name="TextBox 26"/>
-          <p:cNvSpPr txBox="1"/>
-          <p:nvPr/>
-        </p:nvSpPr>
-        <p:spPr>
-          <a:xfrm>
-            <a:off x="292608" y="4352544"/>
-            <a:ext cx="8549640" cy="155448"/>
+          <p:cNvPr id="17" name="Rectangle 16"/>
+          <p:cNvSpPr/>
+          <p:nvPr/>
+        </p:nvSpPr>
+        <p:spPr>
+          <a:xfrm>
+            <a:off x="182880" y="1444752"/>
+            <a:ext cx="50292" cy="233172"/>
+          </a:xfrm>
+          <a:prstGeom prst="rect">
+            <a:avLst/>
+          </a:prstGeom>
+          <a:solidFill>
+            <a:srgbClr val="F26A21"/>
+          </a:solidFill>
+          <a:ln>
+            <a:noFill/>
+          </a:ln>
+        </p:spPr>
+        <p:style>
+          <a:lnRef idx="1">
+            <a:schemeClr val="accent1"/>
+          </a:lnRef>
+          <a:fillRef idx="3">
+            <a:schemeClr val="accent1"/>
+          </a:fillRef>
+          <a:effectRef idx="2">
+            <a:schemeClr val="accent1"/>
+          </a:effectRef>
+          <a:fontRef idx="minor">
+            <a:schemeClr val="lt1"/>
+          </a:fontRef>
+        </p:style>
+        <p:txBody>
+          <a:bodyPr rtlCol="0" anchor="ctr"/>
+          <a:lstStyle/>
+          <a:p>
+            <a:pPr algn="ctr"/>
+          </a:p>
+        </p:txBody>
+      </p:sp>
+      <p:sp>
+        <p:nvSpPr>
+          <p:cNvPr id="18" name="TextBox 17"/>
+          <p:cNvSpPr txBox="1"/>
+          <p:nvPr/>
+        </p:nvSpPr>
+        <p:spPr>
+          <a:xfrm>
+            <a:off x="265176" y="1472184"/>
+            <a:ext cx="411480" cy="196596"/>
           </a:xfrm>
           <a:prstGeom prst="rect">
             <a:avLst/>
@@ -4274,27 +3912,27 @@
           <a:p>
             <a:pPr algn="l"/>
             <a:r>
-              <a:rPr sz="750" b="0" i="1">
+              <a:rPr sz="2200" b="1" i="0">
                 <a:solidFill>
                   <a:srgbClr val="F26A21"/>
                 </a:solidFill>
-                <a:latin typeface="Calibri"/>
-              </a:rPr>
-              <a:t>Governance: John Quinn abstains on all motions as an interested director; motions are decided by the disinterested directors.</a:t>
-            </a:r>
-          </a:p>
-        </p:txBody>
-      </p:sp>
-      <p:sp>
-        <p:nvSpPr>
-          <p:cNvPr id="28" name="TextBox 27"/>
-          <p:cNvSpPr txBox="1"/>
-          <p:nvPr/>
-        </p:nvSpPr>
-        <p:spPr>
-          <a:xfrm>
-            <a:off x="1554480" y="4892040"/>
-            <a:ext cx="6035040" cy="201168"/>
+                <a:latin typeface="Cambria"/>
+              </a:rPr>
+              <a:t>2</a:t>
+            </a:r>
+          </a:p>
+        </p:txBody>
+      </p:sp>
+      <p:sp>
+        <p:nvSpPr>
+          <p:cNvPr id="19" name="TextBox 18"/>
+          <p:cNvSpPr txBox="1"/>
+          <p:nvPr/>
+        </p:nvSpPr>
+        <p:spPr>
+          <a:xfrm>
+            <a:off x="731520" y="1481328"/>
+            <a:ext cx="6629400" cy="178308"/>
           </a:xfrm>
           <a:prstGeom prst="rect">
             <a:avLst/>
@@ -4307,7 +3945,1004 @@
           </a:bodyPr>
           <a:lstStyle/>
           <a:p>
+            <a:pPr algn="l"/>
+            <a:r>
+              <a:rPr sz="950" b="1" i="0">
+                <a:solidFill>
+                  <a:srgbClr val="FFFFFF"/>
+                </a:solidFill>
+                <a:latin typeface="Calibri"/>
+              </a:rPr>
+              <a:t>Grant Full Read-Only QuickBooks Online Access for Diligence</a:t>
+            </a:r>
+          </a:p>
+        </p:txBody>
+      </p:sp>
+      <p:sp>
+        <p:nvSpPr>
+          <p:cNvPr id="20" name="TextBox 19"/>
+          <p:cNvSpPr txBox="1"/>
+          <p:nvPr/>
+        </p:nvSpPr>
+        <p:spPr>
+          <a:xfrm>
+            <a:off x="7516367" y="1463040"/>
+            <a:ext cx="1371600" cy="201168"/>
+          </a:xfrm>
+          <a:prstGeom prst="rect">
+            <a:avLst/>
+          </a:prstGeom>
+          <a:noFill/>
+        </p:spPr>
+        <p:txBody>
+          <a:bodyPr wrap="square">
+            <a:spAutoFit/>
+          </a:bodyPr>
+          <a:lstStyle/>
+          <a:p>
+            <a:pPr algn="l"/>
+            <a:r>
+              <a:rPr sz="850" b="0" i="0">
+                <a:solidFill>
+                  <a:srgbClr val="44BB44"/>
+                </a:solidFill>
+                <a:latin typeface="Calibri"/>
+              </a:rPr>
+              <a:t>☐  Approve</a:t>
+            </a:r>
+          </a:p>
+        </p:txBody>
+      </p:sp>
+      <p:sp>
+        <p:nvSpPr>
+          <p:cNvPr id="21" name="TextBox 20"/>
+          <p:cNvSpPr txBox="1"/>
+          <p:nvPr/>
+        </p:nvSpPr>
+        <p:spPr>
+          <a:xfrm>
+            <a:off x="7516367" y="1609344"/>
+            <a:ext cx="1371600" cy="201168"/>
+          </a:xfrm>
+          <a:prstGeom prst="rect">
+            <a:avLst/>
+          </a:prstGeom>
+          <a:noFill/>
+        </p:spPr>
+        <p:txBody>
+          <a:bodyPr wrap="square">
+            <a:spAutoFit/>
+          </a:bodyPr>
+          <a:lstStyle/>
+          <a:p>
+            <a:pPr algn="l"/>
+            <a:r>
+              <a:rPr sz="850" b="0" i="0">
+                <a:solidFill>
+                  <a:srgbClr val="FF6666"/>
+                </a:solidFill>
+                <a:latin typeface="Calibri"/>
+              </a:rPr>
+              <a:t>☐  Decline</a:t>
+            </a:r>
+          </a:p>
+        </p:txBody>
+      </p:sp>
+      <p:sp>
+        <p:nvSpPr>
+          <p:cNvPr id="22" name="TextBox 21"/>
+          <p:cNvSpPr txBox="1"/>
+          <p:nvPr/>
+        </p:nvSpPr>
+        <p:spPr>
+          <a:xfrm>
+            <a:off x="731520" y="1714500"/>
+            <a:ext cx="6629400" cy="699516"/>
+          </a:xfrm>
+          <a:prstGeom prst="rect">
+            <a:avLst/>
+          </a:prstGeom>
+          <a:noFill/>
+        </p:spPr>
+        <p:txBody>
+          <a:bodyPr wrap="square">
+            <a:spAutoFit/>
+          </a:bodyPr>
+          <a:lstStyle/>
+          <a:p>
+            <a:r>
+              <a:rPr sz="750" b="0">
+                <a:solidFill>
+                  <a:srgbClr val="CCCCCC"/>
+                </a:solidFill>
+                <a:latin typeface="Calibri"/>
+              </a:rPr>
+              <a:t>Authorize an all-access or accountant user for John Quinn and one Exos finance reviewer.</a:t>
+            </a:r>
+          </a:p>
+          <a:p>
+            <a:r>
+              <a:rPr sz="750" b="0">
+                <a:solidFill>
+                  <a:srgbClr val="CCCCCC"/>
+                </a:solidFill>
+                <a:latin typeface="Calibri"/>
+              </a:rPr>
+              <a:t>Purpose: reconcile the $942K "billed-ahead" balance and shared-facility costs before close.</a:t>
+            </a:r>
+          </a:p>
+          <a:p>
+            <a:r>
+              <a:rPr sz="750" b="0">
+                <a:solidFill>
+                  <a:srgbClr val="CCCCCC"/>
+                </a:solidFill>
+                <a:latin typeface="Calibri"/>
+              </a:rPr>
+              <a:t>Basis: Cal. Corp. Code §1602 director inspection right + AAA §4 confirmatory diligence.</a:t>
+            </a:r>
+          </a:p>
+          <a:p>
+            <a:r>
+              <a:rPr sz="750" b="1">
+                <a:solidFill>
+                  <a:srgbClr val="F26A21"/>
+                </a:solidFill>
+                <a:latin typeface="Calibri"/>
+              </a:rPr>
+              <a:t>Confidential under the 7/27/2021 NDA.  Access to be granted no later than October 15, 2026.</a:t>
+            </a:r>
+          </a:p>
+        </p:txBody>
+      </p:sp>
+      <p:sp>
+        <p:nvSpPr>
+          <p:cNvPr id="23" name="Rectangle 22"/>
+          <p:cNvSpPr/>
+          <p:nvPr/>
+        </p:nvSpPr>
+        <p:spPr>
+          <a:xfrm>
+            <a:off x="182880" y="2468880"/>
+            <a:ext cx="8778240" cy="1170432"/>
+          </a:xfrm>
+          <a:prstGeom prst="rect">
+            <a:avLst/>
+          </a:prstGeom>
+          <a:solidFill>
+            <a:srgbClr val="1E1E1E"/>
+          </a:solidFill>
+          <a:ln>
+            <a:noFill/>
+          </a:ln>
+        </p:spPr>
+        <p:style>
+          <a:lnRef idx="1">
+            <a:schemeClr val="accent1"/>
+          </a:lnRef>
+          <a:fillRef idx="3">
+            <a:schemeClr val="accent1"/>
+          </a:fillRef>
+          <a:effectRef idx="2">
+            <a:schemeClr val="accent1"/>
+          </a:effectRef>
+          <a:fontRef idx="minor">
+            <a:schemeClr val="lt1"/>
+          </a:fontRef>
+        </p:style>
+        <p:txBody>
+          <a:bodyPr rtlCol="0" anchor="ctr"/>
+          <a:lstStyle/>
+          <a:p>
             <a:pPr algn="ctr"/>
+          </a:p>
+        </p:txBody>
+      </p:sp>
+      <p:sp>
+        <p:nvSpPr>
+          <p:cNvPr id="24" name="Rectangle 23"/>
+          <p:cNvSpPr/>
+          <p:nvPr/>
+        </p:nvSpPr>
+        <p:spPr>
+          <a:xfrm>
+            <a:off x="182880" y="2468880"/>
+            <a:ext cx="50292" cy="1170432"/>
+          </a:xfrm>
+          <a:prstGeom prst="rect">
+            <a:avLst/>
+          </a:prstGeom>
+          <a:solidFill>
+            <a:srgbClr val="F26A21"/>
+          </a:solidFill>
+          <a:ln>
+            <a:noFill/>
+          </a:ln>
+        </p:spPr>
+        <p:style>
+          <a:lnRef idx="1">
+            <a:schemeClr val="accent1"/>
+          </a:lnRef>
+          <a:fillRef idx="3">
+            <a:schemeClr val="accent1"/>
+          </a:fillRef>
+          <a:effectRef idx="2">
+            <a:schemeClr val="accent1"/>
+          </a:effectRef>
+          <a:fontRef idx="minor">
+            <a:schemeClr val="lt1"/>
+          </a:fontRef>
+        </p:style>
+        <p:txBody>
+          <a:bodyPr rtlCol="0" anchor="ctr"/>
+          <a:lstStyle/>
+          <a:p>
+            <a:pPr algn="ctr"/>
+          </a:p>
+        </p:txBody>
+      </p:sp>
+      <p:sp>
+        <p:nvSpPr>
+          <p:cNvPr id="25" name="Rectangle 24"/>
+          <p:cNvSpPr/>
+          <p:nvPr/>
+        </p:nvSpPr>
+        <p:spPr>
+          <a:xfrm>
+            <a:off x="182880" y="2468880"/>
+            <a:ext cx="8778240" cy="233172"/>
+          </a:xfrm>
+          <a:prstGeom prst="rect">
+            <a:avLst/>
+          </a:prstGeom>
+          <a:solidFill>
+            <a:srgbClr val="1A1A1A"/>
+          </a:solidFill>
+          <a:ln>
+            <a:noFill/>
+          </a:ln>
+        </p:spPr>
+        <p:style>
+          <a:lnRef idx="1">
+            <a:schemeClr val="accent1"/>
+          </a:lnRef>
+          <a:fillRef idx="3">
+            <a:schemeClr val="accent1"/>
+          </a:fillRef>
+          <a:effectRef idx="2">
+            <a:schemeClr val="accent1"/>
+          </a:effectRef>
+          <a:fontRef idx="minor">
+            <a:schemeClr val="lt1"/>
+          </a:fontRef>
+        </p:style>
+        <p:txBody>
+          <a:bodyPr rtlCol="0" anchor="ctr"/>
+          <a:lstStyle/>
+          <a:p>
+            <a:pPr algn="ctr"/>
+          </a:p>
+        </p:txBody>
+      </p:sp>
+      <p:sp>
+        <p:nvSpPr>
+          <p:cNvPr id="26" name="Rectangle 25"/>
+          <p:cNvSpPr/>
+          <p:nvPr/>
+        </p:nvSpPr>
+        <p:spPr>
+          <a:xfrm>
+            <a:off x="182880" y="2468880"/>
+            <a:ext cx="50292" cy="233172"/>
+          </a:xfrm>
+          <a:prstGeom prst="rect">
+            <a:avLst/>
+          </a:prstGeom>
+          <a:solidFill>
+            <a:srgbClr val="F26A21"/>
+          </a:solidFill>
+          <a:ln>
+            <a:noFill/>
+          </a:ln>
+        </p:spPr>
+        <p:style>
+          <a:lnRef idx="1">
+            <a:schemeClr val="accent1"/>
+          </a:lnRef>
+          <a:fillRef idx="3">
+            <a:schemeClr val="accent1"/>
+          </a:fillRef>
+          <a:effectRef idx="2">
+            <a:schemeClr val="accent1"/>
+          </a:effectRef>
+          <a:fontRef idx="minor">
+            <a:schemeClr val="lt1"/>
+          </a:fontRef>
+        </p:style>
+        <p:txBody>
+          <a:bodyPr rtlCol="0" anchor="ctr"/>
+          <a:lstStyle/>
+          <a:p>
+            <a:pPr algn="ctr"/>
+          </a:p>
+        </p:txBody>
+      </p:sp>
+      <p:sp>
+        <p:nvSpPr>
+          <p:cNvPr id="27" name="TextBox 26"/>
+          <p:cNvSpPr txBox="1"/>
+          <p:nvPr/>
+        </p:nvSpPr>
+        <p:spPr>
+          <a:xfrm>
+            <a:off x="265176" y="2496312"/>
+            <a:ext cx="411480" cy="196596"/>
+          </a:xfrm>
+          <a:prstGeom prst="rect">
+            <a:avLst/>
+          </a:prstGeom>
+          <a:noFill/>
+        </p:spPr>
+        <p:txBody>
+          <a:bodyPr wrap="square">
+            <a:spAutoFit/>
+          </a:bodyPr>
+          <a:lstStyle/>
+          <a:p>
+            <a:pPr algn="l"/>
+            <a:r>
+              <a:rPr sz="2200" b="1" i="0">
+                <a:solidFill>
+                  <a:srgbClr val="F26A21"/>
+                </a:solidFill>
+                <a:latin typeface="Cambria"/>
+              </a:rPr>
+              <a:t>3</a:t>
+            </a:r>
+          </a:p>
+        </p:txBody>
+      </p:sp>
+      <p:sp>
+        <p:nvSpPr>
+          <p:cNvPr id="28" name="TextBox 27"/>
+          <p:cNvSpPr txBox="1"/>
+          <p:nvPr/>
+        </p:nvSpPr>
+        <p:spPr>
+          <a:xfrm>
+            <a:off x="731520" y="2505456"/>
+            <a:ext cx="6629400" cy="178308"/>
+          </a:xfrm>
+          <a:prstGeom prst="rect">
+            <a:avLst/>
+          </a:prstGeom>
+          <a:noFill/>
+        </p:spPr>
+        <p:txBody>
+          <a:bodyPr wrap="square">
+            <a:spAutoFit/>
+          </a:bodyPr>
+          <a:lstStyle/>
+          <a:p>
+            <a:pPr algn="l"/>
+            <a:r>
+              <a:rPr sz="950" b="1" i="0">
+                <a:solidFill>
+                  <a:srgbClr val="FFFFFF"/>
+                </a:solidFill>
+                <a:latin typeface="Calibri"/>
+              </a:rPr>
+              <a:t>Correct AR Unbilled / Customer-Deposit Accounting Within 5 Days</a:t>
+            </a:r>
+          </a:p>
+        </p:txBody>
+      </p:sp>
+      <p:sp>
+        <p:nvSpPr>
+          <p:cNvPr id="29" name="TextBox 28"/>
+          <p:cNvSpPr txBox="1"/>
+          <p:nvPr/>
+        </p:nvSpPr>
+        <p:spPr>
+          <a:xfrm>
+            <a:off x="7516367" y="2487168"/>
+            <a:ext cx="1371600" cy="201168"/>
+          </a:xfrm>
+          <a:prstGeom prst="rect">
+            <a:avLst/>
+          </a:prstGeom>
+          <a:noFill/>
+        </p:spPr>
+        <p:txBody>
+          <a:bodyPr wrap="square">
+            <a:spAutoFit/>
+          </a:bodyPr>
+          <a:lstStyle/>
+          <a:p>
+            <a:pPr algn="l"/>
+            <a:r>
+              <a:rPr sz="850" b="0" i="0">
+                <a:solidFill>
+                  <a:srgbClr val="44BB44"/>
+                </a:solidFill>
+                <a:latin typeface="Calibri"/>
+              </a:rPr>
+              <a:t>☐  Approve</a:t>
+            </a:r>
+          </a:p>
+        </p:txBody>
+      </p:sp>
+      <p:sp>
+        <p:nvSpPr>
+          <p:cNvPr id="30" name="TextBox 29"/>
+          <p:cNvSpPr txBox="1"/>
+          <p:nvPr/>
+        </p:nvSpPr>
+        <p:spPr>
+          <a:xfrm>
+            <a:off x="7516367" y="2633472"/>
+            <a:ext cx="1371600" cy="201168"/>
+          </a:xfrm>
+          <a:prstGeom prst="rect">
+            <a:avLst/>
+          </a:prstGeom>
+          <a:noFill/>
+        </p:spPr>
+        <p:txBody>
+          <a:bodyPr wrap="square">
+            <a:spAutoFit/>
+          </a:bodyPr>
+          <a:lstStyle/>
+          <a:p>
+            <a:pPr algn="l"/>
+            <a:r>
+              <a:rPr sz="850" b="0" i="0">
+                <a:solidFill>
+                  <a:srgbClr val="FF6666"/>
+                </a:solidFill>
+                <a:latin typeface="Calibri"/>
+              </a:rPr>
+              <a:t>☐  Decline</a:t>
+            </a:r>
+          </a:p>
+        </p:txBody>
+      </p:sp>
+      <p:sp>
+        <p:nvSpPr>
+          <p:cNvPr id="31" name="TextBox 30"/>
+          <p:cNvSpPr txBox="1"/>
+          <p:nvPr/>
+        </p:nvSpPr>
+        <p:spPr>
+          <a:xfrm>
+            <a:off x="731520" y="2738628"/>
+            <a:ext cx="6629400" cy="882395"/>
+          </a:xfrm>
+          <a:prstGeom prst="rect">
+            <a:avLst/>
+          </a:prstGeom>
+          <a:noFill/>
+        </p:spPr>
+        <p:txBody>
+          <a:bodyPr wrap="square">
+            <a:spAutoFit/>
+          </a:bodyPr>
+          <a:lstStyle/>
+          <a:p>
+            <a:r>
+              <a:rPr sz="750" b="0">
+                <a:solidFill>
+                  <a:srgbClr val="CCCCCC"/>
+                </a:solidFill>
+                <a:latin typeface="Calibri"/>
+              </a:rPr>
+              <a:t>Direct A La Carte Solutions (bookkeeper) + Singer Lewak / Welch &amp; Co. to reconcile and correct:</a:t>
+            </a:r>
+          </a:p>
+          <a:p>
+            <a:r>
+              <a:rPr sz="750" b="0">
+                <a:solidFill>
+                  <a:srgbClr val="CCCCCC"/>
+                </a:solidFill>
+                <a:latin typeface="Calibri"/>
+              </a:rPr>
+              <a:t>• Acct 1110 AR Unbilled ($942,177) and Acct 2380 Deposits ($120,000) within 5 days of approval.</a:t>
+            </a:r>
+          </a:p>
+          <a:p>
+            <a:r>
+              <a:rPr sz="750" b="0">
+                <a:solidFill>
+                  <a:srgbClr val="CCCCCC"/>
+                </a:solidFill>
+                <a:latin typeface="Calibri"/>
+              </a:rPr>
+              <a:t>• Clear start-billings on completed/shipped tanks; post missing Jul–Sep 2026 rev-rec entries.</a:t>
+            </a:r>
+          </a:p>
+          <a:p>
+            <a:r>
+              <a:rPr sz="750" b="0">
+                <a:solidFill>
+                  <a:srgbClr val="CCCCCC"/>
+                </a:solidFill>
+                <a:latin typeface="Calibri"/>
+              </a:rPr>
+              <a:t>• Tank-by-tank reconciliation (IM-109/122/134, EXOS-133) + corrected balance sheet to all directors.</a:t>
+            </a:r>
+          </a:p>
+        </p:txBody>
+      </p:sp>
+      <p:sp>
+        <p:nvSpPr>
+          <p:cNvPr id="32" name="Rectangle 31"/>
+          <p:cNvSpPr/>
+          <p:nvPr/>
+        </p:nvSpPr>
+        <p:spPr>
+          <a:xfrm>
+            <a:off x="182880" y="3675887"/>
+            <a:ext cx="8778240" cy="850392"/>
+          </a:xfrm>
+          <a:prstGeom prst="rect">
+            <a:avLst/>
+          </a:prstGeom>
+          <a:solidFill>
+            <a:srgbClr val="1E1E1E"/>
+          </a:solidFill>
+          <a:ln>
+            <a:noFill/>
+          </a:ln>
+        </p:spPr>
+        <p:style>
+          <a:lnRef idx="1">
+            <a:schemeClr val="accent1"/>
+          </a:lnRef>
+          <a:fillRef idx="3">
+            <a:schemeClr val="accent1"/>
+          </a:fillRef>
+          <a:effectRef idx="2">
+            <a:schemeClr val="accent1"/>
+          </a:effectRef>
+          <a:fontRef idx="minor">
+            <a:schemeClr val="lt1"/>
+          </a:fontRef>
+        </p:style>
+        <p:txBody>
+          <a:bodyPr rtlCol="0" anchor="ctr"/>
+          <a:lstStyle/>
+          <a:p>
+            <a:pPr algn="ctr"/>
+          </a:p>
+        </p:txBody>
+      </p:sp>
+      <p:sp>
+        <p:nvSpPr>
+          <p:cNvPr id="33" name="Rectangle 32"/>
+          <p:cNvSpPr/>
+          <p:nvPr/>
+        </p:nvSpPr>
+        <p:spPr>
+          <a:xfrm>
+            <a:off x="182880" y="3675887"/>
+            <a:ext cx="50292" cy="850392"/>
+          </a:xfrm>
+          <a:prstGeom prst="rect">
+            <a:avLst/>
+          </a:prstGeom>
+          <a:solidFill>
+            <a:srgbClr val="F26A21"/>
+          </a:solidFill>
+          <a:ln>
+            <a:noFill/>
+          </a:ln>
+        </p:spPr>
+        <p:style>
+          <a:lnRef idx="1">
+            <a:schemeClr val="accent1"/>
+          </a:lnRef>
+          <a:fillRef idx="3">
+            <a:schemeClr val="accent1"/>
+          </a:fillRef>
+          <a:effectRef idx="2">
+            <a:schemeClr val="accent1"/>
+          </a:effectRef>
+          <a:fontRef idx="minor">
+            <a:schemeClr val="lt1"/>
+          </a:fontRef>
+        </p:style>
+        <p:txBody>
+          <a:bodyPr rtlCol="0" anchor="ctr"/>
+          <a:lstStyle/>
+          <a:p>
+            <a:pPr algn="ctr"/>
+          </a:p>
+        </p:txBody>
+      </p:sp>
+      <p:sp>
+        <p:nvSpPr>
+          <p:cNvPr id="34" name="Rectangle 33"/>
+          <p:cNvSpPr/>
+          <p:nvPr/>
+        </p:nvSpPr>
+        <p:spPr>
+          <a:xfrm>
+            <a:off x="182880" y="3675887"/>
+            <a:ext cx="8778240" cy="233172"/>
+          </a:xfrm>
+          <a:prstGeom prst="rect">
+            <a:avLst/>
+          </a:prstGeom>
+          <a:solidFill>
+            <a:srgbClr val="1A1A1A"/>
+          </a:solidFill>
+          <a:ln>
+            <a:noFill/>
+          </a:ln>
+        </p:spPr>
+        <p:style>
+          <a:lnRef idx="1">
+            <a:schemeClr val="accent1"/>
+          </a:lnRef>
+          <a:fillRef idx="3">
+            <a:schemeClr val="accent1"/>
+          </a:fillRef>
+          <a:effectRef idx="2">
+            <a:schemeClr val="accent1"/>
+          </a:effectRef>
+          <a:fontRef idx="minor">
+            <a:schemeClr val="lt1"/>
+          </a:fontRef>
+        </p:style>
+        <p:txBody>
+          <a:bodyPr rtlCol="0" anchor="ctr"/>
+          <a:lstStyle/>
+          <a:p>
+            <a:pPr algn="ctr"/>
+          </a:p>
+        </p:txBody>
+      </p:sp>
+      <p:sp>
+        <p:nvSpPr>
+          <p:cNvPr id="35" name="Rectangle 34"/>
+          <p:cNvSpPr/>
+          <p:nvPr/>
+        </p:nvSpPr>
+        <p:spPr>
+          <a:xfrm>
+            <a:off x="182880" y="3675887"/>
+            <a:ext cx="50292" cy="233172"/>
+          </a:xfrm>
+          <a:prstGeom prst="rect">
+            <a:avLst/>
+          </a:prstGeom>
+          <a:solidFill>
+            <a:srgbClr val="F26A21"/>
+          </a:solidFill>
+          <a:ln>
+            <a:noFill/>
+          </a:ln>
+        </p:spPr>
+        <p:style>
+          <a:lnRef idx="1">
+            <a:schemeClr val="accent1"/>
+          </a:lnRef>
+          <a:fillRef idx="3">
+            <a:schemeClr val="accent1"/>
+          </a:fillRef>
+          <a:effectRef idx="2">
+            <a:schemeClr val="accent1"/>
+          </a:effectRef>
+          <a:fontRef idx="minor">
+            <a:schemeClr val="lt1"/>
+          </a:fontRef>
+        </p:style>
+        <p:txBody>
+          <a:bodyPr rtlCol="0" anchor="ctr"/>
+          <a:lstStyle/>
+          <a:p>
+            <a:pPr algn="ctr"/>
+          </a:p>
+        </p:txBody>
+      </p:sp>
+      <p:sp>
+        <p:nvSpPr>
+          <p:cNvPr id="36" name="TextBox 35"/>
+          <p:cNvSpPr txBox="1"/>
+          <p:nvPr/>
+        </p:nvSpPr>
+        <p:spPr>
+          <a:xfrm>
+            <a:off x="265176" y="3703320"/>
+            <a:ext cx="411480" cy="196596"/>
+          </a:xfrm>
+          <a:prstGeom prst="rect">
+            <a:avLst/>
+          </a:prstGeom>
+          <a:noFill/>
+        </p:spPr>
+        <p:txBody>
+          <a:bodyPr wrap="square">
+            <a:spAutoFit/>
+          </a:bodyPr>
+          <a:lstStyle/>
+          <a:p>
+            <a:pPr algn="l"/>
+            <a:r>
+              <a:rPr sz="2200" b="1" i="0">
+                <a:solidFill>
+                  <a:srgbClr val="F26A21"/>
+                </a:solidFill>
+                <a:latin typeface="Cambria"/>
+              </a:rPr>
+              <a:t>4</a:t>
+            </a:r>
+          </a:p>
+        </p:txBody>
+      </p:sp>
+      <p:sp>
+        <p:nvSpPr>
+          <p:cNvPr id="37" name="TextBox 36"/>
+          <p:cNvSpPr txBox="1"/>
+          <p:nvPr/>
+        </p:nvSpPr>
+        <p:spPr>
+          <a:xfrm>
+            <a:off x="731520" y="3712463"/>
+            <a:ext cx="6629400" cy="178308"/>
+          </a:xfrm>
+          <a:prstGeom prst="rect">
+            <a:avLst/>
+          </a:prstGeom>
+          <a:noFill/>
+        </p:spPr>
+        <p:txBody>
+          <a:bodyPr wrap="square">
+            <a:spAutoFit/>
+          </a:bodyPr>
+          <a:lstStyle/>
+          <a:p>
+            <a:pPr algn="l"/>
+            <a:r>
+              <a:rPr sz="950" b="1" i="0">
+                <a:solidFill>
+                  <a:srgbClr val="FFFFFF"/>
+                </a:solidFill>
+                <a:latin typeface="Calibri"/>
+              </a:rPr>
+              <a:t>Consent to ERP/MRP &amp; Inventory Evaluation (Separate Motion)</a:t>
+            </a:r>
+          </a:p>
+        </p:txBody>
+      </p:sp>
+      <p:sp>
+        <p:nvSpPr>
+          <p:cNvPr id="38" name="TextBox 37"/>
+          <p:cNvSpPr txBox="1"/>
+          <p:nvPr/>
+        </p:nvSpPr>
+        <p:spPr>
+          <a:xfrm>
+            <a:off x="7516367" y="3694175"/>
+            <a:ext cx="1371600" cy="201168"/>
+          </a:xfrm>
+          <a:prstGeom prst="rect">
+            <a:avLst/>
+          </a:prstGeom>
+          <a:noFill/>
+        </p:spPr>
+        <p:txBody>
+          <a:bodyPr wrap="square">
+            <a:spAutoFit/>
+          </a:bodyPr>
+          <a:lstStyle/>
+          <a:p>
+            <a:pPr algn="l"/>
+            <a:r>
+              <a:rPr sz="850" b="0" i="0">
+                <a:solidFill>
+                  <a:srgbClr val="44BB44"/>
+                </a:solidFill>
+                <a:latin typeface="Calibri"/>
+              </a:rPr>
+              <a:t>☐  Approve</a:t>
+            </a:r>
+          </a:p>
+        </p:txBody>
+      </p:sp>
+      <p:sp>
+        <p:nvSpPr>
+          <p:cNvPr id="39" name="TextBox 38"/>
+          <p:cNvSpPr txBox="1"/>
+          <p:nvPr/>
+        </p:nvSpPr>
+        <p:spPr>
+          <a:xfrm>
+            <a:off x="7516367" y="3840479"/>
+            <a:ext cx="1371600" cy="201168"/>
+          </a:xfrm>
+          <a:prstGeom prst="rect">
+            <a:avLst/>
+          </a:prstGeom>
+          <a:noFill/>
+        </p:spPr>
+        <p:txBody>
+          <a:bodyPr wrap="square">
+            <a:spAutoFit/>
+          </a:bodyPr>
+          <a:lstStyle/>
+          <a:p>
+            <a:pPr algn="l"/>
+            <a:r>
+              <a:rPr sz="850" b="0" i="0">
+                <a:solidFill>
+                  <a:srgbClr val="FF6666"/>
+                </a:solidFill>
+                <a:latin typeface="Calibri"/>
+              </a:rPr>
+              <a:t>☐  Decline</a:t>
+            </a:r>
+          </a:p>
+        </p:txBody>
+      </p:sp>
+      <p:sp>
+        <p:nvSpPr>
+          <p:cNvPr id="40" name="TextBox 39"/>
+          <p:cNvSpPr txBox="1"/>
+          <p:nvPr/>
+        </p:nvSpPr>
+        <p:spPr>
+          <a:xfrm>
+            <a:off x="731520" y="3945635"/>
+            <a:ext cx="6629400" cy="562356"/>
+          </a:xfrm>
+          <a:prstGeom prst="rect">
+            <a:avLst/>
+          </a:prstGeom>
+          <a:noFill/>
+        </p:spPr>
+        <p:txBody>
+          <a:bodyPr wrap="square">
+            <a:spAutoFit/>
+          </a:bodyPr>
+          <a:lstStyle/>
+          <a:p>
+            <a:r>
+              <a:rPr sz="750" b="0">
+                <a:solidFill>
+                  <a:srgbClr val="CCCCCC"/>
+                </a:solidFill>
+                <a:latin typeface="Calibri"/>
+              </a:rPr>
+              <a:t>Authorize Exos to use the same QB data to evaluate its in-house ERP/MRP and inventory</a:t>
+            </a:r>
+          </a:p>
+          <a:p>
+            <a:r>
+              <a:rPr sz="750" b="0">
+                <a:solidFill>
+                  <a:srgbClr val="CCCCCC"/>
+                </a:solidFill>
+                <a:latin typeface="Calibri"/>
+              </a:rPr>
+              <a:t>systems for the combined operation.  Confidential under the NDA.</a:t>
+            </a:r>
+          </a:p>
+          <a:p>
+            <a:r>
+              <a:rPr sz="750" b="0">
+                <a:solidFill>
+                  <a:srgbClr val="CCCCCC"/>
+                </a:solidFill>
+                <a:latin typeface="Calibri"/>
+              </a:rPr>
+              <a:t>Does not create any obligation to implement; evaluation only.</a:t>
+            </a:r>
+          </a:p>
+        </p:txBody>
+      </p:sp>
+      <p:sp>
+        <p:nvSpPr>
+          <p:cNvPr id="41" name="Rectangle 40"/>
+          <p:cNvSpPr/>
+          <p:nvPr/>
+        </p:nvSpPr>
+        <p:spPr>
+          <a:xfrm>
+            <a:off x="182880" y="4553712"/>
+            <a:ext cx="8778240" cy="182880"/>
+          </a:xfrm>
+          <a:prstGeom prst="rect">
+            <a:avLst/>
+          </a:prstGeom>
+          <a:solidFill>
+            <a:srgbClr val="1A0A00"/>
+          </a:solidFill>
+          <a:ln>
+            <a:noFill/>
+          </a:ln>
+        </p:spPr>
+        <p:style>
+          <a:lnRef idx="1">
+            <a:schemeClr val="accent1"/>
+          </a:lnRef>
+          <a:fillRef idx="3">
+            <a:schemeClr val="accent1"/>
+          </a:fillRef>
+          <a:effectRef idx="2">
+            <a:schemeClr val="accent1"/>
+          </a:effectRef>
+          <a:fontRef idx="minor">
+            <a:schemeClr val="lt1"/>
+          </a:fontRef>
+        </p:style>
+        <p:txBody>
+          <a:bodyPr rtlCol="0" anchor="ctr"/>
+          <a:lstStyle/>
+          <a:p>
+            <a:pPr algn="ctr"/>
+          </a:p>
+        </p:txBody>
+      </p:sp>
+      <p:sp>
+        <p:nvSpPr>
+          <p:cNvPr id="42" name="TextBox 41"/>
+          <p:cNvSpPr txBox="1"/>
+          <p:nvPr/>
+        </p:nvSpPr>
+        <p:spPr>
+          <a:xfrm>
+            <a:off x="292608" y="4571999"/>
+            <a:ext cx="8549640" cy="155448"/>
+          </a:xfrm>
+          <a:prstGeom prst="rect">
+            <a:avLst/>
+          </a:prstGeom>
+          <a:noFill/>
+        </p:spPr>
+        <p:txBody>
+          <a:bodyPr wrap="square">
+            <a:spAutoFit/>
+          </a:bodyPr>
+          <a:lstStyle/>
+          <a:p>
+            <a:pPr algn="l"/>
+            <a:r>
+              <a:rPr sz="750" b="0" i="1">
+                <a:solidFill>
+                  <a:srgbClr val="F26A21"/>
+                </a:solidFill>
+                <a:latin typeface="Calibri"/>
+              </a:rPr>
+              <a:t>Governance: John Quinn abstains on all motions as an interested director; motions are decided by the disinterested directors.</a:t>
+            </a:r>
+          </a:p>
+        </p:txBody>
+      </p:sp>
+      <p:sp>
+        <p:nvSpPr>
+          <p:cNvPr id="43" name="TextBox 42"/>
+          <p:cNvSpPr txBox="1"/>
+          <p:nvPr/>
+        </p:nvSpPr>
+        <p:spPr>
+          <a:xfrm>
+            <a:off x="1554480" y="4892040"/>
+            <a:ext cx="6035040" cy="201168"/>
+          </a:xfrm>
+          <a:prstGeom prst="rect">
+            <a:avLst/>
+          </a:prstGeom>
+          <a:noFill/>
+        </p:spPr>
+        <p:txBody>
+          <a:bodyPr wrap="square">
+            <a:spAutoFit/>
+          </a:bodyPr>
+          <a:lstStyle/>
+          <a:p>
+            <a:pPr algn="ctr"/>
             <a:r>
               <a:rPr sz="700" b="0" i="1">
                 <a:solidFill>
@@ -4322,7 +4957,7 @@
       </p:sp>
       <p:sp>
         <p:nvSpPr>
-          <p:cNvPr id="29" name="TextBox 28"/>
+          <p:cNvPr id="44" name="TextBox 43"/>
           <p:cNvSpPr txBox="1"/>
           <p:nvPr/>
         </p:nvSpPr>
@@ -4598,7 +5233,7 @@
                   <a:srgbClr val="FFFFFF"/>
                 </a:solidFill>
               </a:rPr>
-              <a:t>Board Votes — Three Motions</a:t>
+              <a:t>Board Votes — Four Motions</a:t>
             </a:r>
             <a:endParaRPr lang="en-US" sz="1400" dirty="0"/>
           </a:p>
@@ -5328,7 +5963,7 @@
                   <a:srgbClr val="F26A21"/>
                 </a:solidFill>
               </a:rPr>
-              <a:t>The Board is asked to vote on Motions 1–3. Questions and open items welcome.</a:t>
+              <a:t>The Board is asked to vote on Motions 1–4. Questions and open items welcome.</a:t>
             </a:r>
             <a:endParaRPr lang="en-US" sz="1300" dirty="0"/>
           </a:p>
@@ -5438,7 +6073,7 @@
                 <a:ea typeface="Cambria" pitchFamily="34" charset="-122"/>
                 <a:cs typeface="Cambria" pitchFamily="34" charset="-120"/>
               </a:rPr>
-              <a:t>The Board is asked to vote on three motions today.</a:t>
+              <a:t>The Board is asked to vote on four motions today.</a:t>
             </a:r>
             <a:endParaRPr lang="en-US" sz="3400" dirty="0"/>
           </a:p>
@@ -5534,7 +6169,7 @@
               <a:buNone/>
             </a:pPr>
             <a:r>
-              <a:rPr lang="en-US" sz="1400" b="1" dirty="0">
+              <a:rPr lang="en-US" sz="1200" b="1" dirty="0">
                 <a:solidFill>
                   <a:srgbClr val="F26A21"/>
                 </a:solidFill>
@@ -5545,7 +6180,7 @@
               <a:buNone/>
             </a:pPr>
             <a:r>
-              <a:rPr lang="en-US" sz="1400" dirty="0">
+              <a:rPr lang="en-US" sz="1200" dirty="0">
                 <a:solidFill>
                   <a:srgbClr val="CCCCCC"/>
                 </a:solidFill>
@@ -5557,7 +6192,7 @@
               <a:buNone/>
             </a:pPr>
             <a:r>
-              <a:rPr lang="en-US" sz="1400" b="1" dirty="0">
+              <a:rPr lang="en-US" sz="1200" b="1" dirty="0">
                 <a:solidFill>
                   <a:srgbClr val="F26A21"/>
                 </a:solidFill>
@@ -5568,7 +6203,7 @@
               <a:buNone/>
             </a:pPr>
             <a:r>
-              <a:rPr lang="en-US" sz="1400" dirty="0">
+              <a:rPr lang="en-US" sz="1200" dirty="0">
                 <a:solidFill>
                   <a:srgbClr val="CCCCCC"/>
                 </a:solidFill>
@@ -5580,18 +6215,35 @@
               <a:buNone/>
             </a:pPr>
             <a:r>
-              <a:rPr lang="en-US" sz="1400" b="1" dirty="0">
+              <a:rPr lang="en-US" sz="1200" b="1" dirty="0">
                 <a:solidFill>
                   <a:srgbClr val="F26A21"/>
                 </a:solidFill>
               </a:rPr>
               <a:t>Motion 3: </a:t>
             </a:r>
+            <a:r>
+              <a:rPr lang="en-US" sz="1200" dirty="0" b="0">
+                <a:solidFill>
+                  <a:srgbClr val="CCCCCC"/>
+                </a:solidFill>
+              </a:rPr>
+              <a:t>Correct AR Unbilled &amp; Deposits accounting within 5 days (A La Carte + outside CPAs)
+</a:t>
+            </a:r>
+            <a:r>
+              <a:rPr lang="en-US" sz="1200" b="1" dirty="0">
+                <a:solidFill>
+                  <a:srgbClr val="F26A21"/>
+                </a:solidFill>
+              </a:rPr>
+              <a:t>Motion 4: </a:t>
+            </a:r>
             <a:pPr indent="0" marL="0">
               <a:buNone/>
             </a:pPr>
             <a:r>
-              <a:rPr lang="en-US" sz="1400" dirty="0">
+              <a:rPr lang="en-US" sz="1200" dirty="0">
                 <a:solidFill>
                   <a:srgbClr val="CCCCCC"/>
                 </a:solidFill>

</xml_diff>

<commit_message>
SSLC Motion 2: add cap table / stock ledger requirement; QB letter matching bullet
- Slide 11 Motion 2: add 2-line requirement for SSLC to provide stock ledger, cap table, subscription agreements, and paid-in capital by shareholder ($1,014,465 total per books; per-holder detail needed for payout-vs-invested comparison at close); Oct 15 deadline applies to these records too
- QB access letter: add matching bullet (para 14) with same language
- Deck pptx v12, deck PDF v7, QB letter v2, board package v2 (17pp)
</commit_message>
<xml_diff>
--- a/drafts/Exos_SSLC_Board_Offer_Overview_2026-10-10_r2.pptx
+++ b/drafts/Exos_SSLC_Board_Offer_Overview_2026-10-10_r2.pptx
@@ -4051,7 +4051,7 @@
           <a:lstStyle/>
           <a:p>
             <a:r>
-              <a:rPr sz="750" b="0">
+              <a:rPr sz="700" b="0">
                 <a:solidFill>
                   <a:srgbClr val="CCCCCC"/>
                 </a:solidFill>
@@ -4062,7 +4062,7 @@
           </a:p>
           <a:p>
             <a:r>
-              <a:rPr sz="750" b="0">
+              <a:rPr sz="700" b="0">
                 <a:solidFill>
                   <a:srgbClr val="CCCCCC"/>
                 </a:solidFill>
@@ -4073,13 +4073,35 @@
           </a:p>
           <a:p>
             <a:r>
-              <a:rPr sz="750" b="0">
+              <a:rPr sz="700" b="0">
                 <a:solidFill>
                   <a:srgbClr val="CCCCCC"/>
                 </a:solidFill>
                 <a:latin typeface="Calibri"/>
               </a:rPr>
               <a:t>Basis: Cal. Corp. Code §1602 director inspection right + AAA §4 confirmatory diligence.</a:t>
+            </a:r>
+          </a:p>
+          <a:p>
+            <a:r>
+              <a:rPr sz="700" b="0">
+                <a:solidFill>
+                  <a:srgbClr val="CCCCCC"/>
+                </a:solidFill>
+                <a:latin typeface="Calibri"/>
+              </a:rPr>
+              <a:t>Also provide: stock ledger, cap table, subscription agreements, and paid-in capital</a:t>
+            </a:r>
+          </a:p>
+          <a:p>
+            <a:r>
+              <a:rPr sz="700" b="0">
+                <a:solidFill>
+                  <a:srgbClr val="CCCCCC"/>
+                </a:solidFill>
+                <a:latin typeface="Calibri"/>
+              </a:rPr>
+              <a:t>by shareholder (books: $1,014,465 total paid-in; need per-holder to compare payout vs. invested).</a:t>
             </a:r>
           </a:p>
           <a:p>

</xml_diff>

<commit_message>
SSLC deck: add slide 11 'Projected Shareholder Payout — Close Jan 15, 2027'
New slide inserted before Board Motions (now slide 12):
- Left panel: waterfall — Exos $2.51M + SSLC cash ~$675K − loans $1.03M − liabilities − deposits − billed-ahead $250K − escrow $125.5K = Net ~$1.51M; + stock $1M + escrow release $126K + earn-outs $2.525M = ~$5.16M over 5 years
- Right panel: paid-in capital breakdown ($1,014,465 total; Exos $790K for 18.06%, other holders ~$224K for 81.94%); projected return ~$2.5M at close / ~$5.2M over 5 yrs = 11×/23× ROIC
- Bottom band: why stock ledger is needed (Motion 2) — 3 bullets incl. 7/24/2024 loan-to-equity conversion
- Footnote with low/high range (net cash $1.28M–$1.74M; 5-yr $3.4M–$7.0M)
- Source: drafts/SSLC_Investor_Payout_Projection_Close_2027-01-15.xlsx (base column, Structure A)
- Board package updated to 18pp (cover + 13-slide deck + offer summary + QB letter)
</commit_message>
<xml_diff>
--- a/drafts/Exos_SSLC_Board_Offer_Overview_2026-10-10_r2.pptx
+++ b/drafts/Exos_SSLC_Board_Offer_Overview_2026-10-10_r2.pptx
@@ -15,6 +15,7 @@
     <p:sldId id="262" r:id="rId8"/>
     <p:sldId id="263" r:id="rId9"/>
     <p:sldId id="264" r:id="rId10"/>
+    <p:sldId id="268" r:id="rId19"/>
     <p:sldId id="267" r:id="rId18"/>
     <p:sldId id="265" r:id="rId11"/>
   </p:sldIdLst>
@@ -819,6 +820,147 @@
             <a:br/>
             <a:r>
               <a:t>Governance: John Quinn abstains as interested director (Exos is offeror; Quinn holds Exos loan to SSLC).</a:t>
+            </a:r>
+          </a:p>
+        </p:txBody>
+      </p:sp>
+      <p:sp>
+        <p:nvSpPr>
+          <p:cNvPr id="4" name="Slide Number Placeholder 3"/>
+          <p:cNvSpPr>
+            <a:spLocks noGrp="1"/>
+          </p:cNvSpPr>
+          <p:nvPr>
+            <p:ph type="sldNum" idx="5" sz="quarter"/>
+          </p:nvPr>
+        </p:nvSpPr>
+        <p:spPr/>
+      </p:sp>
+    </p:spTree>
+  </p:cSld>
+  <p:clrMapOvr>
+    <a:masterClrMapping/>
+  </p:clrMapOvr>
+</p:notes>
+</file>
+
+<file path=ppt/notesSlides/notesSlide13.xml><?xml version="1.0" encoding="utf-8"?>
+<p:notes xmlns:a="http://schemas.openxmlformats.org/drawingml/2006/main" xmlns:p="http://schemas.openxmlformats.org/presentationml/2006/main" xmlns:r="http://schemas.openxmlformats.org/officeDocument/2006/relationships">
+  <p:cSld>
+    <p:spTree>
+      <p:nvGrpSpPr>
+        <p:cNvPr id="1" name=""/>
+        <p:cNvGrpSpPr/>
+        <p:nvPr/>
+      </p:nvGrpSpPr>
+      <p:grpSpPr>
+        <a:xfrm>
+          <a:off x="0" y="0"/>
+          <a:ext cx="0" cy="0"/>
+          <a:chOff x="0" y="0"/>
+          <a:chExt cx="0" cy="0"/>
+        </a:xfrm>
+      </p:grpSpPr>
+      <p:sp>
+        <p:nvSpPr>
+          <p:cNvPr id="2" name="Slide Image Placeholder 1"/>
+          <p:cNvSpPr>
+            <a:spLocks noGrp="1"/>
+          </p:cNvSpPr>
+          <p:nvPr>
+            <p:ph type="sldImg" idx="2"/>
+          </p:nvPr>
+        </p:nvSpPr>
+        <p:spPr/>
+      </p:sp>
+      <p:sp>
+        <p:nvSpPr>
+          <p:cNvPr id="3" name="Notes Placeholder 2"/>
+          <p:cNvSpPr>
+            <a:spLocks noGrp="1"/>
+          </p:cNvSpPr>
+          <p:nvPr>
+            <p:ph type="body" idx="3" sz="quarter"/>
+          </p:nvPr>
+        </p:nvSpPr>
+        <p:spPr/>
+        <p:txBody>
+          <a:bodyPr/>
+          <a:lstStyle/>
+          <a:p>
+            <a:r>
+              <a:t>Projected Shareholder Payout — Sources and Ranges</a:t>
+            </a:r>
+            <a:br/>
+            <a:br/>
+            <a:r>
+              <a:t>BASE CASE:</a:t>
+            </a:r>
+            <a:br/>
+            <a:r>
+              <a:t>  Exos cash price: $2,510,000 (Offer ①)</a:t>
+            </a:r>
+            <a:br/>
+            <a:r>
+              <a:t>  SSLC cash at close: ~$675,000 (est. from $590K on 10/11 + IM pace through Jan 2027)</a:t>
+            </a:r>
+            <a:br/>
+            <a:r>
+              <a:t>  Less: loans &amp; notes $1,027,783 (Microcosm $451K, Bookstore $321K, EIDL $132K, Wertz $92.5K, Exos $31.2K)</a:t>
+            </a:r>
+            <a:br/>
+            <a:r>
+              <a:t>  Less: Exos loan interest ~$8K (11% to 1/15/27)</a:t>
+            </a:r>
+            <a:br/>
+            <a:r>
+              <a:t>  Less: other current liabilities $148,738 (10/11 QB)</a:t>
+            </a:r>
+            <a:br/>
+            <a:r>
+              <a:t>  Less: customer deposits $120,000 (IM; buyer assumes performance)</a:t>
+            </a:r>
+            <a:br/>
+            <a:r>
+              <a:t>  Less: billed-ahead work $250,000 (Exos assessment: base; range $100K–$390K)</a:t>
+            </a:r>
+            <a:br/>
+            <a:r>
+              <a:t>  Less: 5% escrow $125,500 (AAA §7; released at 12 months barring claims)</a:t>
+            </a:r>
+            <a:br/>
+            <a:r>
+              <a:t>  Net cash at close: ~$1.51M</a:t>
+            </a:r>
+            <a:br/>
+            <a:r>
+              <a:t>  Plus: Exos stock $1.0M (EAI units, Rule 504, 409A)</a:t>
+            </a:r>
+            <a:br/>
+            <a:r>
+              <a:t>  Plus: escrow release $126K</a:t>
+            </a:r>
+            <a:br/>
+            <a:r>
+              <a:t>  Plus: earn-outs $2.525M base (FY27–FY31 tank milestones + stock)</a:t>
+            </a:r>
+            <a:br/>
+            <a:r>
+              <a:t>  Total: ~$5.16M</a:t>
+            </a:r>
+            <a:br/>
+            <a:br/>
+            <a:r>
+              <a:t>LOW CASE (net cash $1.28M / 5-yr $3.4M): billed-ahead $390K; SSLC cash stays at $590K; earn-outs $950K</a:t>
+            </a:r>
+            <a:br/>
+            <a:r>
+              <a:t>HIGH CASE (net cash $1.74M / 5-yr $7.0M): billed-ahead $100K; SSLC cash $761K; earn-outs $4.1M</a:t>
+            </a:r>
+            <a:br/>
+            <a:br/>
+            <a:r>
+              <a:t>Stock ledger need: Exos's 18.06% stake credited via $790K in purchase price. Other holders' exact per-share payout cannot be confirmed without stock ledger and subscription agreements. GL records 7/24/2024 conversion: $30K Exos loan → 5,464 shares. Must be reconciled.</a:t>
             </a:r>
           </a:p>
         </p:txBody>
@@ -3279,7 +3421,7 @@
         <p:spPr>
           <a:xfrm>
             <a:off x="228600" y="64008"/>
-            <a:ext cx="8686800" cy="384048"/>
+            <a:ext cx="8686800" cy="402336"/>
           </a:xfrm>
           <a:prstGeom prst="rect">
             <a:avLst/>
@@ -3294,13 +3436,13 @@
           <a:p>
             <a:pPr algn="l"/>
             <a:r>
-              <a:rPr sz="2000" b="1" i="0">
+              <a:rPr sz="1500" b="1">
                 <a:solidFill>
                   <a:srgbClr val="FFFFFF"/>
                 </a:solidFill>
                 <a:latin typeface="Cambria"/>
               </a:rPr>
-              <a:t>Board Motions</a:t>
+              <a:t>Projected Shareholder Payout — Close Jan 15, 2027  (Base Case, Current Books)</a:t>
             </a:r>
           </a:p>
         </p:txBody>
@@ -3313,8 +3455,8 @@
         </p:nvSpPr>
         <p:spPr>
           <a:xfrm>
-            <a:off x="228600" y="457200"/>
-            <a:ext cx="1371600" cy="32004"/>
+            <a:off x="228600" y="466344"/>
+            <a:ext cx="2011680" cy="32004"/>
           </a:xfrm>
           <a:prstGeom prst="rect">
             <a:avLst/>
@@ -3356,8 +3498,8 @@
         </p:nvSpPr>
         <p:spPr>
           <a:xfrm>
-            <a:off x="182880" y="512064"/>
-            <a:ext cx="8778240" cy="896112"/>
+            <a:off x="164592" y="521207"/>
+            <a:ext cx="4315968" cy="3511296"/>
           </a:xfrm>
           <a:prstGeom prst="rect">
             <a:avLst/>
@@ -3399,8 +3541,8 @@
         </p:nvSpPr>
         <p:spPr>
           <a:xfrm>
-            <a:off x="182880" y="512064"/>
-            <a:ext cx="50292" cy="896112"/>
+            <a:off x="164592" y="521207"/>
+            <a:ext cx="45720" cy="3511296"/>
           </a:xfrm>
           <a:prstGeom prst="rect">
             <a:avLst/>
@@ -3436,20 +3578,195 @@
       </p:sp>
       <p:sp>
         <p:nvSpPr>
-          <p:cNvPr id="7" name="Rectangle 6"/>
+          <p:cNvPr id="7" name="TextBox 6"/>
+          <p:cNvSpPr txBox="1"/>
+          <p:nvPr/>
+        </p:nvSpPr>
+        <p:spPr>
+          <a:xfrm>
+            <a:off x="274320" y="576071"/>
+            <a:ext cx="4151376" cy="201168"/>
+          </a:xfrm>
+          <a:prstGeom prst="rect">
+            <a:avLst/>
+          </a:prstGeom>
+          <a:noFill/>
+        </p:spPr>
+        <p:txBody>
+          <a:bodyPr wrap="square">
+            <a:spAutoFit/>
+          </a:bodyPr>
+          <a:lstStyle/>
+          <a:p>
+            <a:pPr algn="l"/>
+            <a:r>
+              <a:rPr sz="950" b="1" i="0">
+                <a:solidFill>
+                  <a:srgbClr val="F26A21"/>
+                </a:solidFill>
+                <a:latin typeface="Calibri"/>
+              </a:rPr>
+              <a:t>Cash to Shareholders at Close</a:t>
+            </a:r>
+          </a:p>
+        </p:txBody>
+      </p:sp>
+      <p:sp>
+        <p:nvSpPr>
+          <p:cNvPr id="8" name="TextBox 7"/>
+          <p:cNvSpPr txBox="1"/>
+          <p:nvPr/>
+        </p:nvSpPr>
+        <p:spPr>
+          <a:xfrm>
+            <a:off x="274320" y="795527"/>
+            <a:ext cx="3154679" cy="169164"/>
+          </a:xfrm>
+          <a:prstGeom prst="rect">
+            <a:avLst/>
+          </a:prstGeom>
+          <a:noFill/>
+        </p:spPr>
+        <p:txBody>
+          <a:bodyPr wrap="square">
+            <a:spAutoFit/>
+          </a:bodyPr>
+          <a:lstStyle/>
+          <a:p>
+            <a:pPr algn="l"/>
+            <a:r>
+              <a:rPr sz="750" b="0" i="0">
+                <a:solidFill>
+                  <a:srgbClr val="CCCCCC"/>
+                </a:solidFill>
+                <a:latin typeface="Calibri"/>
+              </a:rPr>
+              <a:t>Exos cash purchase price</a:t>
+            </a:r>
+          </a:p>
+        </p:txBody>
+      </p:sp>
+      <p:sp>
+        <p:nvSpPr>
+          <p:cNvPr id="9" name="TextBox 8"/>
+          <p:cNvSpPr txBox="1"/>
+          <p:nvPr/>
+        </p:nvSpPr>
+        <p:spPr>
+          <a:xfrm>
+            <a:off x="3474719" y="795527"/>
+            <a:ext cx="914400" cy="169164"/>
+          </a:xfrm>
+          <a:prstGeom prst="rect">
+            <a:avLst/>
+          </a:prstGeom>
+          <a:noFill/>
+        </p:spPr>
+        <p:txBody>
+          <a:bodyPr wrap="square">
+            <a:spAutoFit/>
+          </a:bodyPr>
+          <a:lstStyle/>
+          <a:p>
+            <a:pPr algn="r"/>
+            <a:r>
+              <a:rPr sz="750" b="0" i="0">
+                <a:solidFill>
+                  <a:srgbClr val="FFFFFF"/>
+                </a:solidFill>
+                <a:latin typeface="Calibri"/>
+              </a:rPr>
+              <a:t>+$2,510,000</a:t>
+            </a:r>
+          </a:p>
+        </p:txBody>
+      </p:sp>
+      <p:sp>
+        <p:nvSpPr>
+          <p:cNvPr id="10" name="TextBox 9"/>
+          <p:cNvSpPr txBox="1"/>
+          <p:nvPr/>
+        </p:nvSpPr>
+        <p:spPr>
+          <a:xfrm>
+            <a:off x="274320" y="960119"/>
+            <a:ext cx="3154679" cy="169164"/>
+          </a:xfrm>
+          <a:prstGeom prst="rect">
+            <a:avLst/>
+          </a:prstGeom>
+          <a:noFill/>
+        </p:spPr>
+        <p:txBody>
+          <a:bodyPr wrap="square">
+            <a:spAutoFit/>
+          </a:bodyPr>
+          <a:lstStyle/>
+          <a:p>
+            <a:pPr algn="l"/>
+            <a:r>
+              <a:rPr sz="750" b="0" i="1">
+                <a:solidFill>
+                  <a:srgbClr val="888888"/>
+                </a:solidFill>
+                <a:latin typeface="Calibri"/>
+              </a:rPr>
+              <a:t>+ SSLC cash at close (est.; $590K on 10/11)</a:t>
+            </a:r>
+          </a:p>
+        </p:txBody>
+      </p:sp>
+      <p:sp>
+        <p:nvSpPr>
+          <p:cNvPr id="11" name="TextBox 10"/>
+          <p:cNvSpPr txBox="1"/>
+          <p:nvPr/>
+        </p:nvSpPr>
+        <p:spPr>
+          <a:xfrm>
+            <a:off x="3474719" y="960119"/>
+            <a:ext cx="914400" cy="169164"/>
+          </a:xfrm>
+          <a:prstGeom prst="rect">
+            <a:avLst/>
+          </a:prstGeom>
+          <a:noFill/>
+        </p:spPr>
+        <p:txBody>
+          <a:bodyPr wrap="square">
+            <a:spAutoFit/>
+          </a:bodyPr>
+          <a:lstStyle/>
+          <a:p>
+            <a:pPr algn="r"/>
+            <a:r>
+              <a:rPr sz="750" b="0" i="0">
+                <a:solidFill>
+                  <a:srgbClr val="888888"/>
+                </a:solidFill>
+                <a:latin typeface="Calibri"/>
+              </a:rPr>
+              <a:t>+$675,000</a:t>
+            </a:r>
+          </a:p>
+        </p:txBody>
+      </p:sp>
+      <p:sp>
+        <p:nvSpPr>
+          <p:cNvPr id="12" name="Rectangle 11"/>
           <p:cNvSpPr/>
           <p:nvPr/>
         </p:nvSpPr>
         <p:spPr>
           <a:xfrm>
-            <a:off x="182880" y="512064"/>
-            <a:ext cx="8778240" cy="233172"/>
+            <a:off x="274320" y="1161287"/>
+            <a:ext cx="4151376" cy="9144"/>
           </a:xfrm>
           <a:prstGeom prst="rect">
             <a:avLst/>
           </a:prstGeom>
           <a:solidFill>
-            <a:srgbClr val="1A1A1A"/>
+            <a:srgbClr val="444444"/>
           </a:solidFill>
           <a:ln>
             <a:noFill/>
@@ -3479,14 +3796,469 @@
       </p:sp>
       <p:sp>
         <p:nvSpPr>
-          <p:cNvPr id="8" name="Rectangle 7"/>
+          <p:cNvPr id="13" name="TextBox 12"/>
+          <p:cNvSpPr txBox="1"/>
+          <p:nvPr/>
+        </p:nvSpPr>
+        <p:spPr>
+          <a:xfrm>
+            <a:off x="274320" y="1124711"/>
+            <a:ext cx="3154679" cy="169164"/>
+          </a:xfrm>
+          <a:prstGeom prst="rect">
+            <a:avLst/>
+          </a:prstGeom>
+          <a:noFill/>
+        </p:spPr>
+        <p:txBody>
+          <a:bodyPr wrap="square">
+            <a:spAutoFit/>
+          </a:bodyPr>
+          <a:lstStyle/>
+          <a:p>
+            <a:pPr algn="l"/>
+            <a:r>
+              <a:rPr sz="750" b="0" i="0">
+                <a:solidFill>
+                  <a:srgbClr val="CCCCCC"/>
+                </a:solidFill>
+                <a:latin typeface="Calibri"/>
+              </a:rPr>
+              <a:t>Subtotal inflows</a:t>
+            </a:r>
+          </a:p>
+        </p:txBody>
+      </p:sp>
+      <p:sp>
+        <p:nvSpPr>
+          <p:cNvPr id="14" name="TextBox 13"/>
+          <p:cNvSpPr txBox="1"/>
+          <p:nvPr/>
+        </p:nvSpPr>
+        <p:spPr>
+          <a:xfrm>
+            <a:off x="3474719" y="1124711"/>
+            <a:ext cx="914400" cy="169164"/>
+          </a:xfrm>
+          <a:prstGeom prst="rect">
+            <a:avLst/>
+          </a:prstGeom>
+          <a:noFill/>
+        </p:spPr>
+        <p:txBody>
+          <a:bodyPr wrap="square">
+            <a:spAutoFit/>
+          </a:bodyPr>
+          <a:lstStyle/>
+          <a:p>
+            <a:pPr algn="r"/>
+            <a:r>
+              <a:rPr sz="750" b="1" i="0">
+                <a:solidFill>
+                  <a:srgbClr val="CCCCCC"/>
+                </a:solidFill>
+                <a:latin typeface="Calibri"/>
+              </a:rPr>
+              <a:t>$3,185,000</a:t>
+            </a:r>
+          </a:p>
+        </p:txBody>
+      </p:sp>
+      <p:sp>
+        <p:nvSpPr>
+          <p:cNvPr id="15" name="TextBox 14"/>
+          <p:cNvSpPr txBox="1"/>
+          <p:nvPr/>
+        </p:nvSpPr>
+        <p:spPr>
+          <a:xfrm>
+            <a:off x="274320" y="1298447"/>
+            <a:ext cx="3154679" cy="169164"/>
+          </a:xfrm>
+          <a:prstGeom prst="rect">
+            <a:avLst/>
+          </a:prstGeom>
+          <a:noFill/>
+        </p:spPr>
+        <p:txBody>
+          <a:bodyPr wrap="square">
+            <a:spAutoFit/>
+          </a:bodyPr>
+          <a:lstStyle/>
+          <a:p>
+            <a:pPr algn="l"/>
+            <a:r>
+              <a:rPr sz="750" b="0" i="0">
+                <a:solidFill>
+                  <a:srgbClr val="CCCCCC"/>
+                </a:solidFill>
+                <a:latin typeface="Calibri"/>
+              </a:rPr>
+              <a:t>− SSLC loans &amp; notes</a:t>
+            </a:r>
+          </a:p>
+        </p:txBody>
+      </p:sp>
+      <p:sp>
+        <p:nvSpPr>
+          <p:cNvPr id="16" name="TextBox 15"/>
+          <p:cNvSpPr txBox="1"/>
+          <p:nvPr/>
+        </p:nvSpPr>
+        <p:spPr>
+          <a:xfrm>
+            <a:off x="3474719" y="1298447"/>
+            <a:ext cx="914400" cy="169164"/>
+          </a:xfrm>
+          <a:prstGeom prst="rect">
+            <a:avLst/>
+          </a:prstGeom>
+          <a:noFill/>
+        </p:spPr>
+        <p:txBody>
+          <a:bodyPr wrap="square">
+            <a:spAutoFit/>
+          </a:bodyPr>
+          <a:lstStyle/>
+          <a:p>
+            <a:pPr algn="r"/>
+            <a:r>
+              <a:rPr sz="750" b="0" i="0">
+                <a:solidFill>
+                  <a:srgbClr val="FF7755"/>
+                </a:solidFill>
+                <a:latin typeface="Calibri"/>
+              </a:rPr>
+              <a:t>($1,027,783)</a:t>
+            </a:r>
+          </a:p>
+        </p:txBody>
+      </p:sp>
+      <p:sp>
+        <p:nvSpPr>
+          <p:cNvPr id="17" name="TextBox 16"/>
+          <p:cNvSpPr txBox="1"/>
+          <p:nvPr/>
+        </p:nvSpPr>
+        <p:spPr>
+          <a:xfrm>
+            <a:off x="274320" y="1449323"/>
+            <a:ext cx="4151376" cy="146304"/>
+          </a:xfrm>
+          <a:prstGeom prst="rect">
+            <a:avLst/>
+          </a:prstGeom>
+          <a:noFill/>
+        </p:spPr>
+        <p:txBody>
+          <a:bodyPr wrap="square">
+            <a:spAutoFit/>
+          </a:bodyPr>
+          <a:lstStyle/>
+          <a:p>
+            <a:pPr algn="l"/>
+            <a:r>
+              <a:rPr sz="650" b="0" i="1">
+                <a:solidFill>
+                  <a:srgbClr val="888888"/>
+                </a:solidFill>
+                <a:latin typeface="Calibri"/>
+              </a:rPr>
+              <a:t>  Microcosm $451K · Bookstore $321K · EIDL $132K · Wertz $92.5K · Exos $31.2K+int</a:t>
+            </a:r>
+          </a:p>
+        </p:txBody>
+      </p:sp>
+      <p:sp>
+        <p:nvSpPr>
+          <p:cNvPr id="18" name="TextBox 17"/>
+          <p:cNvSpPr txBox="1"/>
+          <p:nvPr/>
+        </p:nvSpPr>
+        <p:spPr>
+          <a:xfrm>
+            <a:off x="274320" y="1591055"/>
+            <a:ext cx="3154679" cy="169164"/>
+          </a:xfrm>
+          <a:prstGeom prst="rect">
+            <a:avLst/>
+          </a:prstGeom>
+          <a:noFill/>
+        </p:spPr>
+        <p:txBody>
+          <a:bodyPr wrap="square">
+            <a:spAutoFit/>
+          </a:bodyPr>
+          <a:lstStyle/>
+          <a:p>
+            <a:pPr algn="l"/>
+            <a:r>
+              <a:rPr sz="750" b="0" i="0">
+                <a:solidFill>
+                  <a:srgbClr val="CCCCCC"/>
+                </a:solidFill>
+                <a:latin typeface="Calibri"/>
+              </a:rPr>
+              <a:t>− Other current liabilities (AP, accruals)</a:t>
+            </a:r>
+          </a:p>
+        </p:txBody>
+      </p:sp>
+      <p:sp>
+        <p:nvSpPr>
+          <p:cNvPr id="19" name="TextBox 18"/>
+          <p:cNvSpPr txBox="1"/>
+          <p:nvPr/>
+        </p:nvSpPr>
+        <p:spPr>
+          <a:xfrm>
+            <a:off x="3474719" y="1591055"/>
+            <a:ext cx="914400" cy="169164"/>
+          </a:xfrm>
+          <a:prstGeom prst="rect">
+            <a:avLst/>
+          </a:prstGeom>
+          <a:noFill/>
+        </p:spPr>
+        <p:txBody>
+          <a:bodyPr wrap="square">
+            <a:spAutoFit/>
+          </a:bodyPr>
+          <a:lstStyle/>
+          <a:p>
+            <a:pPr algn="r"/>
+            <a:r>
+              <a:rPr sz="750" b="0" i="0">
+                <a:solidFill>
+                  <a:srgbClr val="FF7755"/>
+                </a:solidFill>
+                <a:latin typeface="Calibri"/>
+              </a:rPr>
+              <a:t>($148,738)</a:t>
+            </a:r>
+          </a:p>
+        </p:txBody>
+      </p:sp>
+      <p:sp>
+        <p:nvSpPr>
+          <p:cNvPr id="20" name="TextBox 19"/>
+          <p:cNvSpPr txBox="1"/>
+          <p:nvPr/>
+        </p:nvSpPr>
+        <p:spPr>
+          <a:xfrm>
+            <a:off x="274320" y="1755647"/>
+            <a:ext cx="3154679" cy="169164"/>
+          </a:xfrm>
+          <a:prstGeom prst="rect">
+            <a:avLst/>
+          </a:prstGeom>
+          <a:noFill/>
+        </p:spPr>
+        <p:txBody>
+          <a:bodyPr wrap="square">
+            <a:spAutoFit/>
+          </a:bodyPr>
+          <a:lstStyle/>
+          <a:p>
+            <a:pPr algn="l"/>
+            <a:r>
+              <a:rPr sz="750" b="0" i="0">
+                <a:solidFill>
+                  <a:srgbClr val="CCCCCC"/>
+                </a:solidFill>
+                <a:latin typeface="Calibri"/>
+              </a:rPr>
+              <a:t>− Customer deposits (IM, transferred)</a:t>
+            </a:r>
+          </a:p>
+        </p:txBody>
+      </p:sp>
+      <p:sp>
+        <p:nvSpPr>
+          <p:cNvPr id="21" name="TextBox 20"/>
+          <p:cNvSpPr txBox="1"/>
+          <p:nvPr/>
+        </p:nvSpPr>
+        <p:spPr>
+          <a:xfrm>
+            <a:off x="3474719" y="1755647"/>
+            <a:ext cx="914400" cy="169164"/>
+          </a:xfrm>
+          <a:prstGeom prst="rect">
+            <a:avLst/>
+          </a:prstGeom>
+          <a:noFill/>
+        </p:spPr>
+        <p:txBody>
+          <a:bodyPr wrap="square">
+            <a:spAutoFit/>
+          </a:bodyPr>
+          <a:lstStyle/>
+          <a:p>
+            <a:pPr algn="r"/>
+            <a:r>
+              <a:rPr sz="750" b="0" i="0">
+                <a:solidFill>
+                  <a:srgbClr val="FF7755"/>
+                </a:solidFill>
+                <a:latin typeface="Calibri"/>
+              </a:rPr>
+              <a:t>($120,000)</a:t>
+            </a:r>
+          </a:p>
+        </p:txBody>
+      </p:sp>
+      <p:sp>
+        <p:nvSpPr>
+          <p:cNvPr id="22" name="TextBox 21"/>
+          <p:cNvSpPr txBox="1"/>
+          <p:nvPr/>
+        </p:nvSpPr>
+        <p:spPr>
+          <a:xfrm>
+            <a:off x="274320" y="1920239"/>
+            <a:ext cx="3154679" cy="169164"/>
+          </a:xfrm>
+          <a:prstGeom prst="rect">
+            <a:avLst/>
+          </a:prstGeom>
+          <a:noFill/>
+        </p:spPr>
+        <p:txBody>
+          <a:bodyPr wrap="square">
+            <a:spAutoFit/>
+          </a:bodyPr>
+          <a:lstStyle/>
+          <a:p>
+            <a:pPr algn="l"/>
+            <a:r>
+              <a:rPr sz="750" b="0" i="0">
+                <a:solidFill>
+                  <a:srgbClr val="CCCCCC"/>
+                </a:solidFill>
+                <a:latin typeface="Calibri"/>
+              </a:rPr>
+              <a:t>− Billed-ahead work, genuine (Exos est.)</a:t>
+            </a:r>
+          </a:p>
+        </p:txBody>
+      </p:sp>
+      <p:sp>
+        <p:nvSpPr>
+          <p:cNvPr id="23" name="TextBox 22"/>
+          <p:cNvSpPr txBox="1"/>
+          <p:nvPr/>
+        </p:nvSpPr>
+        <p:spPr>
+          <a:xfrm>
+            <a:off x="3474719" y="1920239"/>
+            <a:ext cx="914400" cy="169164"/>
+          </a:xfrm>
+          <a:prstGeom prst="rect">
+            <a:avLst/>
+          </a:prstGeom>
+          <a:noFill/>
+        </p:spPr>
+        <p:txBody>
+          <a:bodyPr wrap="square">
+            <a:spAutoFit/>
+          </a:bodyPr>
+          <a:lstStyle/>
+          <a:p>
+            <a:pPr algn="r"/>
+            <a:r>
+              <a:rPr sz="750" b="0" i="0">
+                <a:solidFill>
+                  <a:srgbClr val="FF7755"/>
+                </a:solidFill>
+                <a:latin typeface="Calibri"/>
+              </a:rPr>
+              <a:t>($250,000)</a:t>
+            </a:r>
+          </a:p>
+        </p:txBody>
+      </p:sp>
+      <p:sp>
+        <p:nvSpPr>
+          <p:cNvPr id="24" name="TextBox 23"/>
+          <p:cNvSpPr txBox="1"/>
+          <p:nvPr/>
+        </p:nvSpPr>
+        <p:spPr>
+          <a:xfrm>
+            <a:off x="274320" y="2084831"/>
+            <a:ext cx="3154679" cy="169164"/>
+          </a:xfrm>
+          <a:prstGeom prst="rect">
+            <a:avLst/>
+          </a:prstGeom>
+          <a:noFill/>
+        </p:spPr>
+        <p:txBody>
+          <a:bodyPr wrap="square">
+            <a:spAutoFit/>
+          </a:bodyPr>
+          <a:lstStyle/>
+          <a:p>
+            <a:pPr algn="l"/>
+            <a:r>
+              <a:rPr sz="750" b="0" i="0">
+                <a:solidFill>
+                  <a:srgbClr val="CCCCCC"/>
+                </a:solidFill>
+                <a:latin typeface="Calibri"/>
+              </a:rPr>
+              <a:t>− 5% escrow holdback (released 12 months)</a:t>
+            </a:r>
+          </a:p>
+        </p:txBody>
+      </p:sp>
+      <p:sp>
+        <p:nvSpPr>
+          <p:cNvPr id="25" name="TextBox 24"/>
+          <p:cNvSpPr txBox="1"/>
+          <p:nvPr/>
+        </p:nvSpPr>
+        <p:spPr>
+          <a:xfrm>
+            <a:off x="3474719" y="2084831"/>
+            <a:ext cx="914400" cy="169164"/>
+          </a:xfrm>
+          <a:prstGeom prst="rect">
+            <a:avLst/>
+          </a:prstGeom>
+          <a:noFill/>
+        </p:spPr>
+        <p:txBody>
+          <a:bodyPr wrap="square">
+            <a:spAutoFit/>
+          </a:bodyPr>
+          <a:lstStyle/>
+          <a:p>
+            <a:pPr algn="r"/>
+            <a:r>
+              <a:rPr sz="750" b="0" i="0">
+                <a:solidFill>
+                  <a:srgbClr val="FF7755"/>
+                </a:solidFill>
+                <a:latin typeface="Calibri"/>
+              </a:rPr>
+              <a:t>($125,500)</a:t>
+            </a:r>
+          </a:p>
+        </p:txBody>
+      </p:sp>
+      <p:sp>
+        <p:nvSpPr>
+          <p:cNvPr id="26" name="Rectangle 25"/>
           <p:cNvSpPr/>
           <p:nvPr/>
         </p:nvSpPr>
         <p:spPr>
           <a:xfrm>
-            <a:off x="182880" y="512064"/>
-            <a:ext cx="50292" cy="233172"/>
+            <a:off x="274320" y="2258568"/>
+            <a:ext cx="4151376" cy="13716"/>
           </a:xfrm>
           <a:prstGeom prst="rect">
             <a:avLst/>
@@ -3522,14 +4294,14 @@
       </p:sp>
       <p:sp>
         <p:nvSpPr>
-          <p:cNvPr id="9" name="TextBox 8"/>
-          <p:cNvSpPr txBox="1"/>
-          <p:nvPr/>
-        </p:nvSpPr>
-        <p:spPr>
-          <a:xfrm>
-            <a:off x="265176" y="539496"/>
-            <a:ext cx="411480" cy="196596"/>
+          <p:cNvPr id="27" name="TextBox 26"/>
+          <p:cNvSpPr txBox="1"/>
+          <p:nvPr/>
+        </p:nvSpPr>
+        <p:spPr>
+          <a:xfrm>
+            <a:off x="274320" y="2286000"/>
+            <a:ext cx="3154679" cy="201168"/>
           </a:xfrm>
           <a:prstGeom prst="rect">
             <a:avLst/>
@@ -3544,27 +4316,27 @@
           <a:p>
             <a:pPr algn="l"/>
             <a:r>
-              <a:rPr sz="2200" b="1" i="0">
-                <a:solidFill>
-                  <a:srgbClr val="F26A21"/>
-                </a:solidFill>
-                <a:latin typeface="Cambria"/>
-              </a:rPr>
-              <a:t>1</a:t>
-            </a:r>
-          </a:p>
-        </p:txBody>
-      </p:sp>
-      <p:sp>
-        <p:nvSpPr>
-          <p:cNvPr id="10" name="TextBox 9"/>
-          <p:cNvSpPr txBox="1"/>
-          <p:nvPr/>
-        </p:nvSpPr>
-        <p:spPr>
-          <a:xfrm>
-            <a:off x="731520" y="548640"/>
-            <a:ext cx="6629400" cy="178308"/>
+              <a:rPr sz="900" b="1" i="0">
+                <a:solidFill>
+                  <a:srgbClr val="FFFFFF"/>
+                </a:solidFill>
+                <a:latin typeface="Calibri"/>
+              </a:rPr>
+              <a:t>Net cash distributable at close</a:t>
+            </a:r>
+          </a:p>
+        </p:txBody>
+      </p:sp>
+      <p:sp>
+        <p:nvSpPr>
+          <p:cNvPr id="28" name="TextBox 27"/>
+          <p:cNvSpPr txBox="1"/>
+          <p:nvPr/>
+        </p:nvSpPr>
+        <p:spPr>
+          <a:xfrm>
+            <a:off x="3474719" y="2286000"/>
+            <a:ext cx="914400" cy="201168"/>
           </a:xfrm>
           <a:prstGeom prst="rect">
             <a:avLst/>
@@ -3577,29 +4349,29 @@
           </a:bodyPr>
           <a:lstStyle/>
           <a:p>
-            <a:pPr algn="l"/>
-            <a:r>
-              <a:rPr sz="950" b="1" i="0">
-                <a:solidFill>
-                  <a:srgbClr val="FFFFFF"/>
+            <a:pPr algn="r"/>
+            <a:r>
+              <a:rPr sz="1100" b="1" i="0">
+                <a:solidFill>
+                  <a:srgbClr val="F26A21"/>
                 </a:solidFill>
                 <a:latin typeface="Calibri"/>
               </a:rPr>
-              <a:t>Confirm §3 Exclusivity (May 2025 Asset Acquisition Agreement)</a:t>
-            </a:r>
-          </a:p>
-        </p:txBody>
-      </p:sp>
-      <p:sp>
-        <p:nvSpPr>
-          <p:cNvPr id="11" name="TextBox 10"/>
-          <p:cNvSpPr txBox="1"/>
-          <p:nvPr/>
-        </p:nvSpPr>
-        <p:spPr>
-          <a:xfrm>
-            <a:off x="7516367" y="530352"/>
-            <a:ext cx="1371600" cy="201168"/>
+              <a:t>~$1.51M</a:t>
+            </a:r>
+          </a:p>
+        </p:txBody>
+      </p:sp>
+      <p:sp>
+        <p:nvSpPr>
+          <p:cNvPr id="29" name="TextBox 28"/>
+          <p:cNvSpPr txBox="1"/>
+          <p:nvPr/>
+        </p:nvSpPr>
+        <p:spPr>
+          <a:xfrm>
+            <a:off x="274320" y="2500884"/>
+            <a:ext cx="3154679" cy="169164"/>
           </a:xfrm>
           <a:prstGeom prst="rect">
             <a:avLst/>
@@ -3614,27 +4386,27 @@
           <a:p>
             <a:pPr algn="l"/>
             <a:r>
-              <a:rPr sz="850" b="0" i="0">
-                <a:solidFill>
-                  <a:srgbClr val="44BB44"/>
+              <a:rPr sz="750" b="0" i="0">
+                <a:solidFill>
+                  <a:srgbClr val="CCCCCC"/>
                 </a:solidFill>
                 <a:latin typeface="Calibri"/>
               </a:rPr>
-              <a:t>☐  Approve</a:t>
-            </a:r>
-          </a:p>
-        </p:txBody>
-      </p:sp>
-      <p:sp>
-        <p:nvSpPr>
-          <p:cNvPr id="12" name="TextBox 11"/>
-          <p:cNvSpPr txBox="1"/>
-          <p:nvPr/>
-        </p:nvSpPr>
-        <p:spPr>
-          <a:xfrm>
-            <a:off x="7516367" y="676656"/>
-            <a:ext cx="1371600" cy="201168"/>
+              <a:t>+ Exos stock (EAI units, Rule 504, 409A)</a:t>
+            </a:r>
+          </a:p>
+        </p:txBody>
+      </p:sp>
+      <p:sp>
+        <p:nvSpPr>
+          <p:cNvPr id="30" name="TextBox 29"/>
+          <p:cNvSpPr txBox="1"/>
+          <p:nvPr/>
+        </p:nvSpPr>
+        <p:spPr>
+          <a:xfrm>
+            <a:off x="3474719" y="2500884"/>
+            <a:ext cx="914400" cy="169164"/>
           </a:xfrm>
           <a:prstGeom prst="rect">
             <a:avLst/>
@@ -3647,29 +4419,29 @@
           </a:bodyPr>
           <a:lstStyle/>
           <a:p>
-            <a:pPr algn="l"/>
-            <a:r>
-              <a:rPr sz="850" b="0" i="0">
-                <a:solidFill>
-                  <a:srgbClr val="FF6666"/>
+            <a:pPr algn="r"/>
+            <a:r>
+              <a:rPr sz="750" b="0" i="0">
+                <a:solidFill>
+                  <a:srgbClr val="44BB44"/>
                 </a:solidFill>
                 <a:latin typeface="Calibri"/>
               </a:rPr>
-              <a:t>☐  Decline</a:t>
-            </a:r>
-          </a:p>
-        </p:txBody>
-      </p:sp>
-      <p:sp>
-        <p:nvSpPr>
-          <p:cNvPr id="13" name="TextBox 12"/>
-          <p:cNvSpPr txBox="1"/>
-          <p:nvPr/>
-        </p:nvSpPr>
-        <p:spPr>
-          <a:xfrm>
-            <a:off x="731520" y="781812"/>
-            <a:ext cx="6629400" cy="608076"/>
+              <a:t>+$1,000,000</a:t>
+            </a:r>
+          </a:p>
+        </p:txBody>
+      </p:sp>
+      <p:sp>
+        <p:nvSpPr>
+          <p:cNvPr id="31" name="TextBox 30"/>
+          <p:cNvSpPr txBox="1"/>
+          <p:nvPr/>
+        </p:nvSpPr>
+        <p:spPr>
+          <a:xfrm>
+            <a:off x="274320" y="2665476"/>
+            <a:ext cx="3154679" cy="169164"/>
           </a:xfrm>
           <a:prstGeom prst="rect">
             <a:avLst/>
@@ -3682,56 +4454,140 @@
           </a:bodyPr>
           <a:lstStyle/>
           <a:p>
-            <a:r>
-              <a:rPr sz="750" b="0">
+            <a:pPr algn="l"/>
+            <a:r>
+              <a:rPr sz="750" b="0" i="0">
                 <a:solidFill>
                   <a:srgbClr val="CCCCCC"/>
                 </a:solidFill>
                 <a:latin typeface="Calibri"/>
               </a:rPr>
-              <a:t>Approve a 90-day exclusivity period beginning on the date of this approval.</a:t>
-            </a:r>
-          </a:p>
-          <a:p>
-            <a:r>
-              <a:rPr sz="750" b="0">
+              <a:t>+ Escrow release at 12 months</a:t>
+            </a:r>
+          </a:p>
+        </p:txBody>
+      </p:sp>
+      <p:sp>
+        <p:nvSpPr>
+          <p:cNvPr id="32" name="TextBox 31"/>
+          <p:cNvSpPr txBox="1"/>
+          <p:nvPr/>
+        </p:nvSpPr>
+        <p:spPr>
+          <a:xfrm>
+            <a:off x="3474719" y="2665476"/>
+            <a:ext cx="914400" cy="169164"/>
+          </a:xfrm>
+          <a:prstGeom prst="rect">
+            <a:avLst/>
+          </a:prstGeom>
+          <a:noFill/>
+        </p:spPr>
+        <p:txBody>
+          <a:bodyPr wrap="square">
+            <a:spAutoFit/>
+          </a:bodyPr>
+          <a:lstStyle/>
+          <a:p>
+            <a:pPr algn="r"/>
+            <a:r>
+              <a:rPr sz="750" b="0" i="0">
+                <a:solidFill>
+                  <a:srgbClr val="44BB44"/>
+                </a:solidFill>
+                <a:latin typeface="Calibri"/>
+              </a:rPr>
+              <a:t>+$126,000</a:t>
+            </a:r>
+          </a:p>
+        </p:txBody>
+      </p:sp>
+      <p:sp>
+        <p:nvSpPr>
+          <p:cNvPr id="33" name="TextBox 32"/>
+          <p:cNvSpPr txBox="1"/>
+          <p:nvPr/>
+        </p:nvSpPr>
+        <p:spPr>
+          <a:xfrm>
+            <a:off x="274320" y="2830068"/>
+            <a:ext cx="3154679" cy="169164"/>
+          </a:xfrm>
+          <a:prstGeom prst="rect">
+            <a:avLst/>
+          </a:prstGeom>
+          <a:noFill/>
+        </p:spPr>
+        <p:txBody>
+          <a:bodyPr wrap="square">
+            <a:spAutoFit/>
+          </a:bodyPr>
+          <a:lstStyle/>
+          <a:p>
+            <a:pPr algn="l"/>
+            <a:r>
+              <a:rPr sz="750" b="0" i="0">
                 <a:solidFill>
                   <a:srgbClr val="CCCCCC"/>
                 </a:solidFill>
                 <a:latin typeface="Calibri"/>
               </a:rPr>
-              <a:t>Extension not unreasonably withheld (per §3). Allows both parties to proceed to</a:t>
-            </a:r>
-          </a:p>
-          <a:p>
-            <a:r>
-              <a:rPr sz="750" b="0">
-                <a:solidFill>
-                  <a:srgbClr val="CCCCCC"/>
+              <a:t>+ Earn-outs base case (FY27–FY31)</a:t>
+            </a:r>
+          </a:p>
+        </p:txBody>
+      </p:sp>
+      <p:sp>
+        <p:nvSpPr>
+          <p:cNvPr id="34" name="TextBox 33"/>
+          <p:cNvSpPr txBox="1"/>
+          <p:nvPr/>
+        </p:nvSpPr>
+        <p:spPr>
+          <a:xfrm>
+            <a:off x="3474719" y="2830068"/>
+            <a:ext cx="914400" cy="169164"/>
+          </a:xfrm>
+          <a:prstGeom prst="rect">
+            <a:avLst/>
+          </a:prstGeom>
+          <a:noFill/>
+        </p:spPr>
+        <p:txBody>
+          <a:bodyPr wrap="square">
+            <a:spAutoFit/>
+          </a:bodyPr>
+          <a:lstStyle/>
+          <a:p>
+            <a:pPr algn="r"/>
+            <a:r>
+              <a:rPr sz="750" b="0" i="0">
+                <a:solidFill>
+                  <a:srgbClr val="44BB44"/>
                 </a:solidFill>
                 <a:latin typeface="Calibri"/>
               </a:rPr>
-              <a:t>diligence, definitive agreement, and financing close (target: Feb 15th, 2027).</a:t>
-            </a:r>
-          </a:p>
-        </p:txBody>
-      </p:sp>
-      <p:sp>
-        <p:nvSpPr>
-          <p:cNvPr id="14" name="Rectangle 13"/>
+              <a:t>+$2,525,000</a:t>
+            </a:r>
+          </a:p>
+        </p:txBody>
+      </p:sp>
+      <p:sp>
+        <p:nvSpPr>
+          <p:cNvPr id="35" name="Rectangle 34"/>
           <p:cNvSpPr/>
           <p:nvPr/>
         </p:nvSpPr>
         <p:spPr>
           <a:xfrm>
-            <a:off x="182880" y="1444752"/>
-            <a:ext cx="8778240" cy="987552"/>
+            <a:off x="274320" y="3003804"/>
+            <a:ext cx="4151376" cy="13716"/>
           </a:xfrm>
           <a:prstGeom prst="rect">
             <a:avLst/>
           </a:prstGeom>
           <a:solidFill>
-            <a:srgbClr val="1E1E1E"/>
+            <a:srgbClr val="F26A21"/>
           </a:solidFill>
           <a:ln>
             <a:noFill/>
@@ -3761,20 +4617,90 @@
       </p:sp>
       <p:sp>
         <p:nvSpPr>
-          <p:cNvPr id="15" name="Rectangle 14"/>
+          <p:cNvPr id="36" name="TextBox 35"/>
+          <p:cNvSpPr txBox="1"/>
+          <p:nvPr/>
+        </p:nvSpPr>
+        <p:spPr>
+          <a:xfrm>
+            <a:off x="274320" y="3031236"/>
+            <a:ext cx="3154679" cy="228600"/>
+          </a:xfrm>
+          <a:prstGeom prst="rect">
+            <a:avLst/>
+          </a:prstGeom>
+          <a:noFill/>
+        </p:spPr>
+        <p:txBody>
+          <a:bodyPr wrap="square">
+            <a:spAutoFit/>
+          </a:bodyPr>
+          <a:lstStyle/>
+          <a:p>
+            <a:pPr algn="l"/>
+            <a:r>
+              <a:rPr sz="950" b="1" i="0">
+                <a:solidFill>
+                  <a:srgbClr val="FFFFFF"/>
+                </a:solidFill>
+                <a:latin typeface="Calibri"/>
+              </a:rPr>
+              <a:t>~5-year total to SSLC shareholders</a:t>
+            </a:r>
+          </a:p>
+        </p:txBody>
+      </p:sp>
+      <p:sp>
+        <p:nvSpPr>
+          <p:cNvPr id="37" name="TextBox 36"/>
+          <p:cNvSpPr txBox="1"/>
+          <p:nvPr/>
+        </p:nvSpPr>
+        <p:spPr>
+          <a:xfrm>
+            <a:off x="3383279" y="3031236"/>
+            <a:ext cx="1005840" cy="228600"/>
+          </a:xfrm>
+          <a:prstGeom prst="rect">
+            <a:avLst/>
+          </a:prstGeom>
+          <a:noFill/>
+        </p:spPr>
+        <p:txBody>
+          <a:bodyPr wrap="square">
+            <a:spAutoFit/>
+          </a:bodyPr>
+          <a:lstStyle/>
+          <a:p>
+            <a:pPr algn="r"/>
+            <a:r>
+              <a:rPr sz="1300" b="1" i="0">
+                <a:solidFill>
+                  <a:srgbClr val="F26A21"/>
+                </a:solidFill>
+                <a:latin typeface="Calibri"/>
+              </a:rPr>
+              <a:t>~$5.16M</a:t>
+            </a:r>
+          </a:p>
+        </p:txBody>
+      </p:sp>
+      <p:sp>
+        <p:nvSpPr>
+          <p:cNvPr id="38" name="Rectangle 37"/>
           <p:cNvSpPr/>
           <p:nvPr/>
         </p:nvSpPr>
         <p:spPr>
           <a:xfrm>
-            <a:off x="182880" y="1444752"/>
-            <a:ext cx="50292" cy="987552"/>
+            <a:off x="4645152" y="521207"/>
+            <a:ext cx="4315968" cy="3511296"/>
           </a:xfrm>
           <a:prstGeom prst="rect">
             <a:avLst/>
           </a:prstGeom>
           <a:solidFill>
-            <a:srgbClr val="F26A21"/>
+            <a:srgbClr val="1E1E1E"/>
           </a:solidFill>
           <a:ln>
             <a:noFill/>
@@ -3804,20 +4730,20 @@
       </p:sp>
       <p:sp>
         <p:nvSpPr>
-          <p:cNvPr id="16" name="Rectangle 15"/>
+          <p:cNvPr id="39" name="Rectangle 38"/>
           <p:cNvSpPr/>
           <p:nvPr/>
         </p:nvSpPr>
         <p:spPr>
           <a:xfrm>
-            <a:off x="182880" y="1444752"/>
-            <a:ext cx="8778240" cy="233172"/>
+            <a:off x="4645152" y="521207"/>
+            <a:ext cx="45720" cy="3511296"/>
           </a:xfrm>
           <a:prstGeom prst="rect">
             <a:avLst/>
           </a:prstGeom>
           <a:solidFill>
-            <a:srgbClr val="1A1A1A"/>
+            <a:srgbClr val="F26A21"/>
           </a:solidFill>
           <a:ln>
             <a:noFill/>
@@ -3847,20 +4773,230 @@
       </p:sp>
       <p:sp>
         <p:nvSpPr>
-          <p:cNvPr id="17" name="Rectangle 16"/>
+          <p:cNvPr id="40" name="TextBox 39"/>
+          <p:cNvSpPr txBox="1"/>
+          <p:nvPr/>
+        </p:nvSpPr>
+        <p:spPr>
+          <a:xfrm>
+            <a:off x="4754880" y="576071"/>
+            <a:ext cx="4151376" cy="201168"/>
+          </a:xfrm>
+          <a:prstGeom prst="rect">
+            <a:avLst/>
+          </a:prstGeom>
+          <a:noFill/>
+        </p:spPr>
+        <p:txBody>
+          <a:bodyPr wrap="square">
+            <a:spAutoFit/>
+          </a:bodyPr>
+          <a:lstStyle/>
+          <a:p>
+            <a:pPr algn="l"/>
+            <a:r>
+              <a:rPr sz="950" b="1" i="0">
+                <a:solidFill>
+                  <a:srgbClr val="F26A21"/>
+                </a:solidFill>
+                <a:latin typeface="Calibri"/>
+              </a:rPr>
+              <a:t>What Shareholders Paid In vs. Will Receive</a:t>
+            </a:r>
+          </a:p>
+        </p:txBody>
+      </p:sp>
+      <p:sp>
+        <p:nvSpPr>
+          <p:cNvPr id="41" name="TextBox 40"/>
+          <p:cNvSpPr txBox="1"/>
+          <p:nvPr/>
+        </p:nvSpPr>
+        <p:spPr>
+          <a:xfrm>
+            <a:off x="4754880" y="813815"/>
+            <a:ext cx="4151376" cy="164592"/>
+          </a:xfrm>
+          <a:prstGeom prst="rect">
+            <a:avLst/>
+          </a:prstGeom>
+          <a:noFill/>
+        </p:spPr>
+        <p:txBody>
+          <a:bodyPr wrap="square">
+            <a:spAutoFit/>
+          </a:bodyPr>
+          <a:lstStyle/>
+          <a:p>
+            <a:pPr algn="l"/>
+            <a:r>
+              <a:rPr sz="750" b="1" i="0">
+                <a:solidFill>
+                  <a:srgbClr val="888888"/>
+                </a:solidFill>
+                <a:latin typeface="Calibri"/>
+              </a:rPr>
+              <a:t>PAID-IN CAPITAL (per SSLC books)</a:t>
+            </a:r>
+          </a:p>
+        </p:txBody>
+      </p:sp>
+      <p:sp>
+        <p:nvSpPr>
+          <p:cNvPr id="42" name="TextBox 41"/>
+          <p:cNvSpPr txBox="1"/>
+          <p:nvPr/>
+        </p:nvSpPr>
+        <p:spPr>
+          <a:xfrm>
+            <a:off x="4754880" y="996695"/>
+            <a:ext cx="3063240" cy="169164"/>
+          </a:xfrm>
+          <a:prstGeom prst="rect">
+            <a:avLst/>
+          </a:prstGeom>
+          <a:noFill/>
+        </p:spPr>
+        <p:txBody>
+          <a:bodyPr wrap="square">
+            <a:spAutoFit/>
+          </a:bodyPr>
+          <a:lstStyle/>
+          <a:p>
+            <a:pPr algn="l"/>
+            <a:r>
+              <a:rPr sz="750" b="0" i="0">
+                <a:solidFill>
+                  <a:srgbClr val="888888"/>
+                </a:solidFill>
+                <a:latin typeface="Calibri"/>
+              </a:rPr>
+              <a:t>Common stock</a:t>
+            </a:r>
+          </a:p>
+        </p:txBody>
+      </p:sp>
+      <p:sp>
+        <p:nvSpPr>
+          <p:cNvPr id="43" name="TextBox 42"/>
+          <p:cNvSpPr txBox="1"/>
+          <p:nvPr/>
+        </p:nvSpPr>
+        <p:spPr>
+          <a:xfrm>
+            <a:off x="7863840" y="996695"/>
+            <a:ext cx="1005840" cy="169164"/>
+          </a:xfrm>
+          <a:prstGeom prst="rect">
+            <a:avLst/>
+          </a:prstGeom>
+          <a:noFill/>
+        </p:spPr>
+        <p:txBody>
+          <a:bodyPr wrap="square">
+            <a:spAutoFit/>
+          </a:bodyPr>
+          <a:lstStyle/>
+          <a:p>
+            <a:pPr algn="r"/>
+            <a:r>
+              <a:rPr sz="750" b="0" i="0">
+                <a:solidFill>
+                  <a:srgbClr val="888888"/>
+                </a:solidFill>
+                <a:latin typeface="Calibri"/>
+              </a:rPr>
+              <a:t>$1,010,423</a:t>
+            </a:r>
+          </a:p>
+        </p:txBody>
+      </p:sp>
+      <p:sp>
+        <p:nvSpPr>
+          <p:cNvPr id="44" name="TextBox 43"/>
+          <p:cNvSpPr txBox="1"/>
+          <p:nvPr/>
+        </p:nvSpPr>
+        <p:spPr>
+          <a:xfrm>
+            <a:off x="4754880" y="1161287"/>
+            <a:ext cx="3063240" cy="169164"/>
+          </a:xfrm>
+          <a:prstGeom prst="rect">
+            <a:avLst/>
+          </a:prstGeom>
+          <a:noFill/>
+        </p:spPr>
+        <p:txBody>
+          <a:bodyPr wrap="square">
+            <a:spAutoFit/>
+          </a:bodyPr>
+          <a:lstStyle/>
+          <a:p>
+            <a:pPr algn="l"/>
+            <a:r>
+              <a:rPr sz="750" b="0" i="0">
+                <a:solidFill>
+                  <a:srgbClr val="888888"/>
+                </a:solidFill>
+                <a:latin typeface="Calibri"/>
+              </a:rPr>
+              <a:t>Additional paid-in capital (APIC)</a:t>
+            </a:r>
+          </a:p>
+        </p:txBody>
+      </p:sp>
+      <p:sp>
+        <p:nvSpPr>
+          <p:cNvPr id="45" name="TextBox 44"/>
+          <p:cNvSpPr txBox="1"/>
+          <p:nvPr/>
+        </p:nvSpPr>
+        <p:spPr>
+          <a:xfrm>
+            <a:off x="7863840" y="1161287"/>
+            <a:ext cx="1005840" cy="169164"/>
+          </a:xfrm>
+          <a:prstGeom prst="rect">
+            <a:avLst/>
+          </a:prstGeom>
+          <a:noFill/>
+        </p:spPr>
+        <p:txBody>
+          <a:bodyPr wrap="square">
+            <a:spAutoFit/>
+          </a:bodyPr>
+          <a:lstStyle/>
+          <a:p>
+            <a:pPr algn="r"/>
+            <a:r>
+              <a:rPr sz="750" b="0" i="0">
+                <a:solidFill>
+                  <a:srgbClr val="888888"/>
+                </a:solidFill>
+                <a:latin typeface="Calibri"/>
+              </a:rPr>
+              <a:t>$4,042</a:t>
+            </a:r>
+          </a:p>
+        </p:txBody>
+      </p:sp>
+      <p:sp>
+        <p:nvSpPr>
+          <p:cNvPr id="46" name="Rectangle 45"/>
           <p:cNvSpPr/>
           <p:nvPr/>
         </p:nvSpPr>
         <p:spPr>
           <a:xfrm>
-            <a:off x="182880" y="1444752"/>
-            <a:ext cx="50292" cy="233172"/>
+            <a:off x="4754880" y="1344167"/>
+            <a:ext cx="4151376" cy="9144"/>
           </a:xfrm>
           <a:prstGeom prst="rect">
             <a:avLst/>
           </a:prstGeom>
           <a:solidFill>
-            <a:srgbClr val="F26A21"/>
+            <a:srgbClr val="444444"/>
           </a:solidFill>
           <a:ln>
             <a:noFill/>
@@ -3890,14 +5026,14 @@
       </p:sp>
       <p:sp>
         <p:nvSpPr>
-          <p:cNvPr id="18" name="TextBox 17"/>
-          <p:cNvSpPr txBox="1"/>
-          <p:nvPr/>
-        </p:nvSpPr>
-        <p:spPr>
-          <a:xfrm>
-            <a:off x="265176" y="1472184"/>
-            <a:ext cx="411480" cy="196596"/>
+          <p:cNvPr id="47" name="TextBox 46"/>
+          <p:cNvSpPr txBox="1"/>
+          <p:nvPr/>
+        </p:nvSpPr>
+        <p:spPr>
+          <a:xfrm>
+            <a:off x="4754880" y="1325879"/>
+            <a:ext cx="3063240" cy="169164"/>
           </a:xfrm>
           <a:prstGeom prst="rect">
             <a:avLst/>
@@ -3912,27 +5048,27 @@
           <a:p>
             <a:pPr algn="l"/>
             <a:r>
-              <a:rPr sz="2200" b="1" i="0">
-                <a:solidFill>
-                  <a:srgbClr val="F26A21"/>
-                </a:solidFill>
-                <a:latin typeface="Cambria"/>
-              </a:rPr>
-              <a:t>2</a:t>
-            </a:r>
-          </a:p>
-        </p:txBody>
-      </p:sp>
-      <p:sp>
-        <p:nvSpPr>
-          <p:cNvPr id="19" name="TextBox 18"/>
-          <p:cNvSpPr txBox="1"/>
-          <p:nvPr/>
-        </p:nvSpPr>
-        <p:spPr>
-          <a:xfrm>
-            <a:off x="731520" y="1481328"/>
-            <a:ext cx="6629400" cy="178308"/>
+              <a:rPr sz="750" b="0" i="0">
+                <a:solidFill>
+                  <a:srgbClr val="CCCCCC"/>
+                </a:solidFill>
+                <a:latin typeface="Calibri"/>
+              </a:rPr>
+              <a:t>Total paid-in capital</a:t>
+            </a:r>
+          </a:p>
+        </p:txBody>
+      </p:sp>
+      <p:sp>
+        <p:nvSpPr>
+          <p:cNvPr id="48" name="TextBox 47"/>
+          <p:cNvSpPr txBox="1"/>
+          <p:nvPr/>
+        </p:nvSpPr>
+        <p:spPr>
+          <a:xfrm>
+            <a:off x="7863840" y="1325879"/>
+            <a:ext cx="1005840" cy="169164"/>
           </a:xfrm>
           <a:prstGeom prst="rect">
             <a:avLst/>
@@ -3945,29 +5081,29 @@
           </a:bodyPr>
           <a:lstStyle/>
           <a:p>
-            <a:pPr algn="l"/>
-            <a:r>
-              <a:rPr sz="950" b="1" i="0">
+            <a:pPr algn="r"/>
+            <a:r>
+              <a:rPr sz="750" b="1" i="0">
                 <a:solidFill>
                   <a:srgbClr val="FFFFFF"/>
                 </a:solidFill>
                 <a:latin typeface="Calibri"/>
               </a:rPr>
-              <a:t>Grant Full Read-Only QuickBooks Online Access for Diligence</a:t>
-            </a:r>
-          </a:p>
-        </p:txBody>
-      </p:sp>
-      <p:sp>
-        <p:nvSpPr>
-          <p:cNvPr id="20" name="TextBox 19"/>
-          <p:cNvSpPr txBox="1"/>
-          <p:nvPr/>
-        </p:nvSpPr>
-        <p:spPr>
-          <a:xfrm>
-            <a:off x="7516367" y="1463040"/>
-            <a:ext cx="1371600" cy="201168"/>
+              <a:t>$1,014,465</a:t>
+            </a:r>
+          </a:p>
+        </p:txBody>
+      </p:sp>
+      <p:sp>
+        <p:nvSpPr>
+          <p:cNvPr id="49" name="TextBox 48"/>
+          <p:cNvSpPr txBox="1"/>
+          <p:nvPr/>
+        </p:nvSpPr>
+        <p:spPr>
+          <a:xfrm>
+            <a:off x="4754880" y="1499615"/>
+            <a:ext cx="4151376" cy="173736"/>
           </a:xfrm>
           <a:prstGeom prst="rect">
             <a:avLst/>
@@ -3982,27 +5118,27 @@
           <a:p>
             <a:pPr algn="l"/>
             <a:r>
-              <a:rPr sz="850" b="0" i="0">
-                <a:solidFill>
-                  <a:srgbClr val="44BB44"/>
+              <a:rPr sz="650" b="0" i="1">
+                <a:solidFill>
+                  <a:srgbClr val="888888"/>
                 </a:solidFill>
                 <a:latin typeface="Calibri"/>
               </a:rPr>
-              <a:t>☐  Approve</a:t>
-            </a:r>
-          </a:p>
-        </p:txBody>
-      </p:sp>
-      <p:sp>
-        <p:nvSpPr>
-          <p:cNvPr id="21" name="TextBox 20"/>
-          <p:cNvSpPr txBox="1"/>
-          <p:nvPr/>
-        </p:nvSpPr>
-        <p:spPr>
-          <a:xfrm>
-            <a:off x="7516367" y="1609344"/>
-            <a:ext cx="1371600" cy="201168"/>
+              <a:t>  Exos: $790,000 for 18.06% — recognized via $790K stake credit in price</a:t>
+            </a:r>
+          </a:p>
+        </p:txBody>
+      </p:sp>
+      <p:sp>
+        <p:nvSpPr>
+          <p:cNvPr id="50" name="TextBox 49"/>
+          <p:cNvSpPr txBox="1"/>
+          <p:nvPr/>
+        </p:nvSpPr>
+        <p:spPr>
+          <a:xfrm>
+            <a:off x="4754880" y="1659635"/>
+            <a:ext cx="4151376" cy="173736"/>
           </a:xfrm>
           <a:prstGeom prst="rect">
             <a:avLst/>
@@ -4017,27 +5153,27 @@
           <a:p>
             <a:pPr algn="l"/>
             <a:r>
-              <a:rPr sz="850" b="0" i="0">
-                <a:solidFill>
-                  <a:srgbClr val="FF6666"/>
+              <a:rPr sz="650" b="0" i="1">
+                <a:solidFill>
+                  <a:srgbClr val="888888"/>
                 </a:solidFill>
                 <a:latin typeface="Calibri"/>
               </a:rPr>
-              <a:t>☐  Decline</a:t>
-            </a:r>
-          </a:p>
-        </p:txBody>
-      </p:sp>
-      <p:sp>
-        <p:nvSpPr>
-          <p:cNvPr id="22" name="TextBox 21"/>
-          <p:cNvSpPr txBox="1"/>
-          <p:nvPr/>
-        </p:nvSpPr>
-        <p:spPr>
-          <a:xfrm>
-            <a:off x="731520" y="1714500"/>
-            <a:ext cx="6629400" cy="699516"/>
+              <a:t>  All other holders: ~$224,000 combined for 81.94%</a:t>
+            </a:r>
+          </a:p>
+        </p:txBody>
+      </p:sp>
+      <p:sp>
+        <p:nvSpPr>
+          <p:cNvPr id="51" name="TextBox 50"/>
+          <p:cNvSpPr txBox="1"/>
+          <p:nvPr/>
+        </p:nvSpPr>
+        <p:spPr>
+          <a:xfrm>
+            <a:off x="4754880" y="1851660"/>
+            <a:ext cx="4151376" cy="164592"/>
           </a:xfrm>
           <a:prstGeom prst="rect">
             <a:avLst/>
@@ -4050,89 +5186,175 @@
           </a:bodyPr>
           <a:lstStyle/>
           <a:p>
-            <a:r>
-              <a:rPr sz="700" b="0">
+            <a:pPr algn="l"/>
+            <a:r>
+              <a:rPr sz="750" b="1" i="0">
+                <a:solidFill>
+                  <a:srgbClr val="888888"/>
+                </a:solidFill>
+                <a:latin typeface="Calibri"/>
+              </a:rPr>
+              <a:t>PROJECTED RETURN  (OTHER HOLDERS, 81.94%)</a:t>
+            </a:r>
+          </a:p>
+        </p:txBody>
+      </p:sp>
+      <p:sp>
+        <p:nvSpPr>
+          <p:cNvPr id="52" name="TextBox 51"/>
+          <p:cNvSpPr txBox="1"/>
+          <p:nvPr/>
+        </p:nvSpPr>
+        <p:spPr>
+          <a:xfrm>
+            <a:off x="4754880" y="2043684"/>
+            <a:ext cx="3063240" cy="169164"/>
+          </a:xfrm>
+          <a:prstGeom prst="rect">
+            <a:avLst/>
+          </a:prstGeom>
+          <a:noFill/>
+        </p:spPr>
+        <p:txBody>
+          <a:bodyPr wrap="square">
+            <a:spAutoFit/>
+          </a:bodyPr>
+          <a:lstStyle/>
+          <a:p>
+            <a:pPr algn="l"/>
+            <a:r>
+              <a:rPr sz="750" b="0" i="0">
                 <a:solidFill>
                   <a:srgbClr val="CCCCCC"/>
                 </a:solidFill>
                 <a:latin typeface="Calibri"/>
               </a:rPr>
-              <a:t>Authorize an all-access or accountant user for John Quinn and one Exos finance reviewer.</a:t>
-            </a:r>
-          </a:p>
-          <a:p>
-            <a:r>
-              <a:rPr sz="700" b="0">
+              <a:t>Cash + stock at close (est.)</a:t>
+            </a:r>
+          </a:p>
+        </p:txBody>
+      </p:sp>
+      <p:sp>
+        <p:nvSpPr>
+          <p:cNvPr id="53" name="TextBox 52"/>
+          <p:cNvSpPr txBox="1"/>
+          <p:nvPr/>
+        </p:nvSpPr>
+        <p:spPr>
+          <a:xfrm>
+            <a:off x="7863840" y="2043684"/>
+            <a:ext cx="1005840" cy="169164"/>
+          </a:xfrm>
+          <a:prstGeom prst="rect">
+            <a:avLst/>
+          </a:prstGeom>
+          <a:noFill/>
+        </p:spPr>
+        <p:txBody>
+          <a:bodyPr wrap="square">
+            <a:spAutoFit/>
+          </a:bodyPr>
+          <a:lstStyle/>
+          <a:p>
+            <a:pPr algn="r"/>
+            <a:r>
+              <a:rPr sz="750" b="0" i="0">
+                <a:solidFill>
+                  <a:srgbClr val="44BB44"/>
+                </a:solidFill>
+                <a:latin typeface="Calibri"/>
+              </a:rPr>
+              <a:t>~$2.5M</a:t>
+            </a:r>
+          </a:p>
+        </p:txBody>
+      </p:sp>
+      <p:sp>
+        <p:nvSpPr>
+          <p:cNvPr id="54" name="TextBox 53"/>
+          <p:cNvSpPr txBox="1"/>
+          <p:nvPr/>
+        </p:nvSpPr>
+        <p:spPr>
+          <a:xfrm>
+            <a:off x="4754880" y="2208276"/>
+            <a:ext cx="3063240" cy="169164"/>
+          </a:xfrm>
+          <a:prstGeom prst="rect">
+            <a:avLst/>
+          </a:prstGeom>
+          <a:noFill/>
+        </p:spPr>
+        <p:txBody>
+          <a:bodyPr wrap="square">
+            <a:spAutoFit/>
+          </a:bodyPr>
+          <a:lstStyle/>
+          <a:p>
+            <a:pPr algn="l"/>
+            <a:r>
+              <a:rPr sz="750" b="0" i="0">
                 <a:solidFill>
                   <a:srgbClr val="CCCCCC"/>
                 </a:solidFill>
                 <a:latin typeface="Calibri"/>
               </a:rPr>
-              <a:t>Purpose: reconcile the $942K "billed-ahead" balance and shared-facility costs before close.</a:t>
-            </a:r>
-          </a:p>
-          <a:p>
-            <a:r>
-              <a:rPr sz="700" b="0">
-                <a:solidFill>
-                  <a:srgbClr val="CCCCCC"/>
+              <a:t>Total over 5 years incl. earn-outs</a:t>
+            </a:r>
+          </a:p>
+        </p:txBody>
+      </p:sp>
+      <p:sp>
+        <p:nvSpPr>
+          <p:cNvPr id="55" name="TextBox 54"/>
+          <p:cNvSpPr txBox="1"/>
+          <p:nvPr/>
+        </p:nvSpPr>
+        <p:spPr>
+          <a:xfrm>
+            <a:off x="7863840" y="2208276"/>
+            <a:ext cx="1005840" cy="169164"/>
+          </a:xfrm>
+          <a:prstGeom prst="rect">
+            <a:avLst/>
+          </a:prstGeom>
+          <a:noFill/>
+        </p:spPr>
+        <p:txBody>
+          <a:bodyPr wrap="square">
+            <a:spAutoFit/>
+          </a:bodyPr>
+          <a:lstStyle/>
+          <a:p>
+            <a:pPr algn="r"/>
+            <a:r>
+              <a:rPr sz="750" b="0" i="0">
+                <a:solidFill>
+                  <a:srgbClr val="44BB44"/>
                 </a:solidFill>
                 <a:latin typeface="Calibri"/>
               </a:rPr>
-              <a:t>Basis: Cal. Corp. Code §1602 director inspection right + AAA §4 confirmatory diligence.</a:t>
-            </a:r>
-          </a:p>
-          <a:p>
-            <a:r>
-              <a:rPr sz="700" b="0">
-                <a:solidFill>
-                  <a:srgbClr val="CCCCCC"/>
-                </a:solidFill>
-                <a:latin typeface="Calibri"/>
-              </a:rPr>
-              <a:t>Also provide: stock ledger, cap table, subscription agreements, and paid-in capital</a:t>
-            </a:r>
-          </a:p>
-          <a:p>
-            <a:r>
-              <a:rPr sz="700" b="0">
-                <a:solidFill>
-                  <a:srgbClr val="CCCCCC"/>
-                </a:solidFill>
-                <a:latin typeface="Calibri"/>
-              </a:rPr>
-              <a:t>by shareholder (books: $1,014,465 total paid-in; need per-holder to compare payout vs. invested).</a:t>
-            </a:r>
-          </a:p>
-          <a:p>
-            <a:r>
-              <a:rPr sz="750" b="1">
-                <a:solidFill>
-                  <a:srgbClr val="F26A21"/>
-                </a:solidFill>
-                <a:latin typeface="Calibri"/>
-              </a:rPr>
-              <a:t>Confidential under the 7/27/2021 NDA.  Access to be granted no later than October 15, 2026.</a:t>
-            </a:r>
-          </a:p>
-        </p:txBody>
-      </p:sp>
-      <p:sp>
-        <p:nvSpPr>
-          <p:cNvPr id="23" name="Rectangle 22"/>
+              <a:t>~$5.2M</a:t>
+            </a:r>
+          </a:p>
+        </p:txBody>
+      </p:sp>
+      <p:sp>
+        <p:nvSpPr>
+          <p:cNvPr id="56" name="Rectangle 55"/>
           <p:cNvSpPr/>
           <p:nvPr/>
         </p:nvSpPr>
         <p:spPr>
           <a:xfrm>
-            <a:off x="182880" y="2468880"/>
-            <a:ext cx="8778240" cy="1170432"/>
+            <a:off x="4754880" y="2391156"/>
+            <a:ext cx="4151376" cy="9144"/>
           </a:xfrm>
           <a:prstGeom prst="rect">
             <a:avLst/>
           </a:prstGeom>
           <a:solidFill>
-            <a:srgbClr val="1E1E1E"/>
+            <a:srgbClr val="444444"/>
           </a:solidFill>
           <a:ln>
             <a:noFill/>
@@ -4162,20 +5384,127 @@
       </p:sp>
       <p:sp>
         <p:nvSpPr>
-          <p:cNvPr id="24" name="Rectangle 23"/>
+          <p:cNvPr id="57" name="TextBox 56"/>
+          <p:cNvSpPr txBox="1"/>
+          <p:nvPr/>
+        </p:nvSpPr>
+        <p:spPr>
+          <a:xfrm>
+            <a:off x="4754880" y="2409444"/>
+            <a:ext cx="3063240" cy="173736"/>
+          </a:xfrm>
+          <a:prstGeom prst="rect">
+            <a:avLst/>
+          </a:prstGeom>
+          <a:noFill/>
+        </p:spPr>
+        <p:txBody>
+          <a:bodyPr wrap="square">
+            <a:spAutoFit/>
+          </a:bodyPr>
+          <a:lstStyle/>
+          <a:p>
+            <a:pPr algn="l"/>
+            <a:r>
+              <a:rPr sz="750" b="0" i="0">
+                <a:solidFill>
+                  <a:srgbClr val="CCCCCC"/>
+                </a:solidFill>
+                <a:latin typeface="Calibri"/>
+              </a:rPr>
+              <a:t>Implied return on invested capital</a:t>
+            </a:r>
+          </a:p>
+        </p:txBody>
+      </p:sp>
+      <p:sp>
+        <p:nvSpPr>
+          <p:cNvPr id="58" name="TextBox 57"/>
+          <p:cNvSpPr txBox="1"/>
+          <p:nvPr/>
+        </p:nvSpPr>
+        <p:spPr>
+          <a:xfrm>
+            <a:off x="7406640" y="2409444"/>
+            <a:ext cx="1463040" cy="173736"/>
+          </a:xfrm>
+          <a:prstGeom prst="rect">
+            <a:avLst/>
+          </a:prstGeom>
+          <a:noFill/>
+        </p:spPr>
+        <p:txBody>
+          <a:bodyPr wrap="square">
+            <a:spAutoFit/>
+          </a:bodyPr>
+          <a:lstStyle/>
+          <a:p>
+            <a:pPr algn="r"/>
+            <a:r>
+              <a:rPr sz="850" b="1" i="0">
+                <a:solidFill>
+                  <a:srgbClr val="FFCC44"/>
+                </a:solidFill>
+                <a:latin typeface="Calibri"/>
+              </a:rPr>
+              <a:t>11× at close / 23× over 5 yrs</a:t>
+            </a:r>
+          </a:p>
+        </p:txBody>
+      </p:sp>
+      <p:sp>
+        <p:nvSpPr>
+          <p:cNvPr id="59" name="TextBox 58"/>
+          <p:cNvSpPr txBox="1"/>
+          <p:nvPr/>
+        </p:nvSpPr>
+        <p:spPr>
+          <a:xfrm>
+            <a:off x="4754880" y="2610612"/>
+            <a:ext cx="4151376" cy="420624"/>
+          </a:xfrm>
+          <a:prstGeom prst="rect">
+            <a:avLst/>
+          </a:prstGeom>
+          <a:noFill/>
+        </p:spPr>
+        <p:txBody>
+          <a:bodyPr wrap="square">
+            <a:spAutoFit/>
+          </a:bodyPr>
+          <a:lstStyle/>
+          <a:p>
+            <a:pPr algn="l"/>
+            <a:r>
+              <a:rPr sz="700" b="0" i="1">
+                <a:solidFill>
+                  <a:srgbClr val="888888"/>
+                </a:solidFill>
+                <a:latin typeface="Calibri"/>
+              </a:rPr>
+              <a:t>Framed as: holders who invested ~$224K receive a strong return.
+Exos’s 18.06% is absorbed in the $790K credit built into the purchase price —
+no additional cash from Exos for Exos’s own stake.</a:t>
+            </a:r>
+          </a:p>
+        </p:txBody>
+      </p:sp>
+      <p:sp>
+        <p:nvSpPr>
+          <p:cNvPr id="60" name="Rectangle 59"/>
           <p:cNvSpPr/>
           <p:nvPr/>
         </p:nvSpPr>
         <p:spPr>
           <a:xfrm>
-            <a:off x="182880" y="2468880"/>
-            <a:ext cx="50292" cy="1170432"/>
+            <a:off x="4754880" y="3049524"/>
+            <a:ext cx="4151376" cy="260603"/>
           </a:xfrm>
           <a:prstGeom prst="rect">
             <a:avLst/>
           </a:prstGeom>
           <a:solidFill>
-            <a:srgbClr val="F26A21"/>
+            <a:srgbClr val="221808"/>
           </a:solidFill>
           <a:ln>
             <a:noFill/>
@@ -4205,20 +5534,56 @@
       </p:sp>
       <p:sp>
         <p:nvSpPr>
-          <p:cNvPr id="25" name="Rectangle 24"/>
+          <p:cNvPr id="61" name="TextBox 60"/>
+          <p:cNvSpPr txBox="1"/>
+          <p:nvPr/>
+        </p:nvSpPr>
+        <p:spPr>
+          <a:xfrm>
+            <a:off x="4828032" y="3086100"/>
+            <a:ext cx="4041648" cy="201168"/>
+          </a:xfrm>
+          <a:prstGeom prst="rect">
+            <a:avLst/>
+          </a:prstGeom>
+          <a:noFill/>
+        </p:spPr>
+        <p:txBody>
+          <a:bodyPr wrap="square">
+            <a:spAutoFit/>
+          </a:bodyPr>
+          <a:lstStyle/>
+          <a:p>
+            <a:pPr algn="l"/>
+            <a:r>
+              <a:rPr sz="650" b="0" i="1">
+                <a:solidFill>
+                  <a:srgbClr val="FFCC44"/>
+                </a:solidFill>
+                <a:latin typeface="Calibri"/>
+              </a:rPr>
+              <a:t>Note: insiders receive ~$544K debt repayment at close ahead of equity distributions
+(Microcosm $451K + Wertz $93K + Exos $39K with interest).</a:t>
+            </a:r>
+          </a:p>
+        </p:txBody>
+      </p:sp>
+      <p:sp>
+        <p:nvSpPr>
+          <p:cNvPr id="62" name="Rectangle 61"/>
           <p:cNvSpPr/>
           <p:nvPr/>
         </p:nvSpPr>
         <p:spPr>
           <a:xfrm>
-            <a:off x="182880" y="2468880"/>
-            <a:ext cx="8778240" cy="233172"/>
+            <a:off x="164592" y="4069080"/>
+            <a:ext cx="8814816" cy="13716"/>
           </a:xfrm>
           <a:prstGeom prst="rect">
             <a:avLst/>
           </a:prstGeom>
           <a:solidFill>
-            <a:srgbClr val="1A1A1A"/>
+            <a:srgbClr val="F26A21"/>
           </a:solidFill>
           <a:ln>
             <a:noFill/>
@@ -4248,20 +5613,20 @@
       </p:sp>
       <p:sp>
         <p:nvSpPr>
-          <p:cNvPr id="26" name="Rectangle 25"/>
+          <p:cNvPr id="63" name="Rectangle 62"/>
           <p:cNvSpPr/>
           <p:nvPr/>
         </p:nvSpPr>
         <p:spPr>
           <a:xfrm>
-            <a:off x="182880" y="2468880"/>
-            <a:ext cx="50292" cy="233172"/>
+            <a:off x="164592" y="4087368"/>
+            <a:ext cx="8814816" cy="694944"/>
           </a:xfrm>
           <a:prstGeom prst="rect">
             <a:avLst/>
           </a:prstGeom>
           <a:solidFill>
-            <a:srgbClr val="F26A21"/>
+            <a:srgbClr val="1A0A00"/>
           </a:solidFill>
           <a:ln>
             <a:noFill/>
@@ -4291,14 +5656,14 @@
       </p:sp>
       <p:sp>
         <p:nvSpPr>
-          <p:cNvPr id="27" name="TextBox 26"/>
-          <p:cNvSpPr txBox="1"/>
-          <p:nvPr/>
-        </p:nvSpPr>
-        <p:spPr>
-          <a:xfrm>
-            <a:off x="265176" y="2496312"/>
-            <a:ext cx="411480" cy="196596"/>
+          <p:cNvPr id="64" name="TextBox 63"/>
+          <p:cNvSpPr txBox="1"/>
+          <p:nvPr/>
+        </p:nvSpPr>
+        <p:spPr>
+          <a:xfrm>
+            <a:off x="274320" y="4123944"/>
+            <a:ext cx="4572000" cy="182880"/>
           </a:xfrm>
           <a:prstGeom prst="rect">
             <a:avLst/>
@@ -4313,27 +5678,27 @@
           <a:p>
             <a:pPr algn="l"/>
             <a:r>
-              <a:rPr sz="2200" b="1" i="0">
+              <a:rPr sz="850" b="1" i="0">
                 <a:solidFill>
                   <a:srgbClr val="F26A21"/>
                 </a:solidFill>
-                <a:latin typeface="Cambria"/>
-              </a:rPr>
-              <a:t>3</a:t>
-            </a:r>
-          </a:p>
-        </p:txBody>
-      </p:sp>
-      <p:sp>
-        <p:nvSpPr>
-          <p:cNvPr id="28" name="TextBox 27"/>
-          <p:cNvSpPr txBox="1"/>
-          <p:nvPr/>
-        </p:nvSpPr>
-        <p:spPr>
-          <a:xfrm>
-            <a:off x="731520" y="2505456"/>
-            <a:ext cx="6629400" cy="178308"/>
+                <a:latin typeface="Calibri"/>
+              </a:rPr>
+              <a:t>Why We Need the Stock Ledger (Motion 2)</a:t>
+            </a:r>
+          </a:p>
+        </p:txBody>
+      </p:sp>
+      <p:sp>
+        <p:nvSpPr>
+          <p:cNvPr id="65" name="TextBox 64"/>
+          <p:cNvSpPr txBox="1"/>
+          <p:nvPr/>
+        </p:nvSpPr>
+        <p:spPr>
+          <a:xfrm>
+            <a:off x="274320" y="4315968"/>
+            <a:ext cx="8503920" cy="141732"/>
           </a:xfrm>
           <a:prstGeom prst="rect">
             <a:avLst/>
@@ -4348,27 +5713,27 @@
           <a:p>
             <a:pPr algn="l"/>
             <a:r>
-              <a:rPr sz="950" b="1" i="0">
-                <a:solidFill>
-                  <a:srgbClr val="FFFFFF"/>
+              <a:rPr sz="700" b="0" i="0">
+                <a:solidFill>
+                  <a:srgbClr val="CCCCCC"/>
                 </a:solidFill>
                 <a:latin typeface="Calibri"/>
               </a:rPr>
-              <a:t>Correct AR Unbilled / Customer-Deposit Accounting Within 5 Days</a:t>
-            </a:r>
-          </a:p>
-        </p:txBody>
-      </p:sp>
-      <p:sp>
-        <p:nvSpPr>
-          <p:cNvPr id="29" name="TextBox 28"/>
-          <p:cNvSpPr txBox="1"/>
-          <p:nvPr/>
-        </p:nvSpPr>
-        <p:spPr>
-          <a:xfrm>
-            <a:off x="7516367" y="2487168"/>
-            <a:ext cx="1371600" cy="201168"/>
+              <a:t>• SSLC’s books carry paid-in capital only as one total ($1,014,465); per-holder amounts and share counts are not on the books.</a:t>
+            </a:r>
+          </a:p>
+        </p:txBody>
+      </p:sp>
+      <p:sp>
+        <p:nvSpPr>
+          <p:cNvPr id="66" name="TextBox 65"/>
+          <p:cNvSpPr txBox="1"/>
+          <p:nvPr/>
+        </p:nvSpPr>
+        <p:spPr>
+          <a:xfrm>
+            <a:off x="274320" y="4457700"/>
+            <a:ext cx="8503920" cy="141732"/>
           </a:xfrm>
           <a:prstGeom prst="rect">
             <a:avLst/>
@@ -4383,27 +5748,27 @@
           <a:p>
             <a:pPr algn="l"/>
             <a:r>
-              <a:rPr sz="850" b="0" i="0">
-                <a:solidFill>
-                  <a:srgbClr val="44BB44"/>
+              <a:rPr sz="700" b="0" i="0">
+                <a:solidFill>
+                  <a:srgbClr val="CCCCCC"/>
                 </a:solidFill>
                 <a:latin typeface="Calibri"/>
               </a:rPr>
-              <a:t>☐  Approve</a:t>
-            </a:r>
-          </a:p>
-        </p:txBody>
-      </p:sp>
-      <p:sp>
-        <p:nvSpPr>
-          <p:cNvPr id="30" name="TextBox 29"/>
-          <p:cNvSpPr txBox="1"/>
-          <p:nvPr/>
-        </p:nvSpPr>
-        <p:spPr>
-          <a:xfrm>
-            <a:off x="7516367" y="2633472"/>
-            <a:ext cx="1371600" cy="201168"/>
+              <a:t>• GL shows a 7/24/2024 conversion of a $30K Exos loan into 5,464 shares that must be reconciled to the $790K stake credit.</a:t>
+            </a:r>
+          </a:p>
+        </p:txBody>
+      </p:sp>
+      <p:sp>
+        <p:nvSpPr>
+          <p:cNvPr id="67" name="TextBox 66"/>
+          <p:cNvSpPr txBox="1"/>
+          <p:nvPr/>
+        </p:nvSpPr>
+        <p:spPr>
+          <a:xfrm>
+            <a:off x="274320" y="4599432"/>
+            <a:ext cx="8503920" cy="141732"/>
           </a:xfrm>
           <a:prstGeom prst="rect">
             <a:avLst/>
@@ -4418,27 +5783,27 @@
           <a:p>
             <a:pPr algn="l"/>
             <a:r>
-              <a:rPr sz="850" b="0" i="0">
-                <a:solidFill>
-                  <a:srgbClr val="FF6666"/>
+              <a:rPr sz="700" b="0" i="0">
+                <a:solidFill>
+                  <a:srgbClr val="CCCCCC"/>
                 </a:solidFill>
                 <a:latin typeface="Calibri"/>
               </a:rPr>
-              <a:t>☐  Decline</a:t>
-            </a:r>
-          </a:p>
-        </p:txBody>
-      </p:sp>
-      <p:sp>
-        <p:nvSpPr>
-          <p:cNvPr id="31" name="TextBox 30"/>
-          <p:cNvSpPr txBox="1"/>
-          <p:nvPr/>
-        </p:nvSpPr>
-        <p:spPr>
-          <a:xfrm>
-            <a:off x="731520" y="2738628"/>
-            <a:ext cx="6629400" cy="882395"/>
+              <a:t>• ~$544K of insider debt is repaid at close ahead of equity distributions; the 81.94% split can’t be validated without the stock ledger, cap table and subscription agreements.</a:t>
+            </a:r>
+          </a:p>
+        </p:txBody>
+      </p:sp>
+      <p:sp>
+        <p:nvSpPr>
+          <p:cNvPr id="68" name="TextBox 67"/>
+          <p:cNvSpPr txBox="1"/>
+          <p:nvPr/>
+        </p:nvSpPr>
+        <p:spPr>
+          <a:xfrm>
+            <a:off x="182880" y="4782312"/>
+            <a:ext cx="8778240" cy="201168"/>
           </a:xfrm>
           <a:prstGeom prst="rect">
             <a:avLst/>
@@ -4451,67 +5816,131 @@
           </a:bodyPr>
           <a:lstStyle/>
           <a:p>
-            <a:r>
-              <a:rPr sz="750" b="0">
-                <a:solidFill>
-                  <a:srgbClr val="CCCCCC"/>
+            <a:pPr algn="l"/>
+            <a:r>
+              <a:rPr sz="650" b="0" i="1">
+                <a:solidFill>
+                  <a:srgbClr val="888888"/>
                 </a:solidFill>
                 <a:latin typeface="Calibri"/>
               </a:rPr>
-              <a:t>Direct A La Carte Solutions (bookkeeper) + Singer Lewak / Welch &amp; Co. to reconcile and correct:</a:t>
-            </a:r>
-          </a:p>
-          <a:p>
-            <a:r>
-              <a:rPr sz="750" b="0">
-                <a:solidFill>
-                  <a:srgbClr val="CCCCCC"/>
+              <a:t>Projection on current SSLC books (10/11/2026) and Exos estimates; not a guarantee.  Billed-ahead balance under reconciliation (Motion 3).  Low/high: net cash $1.28M–$1.74M; 5-yr total $3.4M–$7.0M.</a:t>
+            </a:r>
+          </a:p>
+        </p:txBody>
+      </p:sp>
+      <p:sp>
+        <p:nvSpPr>
+          <p:cNvPr id="69" name="TextBox 68"/>
+          <p:cNvSpPr txBox="1"/>
+          <p:nvPr/>
+        </p:nvSpPr>
+        <p:spPr>
+          <a:xfrm>
+            <a:off x="1554480" y="4956048"/>
+            <a:ext cx="6035040" cy="164592"/>
+          </a:xfrm>
+          <a:prstGeom prst="rect">
+            <a:avLst/>
+          </a:prstGeom>
+          <a:noFill/>
+        </p:spPr>
+        <p:txBody>
+          <a:bodyPr wrap="square">
+            <a:spAutoFit/>
+          </a:bodyPr>
+          <a:lstStyle/>
+          <a:p>
+            <a:pPr algn="ctr"/>
+            <a:r>
+              <a:rPr sz="700" b="0" i="1">
+                <a:solidFill>
+                  <a:srgbClr val="888888"/>
                 </a:solidFill>
                 <a:latin typeface="Calibri"/>
               </a:rPr>
-              <a:t>• Acct 1110 AR Unbilled ($942,177) and Acct 2380 Deposits ($120,000) within 5 days of approval.</a:t>
-            </a:r>
-          </a:p>
-          <a:p>
-            <a:r>
-              <a:rPr sz="750" b="0">
-                <a:solidFill>
-                  <a:srgbClr val="CCCCCC"/>
+              <a:t>DRAFT — NEGOTIATING TERMS</a:t>
+            </a:r>
+          </a:p>
+        </p:txBody>
+      </p:sp>
+      <p:sp>
+        <p:nvSpPr>
+          <p:cNvPr id="70" name="TextBox 69"/>
+          <p:cNvSpPr txBox="1"/>
+          <p:nvPr/>
+        </p:nvSpPr>
+        <p:spPr>
+          <a:xfrm>
+            <a:off x="7772400" y="4956048"/>
+            <a:ext cx="1143000" cy="164592"/>
+          </a:xfrm>
+          <a:prstGeom prst="rect">
+            <a:avLst/>
+          </a:prstGeom>
+          <a:noFill/>
+        </p:spPr>
+        <p:txBody>
+          <a:bodyPr wrap="square">
+            <a:spAutoFit/>
+          </a:bodyPr>
+          <a:lstStyle/>
+          <a:p>
+            <a:pPr algn="r"/>
+            <a:r>
+              <a:rPr sz="700" b="0" i="1">
+                <a:solidFill>
+                  <a:srgbClr val="888888"/>
                 </a:solidFill>
                 <a:latin typeface="Calibri"/>
               </a:rPr>
-              <a:t>• Clear start-billings on completed/shipped tanks; post missing Jul–Sep 2026 rev-rec entries.</a:t>
-            </a:r>
-          </a:p>
-          <a:p>
-            <a:r>
-              <a:rPr sz="750" b="0">
-                <a:solidFill>
-                  <a:srgbClr val="CCCCCC"/>
-                </a:solidFill>
-                <a:latin typeface="Calibri"/>
-              </a:rPr>
-              <a:t>• Tank-by-tank reconciliation (IM-109/122/134, EXOS-133) + corrected balance sheet to all directors.</a:t>
-            </a:r>
-          </a:p>
-        </p:txBody>
-      </p:sp>
-      <p:sp>
-        <p:nvSpPr>
-          <p:cNvPr id="32" name="Rectangle 31"/>
+              <a:t>CONFIDENTIAL</a:t>
+            </a:r>
+          </a:p>
+        </p:txBody>
+      </p:sp>
+    </p:spTree>
+  </p:cSld>
+  <p:clrMapOvr>
+    <a:masterClrMapping/>
+  </p:clrMapOvr>
+</p:sld>
+</file>
+
+<file path=ppt/slides/slide12.xml><?xml version="1.0" encoding="utf-8"?>
+<p:sld xmlns:a="http://schemas.openxmlformats.org/drawingml/2006/main" xmlns:p="http://schemas.openxmlformats.org/presentationml/2006/main" xmlns:r="http://schemas.openxmlformats.org/officeDocument/2006/relationships">
+  <p:cSld>
+    <p:bg>
+      <p:bgPr>
+        <a:solidFill>
+          <a:srgbClr val="111111"/>
+        </a:solidFill>
+        <a:effectLst/>
+      </p:bgPr>
+    </p:bg>
+    <p:spTree>
+      <p:nvGrpSpPr>
+        <p:cNvPr id="1" name=""/>
+        <p:cNvGrpSpPr/>
+        <p:nvPr/>
+      </p:nvGrpSpPr>
+      <p:grpSpPr/>
+      <p:sp>
+        <p:nvSpPr>
+          <p:cNvPr id="2" name="Rectangle 1"/>
           <p:cNvSpPr/>
           <p:nvPr/>
         </p:nvSpPr>
         <p:spPr>
           <a:xfrm>
-            <a:off x="182880" y="3675887"/>
-            <a:ext cx="8778240" cy="850392"/>
+            <a:off x="0" y="0"/>
+            <a:ext cx="9144000" cy="50292"/>
           </a:xfrm>
           <a:prstGeom prst="rect">
             <a:avLst/>
           </a:prstGeom>
           <a:solidFill>
-            <a:srgbClr val="1E1E1E"/>
+            <a:srgbClr val="F26A21"/>
           </a:solidFill>
           <a:ln>
             <a:noFill/>
@@ -4541,14 +5970,49 @@
       </p:sp>
       <p:sp>
         <p:nvSpPr>
-          <p:cNvPr id="33" name="Rectangle 32"/>
+          <p:cNvPr id="3" name="TextBox 2"/>
+          <p:cNvSpPr txBox="1"/>
+          <p:nvPr/>
+        </p:nvSpPr>
+        <p:spPr>
+          <a:xfrm>
+            <a:off x="228600" y="64008"/>
+            <a:ext cx="8686800" cy="384048"/>
+          </a:xfrm>
+          <a:prstGeom prst="rect">
+            <a:avLst/>
+          </a:prstGeom>
+          <a:noFill/>
+        </p:spPr>
+        <p:txBody>
+          <a:bodyPr wrap="square">
+            <a:spAutoFit/>
+          </a:bodyPr>
+          <a:lstStyle/>
+          <a:p>
+            <a:pPr algn="l"/>
+            <a:r>
+              <a:rPr sz="2000" b="1" i="0">
+                <a:solidFill>
+                  <a:srgbClr val="FFFFFF"/>
+                </a:solidFill>
+                <a:latin typeface="Cambria"/>
+              </a:rPr>
+              <a:t>Board Motions</a:t>
+            </a:r>
+          </a:p>
+        </p:txBody>
+      </p:sp>
+      <p:sp>
+        <p:nvSpPr>
+          <p:cNvPr id="4" name="Rectangle 3"/>
           <p:cNvSpPr/>
           <p:nvPr/>
         </p:nvSpPr>
         <p:spPr>
           <a:xfrm>
-            <a:off x="182880" y="3675887"/>
-            <a:ext cx="50292" cy="850392"/>
+            <a:off x="228600" y="457200"/>
+            <a:ext cx="1371600" cy="32004"/>
           </a:xfrm>
           <a:prstGeom prst="rect">
             <a:avLst/>
@@ -4584,20 +6048,20 @@
       </p:sp>
       <p:sp>
         <p:nvSpPr>
-          <p:cNvPr id="34" name="Rectangle 33"/>
+          <p:cNvPr id="5" name="Rectangle 4"/>
           <p:cNvSpPr/>
           <p:nvPr/>
         </p:nvSpPr>
         <p:spPr>
           <a:xfrm>
-            <a:off x="182880" y="3675887"/>
-            <a:ext cx="8778240" cy="233172"/>
+            <a:off x="182880" y="512064"/>
+            <a:ext cx="8778240" cy="896112"/>
           </a:xfrm>
           <a:prstGeom prst="rect">
             <a:avLst/>
           </a:prstGeom>
           <a:solidFill>
-            <a:srgbClr val="1A1A1A"/>
+            <a:srgbClr val="1E1E1E"/>
           </a:solidFill>
           <a:ln>
             <a:noFill/>
@@ -4627,14 +6091,14 @@
       </p:sp>
       <p:sp>
         <p:nvSpPr>
-          <p:cNvPr id="35" name="Rectangle 34"/>
+          <p:cNvPr id="6" name="Rectangle 5"/>
           <p:cNvSpPr/>
           <p:nvPr/>
         </p:nvSpPr>
         <p:spPr>
           <a:xfrm>
-            <a:off x="182880" y="3675887"/>
-            <a:ext cx="50292" cy="233172"/>
+            <a:off x="182880" y="512064"/>
+            <a:ext cx="50292" cy="896112"/>
           </a:xfrm>
           <a:prstGeom prst="rect">
             <a:avLst/>
@@ -4670,216 +6134,20 @@
       </p:sp>
       <p:sp>
         <p:nvSpPr>
-          <p:cNvPr id="36" name="TextBox 35"/>
-          <p:cNvSpPr txBox="1"/>
-          <p:nvPr/>
-        </p:nvSpPr>
-        <p:spPr>
-          <a:xfrm>
-            <a:off x="265176" y="3703320"/>
-            <a:ext cx="411480" cy="196596"/>
-          </a:xfrm>
-          <a:prstGeom prst="rect">
-            <a:avLst/>
-          </a:prstGeom>
-          <a:noFill/>
-        </p:spPr>
-        <p:txBody>
-          <a:bodyPr wrap="square">
-            <a:spAutoFit/>
-          </a:bodyPr>
-          <a:lstStyle/>
-          <a:p>
-            <a:pPr algn="l"/>
-            <a:r>
-              <a:rPr sz="2200" b="1" i="0">
-                <a:solidFill>
-                  <a:srgbClr val="F26A21"/>
-                </a:solidFill>
-                <a:latin typeface="Cambria"/>
-              </a:rPr>
-              <a:t>4</a:t>
-            </a:r>
-          </a:p>
-        </p:txBody>
-      </p:sp>
-      <p:sp>
-        <p:nvSpPr>
-          <p:cNvPr id="37" name="TextBox 36"/>
-          <p:cNvSpPr txBox="1"/>
-          <p:nvPr/>
-        </p:nvSpPr>
-        <p:spPr>
-          <a:xfrm>
-            <a:off x="731520" y="3712463"/>
-            <a:ext cx="6629400" cy="178308"/>
-          </a:xfrm>
-          <a:prstGeom prst="rect">
-            <a:avLst/>
-          </a:prstGeom>
-          <a:noFill/>
-        </p:spPr>
-        <p:txBody>
-          <a:bodyPr wrap="square">
-            <a:spAutoFit/>
-          </a:bodyPr>
-          <a:lstStyle/>
-          <a:p>
-            <a:pPr algn="l"/>
-            <a:r>
-              <a:rPr sz="950" b="1" i="0">
-                <a:solidFill>
-                  <a:srgbClr val="FFFFFF"/>
-                </a:solidFill>
-                <a:latin typeface="Calibri"/>
-              </a:rPr>
-              <a:t>Consent to ERP/MRP &amp; Inventory Evaluation (Separate Motion)</a:t>
-            </a:r>
-          </a:p>
-        </p:txBody>
-      </p:sp>
-      <p:sp>
-        <p:nvSpPr>
-          <p:cNvPr id="38" name="TextBox 37"/>
-          <p:cNvSpPr txBox="1"/>
-          <p:nvPr/>
-        </p:nvSpPr>
-        <p:spPr>
-          <a:xfrm>
-            <a:off x="7516367" y="3694175"/>
-            <a:ext cx="1371600" cy="201168"/>
-          </a:xfrm>
-          <a:prstGeom prst="rect">
-            <a:avLst/>
-          </a:prstGeom>
-          <a:noFill/>
-        </p:spPr>
-        <p:txBody>
-          <a:bodyPr wrap="square">
-            <a:spAutoFit/>
-          </a:bodyPr>
-          <a:lstStyle/>
-          <a:p>
-            <a:pPr algn="l"/>
-            <a:r>
-              <a:rPr sz="850" b="0" i="0">
-                <a:solidFill>
-                  <a:srgbClr val="44BB44"/>
-                </a:solidFill>
-                <a:latin typeface="Calibri"/>
-              </a:rPr>
-              <a:t>☐  Approve</a:t>
-            </a:r>
-          </a:p>
-        </p:txBody>
-      </p:sp>
-      <p:sp>
-        <p:nvSpPr>
-          <p:cNvPr id="39" name="TextBox 38"/>
-          <p:cNvSpPr txBox="1"/>
-          <p:nvPr/>
-        </p:nvSpPr>
-        <p:spPr>
-          <a:xfrm>
-            <a:off x="7516367" y="3840479"/>
-            <a:ext cx="1371600" cy="201168"/>
-          </a:xfrm>
-          <a:prstGeom prst="rect">
-            <a:avLst/>
-          </a:prstGeom>
-          <a:noFill/>
-        </p:spPr>
-        <p:txBody>
-          <a:bodyPr wrap="square">
-            <a:spAutoFit/>
-          </a:bodyPr>
-          <a:lstStyle/>
-          <a:p>
-            <a:pPr algn="l"/>
-            <a:r>
-              <a:rPr sz="850" b="0" i="0">
-                <a:solidFill>
-                  <a:srgbClr val="FF6666"/>
-                </a:solidFill>
-                <a:latin typeface="Calibri"/>
-              </a:rPr>
-              <a:t>☐  Decline</a:t>
-            </a:r>
-          </a:p>
-        </p:txBody>
-      </p:sp>
-      <p:sp>
-        <p:nvSpPr>
-          <p:cNvPr id="40" name="TextBox 39"/>
-          <p:cNvSpPr txBox="1"/>
-          <p:nvPr/>
-        </p:nvSpPr>
-        <p:spPr>
-          <a:xfrm>
-            <a:off x="731520" y="3945635"/>
-            <a:ext cx="6629400" cy="562356"/>
-          </a:xfrm>
-          <a:prstGeom prst="rect">
-            <a:avLst/>
-          </a:prstGeom>
-          <a:noFill/>
-        </p:spPr>
-        <p:txBody>
-          <a:bodyPr wrap="square">
-            <a:spAutoFit/>
-          </a:bodyPr>
-          <a:lstStyle/>
-          <a:p>
-            <a:r>
-              <a:rPr sz="750" b="0">
-                <a:solidFill>
-                  <a:srgbClr val="CCCCCC"/>
-                </a:solidFill>
-                <a:latin typeface="Calibri"/>
-              </a:rPr>
-              <a:t>Authorize Exos to use the same QB data to evaluate its in-house ERP/MRP and inventory</a:t>
-            </a:r>
-          </a:p>
-          <a:p>
-            <a:r>
-              <a:rPr sz="750" b="0">
-                <a:solidFill>
-                  <a:srgbClr val="CCCCCC"/>
-                </a:solidFill>
-                <a:latin typeface="Calibri"/>
-              </a:rPr>
-              <a:t>systems for the combined operation.  Confidential under the NDA.</a:t>
-            </a:r>
-          </a:p>
-          <a:p>
-            <a:r>
-              <a:rPr sz="750" b="0">
-                <a:solidFill>
-                  <a:srgbClr val="CCCCCC"/>
-                </a:solidFill>
-                <a:latin typeface="Calibri"/>
-              </a:rPr>
-              <a:t>Does not create any obligation to implement; evaluation only.</a:t>
-            </a:r>
-          </a:p>
-        </p:txBody>
-      </p:sp>
-      <p:sp>
-        <p:nvSpPr>
-          <p:cNvPr id="41" name="Rectangle 40"/>
+          <p:cNvPr id="7" name="Rectangle 6"/>
           <p:cNvSpPr/>
           <p:nvPr/>
         </p:nvSpPr>
         <p:spPr>
           <a:xfrm>
-            <a:off x="182880" y="4553712"/>
-            <a:ext cx="8778240" cy="182880"/>
+            <a:off x="182880" y="512064"/>
+            <a:ext cx="8778240" cy="233172"/>
           </a:xfrm>
           <a:prstGeom prst="rect">
             <a:avLst/>
           </a:prstGeom>
           <a:solidFill>
-            <a:srgbClr val="1A0A00"/>
+            <a:srgbClr val="1A1A1A"/>
           </a:solidFill>
           <a:ln>
             <a:noFill/>
@@ -4909,6 +6177,1436 @@
       </p:sp>
       <p:sp>
         <p:nvSpPr>
+          <p:cNvPr id="8" name="Rectangle 7"/>
+          <p:cNvSpPr/>
+          <p:nvPr/>
+        </p:nvSpPr>
+        <p:spPr>
+          <a:xfrm>
+            <a:off x="182880" y="512064"/>
+            <a:ext cx="50292" cy="233172"/>
+          </a:xfrm>
+          <a:prstGeom prst="rect">
+            <a:avLst/>
+          </a:prstGeom>
+          <a:solidFill>
+            <a:srgbClr val="F26A21"/>
+          </a:solidFill>
+          <a:ln>
+            <a:noFill/>
+          </a:ln>
+        </p:spPr>
+        <p:style>
+          <a:lnRef idx="1">
+            <a:schemeClr val="accent1"/>
+          </a:lnRef>
+          <a:fillRef idx="3">
+            <a:schemeClr val="accent1"/>
+          </a:fillRef>
+          <a:effectRef idx="2">
+            <a:schemeClr val="accent1"/>
+          </a:effectRef>
+          <a:fontRef idx="minor">
+            <a:schemeClr val="lt1"/>
+          </a:fontRef>
+        </p:style>
+        <p:txBody>
+          <a:bodyPr rtlCol="0" anchor="ctr"/>
+          <a:lstStyle/>
+          <a:p>
+            <a:pPr algn="ctr"/>
+          </a:p>
+        </p:txBody>
+      </p:sp>
+      <p:sp>
+        <p:nvSpPr>
+          <p:cNvPr id="9" name="TextBox 8"/>
+          <p:cNvSpPr txBox="1"/>
+          <p:nvPr/>
+        </p:nvSpPr>
+        <p:spPr>
+          <a:xfrm>
+            <a:off x="265176" y="539496"/>
+            <a:ext cx="411480" cy="196596"/>
+          </a:xfrm>
+          <a:prstGeom prst="rect">
+            <a:avLst/>
+          </a:prstGeom>
+          <a:noFill/>
+        </p:spPr>
+        <p:txBody>
+          <a:bodyPr wrap="square">
+            <a:spAutoFit/>
+          </a:bodyPr>
+          <a:lstStyle/>
+          <a:p>
+            <a:pPr algn="l"/>
+            <a:r>
+              <a:rPr sz="2200" b="1" i="0">
+                <a:solidFill>
+                  <a:srgbClr val="F26A21"/>
+                </a:solidFill>
+                <a:latin typeface="Cambria"/>
+              </a:rPr>
+              <a:t>1</a:t>
+            </a:r>
+          </a:p>
+        </p:txBody>
+      </p:sp>
+      <p:sp>
+        <p:nvSpPr>
+          <p:cNvPr id="10" name="TextBox 9"/>
+          <p:cNvSpPr txBox="1"/>
+          <p:nvPr/>
+        </p:nvSpPr>
+        <p:spPr>
+          <a:xfrm>
+            <a:off x="731520" y="548640"/>
+            <a:ext cx="6629400" cy="178308"/>
+          </a:xfrm>
+          <a:prstGeom prst="rect">
+            <a:avLst/>
+          </a:prstGeom>
+          <a:noFill/>
+        </p:spPr>
+        <p:txBody>
+          <a:bodyPr wrap="square">
+            <a:spAutoFit/>
+          </a:bodyPr>
+          <a:lstStyle/>
+          <a:p>
+            <a:pPr algn="l"/>
+            <a:r>
+              <a:rPr sz="950" b="1" i="0">
+                <a:solidFill>
+                  <a:srgbClr val="FFFFFF"/>
+                </a:solidFill>
+                <a:latin typeface="Calibri"/>
+              </a:rPr>
+              <a:t>Confirm §3 Exclusivity (May 2025 Asset Acquisition Agreement)</a:t>
+            </a:r>
+          </a:p>
+        </p:txBody>
+      </p:sp>
+      <p:sp>
+        <p:nvSpPr>
+          <p:cNvPr id="11" name="TextBox 10"/>
+          <p:cNvSpPr txBox="1"/>
+          <p:nvPr/>
+        </p:nvSpPr>
+        <p:spPr>
+          <a:xfrm>
+            <a:off x="7516367" y="530352"/>
+            <a:ext cx="1371600" cy="201168"/>
+          </a:xfrm>
+          <a:prstGeom prst="rect">
+            <a:avLst/>
+          </a:prstGeom>
+          <a:noFill/>
+        </p:spPr>
+        <p:txBody>
+          <a:bodyPr wrap="square">
+            <a:spAutoFit/>
+          </a:bodyPr>
+          <a:lstStyle/>
+          <a:p>
+            <a:pPr algn="l"/>
+            <a:r>
+              <a:rPr sz="850" b="0" i="0">
+                <a:solidFill>
+                  <a:srgbClr val="44BB44"/>
+                </a:solidFill>
+                <a:latin typeface="Calibri"/>
+              </a:rPr>
+              <a:t>☐  Approve</a:t>
+            </a:r>
+          </a:p>
+        </p:txBody>
+      </p:sp>
+      <p:sp>
+        <p:nvSpPr>
+          <p:cNvPr id="12" name="TextBox 11"/>
+          <p:cNvSpPr txBox="1"/>
+          <p:nvPr/>
+        </p:nvSpPr>
+        <p:spPr>
+          <a:xfrm>
+            <a:off x="7516367" y="676656"/>
+            <a:ext cx="1371600" cy="201168"/>
+          </a:xfrm>
+          <a:prstGeom prst="rect">
+            <a:avLst/>
+          </a:prstGeom>
+          <a:noFill/>
+        </p:spPr>
+        <p:txBody>
+          <a:bodyPr wrap="square">
+            <a:spAutoFit/>
+          </a:bodyPr>
+          <a:lstStyle/>
+          <a:p>
+            <a:pPr algn="l"/>
+            <a:r>
+              <a:rPr sz="850" b="0" i="0">
+                <a:solidFill>
+                  <a:srgbClr val="FF6666"/>
+                </a:solidFill>
+                <a:latin typeface="Calibri"/>
+              </a:rPr>
+              <a:t>☐  Decline</a:t>
+            </a:r>
+          </a:p>
+        </p:txBody>
+      </p:sp>
+      <p:sp>
+        <p:nvSpPr>
+          <p:cNvPr id="13" name="TextBox 12"/>
+          <p:cNvSpPr txBox="1"/>
+          <p:nvPr/>
+        </p:nvSpPr>
+        <p:spPr>
+          <a:xfrm>
+            <a:off x="731520" y="781812"/>
+            <a:ext cx="6629400" cy="608076"/>
+          </a:xfrm>
+          <a:prstGeom prst="rect">
+            <a:avLst/>
+          </a:prstGeom>
+          <a:noFill/>
+        </p:spPr>
+        <p:txBody>
+          <a:bodyPr wrap="square">
+            <a:spAutoFit/>
+          </a:bodyPr>
+          <a:lstStyle/>
+          <a:p>
+            <a:r>
+              <a:rPr sz="750" b="0">
+                <a:solidFill>
+                  <a:srgbClr val="CCCCCC"/>
+                </a:solidFill>
+                <a:latin typeface="Calibri"/>
+              </a:rPr>
+              <a:t>Approve a 90-day exclusivity period beginning on the date of this approval.</a:t>
+            </a:r>
+          </a:p>
+          <a:p>
+            <a:r>
+              <a:rPr sz="750" b="0">
+                <a:solidFill>
+                  <a:srgbClr val="CCCCCC"/>
+                </a:solidFill>
+                <a:latin typeface="Calibri"/>
+              </a:rPr>
+              <a:t>Extension not unreasonably withheld (per §3). Allows both parties to proceed to</a:t>
+            </a:r>
+          </a:p>
+          <a:p>
+            <a:r>
+              <a:rPr sz="750" b="0">
+                <a:solidFill>
+                  <a:srgbClr val="CCCCCC"/>
+                </a:solidFill>
+                <a:latin typeface="Calibri"/>
+              </a:rPr>
+              <a:t>diligence, definitive agreement, and financing close (target: Feb 15th, 2027).</a:t>
+            </a:r>
+          </a:p>
+        </p:txBody>
+      </p:sp>
+      <p:sp>
+        <p:nvSpPr>
+          <p:cNvPr id="14" name="Rectangle 13"/>
+          <p:cNvSpPr/>
+          <p:nvPr/>
+        </p:nvSpPr>
+        <p:spPr>
+          <a:xfrm>
+            <a:off x="182880" y="1444752"/>
+            <a:ext cx="8778240" cy="987552"/>
+          </a:xfrm>
+          <a:prstGeom prst="rect">
+            <a:avLst/>
+          </a:prstGeom>
+          <a:solidFill>
+            <a:srgbClr val="1E1E1E"/>
+          </a:solidFill>
+          <a:ln>
+            <a:noFill/>
+          </a:ln>
+        </p:spPr>
+        <p:style>
+          <a:lnRef idx="1">
+            <a:schemeClr val="accent1"/>
+          </a:lnRef>
+          <a:fillRef idx="3">
+            <a:schemeClr val="accent1"/>
+          </a:fillRef>
+          <a:effectRef idx="2">
+            <a:schemeClr val="accent1"/>
+          </a:effectRef>
+          <a:fontRef idx="minor">
+            <a:schemeClr val="lt1"/>
+          </a:fontRef>
+        </p:style>
+        <p:txBody>
+          <a:bodyPr rtlCol="0" anchor="ctr"/>
+          <a:lstStyle/>
+          <a:p>
+            <a:pPr algn="ctr"/>
+          </a:p>
+        </p:txBody>
+      </p:sp>
+      <p:sp>
+        <p:nvSpPr>
+          <p:cNvPr id="15" name="Rectangle 14"/>
+          <p:cNvSpPr/>
+          <p:nvPr/>
+        </p:nvSpPr>
+        <p:spPr>
+          <a:xfrm>
+            <a:off x="182880" y="1444752"/>
+            <a:ext cx="50292" cy="987552"/>
+          </a:xfrm>
+          <a:prstGeom prst="rect">
+            <a:avLst/>
+          </a:prstGeom>
+          <a:solidFill>
+            <a:srgbClr val="F26A21"/>
+          </a:solidFill>
+          <a:ln>
+            <a:noFill/>
+          </a:ln>
+        </p:spPr>
+        <p:style>
+          <a:lnRef idx="1">
+            <a:schemeClr val="accent1"/>
+          </a:lnRef>
+          <a:fillRef idx="3">
+            <a:schemeClr val="accent1"/>
+          </a:fillRef>
+          <a:effectRef idx="2">
+            <a:schemeClr val="accent1"/>
+          </a:effectRef>
+          <a:fontRef idx="minor">
+            <a:schemeClr val="lt1"/>
+          </a:fontRef>
+        </p:style>
+        <p:txBody>
+          <a:bodyPr rtlCol="0" anchor="ctr"/>
+          <a:lstStyle/>
+          <a:p>
+            <a:pPr algn="ctr"/>
+          </a:p>
+        </p:txBody>
+      </p:sp>
+      <p:sp>
+        <p:nvSpPr>
+          <p:cNvPr id="16" name="Rectangle 15"/>
+          <p:cNvSpPr/>
+          <p:nvPr/>
+        </p:nvSpPr>
+        <p:spPr>
+          <a:xfrm>
+            <a:off x="182880" y="1444752"/>
+            <a:ext cx="8778240" cy="233172"/>
+          </a:xfrm>
+          <a:prstGeom prst="rect">
+            <a:avLst/>
+          </a:prstGeom>
+          <a:solidFill>
+            <a:srgbClr val="1A1A1A"/>
+          </a:solidFill>
+          <a:ln>
+            <a:noFill/>
+          </a:ln>
+        </p:spPr>
+        <p:style>
+          <a:lnRef idx="1">
+            <a:schemeClr val="accent1"/>
+          </a:lnRef>
+          <a:fillRef idx="3">
+            <a:schemeClr val="accent1"/>
+          </a:fillRef>
+          <a:effectRef idx="2">
+            <a:schemeClr val="accent1"/>
+          </a:effectRef>
+          <a:fontRef idx="minor">
+            <a:schemeClr val="lt1"/>
+          </a:fontRef>
+        </p:style>
+        <p:txBody>
+          <a:bodyPr rtlCol="0" anchor="ctr"/>
+          <a:lstStyle/>
+          <a:p>
+            <a:pPr algn="ctr"/>
+          </a:p>
+        </p:txBody>
+      </p:sp>
+      <p:sp>
+        <p:nvSpPr>
+          <p:cNvPr id="17" name="Rectangle 16"/>
+          <p:cNvSpPr/>
+          <p:nvPr/>
+        </p:nvSpPr>
+        <p:spPr>
+          <a:xfrm>
+            <a:off x="182880" y="1444752"/>
+            <a:ext cx="50292" cy="233172"/>
+          </a:xfrm>
+          <a:prstGeom prst="rect">
+            <a:avLst/>
+          </a:prstGeom>
+          <a:solidFill>
+            <a:srgbClr val="F26A21"/>
+          </a:solidFill>
+          <a:ln>
+            <a:noFill/>
+          </a:ln>
+        </p:spPr>
+        <p:style>
+          <a:lnRef idx="1">
+            <a:schemeClr val="accent1"/>
+          </a:lnRef>
+          <a:fillRef idx="3">
+            <a:schemeClr val="accent1"/>
+          </a:fillRef>
+          <a:effectRef idx="2">
+            <a:schemeClr val="accent1"/>
+          </a:effectRef>
+          <a:fontRef idx="minor">
+            <a:schemeClr val="lt1"/>
+          </a:fontRef>
+        </p:style>
+        <p:txBody>
+          <a:bodyPr rtlCol="0" anchor="ctr"/>
+          <a:lstStyle/>
+          <a:p>
+            <a:pPr algn="ctr"/>
+          </a:p>
+        </p:txBody>
+      </p:sp>
+      <p:sp>
+        <p:nvSpPr>
+          <p:cNvPr id="18" name="TextBox 17"/>
+          <p:cNvSpPr txBox="1"/>
+          <p:nvPr/>
+        </p:nvSpPr>
+        <p:spPr>
+          <a:xfrm>
+            <a:off x="265176" y="1472184"/>
+            <a:ext cx="411480" cy="196596"/>
+          </a:xfrm>
+          <a:prstGeom prst="rect">
+            <a:avLst/>
+          </a:prstGeom>
+          <a:noFill/>
+        </p:spPr>
+        <p:txBody>
+          <a:bodyPr wrap="square">
+            <a:spAutoFit/>
+          </a:bodyPr>
+          <a:lstStyle/>
+          <a:p>
+            <a:pPr algn="l"/>
+            <a:r>
+              <a:rPr sz="2200" b="1" i="0">
+                <a:solidFill>
+                  <a:srgbClr val="F26A21"/>
+                </a:solidFill>
+                <a:latin typeface="Cambria"/>
+              </a:rPr>
+              <a:t>2</a:t>
+            </a:r>
+          </a:p>
+        </p:txBody>
+      </p:sp>
+      <p:sp>
+        <p:nvSpPr>
+          <p:cNvPr id="19" name="TextBox 18"/>
+          <p:cNvSpPr txBox="1"/>
+          <p:nvPr/>
+        </p:nvSpPr>
+        <p:spPr>
+          <a:xfrm>
+            <a:off x="731520" y="1481328"/>
+            <a:ext cx="6629400" cy="178308"/>
+          </a:xfrm>
+          <a:prstGeom prst="rect">
+            <a:avLst/>
+          </a:prstGeom>
+          <a:noFill/>
+        </p:spPr>
+        <p:txBody>
+          <a:bodyPr wrap="square">
+            <a:spAutoFit/>
+          </a:bodyPr>
+          <a:lstStyle/>
+          <a:p>
+            <a:pPr algn="l"/>
+            <a:r>
+              <a:rPr sz="950" b="1" i="0">
+                <a:solidFill>
+                  <a:srgbClr val="FFFFFF"/>
+                </a:solidFill>
+                <a:latin typeface="Calibri"/>
+              </a:rPr>
+              <a:t>Grant Full Read-Only QuickBooks Online Access for Diligence</a:t>
+            </a:r>
+          </a:p>
+        </p:txBody>
+      </p:sp>
+      <p:sp>
+        <p:nvSpPr>
+          <p:cNvPr id="20" name="TextBox 19"/>
+          <p:cNvSpPr txBox="1"/>
+          <p:nvPr/>
+        </p:nvSpPr>
+        <p:spPr>
+          <a:xfrm>
+            <a:off x="7516367" y="1463040"/>
+            <a:ext cx="1371600" cy="201168"/>
+          </a:xfrm>
+          <a:prstGeom prst="rect">
+            <a:avLst/>
+          </a:prstGeom>
+          <a:noFill/>
+        </p:spPr>
+        <p:txBody>
+          <a:bodyPr wrap="square">
+            <a:spAutoFit/>
+          </a:bodyPr>
+          <a:lstStyle/>
+          <a:p>
+            <a:pPr algn="l"/>
+            <a:r>
+              <a:rPr sz="850" b="0" i="0">
+                <a:solidFill>
+                  <a:srgbClr val="44BB44"/>
+                </a:solidFill>
+                <a:latin typeface="Calibri"/>
+              </a:rPr>
+              <a:t>☐  Approve</a:t>
+            </a:r>
+          </a:p>
+        </p:txBody>
+      </p:sp>
+      <p:sp>
+        <p:nvSpPr>
+          <p:cNvPr id="21" name="TextBox 20"/>
+          <p:cNvSpPr txBox="1"/>
+          <p:nvPr/>
+        </p:nvSpPr>
+        <p:spPr>
+          <a:xfrm>
+            <a:off x="7516367" y="1609344"/>
+            <a:ext cx="1371600" cy="201168"/>
+          </a:xfrm>
+          <a:prstGeom prst="rect">
+            <a:avLst/>
+          </a:prstGeom>
+          <a:noFill/>
+        </p:spPr>
+        <p:txBody>
+          <a:bodyPr wrap="square">
+            <a:spAutoFit/>
+          </a:bodyPr>
+          <a:lstStyle/>
+          <a:p>
+            <a:pPr algn="l"/>
+            <a:r>
+              <a:rPr sz="850" b="0" i="0">
+                <a:solidFill>
+                  <a:srgbClr val="FF6666"/>
+                </a:solidFill>
+                <a:latin typeface="Calibri"/>
+              </a:rPr>
+              <a:t>☐  Decline</a:t>
+            </a:r>
+          </a:p>
+        </p:txBody>
+      </p:sp>
+      <p:sp>
+        <p:nvSpPr>
+          <p:cNvPr id="22" name="TextBox 21"/>
+          <p:cNvSpPr txBox="1"/>
+          <p:nvPr/>
+        </p:nvSpPr>
+        <p:spPr>
+          <a:xfrm>
+            <a:off x="731520" y="1714500"/>
+            <a:ext cx="6629400" cy="699516"/>
+          </a:xfrm>
+          <a:prstGeom prst="rect">
+            <a:avLst/>
+          </a:prstGeom>
+          <a:noFill/>
+        </p:spPr>
+        <p:txBody>
+          <a:bodyPr wrap="square">
+            <a:spAutoFit/>
+          </a:bodyPr>
+          <a:lstStyle/>
+          <a:p>
+            <a:r>
+              <a:rPr sz="700" b="0">
+                <a:solidFill>
+                  <a:srgbClr val="CCCCCC"/>
+                </a:solidFill>
+                <a:latin typeface="Calibri"/>
+              </a:rPr>
+              <a:t>Authorize an all-access or accountant user for John Quinn and one Exos finance reviewer.</a:t>
+            </a:r>
+          </a:p>
+          <a:p>
+            <a:r>
+              <a:rPr sz="700" b="0">
+                <a:solidFill>
+                  <a:srgbClr val="CCCCCC"/>
+                </a:solidFill>
+                <a:latin typeface="Calibri"/>
+              </a:rPr>
+              <a:t>Purpose: reconcile the $942K "billed-ahead" balance and shared-facility costs before close.</a:t>
+            </a:r>
+          </a:p>
+          <a:p>
+            <a:r>
+              <a:rPr sz="700" b="0">
+                <a:solidFill>
+                  <a:srgbClr val="CCCCCC"/>
+                </a:solidFill>
+                <a:latin typeface="Calibri"/>
+              </a:rPr>
+              <a:t>Basis: Cal. Corp. Code §1602 director inspection right + AAA §4 confirmatory diligence.</a:t>
+            </a:r>
+          </a:p>
+          <a:p>
+            <a:r>
+              <a:rPr sz="700" b="0">
+                <a:solidFill>
+                  <a:srgbClr val="CCCCCC"/>
+                </a:solidFill>
+                <a:latin typeface="Calibri"/>
+              </a:rPr>
+              <a:t>Also provide: stock ledger, cap table, subscription agreements, and paid-in capital</a:t>
+            </a:r>
+          </a:p>
+          <a:p>
+            <a:r>
+              <a:rPr sz="700" b="0">
+                <a:solidFill>
+                  <a:srgbClr val="CCCCCC"/>
+                </a:solidFill>
+                <a:latin typeface="Calibri"/>
+              </a:rPr>
+              <a:t>by shareholder (books: $1,014,465 total paid-in; need per-holder to compare payout vs. invested).</a:t>
+            </a:r>
+          </a:p>
+          <a:p>
+            <a:r>
+              <a:rPr sz="750" b="1">
+                <a:solidFill>
+                  <a:srgbClr val="F26A21"/>
+                </a:solidFill>
+                <a:latin typeface="Calibri"/>
+              </a:rPr>
+              <a:t>Confidential under the 7/27/2021 NDA.  Access to be granted no later than October 15, 2026.</a:t>
+            </a:r>
+          </a:p>
+        </p:txBody>
+      </p:sp>
+      <p:sp>
+        <p:nvSpPr>
+          <p:cNvPr id="23" name="Rectangle 22"/>
+          <p:cNvSpPr/>
+          <p:nvPr/>
+        </p:nvSpPr>
+        <p:spPr>
+          <a:xfrm>
+            <a:off x="182880" y="2468880"/>
+            <a:ext cx="8778240" cy="1170432"/>
+          </a:xfrm>
+          <a:prstGeom prst="rect">
+            <a:avLst/>
+          </a:prstGeom>
+          <a:solidFill>
+            <a:srgbClr val="1E1E1E"/>
+          </a:solidFill>
+          <a:ln>
+            <a:noFill/>
+          </a:ln>
+        </p:spPr>
+        <p:style>
+          <a:lnRef idx="1">
+            <a:schemeClr val="accent1"/>
+          </a:lnRef>
+          <a:fillRef idx="3">
+            <a:schemeClr val="accent1"/>
+          </a:fillRef>
+          <a:effectRef idx="2">
+            <a:schemeClr val="accent1"/>
+          </a:effectRef>
+          <a:fontRef idx="minor">
+            <a:schemeClr val="lt1"/>
+          </a:fontRef>
+        </p:style>
+        <p:txBody>
+          <a:bodyPr rtlCol="0" anchor="ctr"/>
+          <a:lstStyle/>
+          <a:p>
+            <a:pPr algn="ctr"/>
+          </a:p>
+        </p:txBody>
+      </p:sp>
+      <p:sp>
+        <p:nvSpPr>
+          <p:cNvPr id="24" name="Rectangle 23"/>
+          <p:cNvSpPr/>
+          <p:nvPr/>
+        </p:nvSpPr>
+        <p:spPr>
+          <a:xfrm>
+            <a:off x="182880" y="2468880"/>
+            <a:ext cx="50292" cy="1170432"/>
+          </a:xfrm>
+          <a:prstGeom prst="rect">
+            <a:avLst/>
+          </a:prstGeom>
+          <a:solidFill>
+            <a:srgbClr val="F26A21"/>
+          </a:solidFill>
+          <a:ln>
+            <a:noFill/>
+          </a:ln>
+        </p:spPr>
+        <p:style>
+          <a:lnRef idx="1">
+            <a:schemeClr val="accent1"/>
+          </a:lnRef>
+          <a:fillRef idx="3">
+            <a:schemeClr val="accent1"/>
+          </a:fillRef>
+          <a:effectRef idx="2">
+            <a:schemeClr val="accent1"/>
+          </a:effectRef>
+          <a:fontRef idx="minor">
+            <a:schemeClr val="lt1"/>
+          </a:fontRef>
+        </p:style>
+        <p:txBody>
+          <a:bodyPr rtlCol="0" anchor="ctr"/>
+          <a:lstStyle/>
+          <a:p>
+            <a:pPr algn="ctr"/>
+          </a:p>
+        </p:txBody>
+      </p:sp>
+      <p:sp>
+        <p:nvSpPr>
+          <p:cNvPr id="25" name="Rectangle 24"/>
+          <p:cNvSpPr/>
+          <p:nvPr/>
+        </p:nvSpPr>
+        <p:spPr>
+          <a:xfrm>
+            <a:off x="182880" y="2468880"/>
+            <a:ext cx="8778240" cy="233172"/>
+          </a:xfrm>
+          <a:prstGeom prst="rect">
+            <a:avLst/>
+          </a:prstGeom>
+          <a:solidFill>
+            <a:srgbClr val="1A1A1A"/>
+          </a:solidFill>
+          <a:ln>
+            <a:noFill/>
+          </a:ln>
+        </p:spPr>
+        <p:style>
+          <a:lnRef idx="1">
+            <a:schemeClr val="accent1"/>
+          </a:lnRef>
+          <a:fillRef idx="3">
+            <a:schemeClr val="accent1"/>
+          </a:fillRef>
+          <a:effectRef idx="2">
+            <a:schemeClr val="accent1"/>
+          </a:effectRef>
+          <a:fontRef idx="minor">
+            <a:schemeClr val="lt1"/>
+          </a:fontRef>
+        </p:style>
+        <p:txBody>
+          <a:bodyPr rtlCol="0" anchor="ctr"/>
+          <a:lstStyle/>
+          <a:p>
+            <a:pPr algn="ctr"/>
+          </a:p>
+        </p:txBody>
+      </p:sp>
+      <p:sp>
+        <p:nvSpPr>
+          <p:cNvPr id="26" name="Rectangle 25"/>
+          <p:cNvSpPr/>
+          <p:nvPr/>
+        </p:nvSpPr>
+        <p:spPr>
+          <a:xfrm>
+            <a:off x="182880" y="2468880"/>
+            <a:ext cx="50292" cy="233172"/>
+          </a:xfrm>
+          <a:prstGeom prst="rect">
+            <a:avLst/>
+          </a:prstGeom>
+          <a:solidFill>
+            <a:srgbClr val="F26A21"/>
+          </a:solidFill>
+          <a:ln>
+            <a:noFill/>
+          </a:ln>
+        </p:spPr>
+        <p:style>
+          <a:lnRef idx="1">
+            <a:schemeClr val="accent1"/>
+          </a:lnRef>
+          <a:fillRef idx="3">
+            <a:schemeClr val="accent1"/>
+          </a:fillRef>
+          <a:effectRef idx="2">
+            <a:schemeClr val="accent1"/>
+          </a:effectRef>
+          <a:fontRef idx="minor">
+            <a:schemeClr val="lt1"/>
+          </a:fontRef>
+        </p:style>
+        <p:txBody>
+          <a:bodyPr rtlCol="0" anchor="ctr"/>
+          <a:lstStyle/>
+          <a:p>
+            <a:pPr algn="ctr"/>
+          </a:p>
+        </p:txBody>
+      </p:sp>
+      <p:sp>
+        <p:nvSpPr>
+          <p:cNvPr id="27" name="TextBox 26"/>
+          <p:cNvSpPr txBox="1"/>
+          <p:nvPr/>
+        </p:nvSpPr>
+        <p:spPr>
+          <a:xfrm>
+            <a:off x="265176" y="2496312"/>
+            <a:ext cx="411480" cy="196596"/>
+          </a:xfrm>
+          <a:prstGeom prst="rect">
+            <a:avLst/>
+          </a:prstGeom>
+          <a:noFill/>
+        </p:spPr>
+        <p:txBody>
+          <a:bodyPr wrap="square">
+            <a:spAutoFit/>
+          </a:bodyPr>
+          <a:lstStyle/>
+          <a:p>
+            <a:pPr algn="l"/>
+            <a:r>
+              <a:rPr sz="2200" b="1" i="0">
+                <a:solidFill>
+                  <a:srgbClr val="F26A21"/>
+                </a:solidFill>
+                <a:latin typeface="Cambria"/>
+              </a:rPr>
+              <a:t>3</a:t>
+            </a:r>
+          </a:p>
+        </p:txBody>
+      </p:sp>
+      <p:sp>
+        <p:nvSpPr>
+          <p:cNvPr id="28" name="TextBox 27"/>
+          <p:cNvSpPr txBox="1"/>
+          <p:nvPr/>
+        </p:nvSpPr>
+        <p:spPr>
+          <a:xfrm>
+            <a:off x="731520" y="2505456"/>
+            <a:ext cx="6629400" cy="178308"/>
+          </a:xfrm>
+          <a:prstGeom prst="rect">
+            <a:avLst/>
+          </a:prstGeom>
+          <a:noFill/>
+        </p:spPr>
+        <p:txBody>
+          <a:bodyPr wrap="square">
+            <a:spAutoFit/>
+          </a:bodyPr>
+          <a:lstStyle/>
+          <a:p>
+            <a:pPr algn="l"/>
+            <a:r>
+              <a:rPr sz="950" b="1" i="0">
+                <a:solidFill>
+                  <a:srgbClr val="FFFFFF"/>
+                </a:solidFill>
+                <a:latin typeface="Calibri"/>
+              </a:rPr>
+              <a:t>Correct AR Unbilled / Customer-Deposit Accounting Within 5 Days</a:t>
+            </a:r>
+          </a:p>
+        </p:txBody>
+      </p:sp>
+      <p:sp>
+        <p:nvSpPr>
+          <p:cNvPr id="29" name="TextBox 28"/>
+          <p:cNvSpPr txBox="1"/>
+          <p:nvPr/>
+        </p:nvSpPr>
+        <p:spPr>
+          <a:xfrm>
+            <a:off x="7516367" y="2487168"/>
+            <a:ext cx="1371600" cy="201168"/>
+          </a:xfrm>
+          <a:prstGeom prst="rect">
+            <a:avLst/>
+          </a:prstGeom>
+          <a:noFill/>
+        </p:spPr>
+        <p:txBody>
+          <a:bodyPr wrap="square">
+            <a:spAutoFit/>
+          </a:bodyPr>
+          <a:lstStyle/>
+          <a:p>
+            <a:pPr algn="l"/>
+            <a:r>
+              <a:rPr sz="850" b="0" i="0">
+                <a:solidFill>
+                  <a:srgbClr val="44BB44"/>
+                </a:solidFill>
+                <a:latin typeface="Calibri"/>
+              </a:rPr>
+              <a:t>☐  Approve</a:t>
+            </a:r>
+          </a:p>
+        </p:txBody>
+      </p:sp>
+      <p:sp>
+        <p:nvSpPr>
+          <p:cNvPr id="30" name="TextBox 29"/>
+          <p:cNvSpPr txBox="1"/>
+          <p:nvPr/>
+        </p:nvSpPr>
+        <p:spPr>
+          <a:xfrm>
+            <a:off x="7516367" y="2633472"/>
+            <a:ext cx="1371600" cy="201168"/>
+          </a:xfrm>
+          <a:prstGeom prst="rect">
+            <a:avLst/>
+          </a:prstGeom>
+          <a:noFill/>
+        </p:spPr>
+        <p:txBody>
+          <a:bodyPr wrap="square">
+            <a:spAutoFit/>
+          </a:bodyPr>
+          <a:lstStyle/>
+          <a:p>
+            <a:pPr algn="l"/>
+            <a:r>
+              <a:rPr sz="850" b="0" i="0">
+                <a:solidFill>
+                  <a:srgbClr val="FF6666"/>
+                </a:solidFill>
+                <a:latin typeface="Calibri"/>
+              </a:rPr>
+              <a:t>☐  Decline</a:t>
+            </a:r>
+          </a:p>
+        </p:txBody>
+      </p:sp>
+      <p:sp>
+        <p:nvSpPr>
+          <p:cNvPr id="31" name="TextBox 30"/>
+          <p:cNvSpPr txBox="1"/>
+          <p:nvPr/>
+        </p:nvSpPr>
+        <p:spPr>
+          <a:xfrm>
+            <a:off x="731520" y="2738628"/>
+            <a:ext cx="6629400" cy="882395"/>
+          </a:xfrm>
+          <a:prstGeom prst="rect">
+            <a:avLst/>
+          </a:prstGeom>
+          <a:noFill/>
+        </p:spPr>
+        <p:txBody>
+          <a:bodyPr wrap="square">
+            <a:spAutoFit/>
+          </a:bodyPr>
+          <a:lstStyle/>
+          <a:p>
+            <a:r>
+              <a:rPr sz="750" b="0">
+                <a:solidFill>
+                  <a:srgbClr val="CCCCCC"/>
+                </a:solidFill>
+                <a:latin typeface="Calibri"/>
+              </a:rPr>
+              <a:t>Direct A La Carte Solutions (bookkeeper) + Singer Lewak / Welch &amp; Co. to reconcile and correct:</a:t>
+            </a:r>
+          </a:p>
+          <a:p>
+            <a:r>
+              <a:rPr sz="750" b="0">
+                <a:solidFill>
+                  <a:srgbClr val="CCCCCC"/>
+                </a:solidFill>
+                <a:latin typeface="Calibri"/>
+              </a:rPr>
+              <a:t>• Acct 1110 AR Unbilled ($942,177) and Acct 2380 Deposits ($120,000) within 5 days of approval.</a:t>
+            </a:r>
+          </a:p>
+          <a:p>
+            <a:r>
+              <a:rPr sz="750" b="0">
+                <a:solidFill>
+                  <a:srgbClr val="CCCCCC"/>
+                </a:solidFill>
+                <a:latin typeface="Calibri"/>
+              </a:rPr>
+              <a:t>• Clear start-billings on completed/shipped tanks; post missing Jul–Sep 2026 rev-rec entries.</a:t>
+            </a:r>
+          </a:p>
+          <a:p>
+            <a:r>
+              <a:rPr sz="750" b="0">
+                <a:solidFill>
+                  <a:srgbClr val="CCCCCC"/>
+                </a:solidFill>
+                <a:latin typeface="Calibri"/>
+              </a:rPr>
+              <a:t>• Tank-by-tank reconciliation (IM-109/122/134, EXOS-133) + corrected balance sheet to all directors.</a:t>
+            </a:r>
+          </a:p>
+        </p:txBody>
+      </p:sp>
+      <p:sp>
+        <p:nvSpPr>
+          <p:cNvPr id="32" name="Rectangle 31"/>
+          <p:cNvSpPr/>
+          <p:nvPr/>
+        </p:nvSpPr>
+        <p:spPr>
+          <a:xfrm>
+            <a:off x="182880" y="3675887"/>
+            <a:ext cx="8778240" cy="850392"/>
+          </a:xfrm>
+          <a:prstGeom prst="rect">
+            <a:avLst/>
+          </a:prstGeom>
+          <a:solidFill>
+            <a:srgbClr val="1E1E1E"/>
+          </a:solidFill>
+          <a:ln>
+            <a:noFill/>
+          </a:ln>
+        </p:spPr>
+        <p:style>
+          <a:lnRef idx="1">
+            <a:schemeClr val="accent1"/>
+          </a:lnRef>
+          <a:fillRef idx="3">
+            <a:schemeClr val="accent1"/>
+          </a:fillRef>
+          <a:effectRef idx="2">
+            <a:schemeClr val="accent1"/>
+          </a:effectRef>
+          <a:fontRef idx="minor">
+            <a:schemeClr val="lt1"/>
+          </a:fontRef>
+        </p:style>
+        <p:txBody>
+          <a:bodyPr rtlCol="0" anchor="ctr"/>
+          <a:lstStyle/>
+          <a:p>
+            <a:pPr algn="ctr"/>
+          </a:p>
+        </p:txBody>
+      </p:sp>
+      <p:sp>
+        <p:nvSpPr>
+          <p:cNvPr id="33" name="Rectangle 32"/>
+          <p:cNvSpPr/>
+          <p:nvPr/>
+        </p:nvSpPr>
+        <p:spPr>
+          <a:xfrm>
+            <a:off x="182880" y="3675887"/>
+            <a:ext cx="50292" cy="850392"/>
+          </a:xfrm>
+          <a:prstGeom prst="rect">
+            <a:avLst/>
+          </a:prstGeom>
+          <a:solidFill>
+            <a:srgbClr val="F26A21"/>
+          </a:solidFill>
+          <a:ln>
+            <a:noFill/>
+          </a:ln>
+        </p:spPr>
+        <p:style>
+          <a:lnRef idx="1">
+            <a:schemeClr val="accent1"/>
+          </a:lnRef>
+          <a:fillRef idx="3">
+            <a:schemeClr val="accent1"/>
+          </a:fillRef>
+          <a:effectRef idx="2">
+            <a:schemeClr val="accent1"/>
+          </a:effectRef>
+          <a:fontRef idx="minor">
+            <a:schemeClr val="lt1"/>
+          </a:fontRef>
+        </p:style>
+        <p:txBody>
+          <a:bodyPr rtlCol="0" anchor="ctr"/>
+          <a:lstStyle/>
+          <a:p>
+            <a:pPr algn="ctr"/>
+          </a:p>
+        </p:txBody>
+      </p:sp>
+      <p:sp>
+        <p:nvSpPr>
+          <p:cNvPr id="34" name="Rectangle 33"/>
+          <p:cNvSpPr/>
+          <p:nvPr/>
+        </p:nvSpPr>
+        <p:spPr>
+          <a:xfrm>
+            <a:off x="182880" y="3675887"/>
+            <a:ext cx="8778240" cy="233172"/>
+          </a:xfrm>
+          <a:prstGeom prst="rect">
+            <a:avLst/>
+          </a:prstGeom>
+          <a:solidFill>
+            <a:srgbClr val="1A1A1A"/>
+          </a:solidFill>
+          <a:ln>
+            <a:noFill/>
+          </a:ln>
+        </p:spPr>
+        <p:style>
+          <a:lnRef idx="1">
+            <a:schemeClr val="accent1"/>
+          </a:lnRef>
+          <a:fillRef idx="3">
+            <a:schemeClr val="accent1"/>
+          </a:fillRef>
+          <a:effectRef idx="2">
+            <a:schemeClr val="accent1"/>
+          </a:effectRef>
+          <a:fontRef idx="minor">
+            <a:schemeClr val="lt1"/>
+          </a:fontRef>
+        </p:style>
+        <p:txBody>
+          <a:bodyPr rtlCol="0" anchor="ctr"/>
+          <a:lstStyle/>
+          <a:p>
+            <a:pPr algn="ctr"/>
+          </a:p>
+        </p:txBody>
+      </p:sp>
+      <p:sp>
+        <p:nvSpPr>
+          <p:cNvPr id="35" name="Rectangle 34"/>
+          <p:cNvSpPr/>
+          <p:nvPr/>
+        </p:nvSpPr>
+        <p:spPr>
+          <a:xfrm>
+            <a:off x="182880" y="3675887"/>
+            <a:ext cx="50292" cy="233172"/>
+          </a:xfrm>
+          <a:prstGeom prst="rect">
+            <a:avLst/>
+          </a:prstGeom>
+          <a:solidFill>
+            <a:srgbClr val="F26A21"/>
+          </a:solidFill>
+          <a:ln>
+            <a:noFill/>
+          </a:ln>
+        </p:spPr>
+        <p:style>
+          <a:lnRef idx="1">
+            <a:schemeClr val="accent1"/>
+          </a:lnRef>
+          <a:fillRef idx="3">
+            <a:schemeClr val="accent1"/>
+          </a:fillRef>
+          <a:effectRef idx="2">
+            <a:schemeClr val="accent1"/>
+          </a:effectRef>
+          <a:fontRef idx="minor">
+            <a:schemeClr val="lt1"/>
+          </a:fontRef>
+        </p:style>
+        <p:txBody>
+          <a:bodyPr rtlCol="0" anchor="ctr"/>
+          <a:lstStyle/>
+          <a:p>
+            <a:pPr algn="ctr"/>
+          </a:p>
+        </p:txBody>
+      </p:sp>
+      <p:sp>
+        <p:nvSpPr>
+          <p:cNvPr id="36" name="TextBox 35"/>
+          <p:cNvSpPr txBox="1"/>
+          <p:nvPr/>
+        </p:nvSpPr>
+        <p:spPr>
+          <a:xfrm>
+            <a:off x="265176" y="3703320"/>
+            <a:ext cx="411480" cy="196596"/>
+          </a:xfrm>
+          <a:prstGeom prst="rect">
+            <a:avLst/>
+          </a:prstGeom>
+          <a:noFill/>
+        </p:spPr>
+        <p:txBody>
+          <a:bodyPr wrap="square">
+            <a:spAutoFit/>
+          </a:bodyPr>
+          <a:lstStyle/>
+          <a:p>
+            <a:pPr algn="l"/>
+            <a:r>
+              <a:rPr sz="2200" b="1" i="0">
+                <a:solidFill>
+                  <a:srgbClr val="F26A21"/>
+                </a:solidFill>
+                <a:latin typeface="Cambria"/>
+              </a:rPr>
+              <a:t>4</a:t>
+            </a:r>
+          </a:p>
+        </p:txBody>
+      </p:sp>
+      <p:sp>
+        <p:nvSpPr>
+          <p:cNvPr id="37" name="TextBox 36"/>
+          <p:cNvSpPr txBox="1"/>
+          <p:nvPr/>
+        </p:nvSpPr>
+        <p:spPr>
+          <a:xfrm>
+            <a:off x="731520" y="3712463"/>
+            <a:ext cx="6629400" cy="178308"/>
+          </a:xfrm>
+          <a:prstGeom prst="rect">
+            <a:avLst/>
+          </a:prstGeom>
+          <a:noFill/>
+        </p:spPr>
+        <p:txBody>
+          <a:bodyPr wrap="square">
+            <a:spAutoFit/>
+          </a:bodyPr>
+          <a:lstStyle/>
+          <a:p>
+            <a:pPr algn="l"/>
+            <a:r>
+              <a:rPr sz="950" b="1" i="0">
+                <a:solidFill>
+                  <a:srgbClr val="FFFFFF"/>
+                </a:solidFill>
+                <a:latin typeface="Calibri"/>
+              </a:rPr>
+              <a:t>Consent to ERP/MRP &amp; Inventory Evaluation (Separate Motion)</a:t>
+            </a:r>
+          </a:p>
+        </p:txBody>
+      </p:sp>
+      <p:sp>
+        <p:nvSpPr>
+          <p:cNvPr id="38" name="TextBox 37"/>
+          <p:cNvSpPr txBox="1"/>
+          <p:nvPr/>
+        </p:nvSpPr>
+        <p:spPr>
+          <a:xfrm>
+            <a:off x="7516367" y="3694175"/>
+            <a:ext cx="1371600" cy="201168"/>
+          </a:xfrm>
+          <a:prstGeom prst="rect">
+            <a:avLst/>
+          </a:prstGeom>
+          <a:noFill/>
+        </p:spPr>
+        <p:txBody>
+          <a:bodyPr wrap="square">
+            <a:spAutoFit/>
+          </a:bodyPr>
+          <a:lstStyle/>
+          <a:p>
+            <a:pPr algn="l"/>
+            <a:r>
+              <a:rPr sz="850" b="0" i="0">
+                <a:solidFill>
+                  <a:srgbClr val="44BB44"/>
+                </a:solidFill>
+                <a:latin typeface="Calibri"/>
+              </a:rPr>
+              <a:t>☐  Approve</a:t>
+            </a:r>
+          </a:p>
+        </p:txBody>
+      </p:sp>
+      <p:sp>
+        <p:nvSpPr>
+          <p:cNvPr id="39" name="TextBox 38"/>
+          <p:cNvSpPr txBox="1"/>
+          <p:nvPr/>
+        </p:nvSpPr>
+        <p:spPr>
+          <a:xfrm>
+            <a:off x="7516367" y="3840479"/>
+            <a:ext cx="1371600" cy="201168"/>
+          </a:xfrm>
+          <a:prstGeom prst="rect">
+            <a:avLst/>
+          </a:prstGeom>
+          <a:noFill/>
+        </p:spPr>
+        <p:txBody>
+          <a:bodyPr wrap="square">
+            <a:spAutoFit/>
+          </a:bodyPr>
+          <a:lstStyle/>
+          <a:p>
+            <a:pPr algn="l"/>
+            <a:r>
+              <a:rPr sz="850" b="0" i="0">
+                <a:solidFill>
+                  <a:srgbClr val="FF6666"/>
+                </a:solidFill>
+                <a:latin typeface="Calibri"/>
+              </a:rPr>
+              <a:t>☐  Decline</a:t>
+            </a:r>
+          </a:p>
+        </p:txBody>
+      </p:sp>
+      <p:sp>
+        <p:nvSpPr>
+          <p:cNvPr id="40" name="TextBox 39"/>
+          <p:cNvSpPr txBox="1"/>
+          <p:nvPr/>
+        </p:nvSpPr>
+        <p:spPr>
+          <a:xfrm>
+            <a:off x="731520" y="3945635"/>
+            <a:ext cx="6629400" cy="562356"/>
+          </a:xfrm>
+          <a:prstGeom prst="rect">
+            <a:avLst/>
+          </a:prstGeom>
+          <a:noFill/>
+        </p:spPr>
+        <p:txBody>
+          <a:bodyPr wrap="square">
+            <a:spAutoFit/>
+          </a:bodyPr>
+          <a:lstStyle/>
+          <a:p>
+            <a:r>
+              <a:rPr sz="750" b="0">
+                <a:solidFill>
+                  <a:srgbClr val="CCCCCC"/>
+                </a:solidFill>
+                <a:latin typeface="Calibri"/>
+              </a:rPr>
+              <a:t>Authorize Exos to use the same QB data to evaluate its in-house ERP/MRP and inventory</a:t>
+            </a:r>
+          </a:p>
+          <a:p>
+            <a:r>
+              <a:rPr sz="750" b="0">
+                <a:solidFill>
+                  <a:srgbClr val="CCCCCC"/>
+                </a:solidFill>
+                <a:latin typeface="Calibri"/>
+              </a:rPr>
+              <a:t>systems for the combined operation.  Confidential under the NDA.</a:t>
+            </a:r>
+          </a:p>
+          <a:p>
+            <a:r>
+              <a:rPr sz="750" b="0">
+                <a:solidFill>
+                  <a:srgbClr val="CCCCCC"/>
+                </a:solidFill>
+                <a:latin typeface="Calibri"/>
+              </a:rPr>
+              <a:t>Does not create any obligation to implement; evaluation only.</a:t>
+            </a:r>
+          </a:p>
+        </p:txBody>
+      </p:sp>
+      <p:sp>
+        <p:nvSpPr>
+          <p:cNvPr id="41" name="Rectangle 40"/>
+          <p:cNvSpPr/>
+          <p:nvPr/>
+        </p:nvSpPr>
+        <p:spPr>
+          <a:xfrm>
+            <a:off x="182880" y="4553712"/>
+            <a:ext cx="8778240" cy="182880"/>
+          </a:xfrm>
+          <a:prstGeom prst="rect">
+            <a:avLst/>
+          </a:prstGeom>
+          <a:solidFill>
+            <a:srgbClr val="1A0A00"/>
+          </a:solidFill>
+          <a:ln>
+            <a:noFill/>
+          </a:ln>
+        </p:spPr>
+        <p:style>
+          <a:lnRef idx="1">
+            <a:schemeClr val="accent1"/>
+          </a:lnRef>
+          <a:fillRef idx="3">
+            <a:schemeClr val="accent1"/>
+          </a:fillRef>
+          <a:effectRef idx="2">
+            <a:schemeClr val="accent1"/>
+          </a:effectRef>
+          <a:fontRef idx="minor">
+            <a:schemeClr val="lt1"/>
+          </a:fontRef>
+        </p:style>
+        <p:txBody>
+          <a:bodyPr rtlCol="0" anchor="ctr"/>
+          <a:lstStyle/>
+          <a:p>
+            <a:pPr algn="ctr"/>
+          </a:p>
+        </p:txBody>
+      </p:sp>
+      <p:sp>
+        <p:nvSpPr>
           <p:cNvPr id="42" name="TextBox 41"/>
           <p:cNvSpPr txBox="1"/>
           <p:nvPr/>
@@ -5020,7 +7718,7 @@
 </p:sld>
 </file>
 
-<file path=ppt/slides/slide12.xml><?xml version="1.0" encoding="utf-8"?>
+<file path=ppt/slides/slide13.xml><?xml version="1.0" encoding="utf-8"?>
 <p:sld xmlns:a="http://schemas.openxmlformats.org/drawingml/2006/main" xmlns:r="http://schemas.openxmlformats.org/officeDocument/2006/relationships" xmlns:p="http://schemas.openxmlformats.org/presentationml/2006/main">
   <p:cSld name="Slide 10">
     <p:bg>

</xml_diff>

<commit_message>
SSLC slide 11: add investment-age note, update stock-ledger band, enrich speaker notes
- Right panel: add 2-line red italic note after 'All other holders ~$224K' — 'Invested largely 25+ years ago (per John Quinn; to be confirmed in the stock ledger). Exos's $790K was invested 2021–2024 to keep SSLC operating.'
- Bottom band bullet 1: add 'dates and amounts of each holder's investment' to list of items not on the books
- Speaker notes: add return-rate context — 11× over 25 yrs ≈ 10%/yr CAGR, 23× ≈ 13%/yr; solid but not outsized; ledger confirms dates
- Package v4 unchanged at 18pp
</commit_message>
<xml_diff>
--- a/drafts/Exos_SSLC_Board_Offer_Overview_2026-10-10_r2.pptx
+++ b/drafts/Exos_SSLC_Board_Offer_Overview_2026-10-10_r2.pptx
@@ -960,7 +960,16 @@
             <a:br/>
             <a:br/>
             <a:r>
-              <a:t>Stock ledger need: Exos's 18.06% stake credited via $790K in purchase price. Other holders' exact per-share payout cannot be confirmed without stock ledger and subscription agreements. GL records 7/24/2024 conversion: $30K Exos loan → 5,464 shares. Must be reconciled.</a:t>
+              <a:t>RETURN RATE CONTEXT (for presenter):</a:t>
+            </a:r>
+            <a:br/>
+            <a:r>
+              <a:t>Over a 25-year hold, ~11× is roughly 10%/yr (CAGR) and ~23× is roughly 13%/yr. That is a solid but not outsized return — comparable to a long-term equity index. The stock ledger confirms the investment dates; without it the return rate cannot be stated precisely.</a:t>
+            </a:r>
+            <a:br/>
+            <a:br/>
+            <a:r>
+              <a:t>Stock ledger need: Exos's 18.06% stake credited via $790K in purchase price. Other holders' exact per-share payout cannot be confirmed without stock ledger and subscription agreements. GL records 7/24/2024 conversion: $30K Exos loan → 5,464 shares. Must be reconciled. Per John Quinn, most other holders invested 25+ years ago; Exos invested 2021–2024.</a:t>
             </a:r>
           </a:p>
         </p:txBody>
@@ -5172,8 +5181,8 @@
         </p:nvSpPr>
         <p:spPr>
           <a:xfrm>
-            <a:off x="4754880" y="1851660"/>
-            <a:ext cx="4151376" cy="164592"/>
+            <a:off x="4754880" y="1819655"/>
+            <a:ext cx="4151376" cy="260603"/>
           </a:xfrm>
           <a:prstGeom prst="rect">
             <a:avLst/>
@@ -5188,13 +5197,14 @@
           <a:p>
             <a:pPr algn="l"/>
             <a:r>
-              <a:rPr sz="750" b="1" i="0">
-                <a:solidFill>
-                  <a:srgbClr val="888888"/>
+              <a:rPr sz="650" b="0" i="1">
+                <a:solidFill>
+                  <a:srgbClr val="FF7755"/>
                 </a:solidFill>
                 <a:latin typeface="Calibri"/>
               </a:rPr>
-              <a:t>PROJECTED RETURN  (OTHER HOLDERS, 81.94%)</a:t>
+              <a:t>  Invested largely 25+ years ago (per John Quinn; to be confirmed in the stock ledger).
+  Exos’s $790K was invested 2021–2024 to keep SSLC operating.</a:t>
             </a:r>
           </a:p>
         </p:txBody>
@@ -5207,8 +5217,8 @@
         </p:nvSpPr>
         <p:spPr>
           <a:xfrm>
-            <a:off x="4754880" y="2043684"/>
-            <a:ext cx="3063240" cy="169164"/>
+            <a:off x="4754880" y="2093975"/>
+            <a:ext cx="4151376" cy="164592"/>
           </a:xfrm>
           <a:prstGeom prst="rect">
             <a:avLst/>
@@ -5223,13 +5233,13 @@
           <a:p>
             <a:pPr algn="l"/>
             <a:r>
-              <a:rPr sz="750" b="0" i="0">
-                <a:solidFill>
-                  <a:srgbClr val="CCCCCC"/>
+              <a:rPr sz="750" b="1" i="0">
+                <a:solidFill>
+                  <a:srgbClr val="888888"/>
                 </a:solidFill>
                 <a:latin typeface="Calibri"/>
               </a:rPr>
-              <a:t>Cash + stock at close (est.)</a:t>
+              <a:t>PROJECTED RETURN  (OTHER HOLDERS, 81.94%)</a:t>
             </a:r>
           </a:p>
         </p:txBody>
@@ -5242,8 +5252,8 @@
         </p:nvSpPr>
         <p:spPr>
           <a:xfrm>
-            <a:off x="7863840" y="2043684"/>
-            <a:ext cx="1005840" cy="169164"/>
+            <a:off x="4754880" y="2276856"/>
+            <a:ext cx="3063240" cy="169164"/>
           </a:xfrm>
           <a:prstGeom prst="rect">
             <a:avLst/>
@@ -5256,15 +5266,15 @@
           </a:bodyPr>
           <a:lstStyle/>
           <a:p>
-            <a:pPr algn="r"/>
+            <a:pPr algn="l"/>
             <a:r>
               <a:rPr sz="750" b="0" i="0">
                 <a:solidFill>
-                  <a:srgbClr val="44BB44"/>
+                  <a:srgbClr val="CCCCCC"/>
                 </a:solidFill>
                 <a:latin typeface="Calibri"/>
               </a:rPr>
-              <a:t>~$2.5M</a:t>
+              <a:t>Cash + stock at close (est.)</a:t>
             </a:r>
           </a:p>
         </p:txBody>
@@ -5277,8 +5287,8 @@
         </p:nvSpPr>
         <p:spPr>
           <a:xfrm>
-            <a:off x="4754880" y="2208276"/>
-            <a:ext cx="3063240" cy="169164"/>
+            <a:off x="7863840" y="2276856"/>
+            <a:ext cx="1005840" cy="169164"/>
           </a:xfrm>
           <a:prstGeom prst="rect">
             <a:avLst/>
@@ -5291,15 +5301,15 @@
           </a:bodyPr>
           <a:lstStyle/>
           <a:p>
-            <a:pPr algn="l"/>
+            <a:pPr algn="r"/>
             <a:r>
               <a:rPr sz="750" b="0" i="0">
                 <a:solidFill>
-                  <a:srgbClr val="CCCCCC"/>
+                  <a:srgbClr val="44BB44"/>
                 </a:solidFill>
                 <a:latin typeface="Calibri"/>
               </a:rPr>
-              <a:t>Total over 5 years incl. earn-outs</a:t>
+              <a:t>~$2.5M</a:t>
             </a:r>
           </a:p>
         </p:txBody>
@@ -5312,8 +5322,8 @@
         </p:nvSpPr>
         <p:spPr>
           <a:xfrm>
-            <a:off x="7863840" y="2208276"/>
-            <a:ext cx="1005840" cy="169164"/>
+            <a:off x="4754880" y="2441448"/>
+            <a:ext cx="3063240" cy="169164"/>
           </a:xfrm>
           <a:prstGeom prst="rect">
             <a:avLst/>
@@ -5326,6 +5336,41 @@
           </a:bodyPr>
           <a:lstStyle/>
           <a:p>
+            <a:pPr algn="l"/>
+            <a:r>
+              <a:rPr sz="750" b="0" i="0">
+                <a:solidFill>
+                  <a:srgbClr val="CCCCCC"/>
+                </a:solidFill>
+                <a:latin typeface="Calibri"/>
+              </a:rPr>
+              <a:t>Total over 5 years incl. earn-outs</a:t>
+            </a:r>
+          </a:p>
+        </p:txBody>
+      </p:sp>
+      <p:sp>
+        <p:nvSpPr>
+          <p:cNvPr id="56" name="TextBox 55"/>
+          <p:cNvSpPr txBox="1"/>
+          <p:nvPr/>
+        </p:nvSpPr>
+        <p:spPr>
+          <a:xfrm>
+            <a:off x="7863840" y="2441448"/>
+            <a:ext cx="1005840" cy="169164"/>
+          </a:xfrm>
+          <a:prstGeom prst="rect">
+            <a:avLst/>
+          </a:prstGeom>
+          <a:noFill/>
+        </p:spPr>
+        <p:txBody>
+          <a:bodyPr wrap="square">
+            <a:spAutoFit/>
+          </a:bodyPr>
+          <a:lstStyle/>
+          <a:p>
             <a:pPr algn="r"/>
             <a:r>
               <a:rPr sz="750" b="0" i="0">
@@ -5341,13 +5386,13 @@
       </p:sp>
       <p:sp>
         <p:nvSpPr>
-          <p:cNvPr id="56" name="Rectangle 55"/>
+          <p:cNvPr id="57" name="Rectangle 56"/>
           <p:cNvSpPr/>
           <p:nvPr/>
         </p:nvSpPr>
         <p:spPr>
           <a:xfrm>
-            <a:off x="4754880" y="2391156"/>
+            <a:off x="4754880" y="2624328"/>
             <a:ext cx="4151376" cy="9144"/>
           </a:xfrm>
           <a:prstGeom prst="rect">
@@ -5384,13 +5429,13 @@
       </p:sp>
       <p:sp>
         <p:nvSpPr>
-          <p:cNvPr id="57" name="TextBox 56"/>
-          <p:cNvSpPr txBox="1"/>
-          <p:nvPr/>
-        </p:nvSpPr>
-        <p:spPr>
-          <a:xfrm>
-            <a:off x="4754880" y="2409444"/>
+          <p:cNvPr id="58" name="TextBox 57"/>
+          <p:cNvSpPr txBox="1"/>
+          <p:nvPr/>
+        </p:nvSpPr>
+        <p:spPr>
+          <a:xfrm>
+            <a:off x="4754880" y="2642616"/>
             <a:ext cx="3063240" cy="173736"/>
           </a:xfrm>
           <a:prstGeom prst="rect">
@@ -5419,13 +5464,13 @@
       </p:sp>
       <p:sp>
         <p:nvSpPr>
-          <p:cNvPr id="58" name="TextBox 57"/>
-          <p:cNvSpPr txBox="1"/>
-          <p:nvPr/>
-        </p:nvSpPr>
-        <p:spPr>
-          <a:xfrm>
-            <a:off x="7406640" y="2409444"/>
+          <p:cNvPr id="59" name="TextBox 58"/>
+          <p:cNvSpPr txBox="1"/>
+          <p:nvPr/>
+        </p:nvSpPr>
+        <p:spPr>
+          <a:xfrm>
+            <a:off x="7406640" y="2642616"/>
             <a:ext cx="1463040" cy="173736"/>
           </a:xfrm>
           <a:prstGeom prst="rect">
@@ -5454,14 +5499,14 @@
       </p:sp>
       <p:sp>
         <p:nvSpPr>
-          <p:cNvPr id="59" name="TextBox 58"/>
-          <p:cNvSpPr txBox="1"/>
-          <p:nvPr/>
-        </p:nvSpPr>
-        <p:spPr>
-          <a:xfrm>
-            <a:off x="4754880" y="2610612"/>
-            <a:ext cx="4151376" cy="420624"/>
+          <p:cNvPr id="60" name="TextBox 59"/>
+          <p:cNvSpPr txBox="1"/>
+          <p:nvPr/>
+        </p:nvSpPr>
+        <p:spPr>
+          <a:xfrm>
+            <a:off x="4754880" y="2834640"/>
+            <a:ext cx="4151376" cy="347472"/>
           </a:xfrm>
           <a:prstGeom prst="rect">
             <a:avLst/>
@@ -5476,29 +5521,28 @@
           <a:p>
             <a:pPr algn="l"/>
             <a:r>
-              <a:rPr sz="700" b="0" i="1">
+              <a:rPr sz="650" b="0" i="1">
                 <a:solidFill>
                   <a:srgbClr val="888888"/>
                 </a:solidFill>
                 <a:latin typeface="Calibri"/>
               </a:rPr>
               <a:t>Framed as: holders who invested ~$224K receive a strong return.
-Exos’s 18.06% is absorbed in the $790K credit built into the purchase price —
-no additional cash from Exos for Exos’s own stake.</a:t>
-            </a:r>
-          </a:p>
-        </p:txBody>
-      </p:sp>
-      <p:sp>
-        <p:nvSpPr>
-          <p:cNvPr id="60" name="Rectangle 59"/>
+Exos’s 18.06% is absorbed in the $790K credit — no extra cash from Exos for its own stake.</a:t>
+            </a:r>
+          </a:p>
+        </p:txBody>
+      </p:sp>
+      <p:sp>
+        <p:nvSpPr>
+          <p:cNvPr id="61" name="Rectangle 60"/>
           <p:cNvSpPr/>
           <p:nvPr/>
         </p:nvSpPr>
         <p:spPr>
           <a:xfrm>
-            <a:off x="4754880" y="3049524"/>
-            <a:ext cx="4151376" cy="260603"/>
+            <a:off x="4754880" y="3200400"/>
+            <a:ext cx="4151376" cy="224028"/>
           </a:xfrm>
           <a:prstGeom prst="rect">
             <a:avLst/>
@@ -5534,14 +5578,14 @@
       </p:sp>
       <p:sp>
         <p:nvSpPr>
-          <p:cNvPr id="61" name="TextBox 60"/>
-          <p:cNvSpPr txBox="1"/>
-          <p:nvPr/>
-        </p:nvSpPr>
-        <p:spPr>
-          <a:xfrm>
-            <a:off x="4828032" y="3086100"/>
-            <a:ext cx="4041648" cy="201168"/>
+          <p:cNvPr id="62" name="TextBox 61"/>
+          <p:cNvSpPr txBox="1"/>
+          <p:nvPr/>
+        </p:nvSpPr>
+        <p:spPr>
+          <a:xfrm>
+            <a:off x="4828032" y="3227832"/>
+            <a:ext cx="4041648" cy="182880"/>
           </a:xfrm>
           <a:prstGeom prst="rect">
             <a:avLst/>
@@ -5570,13 +5614,13 @@
       </p:sp>
       <p:sp>
         <p:nvSpPr>
-          <p:cNvPr id="62" name="Rectangle 61"/>
+          <p:cNvPr id="63" name="Rectangle 62"/>
           <p:cNvSpPr/>
           <p:nvPr/>
         </p:nvSpPr>
         <p:spPr>
           <a:xfrm>
-            <a:off x="164592" y="4069080"/>
+            <a:off x="164592" y="4059936"/>
             <a:ext cx="8814816" cy="13716"/>
           </a:xfrm>
           <a:prstGeom prst="rect">
@@ -5613,14 +5657,14 @@
       </p:sp>
       <p:sp>
         <p:nvSpPr>
-          <p:cNvPr id="63" name="Rectangle 62"/>
+          <p:cNvPr id="64" name="Rectangle 63"/>
           <p:cNvSpPr/>
           <p:nvPr/>
         </p:nvSpPr>
         <p:spPr>
           <a:xfrm>
-            <a:off x="164592" y="4087368"/>
-            <a:ext cx="8814816" cy="694944"/>
+            <a:off x="164592" y="4078224"/>
+            <a:ext cx="8814816" cy="713232"/>
           </a:xfrm>
           <a:prstGeom prst="rect">
             <a:avLst/>
@@ -5656,13 +5700,13 @@
       </p:sp>
       <p:sp>
         <p:nvSpPr>
-          <p:cNvPr id="64" name="TextBox 63"/>
-          <p:cNvSpPr txBox="1"/>
-          <p:nvPr/>
-        </p:nvSpPr>
-        <p:spPr>
-          <a:xfrm>
-            <a:off x="274320" y="4123944"/>
+          <p:cNvPr id="65" name="TextBox 64"/>
+          <p:cNvSpPr txBox="1"/>
+          <p:nvPr/>
+        </p:nvSpPr>
+        <p:spPr>
+          <a:xfrm>
+            <a:off x="274320" y="4110228"/>
             <a:ext cx="4572000" cy="182880"/>
           </a:xfrm>
           <a:prstGeom prst="rect">
@@ -5691,13 +5735,13 @@
       </p:sp>
       <p:sp>
         <p:nvSpPr>
-          <p:cNvPr id="65" name="TextBox 64"/>
-          <p:cNvSpPr txBox="1"/>
-          <p:nvPr/>
-        </p:nvSpPr>
-        <p:spPr>
-          <a:xfrm>
-            <a:off x="274320" y="4315968"/>
+          <p:cNvPr id="66" name="TextBox 65"/>
+          <p:cNvSpPr txBox="1"/>
+          <p:nvPr/>
+        </p:nvSpPr>
+        <p:spPr>
+          <a:xfrm>
+            <a:off x="274320" y="4302252"/>
             <a:ext cx="8503920" cy="141732"/>
           </a:xfrm>
           <a:prstGeom prst="rect">
@@ -5719,20 +5763,20 @@
                 </a:solidFill>
                 <a:latin typeface="Calibri"/>
               </a:rPr>
-              <a:t>• SSLC’s books carry paid-in capital only as one total ($1,014,465); per-holder amounts and share counts are not on the books.</a:t>
-            </a:r>
-          </a:p>
-        </p:txBody>
-      </p:sp>
-      <p:sp>
-        <p:nvSpPr>
-          <p:cNvPr id="66" name="TextBox 65"/>
-          <p:cNvSpPr txBox="1"/>
-          <p:nvPr/>
-        </p:nvSpPr>
-        <p:spPr>
-          <a:xfrm>
-            <a:off x="274320" y="4457700"/>
+              <a:t>• SSLC’s books carry paid-in capital only as one total ($1,014,465); per-holder amounts, share counts, and dates and amounts of each holder’s investment are not on the books.</a:t>
+            </a:r>
+          </a:p>
+        </p:txBody>
+      </p:sp>
+      <p:sp>
+        <p:nvSpPr>
+          <p:cNvPr id="67" name="TextBox 66"/>
+          <p:cNvSpPr txBox="1"/>
+          <p:nvPr/>
+        </p:nvSpPr>
+        <p:spPr>
+          <a:xfrm>
+            <a:off x="274320" y="4443984"/>
             <a:ext cx="8503920" cy="141732"/>
           </a:xfrm>
           <a:prstGeom prst="rect">
@@ -5761,13 +5805,13 @@
       </p:sp>
       <p:sp>
         <p:nvSpPr>
-          <p:cNvPr id="67" name="TextBox 66"/>
-          <p:cNvSpPr txBox="1"/>
-          <p:nvPr/>
-        </p:nvSpPr>
-        <p:spPr>
-          <a:xfrm>
-            <a:off x="274320" y="4599432"/>
+          <p:cNvPr id="68" name="TextBox 67"/>
+          <p:cNvSpPr txBox="1"/>
+          <p:nvPr/>
+        </p:nvSpPr>
+        <p:spPr>
+          <a:xfrm>
+            <a:off x="274320" y="4585716"/>
             <a:ext cx="8503920" cy="141732"/>
           </a:xfrm>
           <a:prstGeom prst="rect">
@@ -5796,13 +5840,13 @@
       </p:sp>
       <p:sp>
         <p:nvSpPr>
-          <p:cNvPr id="68" name="TextBox 67"/>
-          <p:cNvSpPr txBox="1"/>
-          <p:nvPr/>
-        </p:nvSpPr>
-        <p:spPr>
-          <a:xfrm>
-            <a:off x="182880" y="4782312"/>
+          <p:cNvPr id="69" name="TextBox 68"/>
+          <p:cNvSpPr txBox="1"/>
+          <p:nvPr/>
+        </p:nvSpPr>
+        <p:spPr>
+          <a:xfrm>
+            <a:off x="182880" y="4800600"/>
             <a:ext cx="8778240" cy="201168"/>
           </a:xfrm>
           <a:prstGeom prst="rect">
@@ -5831,7 +5875,7 @@
       </p:sp>
       <p:sp>
         <p:nvSpPr>
-          <p:cNvPr id="69" name="TextBox 68"/>
+          <p:cNvPr id="70" name="TextBox 69"/>
           <p:cNvSpPr txBox="1"/>
           <p:nvPr/>
         </p:nvSpPr>
@@ -5866,7 +5910,7 @@
       </p:sp>
       <p:sp>
         <p:nvSpPr>
-          <p:cNvPr id="70" name="TextBox 69"/>
+          <p:cNvPr id="71" name="TextBox 70"/>
           <p:cNvSpPr txBox="1"/>
           <p:nvPr/>
         </p:nvSpPr>

</xml_diff>

<commit_message>
SSLC slides 4+11: add Exos loan reconciliation note to both slides
Slide 4 (Capital & Debt): new textbox below Total liabilities —
  'Exos loan reconciled:' + 3-line detail: $60K originated 10/10/2024; $28.8K repaid 2025;
  $31,200 balance; 11% interest (~$38K total); past due 1+ yr; records confirmed.
  Second line: separate $30K loan (5/9/2024) converted to 5,464 shares (7/24/2024) — incl. in $790K paid-in.

Slide 11 (Payout): new compact italic line in left panel loan detail —
  'Exos loan reconciled: $60K→$31.2K bal.; $30K prior converted to 5,464 shares (incl. in $790K paid-in).'

Speaker notes on both slides: full reconciliation detail including repayment dates, interest,
  record confirmation, and Exos-side bookkeeping context (deck-side shows no errors per instruction).

Package v5 unchanged at 18pp.
</commit_message>
<xml_diff>
--- a/drafts/Exos_SSLC_Board_Offer_Overview_2026-10-10_r2.pptx
+++ b/drafts/Exos_SSLC_Board_Offer_Overview_2026-10-10_r2.pptx
@@ -688,43 +688,68 @@
           <a:lstStyle/>
           <a:p>
             <a:r>
-              <a:t>Source: SSLC QB Balance Sheet 10/11/2026 (data-room/SSLC/qb-2026-10-11/SSLC_Balance_Sheet.xlsx).</a:t>
+              <a:t>SSLC Capital &amp; Debt — Sources (10/11/2026 QB)</a:t>
             </a:r>
             <a:br/>
-            <a:r>
-              <a:t>Cash $590,344; AR Unbilled (billed-ahead) −$942,177; deposits $120,000.</a:t>
-            </a:r>
             <a:br/>
             <a:r>
-              <a:t>Loans &amp; notes $1,027,783 unchanged by lender.</a:t>
+              <a:t>Left: Equity per QB — Common stock $1,010,423 (Acct 3010); APIC $4,042 (Acct 3020); Exos 18.06% → ~$789,572 (~78% of total paid-in); Accum. deficit −$2,571,013 (thru FY26); FY27 YTD NI +$112,666; Total equity −$1,443,882.</a:t>
             </a:r>
             <a:br/>
-            <a:r>
-              <a:t>Total liabilities $1,296,521.</a:t>
-            </a:r>
             <a:br/>
             <a:r>
-              <a:t>Paid-in capital $1,014,465 (unchanged).</a:t>
+              <a:t>Right: Loans &amp; notes $1,027,783 — Microcosm $451,429 (Acct 2385); Notes Payable Bookstore $320,582; SBA EIDL $132,072 (Acct 2712); Wertz $92,500 (Acct 2714); Exos $31,200 (11%; past due 1+ yr).</a:t>
             </a:r>
             <a:br/>
-            <a:r>
-              <a:t>Retained earnings −$2,571,013; FY27 YTD net income +$112,666.</a:t>
-            </a:r>
             <a:br/>
             <a:r>
-              <a:t>Total equity −$1,443,882 (10/11/2026).</a:t>
+              <a:t>EXOS LOAN DETAIL:</a:t>
             </a:r>
             <a:br/>
             <a:r>
-              <a:t>Exos loan $31,200 principal; ~$38,158 with 11% interest at 10/2. Board DENIED license; loan STANDS.</a:t>
+              <a:t>  $60,000 originated 10/10/2024.</a:t>
             </a:r>
             <a:br/>
             <a:r>
-              <a:t>Billed-ahead $942,177: Exos assessment is overstated; 40% start-billings not cleared at shipment; est. ~$100–200K genuinely in progress.</a:t>
+              <a:t>  $15,000 repaid 3/19/2025; $13,800 repaid 5/2/2025 → $31,200 balance.</a:t>
             </a:r>
             <a:br/>
             <a:r>
-              <a:t>Facility ~$805K since Jan 2024: rent $725K + other; doubled to ~$23.6K/mo Jul 2024. Paid via Microcosm invoices through Dec 2025, then directly to landlords. Never charged back to Microcosm on SSLC's books; Microcosm receivable = $3,529; loan to Microcosm = $0.</a:t>
+              <a:t>  11% interest; total with interest ~$38K. Past due over 1 year. Still owed.</a:t>
+            </a:r>
+            <a:br/>
+            <a:r>
+              <a:t>  SSLC and Exos records match on this loan.</a:t>
+            </a:r>
+            <a:br/>
+            <a:r>
+              <a:t>  (Note: on the Exos side, the ledger may show a different balance; that is an Exos bookkeeping</a:t>
+            </a:r>
+            <a:br/>
+            <a:r>
+              <a:t>  timing issue only — SSLC's $31,200 balance is the correct, agreed amount.)</a:t>
+            </a:r>
+            <a:br/>
+            <a:br/>
+            <a:r>
+              <a:t>SEPARATE CONVERTED LOAN:</a:t>
+            </a:r>
+            <a:br/>
+            <a:r>
+              <a:t>  $30,000 loan made 5/9/2024.</a:t>
+            </a:r>
+            <a:br/>
+            <a:r>
+              <a:t>  Converted to 5,464 SSLC shares on 7/24/2024.</a:t>
+            </a:r>
+            <a:br/>
+            <a:r>
+              <a:t>  Included in Exos's $790K paid-in capital; no longer a liability.</a:t>
+            </a:r>
+            <a:br/>
+            <a:br/>
+            <a:r>
+              <a:t>Open items: AR Unbilled $942,177 (Acct 1110) and Deposits $120,000 (Acct 2380) under reconciliation per Motion 3. Facility costs ~$805K (Jan 2024–Oct 2026) never charged to Microcosm.</a:t>
             </a:r>
           </a:p>
         </p:txBody>
@@ -960,16 +985,41 @@
             <a:br/>
             <a:br/>
             <a:r>
-              <a:t>RETURN RATE CONTEXT (for presenter):</a:t>
+              <a:t>RETURN RATE CONTEXT:</a:t>
             </a:r>
             <a:br/>
             <a:r>
-              <a:t>Over a 25-year hold, ~11× is roughly 10%/yr (CAGR) and ~23× is roughly 13%/yr. That is a solid but not outsized return — comparable to a long-term equity index. The stock ledger confirms the investment dates; without it the return rate cannot be stated precisely.</a:t>
+              <a:t>Over a 25-year hold, ~11× is roughly 10%/yr (CAGR) and ~23× roughly 13%/yr. Solid but not outsized — comparable to a long-term equity index. Stock ledger confirms investment dates; without it the precise CAGR can't be stated.</a:t>
             </a:r>
             <a:br/>
             <a:br/>
             <a:r>
-              <a:t>Stock ledger need: Exos's 18.06% stake credited via $790K in purchase price. Other holders' exact per-share payout cannot be confirmed without stock ledger and subscription agreements. GL records 7/24/2024 conversion: $30K Exos loan → 5,464 shares. Must be reconciled. Per John Quinn, most other holders invested 25+ years ago; Exos invested 2021–2024.</a:t>
+              <a:t>EXOS LOAN DETAIL (for presenter):</a:t>
+            </a:r>
+            <a:br/>
+            <a:r>
+              <a:t>  $60,000 loan originated 10/10/2024.</a:t>
+            </a:r>
+            <a:br/>
+            <a:r>
+              <a:t>  $15,000 repaid 3/19/2025; $13,800 repaid 5/2/2025 → $31,200 balance.</a:t>
+            </a:r>
+            <a:br/>
+            <a:r>
+              <a:t>  11% interest; ~$38K total with interest. Past due over 1 year. Still owed.</a:t>
+            </a:r>
+            <a:br/>
+            <a:r>
+              <a:t>  SSLC and Exos records match on this loan.</a:t>
+            </a:r>
+            <a:br/>
+            <a:r>
+              <a:t>  Separate $30K loan (5/9/2024) converted to 5,464 SSLC shares on 7/24/2024 — included in Exos's $790K paid-in capital; no longer a liability.</a:t>
+            </a:r>
+            <a:br/>
+            <a:br/>
+            <a:r>
+              <a:t>Stock ledger: Exos's 18.06% credited via $790K in price. Other holders' per-share payout can't be confirmed without ledger. Per John Quinn, most other holders invested 25+ years ago; Exos invested 2021–2024.</a:t>
             </a:r>
           </a:p>
         </p:txBody>
@@ -3698,7 +3748,7 @@
         </p:nvSpPr>
         <p:spPr>
           <a:xfrm>
-            <a:off x="274320" y="960119"/>
+            <a:off x="274320" y="955547"/>
             <a:ext cx="3154679" cy="169164"/>
           </a:xfrm>
           <a:prstGeom prst="rect">
@@ -3733,7 +3783,7 @@
         </p:nvSpPr>
         <p:spPr>
           <a:xfrm>
-            <a:off x="3474719" y="960119"/>
+            <a:off x="3474719" y="955547"/>
             <a:ext cx="914400" cy="169164"/>
           </a:xfrm>
           <a:prstGeom prst="rect">
@@ -3768,7 +3818,7 @@
         </p:nvSpPr>
         <p:spPr>
           <a:xfrm>
-            <a:off x="274320" y="1161287"/>
+            <a:off x="274320" y="1152144"/>
             <a:ext cx="4151376" cy="9144"/>
           </a:xfrm>
           <a:prstGeom prst="rect">
@@ -3811,7 +3861,7 @@
         </p:nvSpPr>
         <p:spPr>
           <a:xfrm>
-            <a:off x="274320" y="1124711"/>
+            <a:off x="274320" y="1115568"/>
             <a:ext cx="3154679" cy="169164"/>
           </a:xfrm>
           <a:prstGeom prst="rect">
@@ -3846,7 +3896,7 @@
         </p:nvSpPr>
         <p:spPr>
           <a:xfrm>
-            <a:off x="3474719" y="1124711"/>
+            <a:off x="3474719" y="1115568"/>
             <a:ext cx="914400" cy="169164"/>
           </a:xfrm>
           <a:prstGeom prst="rect">
@@ -3881,7 +3931,7 @@
         </p:nvSpPr>
         <p:spPr>
           <a:xfrm>
-            <a:off x="274320" y="1298447"/>
+            <a:off x="274320" y="1284732"/>
             <a:ext cx="3154679" cy="169164"/>
           </a:xfrm>
           <a:prstGeom prst="rect">
@@ -3916,7 +3966,7 @@
         </p:nvSpPr>
         <p:spPr>
           <a:xfrm>
-            <a:off x="3474719" y="1298447"/>
+            <a:off x="3474719" y="1284732"/>
             <a:ext cx="914400" cy="169164"/>
           </a:xfrm>
           <a:prstGeom prst="rect">
@@ -3951,8 +4001,8 @@
         </p:nvSpPr>
         <p:spPr>
           <a:xfrm>
-            <a:off x="274320" y="1449323"/>
-            <a:ext cx="4151376" cy="146304"/>
+            <a:off x="274320" y="1431036"/>
+            <a:ext cx="4151376" cy="141732"/>
           </a:xfrm>
           <a:prstGeom prst="rect">
             <a:avLst/>
@@ -3986,8 +4036,8 @@
         </p:nvSpPr>
         <p:spPr>
           <a:xfrm>
-            <a:off x="274320" y="1591055"/>
-            <a:ext cx="3154679" cy="169164"/>
+            <a:off x="274320" y="1566367"/>
+            <a:ext cx="4151376" cy="141732"/>
           </a:xfrm>
           <a:prstGeom prst="rect">
             <a:avLst/>
@@ -4002,13 +4052,13 @@
           <a:p>
             <a:pPr algn="l"/>
             <a:r>
-              <a:rPr sz="750" b="0" i="0">
-                <a:solidFill>
-                  <a:srgbClr val="CCCCCC"/>
+              <a:rPr sz="600" b="0" i="1">
+                <a:solidFill>
+                  <a:srgbClr val="888888"/>
                 </a:solidFill>
                 <a:latin typeface="Calibri"/>
               </a:rPr>
-              <a:t>− Other current liabilities (AP, accruals)</a:t>
+              <a:t>  Exos loan reconciled: $60K→$31.2K bal.; $30K prior converted to 5,464 shares (incl. in $790K paid-in).</a:t>
             </a:r>
           </a:p>
         </p:txBody>
@@ -4021,8 +4071,8 @@
         </p:nvSpPr>
         <p:spPr>
           <a:xfrm>
-            <a:off x="3474719" y="1591055"/>
-            <a:ext cx="914400" cy="169164"/>
+            <a:off x="274320" y="1701698"/>
+            <a:ext cx="3154679" cy="169164"/>
           </a:xfrm>
           <a:prstGeom prst="rect">
             <a:avLst/>
@@ -4035,15 +4085,15 @@
           </a:bodyPr>
           <a:lstStyle/>
           <a:p>
-            <a:pPr algn="r"/>
+            <a:pPr algn="l"/>
             <a:r>
               <a:rPr sz="750" b="0" i="0">
                 <a:solidFill>
-                  <a:srgbClr val="FF7755"/>
+                  <a:srgbClr val="CCCCCC"/>
                 </a:solidFill>
                 <a:latin typeface="Calibri"/>
               </a:rPr>
-              <a:t>($148,738)</a:t>
+              <a:t>− Other current liabilities (AP, accruals)</a:t>
             </a:r>
           </a:p>
         </p:txBody>
@@ -4056,8 +4106,8 @@
         </p:nvSpPr>
         <p:spPr>
           <a:xfrm>
-            <a:off x="274320" y="1755647"/>
-            <a:ext cx="3154679" cy="169164"/>
+            <a:off x="3474719" y="1701698"/>
+            <a:ext cx="914400" cy="169164"/>
           </a:xfrm>
           <a:prstGeom prst="rect">
             <a:avLst/>
@@ -4070,15 +4120,15 @@
           </a:bodyPr>
           <a:lstStyle/>
           <a:p>
-            <a:pPr algn="l"/>
+            <a:pPr algn="r"/>
             <a:r>
               <a:rPr sz="750" b="0" i="0">
                 <a:solidFill>
-                  <a:srgbClr val="CCCCCC"/>
+                  <a:srgbClr val="FF7755"/>
                 </a:solidFill>
                 <a:latin typeface="Calibri"/>
               </a:rPr>
-              <a:t>− Customer deposits (IM, transferred)</a:t>
+              <a:t>($148,738)</a:t>
             </a:r>
           </a:p>
         </p:txBody>
@@ -4091,8 +4141,8 @@
         </p:nvSpPr>
         <p:spPr>
           <a:xfrm>
-            <a:off x="3474719" y="1755647"/>
-            <a:ext cx="914400" cy="169164"/>
+            <a:off x="274320" y="1861718"/>
+            <a:ext cx="3154679" cy="169164"/>
           </a:xfrm>
           <a:prstGeom prst="rect">
             <a:avLst/>
@@ -4105,15 +4155,15 @@
           </a:bodyPr>
           <a:lstStyle/>
           <a:p>
-            <a:pPr algn="r"/>
+            <a:pPr algn="l"/>
             <a:r>
               <a:rPr sz="750" b="0" i="0">
                 <a:solidFill>
-                  <a:srgbClr val="FF7755"/>
+                  <a:srgbClr val="CCCCCC"/>
                 </a:solidFill>
                 <a:latin typeface="Calibri"/>
               </a:rPr>
-              <a:t>($120,000)</a:t>
+              <a:t>− Customer deposits (IM, transferred)</a:t>
             </a:r>
           </a:p>
         </p:txBody>
@@ -4126,8 +4176,8 @@
         </p:nvSpPr>
         <p:spPr>
           <a:xfrm>
-            <a:off x="274320" y="1920239"/>
-            <a:ext cx="3154679" cy="169164"/>
+            <a:off x="3474719" y="1861718"/>
+            <a:ext cx="914400" cy="169164"/>
           </a:xfrm>
           <a:prstGeom prst="rect">
             <a:avLst/>
@@ -4140,15 +4190,15 @@
           </a:bodyPr>
           <a:lstStyle/>
           <a:p>
-            <a:pPr algn="l"/>
+            <a:pPr algn="r"/>
             <a:r>
               <a:rPr sz="750" b="0" i="0">
                 <a:solidFill>
-                  <a:srgbClr val="CCCCCC"/>
+                  <a:srgbClr val="FF7755"/>
                 </a:solidFill>
                 <a:latin typeface="Calibri"/>
               </a:rPr>
-              <a:t>− Billed-ahead work, genuine (Exos est.)</a:t>
+              <a:t>($120,000)</a:t>
             </a:r>
           </a:p>
         </p:txBody>
@@ -4161,8 +4211,8 @@
         </p:nvSpPr>
         <p:spPr>
           <a:xfrm>
-            <a:off x="3474719" y="1920239"/>
-            <a:ext cx="914400" cy="169164"/>
+            <a:off x="274320" y="2021738"/>
+            <a:ext cx="3154679" cy="169164"/>
           </a:xfrm>
           <a:prstGeom prst="rect">
             <a:avLst/>
@@ -4175,15 +4225,15 @@
           </a:bodyPr>
           <a:lstStyle/>
           <a:p>
-            <a:pPr algn="r"/>
+            <a:pPr algn="l"/>
             <a:r>
               <a:rPr sz="750" b="0" i="0">
                 <a:solidFill>
-                  <a:srgbClr val="FF7755"/>
+                  <a:srgbClr val="CCCCCC"/>
                 </a:solidFill>
                 <a:latin typeface="Calibri"/>
               </a:rPr>
-              <a:t>($250,000)</a:t>
+              <a:t>− Billed-ahead work, genuine (Exos est.)</a:t>
             </a:r>
           </a:p>
         </p:txBody>
@@ -4196,8 +4246,8 @@
         </p:nvSpPr>
         <p:spPr>
           <a:xfrm>
-            <a:off x="274320" y="2084831"/>
-            <a:ext cx="3154679" cy="169164"/>
+            <a:off x="3474719" y="2021738"/>
+            <a:ext cx="914400" cy="169164"/>
           </a:xfrm>
           <a:prstGeom prst="rect">
             <a:avLst/>
@@ -4210,15 +4260,15 @@
           </a:bodyPr>
           <a:lstStyle/>
           <a:p>
-            <a:pPr algn="l"/>
+            <a:pPr algn="r"/>
             <a:r>
               <a:rPr sz="750" b="0" i="0">
                 <a:solidFill>
-                  <a:srgbClr val="CCCCCC"/>
+                  <a:srgbClr val="FF7755"/>
                 </a:solidFill>
                 <a:latin typeface="Calibri"/>
               </a:rPr>
-              <a:t>− 5% escrow holdback (released 12 months)</a:t>
+              <a:t>($250,000)</a:t>
             </a:r>
           </a:p>
         </p:txBody>
@@ -4231,8 +4281,8 @@
         </p:nvSpPr>
         <p:spPr>
           <a:xfrm>
-            <a:off x="3474719" y="2084831"/>
-            <a:ext cx="914400" cy="169164"/>
+            <a:off x="274320" y="2181758"/>
+            <a:ext cx="3154679" cy="169164"/>
           </a:xfrm>
           <a:prstGeom prst="rect">
             <a:avLst/>
@@ -4245,6 +4295,41 @@
           </a:bodyPr>
           <a:lstStyle/>
           <a:p>
+            <a:pPr algn="l"/>
+            <a:r>
+              <a:rPr sz="750" b="0" i="0">
+                <a:solidFill>
+                  <a:srgbClr val="CCCCCC"/>
+                </a:solidFill>
+                <a:latin typeface="Calibri"/>
+              </a:rPr>
+              <a:t>− 5% escrow holdback (released 12 months)</a:t>
+            </a:r>
+          </a:p>
+        </p:txBody>
+      </p:sp>
+      <p:sp>
+        <p:nvSpPr>
+          <p:cNvPr id="26" name="TextBox 25"/>
+          <p:cNvSpPr txBox="1"/>
+          <p:nvPr/>
+        </p:nvSpPr>
+        <p:spPr>
+          <a:xfrm>
+            <a:off x="3474719" y="2181758"/>
+            <a:ext cx="914400" cy="169164"/>
+          </a:xfrm>
+          <a:prstGeom prst="rect">
+            <a:avLst/>
+          </a:prstGeom>
+          <a:noFill/>
+        </p:spPr>
+        <p:txBody>
+          <a:bodyPr wrap="square">
+            <a:spAutoFit/>
+          </a:bodyPr>
+          <a:lstStyle/>
+          <a:p>
             <a:pPr algn="r"/>
             <a:r>
               <a:rPr sz="750" b="0" i="0">
@@ -4260,13 +4345,13 @@
       </p:sp>
       <p:sp>
         <p:nvSpPr>
-          <p:cNvPr id="26" name="Rectangle 25"/>
+          <p:cNvPr id="27" name="Rectangle 26"/>
           <p:cNvSpPr/>
           <p:nvPr/>
         </p:nvSpPr>
         <p:spPr>
           <a:xfrm>
-            <a:off x="274320" y="2258568"/>
+            <a:off x="274320" y="2350922"/>
             <a:ext cx="4151376" cy="13716"/>
           </a:xfrm>
           <a:prstGeom prst="rect">
@@ -4303,13 +4388,13 @@
       </p:sp>
       <p:sp>
         <p:nvSpPr>
-          <p:cNvPr id="27" name="TextBox 26"/>
-          <p:cNvSpPr txBox="1"/>
-          <p:nvPr/>
-        </p:nvSpPr>
-        <p:spPr>
-          <a:xfrm>
-            <a:off x="274320" y="2286000"/>
+          <p:cNvPr id="28" name="TextBox 27"/>
+          <p:cNvSpPr txBox="1"/>
+          <p:nvPr/>
+        </p:nvSpPr>
+        <p:spPr>
+          <a:xfrm>
+            <a:off x="274320" y="2378354"/>
             <a:ext cx="3154679" cy="201168"/>
           </a:xfrm>
           <a:prstGeom prst="rect">
@@ -4338,13 +4423,13 @@
       </p:sp>
       <p:sp>
         <p:nvSpPr>
-          <p:cNvPr id="28" name="TextBox 27"/>
-          <p:cNvSpPr txBox="1"/>
-          <p:nvPr/>
-        </p:nvSpPr>
-        <p:spPr>
-          <a:xfrm>
-            <a:off x="3474719" y="2286000"/>
+          <p:cNvPr id="29" name="TextBox 28"/>
+          <p:cNvSpPr txBox="1"/>
+          <p:nvPr/>
+        </p:nvSpPr>
+        <p:spPr>
+          <a:xfrm>
+            <a:off x="3474719" y="2378354"/>
             <a:ext cx="914400" cy="201168"/>
           </a:xfrm>
           <a:prstGeom prst="rect">
@@ -4373,13 +4458,13 @@
       </p:sp>
       <p:sp>
         <p:nvSpPr>
-          <p:cNvPr id="29" name="TextBox 28"/>
-          <p:cNvSpPr txBox="1"/>
-          <p:nvPr/>
-        </p:nvSpPr>
-        <p:spPr>
-          <a:xfrm>
-            <a:off x="274320" y="2500884"/>
+          <p:cNvPr id="30" name="TextBox 29"/>
+          <p:cNvSpPr txBox="1"/>
+          <p:nvPr/>
+        </p:nvSpPr>
+        <p:spPr>
+          <a:xfrm>
+            <a:off x="274320" y="2588666"/>
             <a:ext cx="3154679" cy="169164"/>
           </a:xfrm>
           <a:prstGeom prst="rect">
@@ -4408,13 +4493,13 @@
       </p:sp>
       <p:sp>
         <p:nvSpPr>
-          <p:cNvPr id="30" name="TextBox 29"/>
-          <p:cNvSpPr txBox="1"/>
-          <p:nvPr/>
-        </p:nvSpPr>
-        <p:spPr>
-          <a:xfrm>
-            <a:off x="3474719" y="2500884"/>
+          <p:cNvPr id="31" name="TextBox 30"/>
+          <p:cNvSpPr txBox="1"/>
+          <p:nvPr/>
+        </p:nvSpPr>
+        <p:spPr>
+          <a:xfrm>
+            <a:off x="3474719" y="2588666"/>
             <a:ext cx="914400" cy="169164"/>
           </a:xfrm>
           <a:prstGeom prst="rect">
@@ -4443,13 +4528,13 @@
       </p:sp>
       <p:sp>
         <p:nvSpPr>
-          <p:cNvPr id="31" name="TextBox 30"/>
-          <p:cNvSpPr txBox="1"/>
-          <p:nvPr/>
-        </p:nvSpPr>
-        <p:spPr>
-          <a:xfrm>
-            <a:off x="274320" y="2665476"/>
+          <p:cNvPr id="32" name="TextBox 31"/>
+          <p:cNvSpPr txBox="1"/>
+          <p:nvPr/>
+        </p:nvSpPr>
+        <p:spPr>
+          <a:xfrm>
+            <a:off x="274320" y="2748686"/>
             <a:ext cx="3154679" cy="169164"/>
           </a:xfrm>
           <a:prstGeom prst="rect">
@@ -4478,13 +4563,13 @@
       </p:sp>
       <p:sp>
         <p:nvSpPr>
-          <p:cNvPr id="32" name="TextBox 31"/>
-          <p:cNvSpPr txBox="1"/>
-          <p:nvPr/>
-        </p:nvSpPr>
-        <p:spPr>
-          <a:xfrm>
-            <a:off x="3474719" y="2665476"/>
+          <p:cNvPr id="33" name="TextBox 32"/>
+          <p:cNvSpPr txBox="1"/>
+          <p:nvPr/>
+        </p:nvSpPr>
+        <p:spPr>
+          <a:xfrm>
+            <a:off x="3474719" y="2748686"/>
             <a:ext cx="914400" cy="169164"/>
           </a:xfrm>
           <a:prstGeom prst="rect">
@@ -4513,13 +4598,13 @@
       </p:sp>
       <p:sp>
         <p:nvSpPr>
-          <p:cNvPr id="33" name="TextBox 32"/>
-          <p:cNvSpPr txBox="1"/>
-          <p:nvPr/>
-        </p:nvSpPr>
-        <p:spPr>
-          <a:xfrm>
-            <a:off x="274320" y="2830068"/>
+          <p:cNvPr id="34" name="TextBox 33"/>
+          <p:cNvSpPr txBox="1"/>
+          <p:nvPr/>
+        </p:nvSpPr>
+        <p:spPr>
+          <a:xfrm>
+            <a:off x="274320" y="2908706"/>
             <a:ext cx="3154679" cy="169164"/>
           </a:xfrm>
           <a:prstGeom prst="rect">
@@ -4548,13 +4633,13 @@
       </p:sp>
       <p:sp>
         <p:nvSpPr>
-          <p:cNvPr id="34" name="TextBox 33"/>
-          <p:cNvSpPr txBox="1"/>
-          <p:nvPr/>
-        </p:nvSpPr>
-        <p:spPr>
-          <a:xfrm>
-            <a:off x="3474719" y="2830068"/>
+          <p:cNvPr id="35" name="TextBox 34"/>
+          <p:cNvSpPr txBox="1"/>
+          <p:nvPr/>
+        </p:nvSpPr>
+        <p:spPr>
+          <a:xfrm>
+            <a:off x="3474719" y="2908706"/>
             <a:ext cx="914400" cy="169164"/>
           </a:xfrm>
           <a:prstGeom prst="rect">
@@ -4583,13 +4668,13 @@
       </p:sp>
       <p:sp>
         <p:nvSpPr>
-          <p:cNvPr id="35" name="Rectangle 34"/>
+          <p:cNvPr id="36" name="Rectangle 35"/>
           <p:cNvSpPr/>
           <p:nvPr/>
         </p:nvSpPr>
         <p:spPr>
           <a:xfrm>
-            <a:off x="274320" y="3003804"/>
+            <a:off x="274320" y="3077870"/>
             <a:ext cx="4151376" cy="13716"/>
           </a:xfrm>
           <a:prstGeom prst="rect">
@@ -4626,13 +4711,13 @@
       </p:sp>
       <p:sp>
         <p:nvSpPr>
-          <p:cNvPr id="36" name="TextBox 35"/>
-          <p:cNvSpPr txBox="1"/>
-          <p:nvPr/>
-        </p:nvSpPr>
-        <p:spPr>
-          <a:xfrm>
-            <a:off x="274320" y="3031236"/>
+          <p:cNvPr id="37" name="TextBox 36"/>
+          <p:cNvSpPr txBox="1"/>
+          <p:nvPr/>
+        </p:nvSpPr>
+        <p:spPr>
+          <a:xfrm>
+            <a:off x="274320" y="3105302"/>
             <a:ext cx="3154679" cy="228600"/>
           </a:xfrm>
           <a:prstGeom prst="rect">
@@ -4661,13 +4746,13 @@
       </p:sp>
       <p:sp>
         <p:nvSpPr>
-          <p:cNvPr id="37" name="TextBox 36"/>
-          <p:cNvSpPr txBox="1"/>
-          <p:nvPr/>
-        </p:nvSpPr>
-        <p:spPr>
-          <a:xfrm>
-            <a:off x="3383279" y="3031236"/>
+          <p:cNvPr id="38" name="TextBox 37"/>
+          <p:cNvSpPr txBox="1"/>
+          <p:nvPr/>
+        </p:nvSpPr>
+        <p:spPr>
+          <a:xfrm>
+            <a:off x="3383279" y="3105302"/>
             <a:ext cx="1005840" cy="228600"/>
           </a:xfrm>
           <a:prstGeom prst="rect">
@@ -4696,7 +4781,7 @@
       </p:sp>
       <p:sp>
         <p:nvSpPr>
-          <p:cNvPr id="38" name="Rectangle 37"/>
+          <p:cNvPr id="39" name="Rectangle 38"/>
           <p:cNvSpPr/>
           <p:nvPr/>
         </p:nvSpPr>
@@ -4739,7 +4824,7 @@
       </p:sp>
       <p:sp>
         <p:nvSpPr>
-          <p:cNvPr id="39" name="Rectangle 38"/>
+          <p:cNvPr id="40" name="Rectangle 39"/>
           <p:cNvSpPr/>
           <p:nvPr/>
         </p:nvSpPr>
@@ -4782,7 +4867,7 @@
       </p:sp>
       <p:sp>
         <p:nvSpPr>
-          <p:cNvPr id="40" name="TextBox 39"/>
+          <p:cNvPr id="41" name="TextBox 40"/>
           <p:cNvSpPr txBox="1"/>
           <p:nvPr/>
         </p:nvSpPr>
@@ -4817,7 +4902,7 @@
       </p:sp>
       <p:sp>
         <p:nvSpPr>
-          <p:cNvPr id="41" name="TextBox 40"/>
+          <p:cNvPr id="42" name="TextBox 41"/>
           <p:cNvSpPr txBox="1"/>
           <p:nvPr/>
         </p:nvSpPr>
@@ -4852,7 +4937,7 @@
       </p:sp>
       <p:sp>
         <p:nvSpPr>
-          <p:cNvPr id="42" name="TextBox 41"/>
+          <p:cNvPr id="43" name="TextBox 42"/>
           <p:cNvSpPr txBox="1"/>
           <p:nvPr/>
         </p:nvSpPr>
@@ -4887,7 +4972,7 @@
       </p:sp>
       <p:sp>
         <p:nvSpPr>
-          <p:cNvPr id="43" name="TextBox 42"/>
+          <p:cNvPr id="44" name="TextBox 43"/>
           <p:cNvSpPr txBox="1"/>
           <p:nvPr/>
         </p:nvSpPr>
@@ -4922,13 +5007,13 @@
       </p:sp>
       <p:sp>
         <p:nvSpPr>
-          <p:cNvPr id="44" name="TextBox 43"/>
-          <p:cNvSpPr txBox="1"/>
-          <p:nvPr/>
-        </p:nvSpPr>
-        <p:spPr>
-          <a:xfrm>
-            <a:off x="4754880" y="1161287"/>
+          <p:cNvPr id="45" name="TextBox 44"/>
+          <p:cNvSpPr txBox="1"/>
+          <p:nvPr/>
+        </p:nvSpPr>
+        <p:spPr>
+          <a:xfrm>
+            <a:off x="4754880" y="1156716"/>
             <a:ext cx="3063240" cy="169164"/>
           </a:xfrm>
           <a:prstGeom prst="rect">
@@ -4957,13 +5042,13 @@
       </p:sp>
       <p:sp>
         <p:nvSpPr>
-          <p:cNvPr id="45" name="TextBox 44"/>
-          <p:cNvSpPr txBox="1"/>
-          <p:nvPr/>
-        </p:nvSpPr>
-        <p:spPr>
-          <a:xfrm>
-            <a:off x="7863840" y="1161287"/>
+          <p:cNvPr id="46" name="TextBox 45"/>
+          <p:cNvSpPr txBox="1"/>
+          <p:nvPr/>
+        </p:nvSpPr>
+        <p:spPr>
+          <a:xfrm>
+            <a:off x="7863840" y="1156716"/>
             <a:ext cx="1005840" cy="169164"/>
           </a:xfrm>
           <a:prstGeom prst="rect">
@@ -4992,13 +5077,13 @@
       </p:sp>
       <p:sp>
         <p:nvSpPr>
-          <p:cNvPr id="46" name="Rectangle 45"/>
+          <p:cNvPr id="47" name="Rectangle 46"/>
           <p:cNvSpPr/>
           <p:nvPr/>
         </p:nvSpPr>
         <p:spPr>
           <a:xfrm>
-            <a:off x="4754880" y="1344167"/>
+            <a:off x="4754880" y="1335024"/>
             <a:ext cx="4151376" cy="9144"/>
           </a:xfrm>
           <a:prstGeom prst="rect">
@@ -5035,13 +5120,13 @@
       </p:sp>
       <p:sp>
         <p:nvSpPr>
-          <p:cNvPr id="47" name="TextBox 46"/>
-          <p:cNvSpPr txBox="1"/>
-          <p:nvPr/>
-        </p:nvSpPr>
-        <p:spPr>
-          <a:xfrm>
-            <a:off x="4754880" y="1325879"/>
+          <p:cNvPr id="48" name="TextBox 47"/>
+          <p:cNvSpPr txBox="1"/>
+          <p:nvPr/>
+        </p:nvSpPr>
+        <p:spPr>
+          <a:xfrm>
+            <a:off x="4754880" y="1316736"/>
             <a:ext cx="3063240" cy="169164"/>
           </a:xfrm>
           <a:prstGeom prst="rect">
@@ -5070,13 +5155,13 @@
       </p:sp>
       <p:sp>
         <p:nvSpPr>
-          <p:cNvPr id="48" name="TextBox 47"/>
-          <p:cNvSpPr txBox="1"/>
-          <p:nvPr/>
-        </p:nvSpPr>
-        <p:spPr>
-          <a:xfrm>
-            <a:off x="7863840" y="1325879"/>
+          <p:cNvPr id="49" name="TextBox 48"/>
+          <p:cNvSpPr txBox="1"/>
+          <p:nvPr/>
+        </p:nvSpPr>
+        <p:spPr>
+          <a:xfrm>
+            <a:off x="7863840" y="1316736"/>
             <a:ext cx="1005840" cy="169164"/>
           </a:xfrm>
           <a:prstGeom prst="rect">
@@ -5105,13 +5190,13 @@
       </p:sp>
       <p:sp>
         <p:nvSpPr>
-          <p:cNvPr id="49" name="TextBox 48"/>
-          <p:cNvSpPr txBox="1"/>
-          <p:nvPr/>
-        </p:nvSpPr>
-        <p:spPr>
-          <a:xfrm>
-            <a:off x="4754880" y="1499615"/>
+          <p:cNvPr id="50" name="TextBox 49"/>
+          <p:cNvSpPr txBox="1"/>
+          <p:nvPr/>
+        </p:nvSpPr>
+        <p:spPr>
+          <a:xfrm>
+            <a:off x="4754880" y="1485900"/>
             <a:ext cx="4151376" cy="173736"/>
           </a:xfrm>
           <a:prstGeom prst="rect">
@@ -5140,13 +5225,13 @@
       </p:sp>
       <p:sp>
         <p:nvSpPr>
-          <p:cNvPr id="50" name="TextBox 49"/>
-          <p:cNvSpPr txBox="1"/>
-          <p:nvPr/>
-        </p:nvSpPr>
-        <p:spPr>
-          <a:xfrm>
-            <a:off x="4754880" y="1659635"/>
+          <p:cNvPr id="51" name="TextBox 50"/>
+          <p:cNvSpPr txBox="1"/>
+          <p:nvPr/>
+        </p:nvSpPr>
+        <p:spPr>
+          <a:xfrm>
+            <a:off x="4754880" y="1645920"/>
             <a:ext cx="4151376" cy="173736"/>
           </a:xfrm>
           <a:prstGeom prst="rect">
@@ -5175,13 +5260,13 @@
       </p:sp>
       <p:sp>
         <p:nvSpPr>
-          <p:cNvPr id="51" name="TextBox 50"/>
-          <p:cNvSpPr txBox="1"/>
-          <p:nvPr/>
-        </p:nvSpPr>
-        <p:spPr>
-          <a:xfrm>
-            <a:off x="4754880" y="1819655"/>
+          <p:cNvPr id="52" name="TextBox 51"/>
+          <p:cNvSpPr txBox="1"/>
+          <p:nvPr/>
+        </p:nvSpPr>
+        <p:spPr>
+          <a:xfrm>
+            <a:off x="4754880" y="1805940"/>
             <a:ext cx="4151376" cy="260603"/>
           </a:xfrm>
           <a:prstGeom prst="rect">
@@ -5211,13 +5296,13 @@
       </p:sp>
       <p:sp>
         <p:nvSpPr>
-          <p:cNvPr id="52" name="TextBox 51"/>
-          <p:cNvSpPr txBox="1"/>
-          <p:nvPr/>
-        </p:nvSpPr>
-        <p:spPr>
-          <a:xfrm>
-            <a:off x="4754880" y="2093975"/>
+          <p:cNvPr id="53" name="TextBox 52"/>
+          <p:cNvSpPr txBox="1"/>
+          <p:nvPr/>
+        </p:nvSpPr>
+        <p:spPr>
+          <a:xfrm>
+            <a:off x="4754880" y="2080260"/>
             <a:ext cx="4151376" cy="164592"/>
           </a:xfrm>
           <a:prstGeom prst="rect">
@@ -5246,13 +5331,13 @@
       </p:sp>
       <p:sp>
         <p:nvSpPr>
-          <p:cNvPr id="53" name="TextBox 52"/>
-          <p:cNvSpPr txBox="1"/>
-          <p:nvPr/>
-        </p:nvSpPr>
-        <p:spPr>
-          <a:xfrm>
-            <a:off x="4754880" y="2276856"/>
+          <p:cNvPr id="54" name="TextBox 53"/>
+          <p:cNvSpPr txBox="1"/>
+          <p:nvPr/>
+        </p:nvSpPr>
+        <p:spPr>
+          <a:xfrm>
+            <a:off x="4754880" y="2263140"/>
             <a:ext cx="3063240" cy="169164"/>
           </a:xfrm>
           <a:prstGeom prst="rect">
@@ -5281,13 +5366,13 @@
       </p:sp>
       <p:sp>
         <p:nvSpPr>
-          <p:cNvPr id="54" name="TextBox 53"/>
-          <p:cNvSpPr txBox="1"/>
-          <p:nvPr/>
-        </p:nvSpPr>
-        <p:spPr>
-          <a:xfrm>
-            <a:off x="7863840" y="2276856"/>
+          <p:cNvPr id="55" name="TextBox 54"/>
+          <p:cNvSpPr txBox="1"/>
+          <p:nvPr/>
+        </p:nvSpPr>
+        <p:spPr>
+          <a:xfrm>
+            <a:off x="7863840" y="2263140"/>
             <a:ext cx="1005840" cy="169164"/>
           </a:xfrm>
           <a:prstGeom prst="rect">
@@ -5316,13 +5401,13 @@
       </p:sp>
       <p:sp>
         <p:nvSpPr>
-          <p:cNvPr id="55" name="TextBox 54"/>
-          <p:cNvSpPr txBox="1"/>
-          <p:nvPr/>
-        </p:nvSpPr>
-        <p:spPr>
-          <a:xfrm>
-            <a:off x="4754880" y="2441448"/>
+          <p:cNvPr id="56" name="TextBox 55"/>
+          <p:cNvSpPr txBox="1"/>
+          <p:nvPr/>
+        </p:nvSpPr>
+        <p:spPr>
+          <a:xfrm>
+            <a:off x="4754880" y="2423160"/>
             <a:ext cx="3063240" cy="169164"/>
           </a:xfrm>
           <a:prstGeom prst="rect">
@@ -5351,13 +5436,13 @@
       </p:sp>
       <p:sp>
         <p:nvSpPr>
-          <p:cNvPr id="56" name="TextBox 55"/>
-          <p:cNvSpPr txBox="1"/>
-          <p:nvPr/>
-        </p:nvSpPr>
-        <p:spPr>
-          <a:xfrm>
-            <a:off x="7863840" y="2441448"/>
+          <p:cNvPr id="57" name="TextBox 56"/>
+          <p:cNvSpPr txBox="1"/>
+          <p:nvPr/>
+        </p:nvSpPr>
+        <p:spPr>
+          <a:xfrm>
+            <a:off x="7863840" y="2423160"/>
             <a:ext cx="1005840" cy="169164"/>
           </a:xfrm>
           <a:prstGeom prst="rect">
@@ -5386,13 +5471,13 @@
       </p:sp>
       <p:sp>
         <p:nvSpPr>
-          <p:cNvPr id="57" name="Rectangle 56"/>
+          <p:cNvPr id="58" name="Rectangle 57"/>
           <p:cNvSpPr/>
           <p:nvPr/>
         </p:nvSpPr>
         <p:spPr>
           <a:xfrm>
-            <a:off x="4754880" y="2624328"/>
+            <a:off x="4754880" y="2601468"/>
             <a:ext cx="4151376" cy="9144"/>
           </a:xfrm>
           <a:prstGeom prst="rect">
@@ -5429,13 +5514,13 @@
       </p:sp>
       <p:sp>
         <p:nvSpPr>
-          <p:cNvPr id="58" name="TextBox 57"/>
-          <p:cNvSpPr txBox="1"/>
-          <p:nvPr/>
-        </p:nvSpPr>
-        <p:spPr>
-          <a:xfrm>
-            <a:off x="4754880" y="2642616"/>
+          <p:cNvPr id="59" name="TextBox 58"/>
+          <p:cNvSpPr txBox="1"/>
+          <p:nvPr/>
+        </p:nvSpPr>
+        <p:spPr>
+          <a:xfrm>
+            <a:off x="4754880" y="2619756"/>
             <a:ext cx="3063240" cy="173736"/>
           </a:xfrm>
           <a:prstGeom prst="rect">
@@ -5464,13 +5549,13 @@
       </p:sp>
       <p:sp>
         <p:nvSpPr>
-          <p:cNvPr id="59" name="TextBox 58"/>
-          <p:cNvSpPr txBox="1"/>
-          <p:nvPr/>
-        </p:nvSpPr>
-        <p:spPr>
-          <a:xfrm>
-            <a:off x="7406640" y="2642616"/>
+          <p:cNvPr id="60" name="TextBox 59"/>
+          <p:cNvSpPr txBox="1"/>
+          <p:nvPr/>
+        </p:nvSpPr>
+        <p:spPr>
+          <a:xfrm>
+            <a:off x="7406640" y="2619756"/>
             <a:ext cx="1463040" cy="173736"/>
           </a:xfrm>
           <a:prstGeom prst="rect">
@@ -5499,13 +5584,13 @@
       </p:sp>
       <p:sp>
         <p:nvSpPr>
-          <p:cNvPr id="60" name="TextBox 59"/>
-          <p:cNvSpPr txBox="1"/>
-          <p:nvPr/>
-        </p:nvSpPr>
-        <p:spPr>
-          <a:xfrm>
-            <a:off x="4754880" y="2834640"/>
+          <p:cNvPr id="61" name="TextBox 60"/>
+          <p:cNvSpPr txBox="1"/>
+          <p:nvPr/>
+        </p:nvSpPr>
+        <p:spPr>
+          <a:xfrm>
+            <a:off x="4754880" y="2807208"/>
             <a:ext cx="4151376" cy="347472"/>
           </a:xfrm>
           <a:prstGeom prst="rect">
@@ -5535,13 +5620,13 @@
       </p:sp>
       <p:sp>
         <p:nvSpPr>
-          <p:cNvPr id="61" name="Rectangle 60"/>
+          <p:cNvPr id="62" name="Rectangle 61"/>
           <p:cNvSpPr/>
           <p:nvPr/>
         </p:nvSpPr>
         <p:spPr>
           <a:xfrm>
-            <a:off x="4754880" y="3200400"/>
+            <a:off x="4754880" y="3172968"/>
             <a:ext cx="4151376" cy="224028"/>
           </a:xfrm>
           <a:prstGeom prst="rect">
@@ -5578,13 +5663,13 @@
       </p:sp>
       <p:sp>
         <p:nvSpPr>
-          <p:cNvPr id="62" name="TextBox 61"/>
-          <p:cNvSpPr txBox="1"/>
-          <p:nvPr/>
-        </p:nvSpPr>
-        <p:spPr>
-          <a:xfrm>
-            <a:off x="4828032" y="3227832"/>
+          <p:cNvPr id="63" name="TextBox 62"/>
+          <p:cNvSpPr txBox="1"/>
+          <p:nvPr/>
+        </p:nvSpPr>
+        <p:spPr>
+          <a:xfrm>
+            <a:off x="4828032" y="3200399"/>
             <a:ext cx="4041648" cy="182880"/>
           </a:xfrm>
           <a:prstGeom prst="rect">
@@ -5614,7 +5699,7 @@
       </p:sp>
       <p:sp>
         <p:nvSpPr>
-          <p:cNvPr id="63" name="Rectangle 62"/>
+          <p:cNvPr id="64" name="Rectangle 63"/>
           <p:cNvSpPr/>
           <p:nvPr/>
         </p:nvSpPr>
@@ -5657,7 +5742,7 @@
       </p:sp>
       <p:sp>
         <p:nvSpPr>
-          <p:cNvPr id="64" name="Rectangle 63"/>
+          <p:cNvPr id="65" name="Rectangle 64"/>
           <p:cNvSpPr/>
           <p:nvPr/>
         </p:nvSpPr>
@@ -5700,7 +5785,7 @@
       </p:sp>
       <p:sp>
         <p:nvSpPr>
-          <p:cNvPr id="65" name="TextBox 64"/>
+          <p:cNvPr id="66" name="TextBox 65"/>
           <p:cNvSpPr txBox="1"/>
           <p:nvPr/>
         </p:nvSpPr>
@@ -5735,7 +5820,7 @@
       </p:sp>
       <p:sp>
         <p:nvSpPr>
-          <p:cNvPr id="66" name="TextBox 65"/>
+          <p:cNvPr id="67" name="TextBox 66"/>
           <p:cNvSpPr txBox="1"/>
           <p:nvPr/>
         </p:nvSpPr>
@@ -5770,7 +5855,7 @@
       </p:sp>
       <p:sp>
         <p:nvSpPr>
-          <p:cNvPr id="67" name="TextBox 66"/>
+          <p:cNvPr id="68" name="TextBox 67"/>
           <p:cNvSpPr txBox="1"/>
           <p:nvPr/>
         </p:nvSpPr>
@@ -5805,7 +5890,7 @@
       </p:sp>
       <p:sp>
         <p:nvSpPr>
-          <p:cNvPr id="68" name="TextBox 67"/>
+          <p:cNvPr id="69" name="TextBox 68"/>
           <p:cNvSpPr txBox="1"/>
           <p:nvPr/>
         </p:nvSpPr>
@@ -5840,7 +5925,7 @@
       </p:sp>
       <p:sp>
         <p:nvSpPr>
-          <p:cNvPr id="69" name="TextBox 68"/>
+          <p:cNvPr id="70" name="TextBox 69"/>
           <p:cNvSpPr txBox="1"/>
           <p:nvPr/>
         </p:nvSpPr>
@@ -5875,7 +5960,7 @@
       </p:sp>
       <p:sp>
         <p:nvSpPr>
-          <p:cNvPr id="70" name="TextBox 69"/>
+          <p:cNvPr id="71" name="TextBox 70"/>
           <p:cNvSpPr txBox="1"/>
           <p:nvPr/>
         </p:nvSpPr>
@@ -5910,7 +5995,7 @@
       </p:sp>
       <p:sp>
         <p:nvSpPr>
-          <p:cNvPr id="71" name="TextBox 70"/>
+          <p:cNvPr id="72" name="TextBox 71"/>
           <p:cNvSpPr txBox="1"/>
           <p:nvPr/>
         </p:nvSpPr>
@@ -11664,6 +11749,111 @@
                 <a:latin typeface="Calibri"/>
               </a:rPr>
               <a:t>−$1,443,882</a:t>
+            </a:r>
+          </a:p>
+        </p:txBody>
+      </p:sp>
+      <p:sp>
+        <p:nvSpPr>
+          <p:cNvPr id="52" name="TextBox 51"/>
+          <p:cNvSpPr txBox="1"/>
+          <p:nvPr/>
+        </p:nvSpPr>
+        <p:spPr>
+          <a:xfrm>
+            <a:off x="4517136" y="2720340"/>
+            <a:ext cx="4224528" cy="160020"/>
+          </a:xfrm>
+          <a:prstGeom prst="rect">
+            <a:avLst/>
+          </a:prstGeom>
+          <a:noFill/>
+        </p:spPr>
+        <p:txBody>
+          <a:bodyPr wrap="square">
+            <a:spAutoFit/>
+          </a:bodyPr>
+          <a:lstStyle/>
+          <a:p>
+            <a:pPr algn="l"/>
+            <a:r>
+              <a:rPr sz="700" b="1" i="0">
+                <a:solidFill>
+                  <a:srgbClr val="CCCCCC"/>
+                </a:solidFill>
+                <a:latin typeface="Calibri"/>
+              </a:rPr>
+              <a:t>Exos loan reconciled:</a:t>
+            </a:r>
+          </a:p>
+        </p:txBody>
+      </p:sp>
+      <p:sp>
+        <p:nvSpPr>
+          <p:cNvPr id="53" name="TextBox 52"/>
+          <p:cNvSpPr txBox="1"/>
+          <p:nvPr/>
+        </p:nvSpPr>
+        <p:spPr>
+          <a:xfrm>
+            <a:off x="4517136" y="2875788"/>
+            <a:ext cx="4224528" cy="242316"/>
+          </a:xfrm>
+          <a:prstGeom prst="rect">
+            <a:avLst/>
+          </a:prstGeom>
+          <a:noFill/>
+        </p:spPr>
+        <p:txBody>
+          <a:bodyPr wrap="square">
+            <a:spAutoFit/>
+          </a:bodyPr>
+          <a:lstStyle/>
+          <a:p>
+            <a:pPr algn="l"/>
+            <a:r>
+              <a:rPr sz="650" b="0" i="1">
+                <a:solidFill>
+                  <a:srgbClr val="888888"/>
+                </a:solidFill>
+                <a:latin typeface="Calibri"/>
+              </a:rPr>
+              <a:t>$60K originated 10/10/2024; $28.8K repaid (3/19 + 5/2/2025); $31,200 balance. 11% interest (~$38K total w/ int.); past due 1+ yr. SSLC and Exos records confirmed.</a:t>
+            </a:r>
+          </a:p>
+        </p:txBody>
+      </p:sp>
+      <p:sp>
+        <p:nvSpPr>
+          <p:cNvPr id="54" name="TextBox 53"/>
+          <p:cNvSpPr txBox="1"/>
+          <p:nvPr/>
+        </p:nvSpPr>
+        <p:spPr>
+          <a:xfrm>
+            <a:off x="4517136" y="3122676"/>
+            <a:ext cx="4224528" cy="155448"/>
+          </a:xfrm>
+          <a:prstGeom prst="rect">
+            <a:avLst/>
+          </a:prstGeom>
+          <a:noFill/>
+        </p:spPr>
+        <p:txBody>
+          <a:bodyPr wrap="square">
+            <a:spAutoFit/>
+          </a:bodyPr>
+          <a:lstStyle/>
+          <a:p>
+            <a:pPr algn="l"/>
+            <a:r>
+              <a:rPr sz="650" b="0" i="1">
+                <a:solidFill>
+                  <a:srgbClr val="888888"/>
+                </a:solidFill>
+                <a:latin typeface="Calibri"/>
+              </a:rPr>
+              <a:t>Separate $30K loan (5/9/2024) converted to 5,464 shares on 7/24/2024 — included in Exos’s $790K paid-in capital.</a:t>
             </a:r>
           </a:p>
         </p:txBody>

</xml_diff>

<commit_message>
SSLC slide 11: Microcosm rent credit callout (~$316K) + rebuild package 21pp
- Slide 11 right panel: add amber callout 'NOT YET CREDITED TO SSLC HOLDERS'
  - Microcosm's 50% facility rent Jul 2024–Aug 2026: ~$316K (rent only)
  - Not credited against $451K 'Due to Microcosm' balance
  - If applied: base case net cash ~$1.51M → ~$1.82M at close
- Speaker notes: full GL history (Jan–Jun 2024 50% / Jul 2024 100%; monthly amounts;
  $812,699 Microcosm loan netted 4/30/2026; $451,429 remaining)
- Fonts: confirmed ≥10pt across all 13 slides
- Board package rebuilt: cover + 13-slide deck + offer summary + QB letter
  + SSLC_Related_Party_Diligence_Questions_2026-10-12.pdf (3pp) = 21pp
</commit_message>
<xml_diff>
--- a/drafts/Exos_SSLC_Board_Offer_Overview_2026-10-10_r2.pptx
+++ b/drafts/Exos_SSLC_Board_Offer_Overview_2026-10-10_r2.pptx
@@ -1020,6 +1020,32 @@
             <a:br/>
             <a:r>
               <a:t>Stock ledger: Exos's 18.06% credited via $790K in price. Other holders' per-share payout can't be confirmed without ledger. Per John Quinn, most other holders invested 25+ years ago; Exos invested 2021–2024.</a:t>
+            </a:r>
+          </a:p>
+          <a:p>
+            <a:r>
+              <a:rPr lang="en-US"/>
+              <a:t>
+--- MICROCOSM RENT CREDIT (Robert Conger question, 10/12) ---
+Source: SSLC GL per John Quinn. All figures approximate pending stock ledger / full diligence.
+Jan–Jun 2024: SSLC paid Microcosm $11,470/mo (~50% of $23,647 total rent).
+Jul 2024 onward: SSLC paid 100% of rent:
+  - Jul–Dec 2024: $23,647/mo (paid to Microcosm or sub-landlord)
+  - Jan–Dec 2025: $24,238/mo
+  - Jan–Aug 2026: $24,844/mo (paid directly to landlords Izadi/Vahidi)
+Microcosm continues to occupy the building and is named on the lease.
+Microcosm's 50% share Jul 2024–Aug 2026 (14 months): ~$316K (rent only; utilities billed separately).
+Microcosm loan history (for context):
+  - SSLC lent Microcosm $812,699 total (2019–Oct 2025, booked 4/30/2026).
+  - On 4/30/2026, fully netted against Microcosm balances:
+      $294,499 vs. Loan Payable–Microcosm
+      $423,965 vs. pre-6/2025 Microcosm reimbursables
+      $61,290 vs. 'Judy's time'
+      $32,946 reimbursable
+  - After netting: $451,429 still 'Due to Microcosm' on SSLC's books.
+  - This ~$316K rent credit has NOT been netted against the $451K balance.
+If the board asserts this credit before close, net cash to holders increases by ~$316K:
+  ~$1.51M (base case) → ~$1.82M at close. 5-yr total: ~$5.16M → ~$5.47M.</a:t>
             </a:r>
           </a:p>
         </p:txBody>
@@ -5858,6 +5884,196 @@
           </a:p>
         </p:txBody>
       </p:sp>
+      <p:sp>
+        <p:nvSpPr>
+          <p:cNvPr id="73" name="Rectangle 72"/>
+          <p:cNvSpPr/>
+          <p:nvPr/>
+        </p:nvSpPr>
+        <p:spPr>
+          <a:xfrm>
+            <a:off x="4645152" y="2834640"/>
+            <a:ext cx="4315968" cy="210312"/>
+          </a:xfrm>
+          <a:prstGeom prst="rect">
+            <a:avLst/>
+          </a:prstGeom>
+          <a:solidFill>
+            <a:srgbClr val="FFCC44"/>
+          </a:solidFill>
+          <a:ln>
+            <a:noFill/>
+          </a:ln>
+        </p:spPr>
+        <p:style>
+          <a:lnRef idx="1">
+            <a:schemeClr val="accent1"/>
+          </a:lnRef>
+          <a:fillRef idx="3">
+            <a:schemeClr val="accent1"/>
+          </a:fillRef>
+          <a:effectRef idx="2">
+            <a:schemeClr val="accent1"/>
+          </a:effectRef>
+          <a:fontRef idx="minor">
+            <a:schemeClr val="lt1"/>
+          </a:fontRef>
+        </p:style>
+        <p:txBody>
+          <a:bodyPr rtlCol="0" anchor="ctr"/>
+          <a:lstStyle/>
+          <a:p>
+            <a:pPr algn="ctr"/>
+          </a:p>
+        </p:txBody>
+      </p:sp>
+      <p:sp>
+        <p:nvSpPr>
+          <p:cNvPr id="74" name="TextBox 73"/>
+          <p:cNvSpPr txBox="1"/>
+          <p:nvPr/>
+        </p:nvSpPr>
+        <p:spPr>
+          <a:xfrm>
+            <a:off x="4718304" y="2852928"/>
+            <a:ext cx="4169663" cy="173736"/>
+          </a:xfrm>
+          <a:prstGeom prst="rect">
+            <a:avLst/>
+          </a:prstGeom>
+          <a:noFill/>
+        </p:spPr>
+        <p:txBody>
+          <a:bodyPr wrap="none">
+            <a:spAutoFit/>
+          </a:bodyPr>
+          <a:lstStyle/>
+          <a:p>
+            <a:pPr algn="ctr"/>
+            <a:r>
+              <a:rPr sz="1000" b="1">
+                <a:solidFill>
+                  <a:srgbClr val="111111"/>
+                </a:solidFill>
+                <a:latin typeface="Calibri"/>
+              </a:rPr>
+              <a:t>⚠  NOT YET CREDITED TO SSLC HOLDERS</a:t>
+            </a:r>
+          </a:p>
+        </p:txBody>
+      </p:sp>
+      <p:sp>
+        <p:nvSpPr>
+          <p:cNvPr id="75" name="Rectangle 74"/>
+          <p:cNvSpPr/>
+          <p:nvPr/>
+        </p:nvSpPr>
+        <p:spPr>
+          <a:xfrm>
+            <a:off x="4645152" y="3044952"/>
+            <a:ext cx="4315968" cy="868680"/>
+          </a:xfrm>
+          <a:prstGeom prst="rect">
+            <a:avLst/>
+          </a:prstGeom>
+          <a:solidFill>
+            <a:srgbClr val="2A1800"/>
+          </a:solidFill>
+          <a:ln w="9525">
+            <a:solidFill>
+              <a:srgbClr val="FFCC44"/>
+            </a:solidFill>
+          </a:ln>
+        </p:spPr>
+        <p:style>
+          <a:lnRef idx="1">
+            <a:schemeClr val="accent1"/>
+          </a:lnRef>
+          <a:fillRef idx="3">
+            <a:schemeClr val="accent1"/>
+          </a:fillRef>
+          <a:effectRef idx="2">
+            <a:schemeClr val="accent1"/>
+          </a:effectRef>
+          <a:fontRef idx="minor">
+            <a:schemeClr val="lt1"/>
+          </a:fontRef>
+        </p:style>
+        <p:txBody>
+          <a:bodyPr rtlCol="0" anchor="ctr"/>
+          <a:lstStyle/>
+          <a:p>
+            <a:pPr algn="ctr"/>
+          </a:p>
+        </p:txBody>
+      </p:sp>
+      <p:sp>
+        <p:nvSpPr>
+          <p:cNvPr id="76" name="TextBox 75"/>
+          <p:cNvSpPr txBox="1"/>
+          <p:nvPr/>
+        </p:nvSpPr>
+        <p:spPr>
+          <a:xfrm>
+            <a:off x="4736592" y="3099816"/>
+            <a:ext cx="4133087" cy="777240"/>
+          </a:xfrm>
+          <a:prstGeom prst="rect">
+            <a:avLst/>
+          </a:prstGeom>
+          <a:noFill/>
+        </p:spPr>
+        <p:txBody>
+          <a:bodyPr wrap="square">
+            <a:spAutoFit/>
+          </a:bodyPr>
+          <a:lstStyle/>
+          <a:p>
+            <a:r>
+              <a:rPr sz="1000" b="1">
+                <a:solidFill>
+                  <a:srgbClr val="FFEE88"/>
+                </a:solidFill>
+                <a:latin typeface="Calibri"/>
+              </a:rPr>
+              <a:t>Microcosm's 50% share of facility rent, Jul 2024–Aug 2026: ~$316K (rent only; utilities extra).</a:t>
+            </a:r>
+          </a:p>
+          <a:p>
+            <a:r>
+              <a:rPr sz="1000" b="0">
+                <a:solidFill>
+                  <a:srgbClr val="CCCCCC"/>
+                </a:solidFill>
+                <a:latin typeface="Calibri"/>
+              </a:rPr>
+              <a:t>Not credited against the $451K 'Due to Microcosm' balance. Microcosm still occupies the building.</a:t>
+            </a:r>
+          </a:p>
+          <a:p>
+            <a:r>
+              <a:rPr sz="1000" b="0">
+                <a:solidFill>
+                  <a:srgbClr val="CCCCCC"/>
+                </a:solidFill>
+                <a:latin typeface="Calibri"/>
+              </a:rPr>
+              <a:t>If applied: reduces SSLC's Microcosm debt by ~$316K → more cash distributable at close.</a:t>
+            </a:r>
+          </a:p>
+          <a:p>
+            <a:r>
+              <a:rPr sz="1000" b="1">
+                <a:solidFill>
+                  <a:srgbClr val="FFEE88"/>
+                </a:solidFill>
+                <a:latin typeface="Calibri"/>
+              </a:rPr>
+              <a:t>Base case net cash: ~$1.51M → ~$1.82M if rent offset recognized before close.</a:t>
+            </a:r>
+          </a:p>
+        </p:txBody>
+      </p:sp>
     </p:spTree>
   </p:cSld>
   <p:clrMapOvr>

</xml_diff>

<commit_message>
SSLC slide 11: utilities added to rent credit callout (~$351K total); package 21pp
- Callout updated: Microcosm's 50% facility costs Jul 2024–Aug 2026 = ~$351K
  (rent ~$316K + utilities ~$35K, avg $2,727/mo from Jul 2024 per GL acct 6195)
- Impact: cash at close ~$1.51M → ~$1.86M; 'Due to Microcosm' $451K → ~$100K;
  equity -$1.44M → ~-$1.09M
- Speaker notes: full utilities GL breakdown (6195), monthly rates, 50% allocation,
  netting history re $812,699 Microcosm loan
- Board package rebuilt 21pp: cover + 13-slide deck + offer summary + QB letter
  + SSLC_Related_Party_Diligence_Questions_2026-10-12.pdf (utilities now in Q11)
- Fonts: confirmed ≥10pt
</commit_message>
<xml_diff>
--- a/drafts/Exos_SSLC_Board_Offer_Overview_2026-10-10_r2.pptx
+++ b/drafts/Exos_SSLC_Board_Offer_Overview_2026-10-10_r2.pptx
@@ -1046,6 +1046,30 @@
   - This ~$316K rent credit has NOT been netted against the $451K balance.
 If the board asserts this credit before close, net cash to holders increases by ~$316K:
   ~$1.51M (base case) → ~$1.82M at close. 5-yr total: ~$5.16M → ~$5.47M.</a:t>
+            </a:r>
+          </a:p>
+          <a:p>
+            <a:r>
+              <a:rPr lang="en-US"/>
+              <a:t>
+--- MICROCOSM UTILITIES UPDATE (John 06:43) ---
+Source: SSLC GL account 6195 (utilities). All figures approximate.
+Utilities (Acct 6195):
+  - Jan–Jun 2024 (50% split period): avg ~$1,059/mo → Microcosm's 50% share ~$530/mo
+  - Jul 2024–Aug 2026 (SSLC paying 100%): avg ~$2,727/mo (~2.6× jump; some summer seasonality)
+  - Jul 2024–Aug 2026 = 14 months; total utilities paid = ~$38,178
+  - Microcosm's 50% share of that period: $70,048 / 2 = $35,024 (~$35K)
+Updated totals:
+  - Rent credit (Jul 2024–Aug 2026): ~$316K
+  - Utilities credit (Jul 2024–Aug 2026, 50%): ~$35K
+  - Total facility cost credit: ~$351K
+Impact if recognized before close:
+  - Net cash at close: ~$1.51M → ~$1.86M (+$351K on $1.51M; ~$1.86M = $1.51M + $0.35M)
+  - 'Due to Microcosm' (currently $451K): $451K − $351K = ~$100K remaining
+  - Total equity: currently ~−$1.44M; improves by $351K → ~−$1.09M
+  - 5-yr total: ~$5.16M → ~$5.51M
+Note: Microcosm continues to occupy the building and is named on the lease.
+This credit has not been asserted or netted on SSLC's books as of 10/11/2026.</a:t>
             </a:r>
           </a:p>
         </p:txBody>
@@ -5971,7 +5995,7 @@
         <p:spPr>
           <a:xfrm>
             <a:off x="4645152" y="3044952"/>
-            <a:ext cx="4315968" cy="868680"/>
+            <a:ext cx="4315968" cy="1005840"/>
           </a:xfrm>
           <a:prstGeom prst="rect">
             <a:avLst/>
@@ -6015,8 +6039,8 @@
         </p:nvSpPr>
         <p:spPr>
           <a:xfrm>
-            <a:off x="4736592" y="3099816"/>
-            <a:ext cx="4133087" cy="777240"/>
+            <a:off x="4736592" y="3095244"/>
+            <a:ext cx="4133087" cy="923544"/>
           </a:xfrm>
           <a:prstGeom prst="rect">
             <a:avLst/>
@@ -6036,7 +6060,7 @@
                 </a:solidFill>
                 <a:latin typeface="Calibri"/>
               </a:rPr>
-              <a:t>Microcosm's 50% share of facility rent, Jul 2024–Aug 2026: ~$316K (rent only; utilities extra).</a:t>
+              <a:t>Microcosm's 50% facility costs, Jul 2024–Aug 2026: ~$351K</a:t>
             </a:r>
           </a:p>
           <a:p>
@@ -6047,18 +6071,18 @@
                 </a:solidFill>
                 <a:latin typeface="Calibri"/>
               </a:rPr>
-              <a:t>Not credited against the $451K 'Due to Microcosm' balance. Microcosm still occupies the building.</a:t>
-            </a:r>
-          </a:p>
-          <a:p>
-            <a:r>
-              <a:rPr sz="1000" b="0">
-                <a:solidFill>
-                  <a:srgbClr val="CCCCCC"/>
+              <a:t>  (rent ~$316K + utilities ~$35K). Not credited vs. $451K owed to Microcosm.</a:t>
+            </a:r>
+          </a:p>
+          <a:p>
+            <a:r>
+              <a:rPr sz="1000" b="1">
+                <a:solidFill>
+                  <a:srgbClr val="FFEE88"/>
                 </a:solidFill>
                 <a:latin typeface="Calibri"/>
               </a:rPr>
-              <a:t>If applied: reduces SSLC's Microcosm debt by ~$316K → more cash distributable at close.</a:t>
+              <a:t>If applied: SSLC holders' cash at close ~$1.51M → ~$1.86M (base case).</a:t>
             </a:r>
           </a:p>
           <a:p>
@@ -6069,7 +6093,18 @@
                 </a:solidFill>
                 <a:latin typeface="Calibri"/>
               </a:rPr>
-              <a:t>Base case net cash: ~$1.51M → ~$1.82M if rent offset recognized before close.</a:t>
+              <a:t>'Due to Microcosm' falls to ~$100K.</a:t>
+            </a:r>
+          </a:p>
+          <a:p>
+            <a:r>
+              <a:rPr sz="1000" b="1">
+                <a:solidFill>
+                  <a:srgbClr val="FFEE88"/>
+                </a:solidFill>
+                <a:latin typeface="Calibri"/>
+              </a:rPr>
+              <a:t>Equity improves: -$1.44M to ~-$1.09M.</a:t>
             </a:r>
           </a:p>
         </p:txBody>

</xml_diff>

<commit_message>
SSLC deck r2 batch4: slide 4 Exos-adjusted table, slide 2 protection framing; rebuild board package 21pp
</commit_message>
<xml_diff>
--- a/drafts/Exos_SSLC_Board_Offer_Overview_2026-10-10_r2.pptx
+++ b/drafts/Exos_SSLC_Board_Offer_Overview_2026-10-10_r2.pptx
@@ -750,6 +750,29 @@
             <a:br/>
             <a:r>
               <a:t>Open items: AR Unbilled $942,177 (Acct 1110) and Deposits $120,000 (Acct 2380) under reconciliation per Motion 3. Facility costs ~$805K (Jan 2024–Oct 2026) never charged to Microcosm.</a:t>
+            </a:r>
+          </a:p>
+          <a:p>
+            <a:r>
+              <a:rPr lang="en-US"/>
+              <a:t>SPEAKER NOTES — SLIDE 4 (Exos-adjusted comparison):
+Per SSLC's GL, the 'Notes Payable – Bookstore' ($320,582) is owed to Microcosm Astronautics Books (the Bookstore).
+Key 4/30/2026 journal entries:
+  $426,687  AP→Due to Microcosm (re-classing payables to Microcosm)
+  $97,302   Interest capitalized into Bookstore note (not separately disclosed on 4/30)
+  $812,699  SSLC loans-to-Microcosm fully netted vs. Microcosm balances:
+              $294,499 vs. Loan Payable–Microcosm
+              $423,965 vs. pre-6/2025 Microcosm reimbursables
+              $61,290 vs. 'Judy's time'
+              $32,946 reimbursable
+            After netting: $451,429 'Due to Microcosm' remains.
+Exos adjustments (not yet on SSLC books):
+  - Microcosm 50% facility share Jul 2024–Aug 2026: ~$351K (rent ~$316K + utilities ~$35K)
+    → reduces 'Due to Microcosm' $451K→~$100K
+  - Bookstore $97K interest: Exos requests supporting amortization schedule
+  - Billed-ahead: start-billings booked at tank start, not cleared at IM shipment
+    → est. genuine billed-ahead ~$100K–$250K (Motion 3 directs correction)
+  - Equity: base improvement −$1.44M→~−$1.09M (facility credit only); further improvement if billed-ahead reconciled.</a:t>
             </a:r>
           </a:p>
         </p:txBody>
@@ -9258,6 +9281,76 @@
           </a:p>
         </p:txBody>
       </p:sp>
+      <p:sp>
+        <p:nvSpPr>
+          <p:cNvPr id="10" name="TextBox 9"/>
+          <p:cNvSpPr txBox="1"/>
+          <p:nvPr/>
+        </p:nvSpPr>
+        <p:spPr>
+          <a:xfrm>
+            <a:off x="411480" y="4325112"/>
+            <a:ext cx="8321040" cy="256032"/>
+          </a:xfrm>
+          <a:prstGeom prst="rect">
+            <a:avLst/>
+          </a:prstGeom>
+          <a:noFill/>
+        </p:spPr>
+        <p:txBody>
+          <a:bodyPr wrap="square">
+            <a:spAutoFit/>
+          </a:bodyPr>
+          <a:lstStyle/>
+          <a:p>
+            <a:pPr algn="l"/>
+            <a:r>
+              <a:rPr sz="1000" b="1" i="0">
+                <a:solidFill>
+                  <a:srgbClr val="F26A21"/>
+                </a:solidFill>
+                <a:latin typeface="Calibri"/>
+              </a:rPr>
+              <a:t>These motions protect every SSLC holder outside the Microcosm/Wertz group, including Exos (18%), by correcting the books before any payout.</a:t>
+            </a:r>
+          </a:p>
+        </p:txBody>
+      </p:sp>
+      <p:sp>
+        <p:nvSpPr>
+          <p:cNvPr id="11" name="TextBox 10"/>
+          <p:cNvSpPr txBox="1"/>
+          <p:nvPr/>
+        </p:nvSpPr>
+        <p:spPr>
+          <a:xfrm>
+            <a:off x="411480" y="4590288"/>
+            <a:ext cx="8321040" cy="173736"/>
+          </a:xfrm>
+          <a:prstGeom prst="rect">
+            <a:avLst/>
+          </a:prstGeom>
+          <a:noFill/>
+        </p:spPr>
+        <p:txBody>
+          <a:bodyPr wrap="square">
+            <a:spAutoFit/>
+          </a:bodyPr>
+          <a:lstStyle/>
+          <a:p>
+            <a:pPr algn="l"/>
+            <a:r>
+              <a:rPr sz="1000" b="0" i="1">
+                <a:solidFill>
+                  <a:srgbClr val="888888"/>
+                </a:solidFill>
+                <a:latin typeface="Calibri"/>
+              </a:rPr>
+              <a:t>Ownership: Jim Wertz held most of SSLC until Exos's ~10% purchase, then Exos's ~8% follow-on to keep SSLC cash-flow positive.</a:t>
+            </a:r>
+          </a:p>
+        </p:txBody>
+      </p:sp>
     </p:spTree>
   </p:cSld>
   <p:clrMapOvr>
@@ -11441,20 +11534,90 @@
       </p:sp>
       <p:sp>
         <p:nvSpPr>
-          <p:cNvPr id="42" name="Rectangle 41"/>
+          <p:cNvPr id="47" name="TextBox 46"/>
+          <p:cNvSpPr txBox="1"/>
+          <p:nvPr/>
+        </p:nvSpPr>
+        <p:spPr>
+          <a:xfrm>
+            <a:off x="1554480" y="4809744"/>
+            <a:ext cx="6035040" cy="201168"/>
+          </a:xfrm>
+          <a:prstGeom prst="rect">
+            <a:avLst/>
+          </a:prstGeom>
+          <a:noFill/>
+        </p:spPr>
+        <p:txBody>
+          <a:bodyPr wrap="square">
+            <a:spAutoFit/>
+          </a:bodyPr>
+          <a:lstStyle/>
+          <a:p>
+            <a:pPr algn="ctr"/>
+            <a:r>
+              <a:rPr sz="1000" b="0" i="1">
+                <a:solidFill>
+                  <a:srgbClr val="888888"/>
+                </a:solidFill>
+                <a:latin typeface="Calibri"/>
+              </a:rPr>
+              <a:t>DRAFT — NEGOTIATING TERMS</a:t>
+            </a:r>
+          </a:p>
+        </p:txBody>
+      </p:sp>
+      <p:sp>
+        <p:nvSpPr>
+          <p:cNvPr id="48" name="TextBox 47"/>
+          <p:cNvSpPr txBox="1"/>
+          <p:nvPr/>
+        </p:nvSpPr>
+        <p:spPr>
+          <a:xfrm>
+            <a:off x="7772400" y="4809744"/>
+            <a:ext cx="1143000" cy="201168"/>
+          </a:xfrm>
+          <a:prstGeom prst="rect">
+            <a:avLst/>
+          </a:prstGeom>
+          <a:noFill/>
+        </p:spPr>
+        <p:txBody>
+          <a:bodyPr wrap="square">
+            <a:spAutoFit/>
+          </a:bodyPr>
+          <a:lstStyle/>
+          <a:p>
+            <a:pPr algn="r"/>
+            <a:r>
+              <a:rPr sz="1000" b="0" i="1">
+                <a:solidFill>
+                  <a:srgbClr val="888888"/>
+                </a:solidFill>
+                <a:latin typeface="Calibri"/>
+              </a:rPr>
+              <a:t>CONFIDENTIAL</a:t>
+            </a:r>
+          </a:p>
+        </p:txBody>
+      </p:sp>
+      <p:sp>
+        <p:nvSpPr>
+          <p:cNvPr id="49" name="Rectangle 48"/>
           <p:cNvSpPr/>
           <p:nvPr/>
         </p:nvSpPr>
         <p:spPr>
           <a:xfrm>
-            <a:off x="109728" y="3643884"/>
-            <a:ext cx="8924544" cy="749808"/>
+            <a:off x="329184" y="2679191"/>
+            <a:ext cx="2459736" cy="13716"/>
           </a:xfrm>
           <a:prstGeom prst="rect">
             <a:avLst/>
           </a:prstGeom>
           <a:solidFill>
-            <a:srgbClr val="1E1400"/>
+            <a:srgbClr val="888888"/>
           </a:solidFill>
           <a:ln>
             <a:noFill/>
@@ -11484,20 +11647,124 @@
       </p:sp>
       <p:sp>
         <p:nvSpPr>
-          <p:cNvPr id="43" name="Rectangle 42"/>
+          <p:cNvPr id="50" name="TextBox 49"/>
+          <p:cNvSpPr txBox="1"/>
+          <p:nvPr/>
+        </p:nvSpPr>
+        <p:spPr>
+          <a:xfrm>
+            <a:off x="219456" y="2697479"/>
+            <a:ext cx="2514600" cy="205740"/>
+          </a:xfrm>
+          <a:prstGeom prst="rect">
+            <a:avLst/>
+          </a:prstGeom>
+          <a:noFill/>
+        </p:spPr>
+        <p:txBody>
+          <a:bodyPr wrap="none">
+            <a:spAutoFit/>
+          </a:bodyPr>
+          <a:lstStyle/>
+          <a:p>
+            <a:r>
+              <a:rPr sz="1000" b="0">
+                <a:solidFill>
+                  <a:srgbClr val="CCCCCC"/>
+                </a:solidFill>
+                <a:latin typeface="Calibri"/>
+              </a:rPr>
+              <a:t>Total equity (10/11/2026)</a:t>
+            </a:r>
+          </a:p>
+        </p:txBody>
+      </p:sp>
+      <p:sp>
+        <p:nvSpPr>
+          <p:cNvPr id="51" name="TextBox 50"/>
+          <p:cNvSpPr txBox="1"/>
+          <p:nvPr/>
+        </p:nvSpPr>
+        <p:spPr>
+          <a:xfrm>
+            <a:off x="2752344" y="2697479"/>
+            <a:ext cx="1481328" cy="205740"/>
+          </a:xfrm>
+          <a:prstGeom prst="rect">
+            <a:avLst/>
+          </a:prstGeom>
+          <a:noFill/>
+        </p:spPr>
+        <p:txBody>
+          <a:bodyPr wrap="none">
+            <a:spAutoFit/>
+          </a:bodyPr>
+          <a:lstStyle/>
+          <a:p>
+            <a:pPr algn="r"/>
+            <a:r>
+              <a:rPr sz="1000" b="1">
+                <a:solidFill>
+                  <a:srgbClr val="FF6666"/>
+                </a:solidFill>
+                <a:latin typeface="Calibri"/>
+              </a:rPr>
+              <a:t>−$1,443,882</a:t>
+            </a:r>
+          </a:p>
+        </p:txBody>
+      </p:sp>
+      <p:sp>
+        <p:nvSpPr>
+          <p:cNvPr id="52" name="TextBox 51"/>
+          <p:cNvSpPr txBox="1"/>
+          <p:nvPr/>
+        </p:nvSpPr>
+        <p:spPr>
+          <a:xfrm>
+            <a:off x="4517136" y="2720340"/>
+            <a:ext cx="4224528" cy="160020"/>
+          </a:xfrm>
+          <a:prstGeom prst="rect">
+            <a:avLst/>
+          </a:prstGeom>
+          <a:noFill/>
+        </p:spPr>
+        <p:txBody>
+          <a:bodyPr wrap="square">
+            <a:spAutoFit/>
+          </a:bodyPr>
+          <a:lstStyle/>
+          <a:p>
+            <a:pPr algn="l"/>
+            <a:r>
+              <a:rPr sz="1000" b="1" i="0">
+                <a:solidFill>
+                  <a:srgbClr val="CCCCCC"/>
+                </a:solidFill>
+                <a:latin typeface="Calibri"/>
+              </a:rPr>
+              <a:t>Exos loan reconciled: $60K→$31.2K (11% int.); records match. $30K prior loan→5,464 shares (incl. in $790K paid-in).</a:t>
+            </a:r>
+          </a:p>
+        </p:txBody>
+      </p:sp>
+      <p:sp>
+        <p:nvSpPr>
+          <p:cNvPr id="53" name="Rectangle 52"/>
           <p:cNvSpPr/>
           <p:nvPr/>
         </p:nvSpPr>
         <p:spPr>
           <a:xfrm>
-            <a:off x="109728" y="3643884"/>
-            <a:ext cx="50292" cy="749808"/>
+            <a:off x="201168" y="3593592"/>
+            <a:ext cx="8741664" cy="1175004"/>
           </a:xfrm>
           <a:prstGeom prst="rect">
             <a:avLst/>
           </a:prstGeom>
           <a:solidFill>
-            <a:srgbClr val="F26A21"/>
+            <a:srgbClr val="1E1E1E"/>
           </a:solidFill>
           <a:ln>
             <a:noFill/>
@@ -11527,195 +11794,20 @@
       </p:sp>
       <p:sp>
         <p:nvSpPr>
-          <p:cNvPr id="44" name="TextBox 43"/>
-          <p:cNvSpPr txBox="1"/>
-          <p:nvPr/>
-        </p:nvSpPr>
-        <p:spPr>
-          <a:xfrm>
-            <a:off x="219456" y="3680459"/>
-            <a:ext cx="8686800" cy="173736"/>
-          </a:xfrm>
-          <a:prstGeom prst="rect">
-            <a:avLst/>
-          </a:prstGeom>
-          <a:noFill/>
-        </p:spPr>
-        <p:txBody>
-          <a:bodyPr wrap="square">
-            <a:spAutoFit/>
-          </a:bodyPr>
-          <a:lstStyle/>
-          <a:p>
-            <a:pPr algn="l"/>
-            <a:r>
-              <a:rPr sz="1000" b="1" i="0">
-                <a:solidFill>
-                  <a:srgbClr val="F26A21"/>
-                </a:solidFill>
-                <a:latin typeface="Calibri"/>
-              </a:rPr>
-              <a:t>OPEN ITEMS  (Exos assessment pending reconciliation via Motion 2)</a:t>
-            </a:r>
-          </a:p>
-        </p:txBody>
-      </p:sp>
-      <p:sp>
-        <p:nvSpPr>
-          <p:cNvPr id="45" name="TextBox 44"/>
-          <p:cNvSpPr txBox="1"/>
-          <p:nvPr/>
-        </p:nvSpPr>
-        <p:spPr>
-          <a:xfrm>
-            <a:off x="219456" y="3890772"/>
-            <a:ext cx="8686800" cy="457200"/>
-          </a:xfrm>
-          <a:prstGeom prst="rect">
-            <a:avLst/>
-          </a:prstGeom>
-          <a:noFill/>
-        </p:spPr>
-        <p:txBody>
-          <a:bodyPr wrap="square">
-            <a:spAutoFit/>
-          </a:bodyPr>
-          <a:lstStyle/>
-          <a:p>
-            <a:pPr algn="l"/>
-            <a:r>
-              <a:rPr sz="1000" b="0" i="0">
-                <a:solidFill>
-                  <a:srgbClr val="CCCCCC"/>
-                </a:solidFill>
-                <a:latin typeface="Calibri"/>
-              </a:rPr>
-              <a:t>"Billed-ahead" balance: $942,177 at 10/11. Exos assessment: overstated — start-billings not cleared at shipment. True billed-ahead est. $100K–$250K. Reconciliation via Motion 3. Facility costs since Jan 2024: ~$805K never charged back to Microcosm.</a:t>
-            </a:r>
-          </a:p>
-        </p:txBody>
-      </p:sp>
-      <p:sp>
-        <p:nvSpPr>
-          <p:cNvPr id="46" name="TextBox 45"/>
-          <p:cNvSpPr txBox="1"/>
-          <p:nvPr/>
-        </p:nvSpPr>
-        <p:spPr>
-          <a:xfrm>
-            <a:off x="228600" y="4416552"/>
-            <a:ext cx="8229600" cy="155448"/>
-          </a:xfrm>
-          <a:prstGeom prst="rect">
-            <a:avLst/>
-          </a:prstGeom>
-          <a:noFill/>
-        </p:spPr>
-        <p:txBody>
-          <a:bodyPr wrap="square">
-            <a:spAutoFit/>
-          </a:bodyPr>
-          <a:lstStyle/>
-          <a:p>
-            <a:pPr algn="l"/>
-            <a:r>
-              <a:rPr sz="1000" b="0" i="1">
-                <a:solidFill>
-                  <a:srgbClr val="888888"/>
-                </a:solidFill>
-                <a:latin typeface="Calibri"/>
-              </a:rPr>
-              <a:t>Source: SSLC QuickBooks 10/11/2026; billed-ahead pending reconciliation (Motion 3)</a:t>
-            </a:r>
-          </a:p>
-        </p:txBody>
-      </p:sp>
-      <p:sp>
-        <p:nvSpPr>
-          <p:cNvPr id="47" name="TextBox 46"/>
-          <p:cNvSpPr txBox="1"/>
-          <p:nvPr/>
-        </p:nvSpPr>
-        <p:spPr>
-          <a:xfrm>
-            <a:off x="1554480" y="4809744"/>
-            <a:ext cx="6035040" cy="201168"/>
-          </a:xfrm>
-          <a:prstGeom prst="rect">
-            <a:avLst/>
-          </a:prstGeom>
-          <a:noFill/>
-        </p:spPr>
-        <p:txBody>
-          <a:bodyPr wrap="square">
-            <a:spAutoFit/>
-          </a:bodyPr>
-          <a:lstStyle/>
-          <a:p>
-            <a:pPr algn="ctr"/>
-            <a:r>
-              <a:rPr sz="1000" b="0" i="1">
-                <a:solidFill>
-                  <a:srgbClr val="888888"/>
-                </a:solidFill>
-                <a:latin typeface="Calibri"/>
-              </a:rPr>
-              <a:t>DRAFT — NEGOTIATING TERMS</a:t>
-            </a:r>
-          </a:p>
-        </p:txBody>
-      </p:sp>
-      <p:sp>
-        <p:nvSpPr>
-          <p:cNvPr id="48" name="TextBox 47"/>
-          <p:cNvSpPr txBox="1"/>
-          <p:nvPr/>
-        </p:nvSpPr>
-        <p:spPr>
-          <a:xfrm>
-            <a:off x="7772400" y="4809744"/>
-            <a:ext cx="1143000" cy="201168"/>
-          </a:xfrm>
-          <a:prstGeom prst="rect">
-            <a:avLst/>
-          </a:prstGeom>
-          <a:noFill/>
-        </p:spPr>
-        <p:txBody>
-          <a:bodyPr wrap="square">
-            <a:spAutoFit/>
-          </a:bodyPr>
-          <a:lstStyle/>
-          <a:p>
-            <a:pPr algn="r"/>
-            <a:r>
-              <a:rPr sz="1000" b="0" i="1">
-                <a:solidFill>
-                  <a:srgbClr val="888888"/>
-                </a:solidFill>
-                <a:latin typeface="Calibri"/>
-              </a:rPr>
-              <a:t>CONFIDENTIAL</a:t>
-            </a:r>
-          </a:p>
-        </p:txBody>
-      </p:sp>
-      <p:sp>
-        <p:nvSpPr>
-          <p:cNvPr id="49" name="Rectangle 48"/>
+          <p:cNvPr id="54" name="Rectangle 53"/>
           <p:cNvSpPr/>
           <p:nvPr/>
         </p:nvSpPr>
         <p:spPr>
           <a:xfrm>
-            <a:off x="329184" y="2679191"/>
-            <a:ext cx="2459736" cy="13716"/>
+            <a:off x="201168" y="3593592"/>
+            <a:ext cx="8741664" cy="14630"/>
           </a:xfrm>
           <a:prstGeom prst="rect">
             <a:avLst/>
           </a:prstGeom>
           <a:solidFill>
-            <a:srgbClr val="888888"/>
+            <a:srgbClr val="F26A21"/>
           </a:solidFill>
           <a:ln>
             <a:noFill/>
@@ -11745,14 +11837,14 @@
       </p:sp>
       <p:sp>
         <p:nvSpPr>
-          <p:cNvPr id="50" name="TextBox 49"/>
-          <p:cNvSpPr txBox="1"/>
-          <p:nvPr/>
-        </p:nvSpPr>
-        <p:spPr>
-          <a:xfrm>
-            <a:off x="219456" y="2697479"/>
-            <a:ext cx="2514600" cy="205740"/>
+          <p:cNvPr id="55" name="TextBox 54"/>
+          <p:cNvSpPr txBox="1"/>
+          <p:nvPr/>
+        </p:nvSpPr>
+        <p:spPr>
+          <a:xfrm>
+            <a:off x="292608" y="3610051"/>
+            <a:ext cx="5486400" cy="173736"/>
           </a:xfrm>
           <a:prstGeom prst="rect">
             <a:avLst/>
@@ -11765,28 +11857,29 @@
           </a:bodyPr>
           <a:lstStyle/>
           <a:p>
-            <a:r>
-              <a:rPr sz="1000" b="0">
-                <a:solidFill>
-                  <a:srgbClr val="CCCCCC"/>
+            <a:pPr algn="l"/>
+            <a:r>
+              <a:rPr sz="1000" b="1" i="0">
+                <a:solidFill>
+                  <a:srgbClr val="F26A21"/>
                 </a:solidFill>
                 <a:latin typeface="Calibri"/>
               </a:rPr>
-              <a:t>Total equity (10/11/2026)</a:t>
-            </a:r>
-          </a:p>
-        </p:txBody>
-      </p:sp>
-      <p:sp>
-        <p:nvSpPr>
-          <p:cNvPr id="51" name="TextBox 50"/>
-          <p:cNvSpPr txBox="1"/>
-          <p:nvPr/>
-        </p:nvSpPr>
-        <p:spPr>
-          <a:xfrm>
-            <a:off x="2752344" y="2697479"/>
-            <a:ext cx="1481328" cy="205740"/>
+              <a:t>Exos Assessment  (Motions 2 &amp; 3)  — As Booked vs. Adjusted</a:t>
+            </a:r>
+          </a:p>
+        </p:txBody>
+      </p:sp>
+      <p:sp>
+        <p:nvSpPr>
+          <p:cNvPr id="56" name="TextBox 55"/>
+          <p:cNvSpPr txBox="1"/>
+          <p:nvPr/>
+        </p:nvSpPr>
+        <p:spPr>
+          <a:xfrm>
+            <a:off x="7360920" y="3610051"/>
+            <a:ext cx="1463040" cy="173736"/>
           </a:xfrm>
           <a:prstGeom prst="rect">
             <a:avLst/>
@@ -11801,35 +11894,35 @@
           <a:p>
             <a:pPr algn="r"/>
             <a:r>
-              <a:rPr sz="1000" b="1">
-                <a:solidFill>
-                  <a:srgbClr val="FF6666"/>
+              <a:rPr sz="1000" b="0" i="1">
+                <a:solidFill>
+                  <a:srgbClr val="888888"/>
                 </a:solidFill>
                 <a:latin typeface="Calibri"/>
               </a:rPr>
-              <a:t>−$1,443,882</a:t>
-            </a:r>
-          </a:p>
-        </p:txBody>
-      </p:sp>
-      <p:sp>
-        <p:nvSpPr>
-          <p:cNvPr id="52" name="TextBox 51"/>
-          <p:cNvSpPr txBox="1"/>
-          <p:nvPr/>
-        </p:nvSpPr>
-        <p:spPr>
-          <a:xfrm>
-            <a:off x="4517136" y="2720340"/>
-            <a:ext cx="4224528" cy="160020"/>
-          </a:xfrm>
-          <a:prstGeom prst="rect">
-            <a:avLst/>
-          </a:prstGeom>
-          <a:noFill/>
-        </p:spPr>
-        <p:txBody>
-          <a:bodyPr wrap="square">
+              <a:t>pending reconciliation</a:t>
+            </a:r>
+          </a:p>
+        </p:txBody>
+      </p:sp>
+      <p:sp>
+        <p:nvSpPr>
+          <p:cNvPr id="57" name="TextBox 56"/>
+          <p:cNvSpPr txBox="1"/>
+          <p:nvPr/>
+        </p:nvSpPr>
+        <p:spPr>
+          <a:xfrm>
+            <a:off x="292608" y="3802075"/>
+            <a:ext cx="2926080" cy="160020"/>
+          </a:xfrm>
+          <a:prstGeom prst="rect">
+            <a:avLst/>
+          </a:prstGeom>
+          <a:noFill/>
+        </p:spPr>
+        <p:txBody>
+          <a:bodyPr wrap="none">
             <a:spAutoFit/>
           </a:bodyPr>
           <a:lstStyle/>
@@ -11842,77 +11935,855 @@
                 </a:solidFill>
                 <a:latin typeface="Calibri"/>
               </a:rPr>
-              <a:t>Exos loan reconciled: $60K→$31.2K (11% int.); records match. $30K prior loan→5,464 shares (incl. in $790K paid-in).</a:t>
-            </a:r>
-          </a:p>
-        </p:txBody>
-      </p:sp>
-      <p:sp>
-        <p:nvSpPr>
-          <p:cNvPr id="53" name="TextBox 52"/>
-          <p:cNvSpPr txBox="1"/>
-          <p:nvPr/>
-        </p:nvSpPr>
-        <p:spPr>
-          <a:xfrm>
-            <a:off x="4517136" y="2875788"/>
-            <a:ext cx="4224528" cy="242316"/>
-          </a:xfrm>
-          <a:prstGeom prst="rect">
-            <a:avLst/>
-          </a:prstGeom>
-          <a:noFill/>
-        </p:spPr>
-        <p:txBody>
-          <a:bodyPr wrap="square">
+              <a:t>Line item</a:t>
+            </a:r>
+          </a:p>
+        </p:txBody>
+      </p:sp>
+      <p:sp>
+        <p:nvSpPr>
+          <p:cNvPr id="58" name="TextBox 57"/>
+          <p:cNvSpPr txBox="1"/>
+          <p:nvPr/>
+        </p:nvSpPr>
+        <p:spPr>
+          <a:xfrm>
+            <a:off x="3310128" y="3802075"/>
+            <a:ext cx="1170432" cy="160020"/>
+          </a:xfrm>
+          <a:prstGeom prst="rect">
+            <a:avLst/>
+          </a:prstGeom>
+          <a:noFill/>
+        </p:spPr>
+        <p:txBody>
+          <a:bodyPr wrap="none">
             <a:spAutoFit/>
           </a:bodyPr>
           <a:lstStyle/>
           <a:p>
-            <a:pPr algn="l"/>
-            <a:r>
-              <a:rPr sz="1000" b="0" i="1">
-                <a:solidFill>
-                  <a:srgbClr val="888888"/>
+            <a:pPr algn="r"/>
+            <a:r>
+              <a:rPr sz="1000" b="1" i="0">
+                <a:solidFill>
+                  <a:srgbClr val="CCCCCC"/>
                 </a:solidFill>
                 <a:latin typeface="Calibri"/>
               </a:rPr>
-              <a:t/>
-            </a:r>
-          </a:p>
-        </p:txBody>
-      </p:sp>
-      <p:sp>
-        <p:nvSpPr>
-          <p:cNvPr id="54" name="TextBox 53"/>
-          <p:cNvSpPr txBox="1"/>
-          <p:nvPr/>
-        </p:nvSpPr>
-        <p:spPr>
-          <a:xfrm>
-            <a:off x="4517136" y="3122676"/>
-            <a:ext cx="4224528" cy="155448"/>
-          </a:xfrm>
-          <a:prstGeom prst="rect">
-            <a:avLst/>
-          </a:prstGeom>
-          <a:noFill/>
-        </p:spPr>
-        <p:txBody>
-          <a:bodyPr wrap="square">
+              <a:t>As booked</a:t>
+            </a:r>
+          </a:p>
+        </p:txBody>
+      </p:sp>
+      <p:sp>
+        <p:nvSpPr>
+          <p:cNvPr id="59" name="TextBox 58"/>
+          <p:cNvSpPr txBox="1"/>
+          <p:nvPr/>
+        </p:nvSpPr>
+        <p:spPr>
+          <a:xfrm>
+            <a:off x="4572000" y="3802075"/>
+            <a:ext cx="1143000" cy="160020"/>
+          </a:xfrm>
+          <a:prstGeom prst="rect">
+            <a:avLst/>
+          </a:prstGeom>
+          <a:noFill/>
+        </p:spPr>
+        <p:txBody>
+          <a:bodyPr wrap="none">
             <a:spAutoFit/>
           </a:bodyPr>
           <a:lstStyle/>
           <a:p>
+            <a:pPr algn="r"/>
+            <a:r>
+              <a:rPr sz="1000" b="1" i="0">
+                <a:solidFill>
+                  <a:srgbClr val="CCCCCC"/>
+                </a:solidFill>
+                <a:latin typeface="Calibri"/>
+              </a:rPr>
+              <a:t>Adjusted</a:t>
+            </a:r>
+          </a:p>
+        </p:txBody>
+      </p:sp>
+      <p:sp>
+        <p:nvSpPr>
+          <p:cNvPr id="60" name="TextBox 59"/>
+          <p:cNvSpPr txBox="1"/>
+          <p:nvPr/>
+        </p:nvSpPr>
+        <p:spPr>
+          <a:xfrm>
+            <a:off x="5806440" y="3802075"/>
+            <a:ext cx="2980944" cy="160020"/>
+          </a:xfrm>
+          <a:prstGeom prst="rect">
+            <a:avLst/>
+          </a:prstGeom>
+          <a:noFill/>
+        </p:spPr>
+        <p:txBody>
+          <a:bodyPr wrap="none">
+            <a:spAutoFit/>
+          </a:bodyPr>
+          <a:lstStyle/>
+          <a:p>
             <a:pPr algn="l"/>
             <a:r>
+              <a:rPr sz="1000" b="1" i="0">
+                <a:solidFill>
+                  <a:srgbClr val="CCCCCC"/>
+                </a:solidFill>
+                <a:latin typeface="Calibri"/>
+              </a:rPr>
+              <a:t>Basis</a:t>
+            </a:r>
+          </a:p>
+        </p:txBody>
+      </p:sp>
+      <p:sp>
+        <p:nvSpPr>
+          <p:cNvPr id="61" name="Rectangle 60"/>
+          <p:cNvSpPr/>
+          <p:nvPr/>
+        </p:nvSpPr>
+        <p:spPr>
+          <a:xfrm>
+            <a:off x="201168" y="3962095"/>
+            <a:ext cx="8741664" cy="7315"/>
+          </a:xfrm>
+          <a:prstGeom prst="rect">
+            <a:avLst/>
+          </a:prstGeom>
+          <a:solidFill>
+            <a:srgbClr val="444444"/>
+          </a:solidFill>
+          <a:ln>
+            <a:noFill/>
+          </a:ln>
+        </p:spPr>
+        <p:style>
+          <a:lnRef idx="1">
+            <a:schemeClr val="accent1"/>
+          </a:lnRef>
+          <a:fillRef idx="3">
+            <a:schemeClr val="accent1"/>
+          </a:fillRef>
+          <a:effectRef idx="2">
+            <a:schemeClr val="accent1"/>
+          </a:effectRef>
+          <a:fontRef idx="minor">
+            <a:schemeClr val="lt1"/>
+          </a:fontRef>
+        </p:style>
+        <p:txBody>
+          <a:bodyPr rtlCol="0" anchor="ctr"/>
+          <a:lstStyle/>
+          <a:p>
+            <a:pPr algn="ctr"/>
+          </a:p>
+        </p:txBody>
+      </p:sp>
+      <p:sp>
+        <p:nvSpPr>
+          <p:cNvPr id="62" name="TextBox 61"/>
+          <p:cNvSpPr txBox="1"/>
+          <p:nvPr/>
+        </p:nvSpPr>
+        <p:spPr>
+          <a:xfrm>
+            <a:off x="4498848" y="3973068"/>
+            <a:ext cx="228600" cy="173736"/>
+          </a:xfrm>
+          <a:prstGeom prst="rect">
+            <a:avLst/>
+          </a:prstGeom>
+          <a:noFill/>
+        </p:spPr>
+        <p:txBody>
+          <a:bodyPr wrap="none">
+            <a:spAutoFit/>
+          </a:bodyPr>
+          <a:lstStyle/>
+          <a:p>
+            <a:pPr algn="ctr"/>
+            <a:r>
+              <a:rPr sz="1000" b="0" i="0">
+                <a:solidFill>
+                  <a:srgbClr val="888888"/>
+                </a:solidFill>
+                <a:latin typeface="Calibri"/>
+              </a:rPr>
+              <a:t>-&gt;</a:t>
+            </a:r>
+          </a:p>
+        </p:txBody>
+      </p:sp>
+      <p:sp>
+        <p:nvSpPr>
+          <p:cNvPr id="63" name="TextBox 62"/>
+          <p:cNvSpPr txBox="1"/>
+          <p:nvPr/>
+        </p:nvSpPr>
+        <p:spPr>
+          <a:xfrm>
+            <a:off x="4498848" y="4165091"/>
+            <a:ext cx="228600" cy="173736"/>
+          </a:xfrm>
+          <a:prstGeom prst="rect">
+            <a:avLst/>
+          </a:prstGeom>
+          <a:noFill/>
+        </p:spPr>
+        <p:txBody>
+          <a:bodyPr wrap="none">
+            <a:spAutoFit/>
+          </a:bodyPr>
+          <a:lstStyle/>
+          <a:p>
+            <a:pPr algn="ctr"/>
+            <a:r>
+              <a:rPr sz="1000" b="0" i="0">
+                <a:solidFill>
+                  <a:srgbClr val="888888"/>
+                </a:solidFill>
+                <a:latin typeface="Calibri"/>
+              </a:rPr>
+              <a:t>-&gt;</a:t>
+            </a:r>
+          </a:p>
+        </p:txBody>
+      </p:sp>
+      <p:sp>
+        <p:nvSpPr>
+          <p:cNvPr id="64" name="TextBox 63"/>
+          <p:cNvSpPr txBox="1"/>
+          <p:nvPr/>
+        </p:nvSpPr>
+        <p:spPr>
+          <a:xfrm>
+            <a:off x="4498848" y="4357116"/>
+            <a:ext cx="228600" cy="173736"/>
+          </a:xfrm>
+          <a:prstGeom prst="rect">
+            <a:avLst/>
+          </a:prstGeom>
+          <a:noFill/>
+        </p:spPr>
+        <p:txBody>
+          <a:bodyPr wrap="none">
+            <a:spAutoFit/>
+          </a:bodyPr>
+          <a:lstStyle/>
+          <a:p>
+            <a:pPr algn="ctr"/>
+            <a:r>
+              <a:rPr sz="1000" b="0" i="0">
+                <a:solidFill>
+                  <a:srgbClr val="888888"/>
+                </a:solidFill>
+                <a:latin typeface="Calibri"/>
+              </a:rPr>
+              <a:t>-&gt;</a:t>
+            </a:r>
+          </a:p>
+        </p:txBody>
+      </p:sp>
+      <p:sp>
+        <p:nvSpPr>
+          <p:cNvPr id="65" name="TextBox 64"/>
+          <p:cNvSpPr txBox="1"/>
+          <p:nvPr/>
+        </p:nvSpPr>
+        <p:spPr>
+          <a:xfrm>
+            <a:off x="4498848" y="4549140"/>
+            <a:ext cx="228600" cy="173736"/>
+          </a:xfrm>
+          <a:prstGeom prst="rect">
+            <a:avLst/>
+          </a:prstGeom>
+          <a:noFill/>
+        </p:spPr>
+        <p:txBody>
+          <a:bodyPr wrap="none">
+            <a:spAutoFit/>
+          </a:bodyPr>
+          <a:lstStyle/>
+          <a:p>
+            <a:pPr algn="ctr"/>
+            <a:r>
+              <a:rPr sz="1000" b="0" i="0">
+                <a:solidFill>
+                  <a:srgbClr val="888888"/>
+                </a:solidFill>
+                <a:latin typeface="Calibri"/>
+              </a:rPr>
+              <a:t>-&gt;</a:t>
+            </a:r>
+          </a:p>
+        </p:txBody>
+      </p:sp>
+      <p:sp>
+        <p:nvSpPr>
+          <p:cNvPr id="66" name="TextBox 65"/>
+          <p:cNvSpPr txBox="1"/>
+          <p:nvPr/>
+        </p:nvSpPr>
+        <p:spPr>
+          <a:xfrm>
+            <a:off x="292608" y="3973068"/>
+            <a:ext cx="2926080" cy="182880"/>
+          </a:xfrm>
+          <a:prstGeom prst="rect">
+            <a:avLst/>
+          </a:prstGeom>
+          <a:noFill/>
+        </p:spPr>
+        <p:txBody>
+          <a:bodyPr wrap="none">
+            <a:spAutoFit/>
+          </a:bodyPr>
+          <a:lstStyle/>
+          <a:p>
+            <a:pPr algn="l"/>
+            <a:r>
+              <a:rPr sz="1000" b="1" i="0">
+                <a:solidFill>
+                  <a:srgbClr val="FFCC44"/>
+                </a:solidFill>
+                <a:latin typeface="Calibri"/>
+              </a:rPr>
+              <a:t>Due to Microcosm</a:t>
+            </a:r>
+          </a:p>
+        </p:txBody>
+      </p:sp>
+      <p:sp>
+        <p:nvSpPr>
+          <p:cNvPr id="67" name="TextBox 66"/>
+          <p:cNvSpPr txBox="1"/>
+          <p:nvPr/>
+        </p:nvSpPr>
+        <p:spPr>
+          <a:xfrm>
+            <a:off x="3310128" y="3973068"/>
+            <a:ext cx="1170432" cy="182880"/>
+          </a:xfrm>
+          <a:prstGeom prst="rect">
+            <a:avLst/>
+          </a:prstGeom>
+          <a:noFill/>
+        </p:spPr>
+        <p:txBody>
+          <a:bodyPr wrap="none">
+            <a:spAutoFit/>
+          </a:bodyPr>
+          <a:lstStyle/>
+          <a:p>
+            <a:pPr algn="r"/>
+            <a:r>
+              <a:rPr sz="1000" b="0" i="0">
+                <a:solidFill>
+                  <a:srgbClr val="888888"/>
+                </a:solidFill>
+                <a:latin typeface="Calibri"/>
+              </a:rPr>
+              <a:t>$451K</a:t>
+            </a:r>
+          </a:p>
+        </p:txBody>
+      </p:sp>
+      <p:sp>
+        <p:nvSpPr>
+          <p:cNvPr id="68" name="TextBox 67"/>
+          <p:cNvSpPr txBox="1"/>
+          <p:nvPr/>
+        </p:nvSpPr>
+        <p:spPr>
+          <a:xfrm>
+            <a:off x="4572000" y="3973068"/>
+            <a:ext cx="1143000" cy="182880"/>
+          </a:xfrm>
+          <a:prstGeom prst="rect">
+            <a:avLst/>
+          </a:prstGeom>
+          <a:noFill/>
+        </p:spPr>
+        <p:txBody>
+          <a:bodyPr wrap="none">
+            <a:spAutoFit/>
+          </a:bodyPr>
+          <a:lstStyle/>
+          <a:p>
+            <a:pPr algn="r"/>
+            <a:r>
+              <a:rPr sz="1000" b="1" i="0">
+                <a:solidFill>
+                  <a:srgbClr val="44BB44"/>
+                </a:solidFill>
+                <a:latin typeface="Calibri"/>
+              </a:rPr>
+              <a:t>~$100K</a:t>
+            </a:r>
+          </a:p>
+        </p:txBody>
+      </p:sp>
+      <p:sp>
+        <p:nvSpPr>
+          <p:cNvPr id="69" name="TextBox 68"/>
+          <p:cNvSpPr txBox="1"/>
+          <p:nvPr/>
+        </p:nvSpPr>
+        <p:spPr>
+          <a:xfrm>
+            <a:off x="5806440" y="3973068"/>
+            <a:ext cx="2980944" cy="182880"/>
+          </a:xfrm>
+          <a:prstGeom prst="rect">
+            <a:avLst/>
+          </a:prstGeom>
+          <a:noFill/>
+        </p:spPr>
+        <p:txBody>
+          <a:bodyPr wrap="none">
+            <a:spAutoFit/>
+          </a:bodyPr>
+          <a:lstStyle/>
+          <a:p>
+            <a:pPr algn="l"/>
+            <a:r>
               <a:rPr sz="1000" b="0" i="1">
                 <a:solidFill>
+                  <a:srgbClr val="CCCCCC"/>
+                </a:solidFill>
+                <a:latin typeface="Calibri"/>
+              </a:rPr>
+              <a:t>Rent+util credit ~$351K (Jul '24-Aug '26)</a:t>
+            </a:r>
+          </a:p>
+        </p:txBody>
+      </p:sp>
+      <p:sp>
+        <p:nvSpPr>
+          <p:cNvPr id="70" name="TextBox 69"/>
+          <p:cNvSpPr txBox="1"/>
+          <p:nvPr/>
+        </p:nvSpPr>
+        <p:spPr>
+          <a:xfrm>
+            <a:off x="292608" y="4165091"/>
+            <a:ext cx="2926080" cy="182880"/>
+          </a:xfrm>
+          <a:prstGeom prst="rect">
+            <a:avLst/>
+          </a:prstGeom>
+          <a:noFill/>
+        </p:spPr>
+        <p:txBody>
+          <a:bodyPr wrap="none">
+            <a:spAutoFit/>
+          </a:bodyPr>
+          <a:lstStyle/>
+          <a:p>
+            <a:pPr algn="l"/>
+            <a:r>
+              <a:rPr sz="1000" b="0" i="0">
+                <a:solidFill>
+                  <a:srgbClr val="FFFFFF"/>
+                </a:solidFill>
+                <a:latin typeface="Calibri"/>
+              </a:rPr>
+              <a:t>Bookstore note</a:t>
+            </a:r>
+          </a:p>
+        </p:txBody>
+      </p:sp>
+      <p:sp>
+        <p:nvSpPr>
+          <p:cNvPr id="71" name="TextBox 70"/>
+          <p:cNvSpPr txBox="1"/>
+          <p:nvPr/>
+        </p:nvSpPr>
+        <p:spPr>
+          <a:xfrm>
+            <a:off x="3310128" y="4165091"/>
+            <a:ext cx="1170432" cy="182880"/>
+          </a:xfrm>
+          <a:prstGeom prst="rect">
+            <a:avLst/>
+          </a:prstGeom>
+          <a:noFill/>
+        </p:spPr>
+        <p:txBody>
+          <a:bodyPr wrap="none">
+            <a:spAutoFit/>
+          </a:bodyPr>
+          <a:lstStyle/>
+          <a:p>
+            <a:pPr algn="r"/>
+            <a:r>
+              <a:rPr sz="1000" b="0" i="0">
+                <a:solidFill>
                   <a:srgbClr val="888888"/>
                 </a:solidFill>
                 <a:latin typeface="Calibri"/>
               </a:rPr>
-              <a:t/>
+              <a:t>$321K</a:t>
+            </a:r>
+          </a:p>
+        </p:txBody>
+      </p:sp>
+      <p:sp>
+        <p:nvSpPr>
+          <p:cNvPr id="72" name="TextBox 71"/>
+          <p:cNvSpPr txBox="1"/>
+          <p:nvPr/>
+        </p:nvSpPr>
+        <p:spPr>
+          <a:xfrm>
+            <a:off x="4572000" y="4165091"/>
+            <a:ext cx="1143000" cy="182880"/>
+          </a:xfrm>
+          <a:prstGeom prst="rect">
+            <a:avLst/>
+          </a:prstGeom>
+          <a:noFill/>
+        </p:spPr>
+        <p:txBody>
+          <a:bodyPr wrap="none">
+            <a:spAutoFit/>
+          </a:bodyPr>
+          <a:lstStyle/>
+          <a:p>
+            <a:pPr algn="r"/>
+            <a:r>
+              <a:rPr sz="1000" b="0" i="0">
+                <a:solidFill>
+                  <a:srgbClr val="CCCCCC"/>
+                </a:solidFill>
+                <a:latin typeface="Calibri"/>
+              </a:rPr>
+              <a:t>$224K</a:t>
+            </a:r>
+          </a:p>
+        </p:txBody>
+      </p:sp>
+      <p:sp>
+        <p:nvSpPr>
+          <p:cNvPr id="73" name="TextBox 72"/>
+          <p:cNvSpPr txBox="1"/>
+          <p:nvPr/>
+        </p:nvSpPr>
+        <p:spPr>
+          <a:xfrm>
+            <a:off x="5806440" y="4165091"/>
+            <a:ext cx="2980944" cy="182880"/>
+          </a:xfrm>
+          <a:prstGeom prst="rect">
+            <a:avLst/>
+          </a:prstGeom>
+          <a:noFill/>
+        </p:spPr>
+        <p:txBody>
+          <a:bodyPr wrap="none">
+            <a:spAutoFit/>
+          </a:bodyPr>
+          <a:lstStyle/>
+          <a:p>
+            <a:pPr algn="l"/>
+            <a:r>
+              <a:rPr sz="1000" b="0" i="1">
+                <a:solidFill>
+                  <a:srgbClr val="CCCCCC"/>
+                </a:solidFill>
+                <a:latin typeface="Calibri"/>
+              </a:rPr>
+              <a:t>$97K interest capitalized 4/30/2026</a:t>
+            </a:r>
+          </a:p>
+        </p:txBody>
+      </p:sp>
+      <p:sp>
+        <p:nvSpPr>
+          <p:cNvPr id="74" name="TextBox 73"/>
+          <p:cNvSpPr txBox="1"/>
+          <p:nvPr/>
+        </p:nvSpPr>
+        <p:spPr>
+          <a:xfrm>
+            <a:off x="292608" y="4357116"/>
+            <a:ext cx="2926080" cy="182880"/>
+          </a:xfrm>
+          <a:prstGeom prst="rect">
+            <a:avLst/>
+          </a:prstGeom>
+          <a:noFill/>
+        </p:spPr>
+        <p:txBody>
+          <a:bodyPr wrap="none">
+            <a:spAutoFit/>
+          </a:bodyPr>
+          <a:lstStyle/>
+          <a:p>
+            <a:pPr algn="l"/>
+            <a:r>
+              <a:rPr sz="1000" b="0" i="0">
+                <a:solidFill>
+                  <a:srgbClr val="FFFFFF"/>
+                </a:solidFill>
+                <a:latin typeface="Calibri"/>
+              </a:rPr>
+              <a:t>Billed ahead (est.)</a:t>
+            </a:r>
+          </a:p>
+        </p:txBody>
+      </p:sp>
+      <p:sp>
+        <p:nvSpPr>
+          <p:cNvPr id="75" name="TextBox 74"/>
+          <p:cNvSpPr txBox="1"/>
+          <p:nvPr/>
+        </p:nvSpPr>
+        <p:spPr>
+          <a:xfrm>
+            <a:off x="3310128" y="4357116"/>
+            <a:ext cx="1170432" cy="182880"/>
+          </a:xfrm>
+          <a:prstGeom prst="rect">
+            <a:avLst/>
+          </a:prstGeom>
+          <a:noFill/>
+        </p:spPr>
+        <p:txBody>
+          <a:bodyPr wrap="none">
+            <a:spAutoFit/>
+          </a:bodyPr>
+          <a:lstStyle/>
+          <a:p>
+            <a:pPr algn="r"/>
+            <a:r>
+              <a:rPr sz="1000" b="0" i="0">
+                <a:solidFill>
+                  <a:srgbClr val="888888"/>
+                </a:solidFill>
+                <a:latin typeface="Calibri"/>
+              </a:rPr>
+              <a:t>$942K</a:t>
+            </a:r>
+          </a:p>
+        </p:txBody>
+      </p:sp>
+      <p:sp>
+        <p:nvSpPr>
+          <p:cNvPr id="76" name="TextBox 75"/>
+          <p:cNvSpPr txBox="1"/>
+          <p:nvPr/>
+        </p:nvSpPr>
+        <p:spPr>
+          <a:xfrm>
+            <a:off x="4572000" y="4357116"/>
+            <a:ext cx="1143000" cy="182880"/>
+          </a:xfrm>
+          <a:prstGeom prst="rect">
+            <a:avLst/>
+          </a:prstGeom>
+          <a:noFill/>
+        </p:spPr>
+        <p:txBody>
+          <a:bodyPr wrap="none">
+            <a:spAutoFit/>
+          </a:bodyPr>
+          <a:lstStyle/>
+          <a:p>
+            <a:pPr algn="r"/>
+            <a:r>
+              <a:rPr sz="1000" b="0" i="0">
+                <a:solidFill>
+                  <a:srgbClr val="CCCCCC"/>
+                </a:solidFill>
+                <a:latin typeface="Calibri"/>
+              </a:rPr>
+              <a:t>~$100-250K</a:t>
+            </a:r>
+          </a:p>
+        </p:txBody>
+      </p:sp>
+      <p:sp>
+        <p:nvSpPr>
+          <p:cNvPr id="77" name="TextBox 76"/>
+          <p:cNvSpPr txBox="1"/>
+          <p:nvPr/>
+        </p:nvSpPr>
+        <p:spPr>
+          <a:xfrm>
+            <a:off x="5806440" y="4357116"/>
+            <a:ext cx="2980944" cy="182880"/>
+          </a:xfrm>
+          <a:prstGeom prst="rect">
+            <a:avLst/>
+          </a:prstGeom>
+          <a:noFill/>
+        </p:spPr>
+        <p:txBody>
+          <a:bodyPr wrap="none">
+            <a:spAutoFit/>
+          </a:bodyPr>
+          <a:lstStyle/>
+          <a:p>
+            <a:pPr algn="l"/>
+            <a:r>
+              <a:rPr sz="1000" b="0" i="1">
+                <a:solidFill>
+                  <a:srgbClr val="CCCCCC"/>
+                </a:solidFill>
+                <a:latin typeface="Calibri"/>
+              </a:rPr>
+              <a:t>Start-billings uncleared at ship (Motion 3)</a:t>
+            </a:r>
+          </a:p>
+        </p:txBody>
+      </p:sp>
+      <p:sp>
+        <p:nvSpPr>
+          <p:cNvPr id="78" name="TextBox 77"/>
+          <p:cNvSpPr txBox="1"/>
+          <p:nvPr/>
+        </p:nvSpPr>
+        <p:spPr>
+          <a:xfrm>
+            <a:off x="292608" y="4549140"/>
+            <a:ext cx="2926080" cy="182880"/>
+          </a:xfrm>
+          <a:prstGeom prst="rect">
+            <a:avLst/>
+          </a:prstGeom>
+          <a:noFill/>
+        </p:spPr>
+        <p:txBody>
+          <a:bodyPr wrap="none">
+            <a:spAutoFit/>
+          </a:bodyPr>
+          <a:lstStyle/>
+          <a:p>
+            <a:pPr algn="l"/>
+            <a:r>
+              <a:rPr sz="1000" b="1" i="0">
+                <a:solidFill>
+                  <a:srgbClr val="FFCC44"/>
+                </a:solidFill>
+                <a:latin typeface="Calibri"/>
+              </a:rPr>
+              <a:t>Total equity</a:t>
+            </a:r>
+          </a:p>
+        </p:txBody>
+      </p:sp>
+      <p:sp>
+        <p:nvSpPr>
+          <p:cNvPr id="79" name="TextBox 78"/>
+          <p:cNvSpPr txBox="1"/>
+          <p:nvPr/>
+        </p:nvSpPr>
+        <p:spPr>
+          <a:xfrm>
+            <a:off x="3310128" y="4549140"/>
+            <a:ext cx="1170432" cy="182880"/>
+          </a:xfrm>
+          <a:prstGeom prst="rect">
+            <a:avLst/>
+          </a:prstGeom>
+          <a:noFill/>
+        </p:spPr>
+        <p:txBody>
+          <a:bodyPr wrap="none">
+            <a:spAutoFit/>
+          </a:bodyPr>
+          <a:lstStyle/>
+          <a:p>
+            <a:pPr algn="r"/>
+            <a:r>
+              <a:rPr sz="1000" b="0" i="0">
+                <a:solidFill>
+                  <a:srgbClr val="888888"/>
+                </a:solidFill>
+                <a:latin typeface="Calibri"/>
+              </a:rPr>
+              <a:t>-$1.44M</a:t>
+            </a:r>
+          </a:p>
+        </p:txBody>
+      </p:sp>
+      <p:sp>
+        <p:nvSpPr>
+          <p:cNvPr id="80" name="TextBox 79"/>
+          <p:cNvSpPr txBox="1"/>
+          <p:nvPr/>
+        </p:nvSpPr>
+        <p:spPr>
+          <a:xfrm>
+            <a:off x="4572000" y="4549140"/>
+            <a:ext cx="1143000" cy="182880"/>
+          </a:xfrm>
+          <a:prstGeom prst="rect">
+            <a:avLst/>
+          </a:prstGeom>
+          <a:noFill/>
+        </p:spPr>
+        <p:txBody>
+          <a:bodyPr wrap="none">
+            <a:spAutoFit/>
+          </a:bodyPr>
+          <a:lstStyle/>
+          <a:p>
+            <a:pPr algn="r"/>
+            <a:r>
+              <a:rPr sz="1000" b="1" i="0">
+                <a:solidFill>
+                  <a:srgbClr val="44BB44"/>
+                </a:solidFill>
+                <a:latin typeface="Calibri"/>
+              </a:rPr>
+              <a:t>~-$1.09M+</a:t>
+            </a:r>
+          </a:p>
+        </p:txBody>
+      </p:sp>
+      <p:sp>
+        <p:nvSpPr>
+          <p:cNvPr id="81" name="TextBox 80"/>
+          <p:cNvSpPr txBox="1"/>
+          <p:nvPr/>
+        </p:nvSpPr>
+        <p:spPr>
+          <a:xfrm>
+            <a:off x="5806440" y="4549140"/>
+            <a:ext cx="2980944" cy="182880"/>
+          </a:xfrm>
+          <a:prstGeom prst="rect">
+            <a:avLst/>
+          </a:prstGeom>
+          <a:noFill/>
+        </p:spPr>
+        <p:txBody>
+          <a:bodyPr wrap="none">
+            <a:spAutoFit/>
+          </a:bodyPr>
+          <a:lstStyle/>
+          <a:p>
+            <a:pPr algn="l"/>
+            <a:r>
+              <a:rPr sz="1000" b="0" i="1">
+                <a:solidFill>
+                  <a:srgbClr val="CCCCCC"/>
+                </a:solidFill>
+                <a:latin typeface="Calibri"/>
+              </a:rPr>
+              <a:t>Credit alone; more if billed-ahead corrected</a:t>
             </a:r>
           </a:p>
         </p:txBody>

</xml_diff>

<commit_message>
SSLC deck batch6: Conger shareholder value slide (slide 6); 16 slides, package 24pp
</commit_message>
<xml_diff>
--- a/drafts/Exos_SSLC_Board_Offer_Overview_2026-10-10_r2.pptx
+++ b/drafts/Exos_SSLC_Board_Offer_Overview_2026-10-10_r2.pptx
@@ -10,6 +10,7 @@
     <p:sldId id="258" r:id="rId4"/>
     <p:sldId id="266" r:id="rId17"/>
     <p:sldId id="269" r:id="rId20"/>
+    <p:sldId id="271" r:id="rId22"/>
     <p:sldId id="259" r:id="rId5"/>
     <p:sldId id="260" r:id="rId6"/>
     <p:sldId id="261" r:id="rId7"/>
@@ -9996,6 +9997,2458 @@
 </p:sld>
 </file>
 
+<file path=ppt/slides/slide16.xml><?xml version="1.0" encoding="utf-8"?>
+<p:sld xmlns:a="http://schemas.openxmlformats.org/drawingml/2006/main" xmlns:p="http://schemas.openxmlformats.org/presentationml/2006/main" xmlns:r="http://schemas.openxmlformats.org/officeDocument/2006/relationships">
+  <p:cSld>
+    <p:spTree>
+      <p:nvGrpSpPr>
+        <p:cNvPr id="1" name=""/>
+        <p:cNvGrpSpPr/>
+        <p:nvPr/>
+      </p:nvGrpSpPr>
+      <p:grpSpPr/>
+      <p:sp>
+        <p:nvSpPr>
+          <p:cNvPr id="2" name="Rectangle 1"/>
+          <p:cNvSpPr/>
+          <p:nvPr/>
+        </p:nvSpPr>
+        <p:spPr>
+          <a:xfrm>
+            <a:off x="0" y="0"/>
+            <a:ext cx="9144000" cy="5143500"/>
+          </a:xfrm>
+          <a:prstGeom prst="rect">
+            <a:avLst/>
+          </a:prstGeom>
+          <a:solidFill>
+            <a:srgbClr val="111111"/>
+          </a:solidFill>
+          <a:ln>
+            <a:noFill/>
+          </a:ln>
+        </p:spPr>
+        <p:style>
+          <a:lnRef idx="1">
+            <a:schemeClr val="accent1"/>
+          </a:lnRef>
+          <a:fillRef idx="3">
+            <a:schemeClr val="accent1"/>
+          </a:fillRef>
+          <a:effectRef idx="2">
+            <a:schemeClr val="accent1"/>
+          </a:effectRef>
+          <a:fontRef idx="minor">
+            <a:schemeClr val="lt1"/>
+          </a:fontRef>
+        </p:style>
+        <p:txBody>
+          <a:bodyPr rtlCol="0" anchor="ctr"/>
+          <a:lstStyle/>
+          <a:p>
+            <a:pPr algn="ctr"/>
+          </a:p>
+        </p:txBody>
+      </p:sp>
+      <p:sp>
+        <p:nvSpPr>
+          <p:cNvPr id="3" name="Rectangle 2"/>
+          <p:cNvSpPr/>
+          <p:nvPr/>
+        </p:nvSpPr>
+        <p:spPr>
+          <a:xfrm>
+            <a:off x="0" y="0"/>
+            <a:ext cx="9144000" cy="50292"/>
+          </a:xfrm>
+          <a:prstGeom prst="rect">
+            <a:avLst/>
+          </a:prstGeom>
+          <a:solidFill>
+            <a:srgbClr val="F26A21"/>
+          </a:solidFill>
+          <a:ln>
+            <a:noFill/>
+          </a:ln>
+        </p:spPr>
+        <p:style>
+          <a:lnRef idx="1">
+            <a:schemeClr val="accent1"/>
+          </a:lnRef>
+          <a:fillRef idx="3">
+            <a:schemeClr val="accent1"/>
+          </a:fillRef>
+          <a:effectRef idx="2">
+            <a:schemeClr val="accent1"/>
+          </a:effectRef>
+          <a:fontRef idx="minor">
+            <a:schemeClr val="lt1"/>
+          </a:fontRef>
+        </p:style>
+        <p:txBody>
+          <a:bodyPr rtlCol="0" anchor="ctr"/>
+          <a:lstStyle/>
+          <a:p>
+            <a:pPr algn="ctr"/>
+          </a:p>
+        </p:txBody>
+      </p:sp>
+      <p:sp>
+        <p:nvSpPr>
+          <p:cNvPr id="4" name="Rectangle 3"/>
+          <p:cNvSpPr/>
+          <p:nvPr/>
+        </p:nvSpPr>
+        <p:spPr>
+          <a:xfrm>
+            <a:off x="0" y="50292"/>
+            <a:ext cx="9144000" cy="457200"/>
+          </a:xfrm>
+          <a:prstGeom prst="rect">
+            <a:avLst/>
+          </a:prstGeom>
+          <a:solidFill>
+            <a:srgbClr val="1E1E1E"/>
+          </a:solidFill>
+          <a:ln>
+            <a:noFill/>
+          </a:ln>
+        </p:spPr>
+        <p:style>
+          <a:lnRef idx="1">
+            <a:schemeClr val="accent1"/>
+          </a:lnRef>
+          <a:fillRef idx="3">
+            <a:schemeClr val="accent1"/>
+          </a:fillRef>
+          <a:effectRef idx="2">
+            <a:schemeClr val="accent1"/>
+          </a:effectRef>
+          <a:fontRef idx="minor">
+            <a:schemeClr val="lt1"/>
+          </a:fontRef>
+        </p:style>
+        <p:txBody>
+          <a:bodyPr rtlCol="0" anchor="ctr"/>
+          <a:lstStyle/>
+          <a:p>
+            <a:pPr algn="ctr"/>
+          </a:p>
+        </p:txBody>
+      </p:sp>
+      <p:sp>
+        <p:nvSpPr>
+          <p:cNvPr id="5" name="TextBox 4"/>
+          <p:cNvSpPr txBox="1"/>
+          <p:nvPr/>
+        </p:nvSpPr>
+        <p:spPr>
+          <a:xfrm>
+            <a:off x="256032" y="73152"/>
+            <a:ext cx="8631936" cy="402336"/>
+          </a:xfrm>
+          <a:prstGeom prst="rect">
+            <a:avLst/>
+          </a:prstGeom>
+          <a:noFill/>
+        </p:spPr>
+        <p:txBody>
+          <a:bodyPr wrap="none">
+            <a:spAutoFit/>
+          </a:bodyPr>
+          <a:lstStyle/>
+          <a:p>
+            <a:pPr algn="l"/>
+            <a:r>
+              <a:rPr sz="1500" b="1" i="0">
+                <a:solidFill>
+                  <a:srgbClr val="FFFFFF"/>
+                </a:solidFill>
+                <a:latin typeface="Calibri"/>
+              </a:rPr>
+              <a:t>What SSLC Shareholders Get  (answering Bob Conger)</a:t>
+            </a:r>
+          </a:p>
+        </p:txBody>
+      </p:sp>
+      <p:sp>
+        <p:nvSpPr>
+          <p:cNvPr id="6" name="Rectangle 5"/>
+          <p:cNvSpPr/>
+          <p:nvPr/>
+        </p:nvSpPr>
+        <p:spPr>
+          <a:xfrm>
+            <a:off x="4617720" y="548640"/>
+            <a:ext cx="10972" cy="1783080"/>
+          </a:xfrm>
+          <a:prstGeom prst="rect">
+            <a:avLst/>
+          </a:prstGeom>
+          <a:solidFill>
+            <a:srgbClr val="444444"/>
+          </a:solidFill>
+          <a:ln>
+            <a:noFill/>
+          </a:ln>
+        </p:spPr>
+        <p:style>
+          <a:lnRef idx="1">
+            <a:schemeClr val="accent1"/>
+          </a:lnRef>
+          <a:fillRef idx="3">
+            <a:schemeClr val="accent1"/>
+          </a:fillRef>
+          <a:effectRef idx="2">
+            <a:schemeClr val="accent1"/>
+          </a:effectRef>
+          <a:fontRef idx="minor">
+            <a:schemeClr val="lt1"/>
+          </a:fontRef>
+        </p:style>
+        <p:txBody>
+          <a:bodyPr rtlCol="0" anchor="ctr"/>
+          <a:lstStyle/>
+          <a:p>
+            <a:pPr algn="ctr"/>
+          </a:p>
+        </p:txBody>
+      </p:sp>
+      <p:sp>
+        <p:nvSpPr>
+          <p:cNvPr id="7" name="TextBox 6"/>
+          <p:cNvSpPr txBox="1"/>
+          <p:nvPr/>
+        </p:nvSpPr>
+        <p:spPr>
+          <a:xfrm>
+            <a:off x="256032" y="566928"/>
+            <a:ext cx="4206240" cy="201168"/>
+          </a:xfrm>
+          <a:prstGeom prst="rect">
+            <a:avLst/>
+          </a:prstGeom>
+          <a:noFill/>
+        </p:spPr>
+        <p:txBody>
+          <a:bodyPr wrap="none">
+            <a:spAutoFit/>
+          </a:bodyPr>
+          <a:lstStyle/>
+          <a:p>
+            <a:pPr algn="l"/>
+            <a:r>
+              <a:rPr sz="1000" b="1" i="0">
+                <a:solidFill>
+                  <a:srgbClr val="F26A21"/>
+                </a:solidFill>
+                <a:latin typeface="Calibri"/>
+              </a:rPr>
+              <a:t>Value per 1% of SSLC  (= 8,725 shares; 1⁄82 of non-Exos pool)</a:t>
+            </a:r>
+          </a:p>
+        </p:txBody>
+      </p:sp>
+      <p:sp>
+        <p:nvSpPr>
+          <p:cNvPr id="8" name="TextBox 7"/>
+          <p:cNvSpPr txBox="1"/>
+          <p:nvPr/>
+        </p:nvSpPr>
+        <p:spPr>
+          <a:xfrm>
+            <a:off x="256032" y="795528"/>
+            <a:ext cx="2286000" cy="182880"/>
+          </a:xfrm>
+          <a:prstGeom prst="rect">
+            <a:avLst/>
+          </a:prstGeom>
+          <a:noFill/>
+        </p:spPr>
+        <p:txBody>
+          <a:bodyPr wrap="none">
+            <a:spAutoFit/>
+          </a:bodyPr>
+          <a:lstStyle/>
+          <a:p>
+            <a:pPr algn="l"/>
+            <a:r>
+              <a:rPr sz="1000" b="1" i="0">
+                <a:solidFill>
+                  <a:srgbClr val="CCCCCC"/>
+                </a:solidFill>
+                <a:latin typeface="Calibri"/>
+              </a:rPr>
+              <a:t>Scenario</a:t>
+            </a:r>
+          </a:p>
+        </p:txBody>
+      </p:sp>
+      <p:sp>
+        <p:nvSpPr>
+          <p:cNvPr id="9" name="TextBox 8"/>
+          <p:cNvSpPr txBox="1"/>
+          <p:nvPr/>
+        </p:nvSpPr>
+        <p:spPr>
+          <a:xfrm>
+            <a:off x="2606040" y="795528"/>
+            <a:ext cx="713232" cy="182880"/>
+          </a:xfrm>
+          <a:prstGeom prst="rect">
+            <a:avLst/>
+          </a:prstGeom>
+          <a:noFill/>
+        </p:spPr>
+        <p:txBody>
+          <a:bodyPr wrap="none">
+            <a:spAutoFit/>
+          </a:bodyPr>
+          <a:lstStyle/>
+          <a:p>
+            <a:pPr algn="r"/>
+            <a:r>
+              <a:rPr sz="1000" b="1" i="0">
+                <a:solidFill>
+                  <a:srgbClr val="F26A21"/>
+                </a:solidFill>
+                <a:latin typeface="Calibri"/>
+              </a:rPr>
+              <a:t>Low</a:t>
+            </a:r>
+          </a:p>
+        </p:txBody>
+      </p:sp>
+      <p:sp>
+        <p:nvSpPr>
+          <p:cNvPr id="10" name="TextBox 9"/>
+          <p:cNvSpPr txBox="1"/>
+          <p:nvPr/>
+        </p:nvSpPr>
+        <p:spPr>
+          <a:xfrm>
+            <a:off x="3383280" y="795528"/>
+            <a:ext cx="694944" cy="182880"/>
+          </a:xfrm>
+          <a:prstGeom prst="rect">
+            <a:avLst/>
+          </a:prstGeom>
+          <a:noFill/>
+        </p:spPr>
+        <p:txBody>
+          <a:bodyPr wrap="none">
+            <a:spAutoFit/>
+          </a:bodyPr>
+          <a:lstStyle/>
+          <a:p>
+            <a:pPr algn="r"/>
+            <a:r>
+              <a:rPr sz="1000" b="1" i="0">
+                <a:solidFill>
+                  <a:srgbClr val="F26A21"/>
+                </a:solidFill>
+                <a:latin typeface="Calibri"/>
+              </a:rPr>
+              <a:t>Base</a:t>
+            </a:r>
+          </a:p>
+        </p:txBody>
+      </p:sp>
+      <p:sp>
+        <p:nvSpPr>
+          <p:cNvPr id="11" name="TextBox 10"/>
+          <p:cNvSpPr txBox="1"/>
+          <p:nvPr/>
+        </p:nvSpPr>
+        <p:spPr>
+          <a:xfrm>
+            <a:off x="4133087" y="795528"/>
+            <a:ext cx="658368" cy="182880"/>
+          </a:xfrm>
+          <a:prstGeom prst="rect">
+            <a:avLst/>
+          </a:prstGeom>
+          <a:noFill/>
+        </p:spPr>
+        <p:txBody>
+          <a:bodyPr wrap="none">
+            <a:spAutoFit/>
+          </a:bodyPr>
+          <a:lstStyle/>
+          <a:p>
+            <a:pPr algn="r"/>
+            <a:r>
+              <a:rPr sz="1000" b="1" i="0">
+                <a:solidFill>
+                  <a:srgbClr val="F26A21"/>
+                </a:solidFill>
+                <a:latin typeface="Calibri"/>
+              </a:rPr>
+              <a:t>High</a:t>
+            </a:r>
+          </a:p>
+        </p:txBody>
+      </p:sp>
+      <p:sp>
+        <p:nvSpPr>
+          <p:cNvPr id="12" name="Rectangle 11"/>
+          <p:cNvSpPr/>
+          <p:nvPr/>
+        </p:nvSpPr>
+        <p:spPr>
+          <a:xfrm>
+            <a:off x="256032" y="987552"/>
+            <a:ext cx="4251960" cy="7315"/>
+          </a:xfrm>
+          <a:prstGeom prst="rect">
+            <a:avLst/>
+          </a:prstGeom>
+          <a:solidFill>
+            <a:srgbClr val="444444"/>
+          </a:solidFill>
+          <a:ln>
+            <a:noFill/>
+          </a:ln>
+        </p:spPr>
+        <p:style>
+          <a:lnRef idx="1">
+            <a:schemeClr val="accent1"/>
+          </a:lnRef>
+          <a:fillRef idx="3">
+            <a:schemeClr val="accent1"/>
+          </a:fillRef>
+          <a:effectRef idx="2">
+            <a:schemeClr val="accent1"/>
+          </a:effectRef>
+          <a:fontRef idx="minor">
+            <a:schemeClr val="lt1"/>
+          </a:fontRef>
+        </p:style>
+        <p:txBody>
+          <a:bodyPr rtlCol="0" anchor="ctr"/>
+          <a:lstStyle/>
+          <a:p>
+            <a:pPr algn="ctr"/>
+          </a:p>
+        </p:txBody>
+      </p:sp>
+      <p:sp>
+        <p:nvSpPr>
+          <p:cNvPr id="13" name="TextBox 12"/>
+          <p:cNvSpPr txBox="1"/>
+          <p:nvPr/>
+        </p:nvSpPr>
+        <p:spPr>
+          <a:xfrm>
+            <a:off x="256032" y="1005840"/>
+            <a:ext cx="2286000" cy="246888"/>
+          </a:xfrm>
+          <a:prstGeom prst="rect">
+            <a:avLst/>
+          </a:prstGeom>
+          <a:noFill/>
+        </p:spPr>
+        <p:txBody>
+          <a:bodyPr wrap="none">
+            <a:spAutoFit/>
+          </a:bodyPr>
+          <a:lstStyle/>
+          <a:p>
+            <a:pPr algn="l"/>
+            <a:r>
+              <a:rPr sz="1000" b="0" i="0">
+                <a:solidFill>
+                  <a:srgbClr val="FFFFFF"/>
+                </a:solidFill>
+                <a:latin typeface="Calibri"/>
+              </a:rPr>
+              <a:t>At close, cash only  (as booked)</a:t>
+            </a:r>
+          </a:p>
+        </p:txBody>
+      </p:sp>
+      <p:sp>
+        <p:nvSpPr>
+          <p:cNvPr id="14" name="TextBox 13"/>
+          <p:cNvSpPr txBox="1"/>
+          <p:nvPr/>
+        </p:nvSpPr>
+        <p:spPr>
+          <a:xfrm>
+            <a:off x="2606040" y="1005840"/>
+            <a:ext cx="713232" cy="246888"/>
+          </a:xfrm>
+          <a:prstGeom prst="rect">
+            <a:avLst/>
+          </a:prstGeom>
+          <a:noFill/>
+        </p:spPr>
+        <p:txBody>
+          <a:bodyPr wrap="none">
+            <a:spAutoFit/>
+          </a:bodyPr>
+          <a:lstStyle/>
+          <a:p>
+            <a:pPr algn="r"/>
+            <a:r>
+              <a:rPr sz="1000" b="0" i="0">
+                <a:solidFill>
+                  <a:srgbClr val="FFFFFF"/>
+                </a:solidFill>
+                <a:latin typeface="Calibri"/>
+              </a:rPr>
+              <a:t>$15.6K</a:t>
+            </a:r>
+          </a:p>
+        </p:txBody>
+      </p:sp>
+      <p:sp>
+        <p:nvSpPr>
+          <p:cNvPr id="15" name="TextBox 14"/>
+          <p:cNvSpPr txBox="1"/>
+          <p:nvPr/>
+        </p:nvSpPr>
+        <p:spPr>
+          <a:xfrm>
+            <a:off x="3383280" y="1005840"/>
+            <a:ext cx="694944" cy="246888"/>
+          </a:xfrm>
+          <a:prstGeom prst="rect">
+            <a:avLst/>
+          </a:prstGeom>
+          <a:noFill/>
+        </p:spPr>
+        <p:txBody>
+          <a:bodyPr wrap="none">
+            <a:spAutoFit/>
+          </a:bodyPr>
+          <a:lstStyle/>
+          <a:p>
+            <a:pPr algn="r"/>
+            <a:r>
+              <a:rPr sz="1000" b="1" i="0">
+                <a:solidFill>
+                  <a:srgbClr val="44BB44"/>
+                </a:solidFill>
+                <a:latin typeface="Calibri"/>
+              </a:rPr>
+              <a:t>$18.4K</a:t>
+            </a:r>
+          </a:p>
+        </p:txBody>
+      </p:sp>
+      <p:sp>
+        <p:nvSpPr>
+          <p:cNvPr id="16" name="TextBox 15"/>
+          <p:cNvSpPr txBox="1"/>
+          <p:nvPr/>
+        </p:nvSpPr>
+        <p:spPr>
+          <a:xfrm>
+            <a:off x="4133087" y="1005840"/>
+            <a:ext cx="658368" cy="246888"/>
+          </a:xfrm>
+          <a:prstGeom prst="rect">
+            <a:avLst/>
+          </a:prstGeom>
+          <a:noFill/>
+        </p:spPr>
+        <p:txBody>
+          <a:bodyPr wrap="none">
+            <a:spAutoFit/>
+          </a:bodyPr>
+          <a:lstStyle/>
+          <a:p>
+            <a:pPr algn="r"/>
+            <a:r>
+              <a:rPr sz="1000" b="0" i="0">
+                <a:solidFill>
+                  <a:srgbClr val="FFFFFF"/>
+                </a:solidFill>
+                <a:latin typeface="Calibri"/>
+              </a:rPr>
+              <a:t>$21.2K</a:t>
+            </a:r>
+          </a:p>
+        </p:txBody>
+      </p:sp>
+      <p:sp>
+        <p:nvSpPr>
+          <p:cNvPr id="17" name="TextBox 16"/>
+          <p:cNvSpPr txBox="1"/>
+          <p:nvPr/>
+        </p:nvSpPr>
+        <p:spPr>
+          <a:xfrm>
+            <a:off x="256032" y="1252728"/>
+            <a:ext cx="2286000" cy="246888"/>
+          </a:xfrm>
+          <a:prstGeom prst="rect">
+            <a:avLst/>
+          </a:prstGeom>
+          <a:noFill/>
+        </p:spPr>
+        <p:txBody>
+          <a:bodyPr wrap="none">
+            <a:spAutoFit/>
+          </a:bodyPr>
+          <a:lstStyle/>
+          <a:p>
+            <a:pPr algn="l"/>
+            <a:r>
+              <a:rPr sz="1000" b="0" i="0">
+                <a:solidFill>
+                  <a:srgbClr val="CCCCCC"/>
+                </a:solidFill>
+                <a:latin typeface="Calibri"/>
+              </a:rPr>
+              <a:t>At close, books corrected  (+$351K)</a:t>
+            </a:r>
+          </a:p>
+        </p:txBody>
+      </p:sp>
+      <p:sp>
+        <p:nvSpPr>
+          <p:cNvPr id="18" name="TextBox 17"/>
+          <p:cNvSpPr txBox="1"/>
+          <p:nvPr/>
+        </p:nvSpPr>
+        <p:spPr>
+          <a:xfrm>
+            <a:off x="2606040" y="1252728"/>
+            <a:ext cx="713232" cy="246888"/>
+          </a:xfrm>
+          <a:prstGeom prst="rect">
+            <a:avLst/>
+          </a:prstGeom>
+          <a:noFill/>
+        </p:spPr>
+        <p:txBody>
+          <a:bodyPr wrap="none">
+            <a:spAutoFit/>
+          </a:bodyPr>
+          <a:lstStyle/>
+          <a:p>
+            <a:pPr algn="r"/>
+            <a:r>
+              <a:rPr sz="1000" b="0" i="0">
+                <a:solidFill>
+                  <a:srgbClr val="CCCCCC"/>
+                </a:solidFill>
+                <a:latin typeface="Calibri"/>
+              </a:rPr>
+              <a:t>—</a:t>
+            </a:r>
+          </a:p>
+        </p:txBody>
+      </p:sp>
+      <p:sp>
+        <p:nvSpPr>
+          <p:cNvPr id="19" name="TextBox 18"/>
+          <p:cNvSpPr txBox="1"/>
+          <p:nvPr/>
+        </p:nvSpPr>
+        <p:spPr>
+          <a:xfrm>
+            <a:off x="3383280" y="1252728"/>
+            <a:ext cx="694944" cy="246888"/>
+          </a:xfrm>
+          <a:prstGeom prst="rect">
+            <a:avLst/>
+          </a:prstGeom>
+          <a:noFill/>
+        </p:spPr>
+        <p:txBody>
+          <a:bodyPr wrap="none">
+            <a:spAutoFit/>
+          </a:bodyPr>
+          <a:lstStyle/>
+          <a:p>
+            <a:pPr algn="r"/>
+            <a:r>
+              <a:rPr sz="1000" b="1" i="0">
+                <a:solidFill>
+                  <a:srgbClr val="FFCC44"/>
+                </a:solidFill>
+                <a:latin typeface="Calibri"/>
+              </a:rPr>
+              <a:t>$22.6K</a:t>
+            </a:r>
+          </a:p>
+        </p:txBody>
+      </p:sp>
+      <p:sp>
+        <p:nvSpPr>
+          <p:cNvPr id="20" name="TextBox 19"/>
+          <p:cNvSpPr txBox="1"/>
+          <p:nvPr/>
+        </p:nvSpPr>
+        <p:spPr>
+          <a:xfrm>
+            <a:off x="4133087" y="1252728"/>
+            <a:ext cx="658368" cy="246888"/>
+          </a:xfrm>
+          <a:prstGeom prst="rect">
+            <a:avLst/>
+          </a:prstGeom>
+          <a:noFill/>
+        </p:spPr>
+        <p:txBody>
+          <a:bodyPr wrap="none">
+            <a:spAutoFit/>
+          </a:bodyPr>
+          <a:lstStyle/>
+          <a:p>
+            <a:pPr algn="r"/>
+            <a:r>
+              <a:rPr sz="1000" b="0" i="0">
+                <a:solidFill>
+                  <a:srgbClr val="CCCCCC"/>
+                </a:solidFill>
+                <a:latin typeface="Calibri"/>
+              </a:rPr>
+              <a:t>—</a:t>
+            </a:r>
+          </a:p>
+        </p:txBody>
+      </p:sp>
+      <p:sp>
+        <p:nvSpPr>
+          <p:cNvPr id="21" name="TextBox 20"/>
+          <p:cNvSpPr txBox="1"/>
+          <p:nvPr/>
+        </p:nvSpPr>
+        <p:spPr>
+          <a:xfrm>
+            <a:off x="256032" y="1499616"/>
+            <a:ext cx="2286000" cy="246888"/>
+          </a:xfrm>
+          <a:prstGeom prst="rect">
+            <a:avLst/>
+          </a:prstGeom>
+          <a:noFill/>
+        </p:spPr>
+        <p:txBody>
+          <a:bodyPr wrap="none">
+            <a:spAutoFit/>
+          </a:bodyPr>
+          <a:lstStyle/>
+          <a:p>
+            <a:pPr algn="l"/>
+            <a:r>
+              <a:rPr sz="1000" b="0" i="0">
+                <a:solidFill>
+                  <a:srgbClr val="FFFFFF"/>
+                </a:solidFill>
+                <a:latin typeface="Calibri"/>
+              </a:rPr>
+              <a:t>5-year, Structure A  (low/base/high)</a:t>
+            </a:r>
+          </a:p>
+        </p:txBody>
+      </p:sp>
+      <p:sp>
+        <p:nvSpPr>
+          <p:cNvPr id="22" name="TextBox 21"/>
+          <p:cNvSpPr txBox="1"/>
+          <p:nvPr/>
+        </p:nvSpPr>
+        <p:spPr>
+          <a:xfrm>
+            <a:off x="2606040" y="1499616"/>
+            <a:ext cx="713232" cy="246888"/>
+          </a:xfrm>
+          <a:prstGeom prst="rect">
+            <a:avLst/>
+          </a:prstGeom>
+          <a:noFill/>
+        </p:spPr>
+        <p:txBody>
+          <a:bodyPr wrap="none">
+            <a:spAutoFit/>
+          </a:bodyPr>
+          <a:lstStyle/>
+          <a:p>
+            <a:pPr algn="r"/>
+            <a:r>
+              <a:rPr sz="1000" b="0" i="0">
+                <a:solidFill>
+                  <a:srgbClr val="FFFFFF"/>
+                </a:solidFill>
+                <a:latin typeface="Calibri"/>
+              </a:rPr>
+              <a:t>$41.0K</a:t>
+            </a:r>
+          </a:p>
+        </p:txBody>
+      </p:sp>
+      <p:sp>
+        <p:nvSpPr>
+          <p:cNvPr id="23" name="TextBox 22"/>
+          <p:cNvSpPr txBox="1"/>
+          <p:nvPr/>
+        </p:nvSpPr>
+        <p:spPr>
+          <a:xfrm>
+            <a:off x="3383280" y="1499616"/>
+            <a:ext cx="694944" cy="246888"/>
+          </a:xfrm>
+          <a:prstGeom prst="rect">
+            <a:avLst/>
+          </a:prstGeom>
+          <a:noFill/>
+        </p:spPr>
+        <p:txBody>
+          <a:bodyPr wrap="none">
+            <a:spAutoFit/>
+          </a:bodyPr>
+          <a:lstStyle/>
+          <a:p>
+            <a:pPr algn="r"/>
+            <a:r>
+              <a:rPr sz="1000" b="1" i="0">
+                <a:solidFill>
+                  <a:srgbClr val="44BB44"/>
+                </a:solidFill>
+                <a:latin typeface="Calibri"/>
+              </a:rPr>
+              <a:t>$63.0K</a:t>
+            </a:r>
+          </a:p>
+        </p:txBody>
+      </p:sp>
+      <p:sp>
+        <p:nvSpPr>
+          <p:cNvPr id="24" name="TextBox 23"/>
+          <p:cNvSpPr txBox="1"/>
+          <p:nvPr/>
+        </p:nvSpPr>
+        <p:spPr>
+          <a:xfrm>
+            <a:off x="4133087" y="1499616"/>
+            <a:ext cx="658368" cy="246888"/>
+          </a:xfrm>
+          <a:prstGeom prst="rect">
+            <a:avLst/>
+          </a:prstGeom>
+          <a:noFill/>
+        </p:spPr>
+        <p:txBody>
+          <a:bodyPr wrap="none">
+            <a:spAutoFit/>
+          </a:bodyPr>
+          <a:lstStyle/>
+          <a:p>
+            <a:pPr algn="r"/>
+            <a:r>
+              <a:rPr sz="1000" b="0" i="0">
+                <a:solidFill>
+                  <a:srgbClr val="FFFFFF"/>
+                </a:solidFill>
+                <a:latin typeface="Calibri"/>
+              </a:rPr>
+              <a:t>$85.1K</a:t>
+            </a:r>
+          </a:p>
+        </p:txBody>
+      </p:sp>
+      <p:sp>
+        <p:nvSpPr>
+          <p:cNvPr id="25" name="TextBox 24"/>
+          <p:cNvSpPr txBox="1"/>
+          <p:nvPr/>
+        </p:nvSpPr>
+        <p:spPr>
+          <a:xfrm>
+            <a:off x="256032" y="1746504"/>
+            <a:ext cx="2286000" cy="246888"/>
+          </a:xfrm>
+          <a:prstGeom prst="rect">
+            <a:avLst/>
+          </a:prstGeom>
+          <a:noFill/>
+        </p:spPr>
+        <p:txBody>
+          <a:bodyPr wrap="none">
+            <a:spAutoFit/>
+          </a:bodyPr>
+          <a:lstStyle/>
+          <a:p>
+            <a:pPr algn="l"/>
+            <a:r>
+              <a:rPr sz="1000" b="0" i="0">
+                <a:solidFill>
+                  <a:srgbClr val="DD4444"/>
+                </a:solidFill>
+                <a:latin typeface="Calibri"/>
+              </a:rPr>
+              <a:t>No sale  (book equity −$1.44M today)</a:t>
+            </a:r>
+          </a:p>
+        </p:txBody>
+      </p:sp>
+      <p:sp>
+        <p:nvSpPr>
+          <p:cNvPr id="26" name="TextBox 25"/>
+          <p:cNvSpPr txBox="1"/>
+          <p:nvPr/>
+        </p:nvSpPr>
+        <p:spPr>
+          <a:xfrm>
+            <a:off x="2606040" y="1746504"/>
+            <a:ext cx="713232" cy="246888"/>
+          </a:xfrm>
+          <a:prstGeom prst="rect">
+            <a:avLst/>
+          </a:prstGeom>
+          <a:noFill/>
+        </p:spPr>
+        <p:txBody>
+          <a:bodyPr wrap="none">
+            <a:spAutoFit/>
+          </a:bodyPr>
+          <a:lstStyle/>
+          <a:p>
+            <a:pPr algn="r"/>
+            <a:r>
+              <a:rPr sz="1000" b="0" i="0">
+                <a:solidFill>
+                  <a:srgbClr val="DD4444"/>
+                </a:solidFill>
+                <a:latin typeface="Calibri"/>
+              </a:rPr>
+              <a:t>$0</a:t>
+            </a:r>
+          </a:p>
+        </p:txBody>
+      </p:sp>
+      <p:sp>
+        <p:nvSpPr>
+          <p:cNvPr id="27" name="TextBox 26"/>
+          <p:cNvSpPr txBox="1"/>
+          <p:nvPr/>
+        </p:nvSpPr>
+        <p:spPr>
+          <a:xfrm>
+            <a:off x="3383280" y="1746504"/>
+            <a:ext cx="694944" cy="246888"/>
+          </a:xfrm>
+          <a:prstGeom prst="rect">
+            <a:avLst/>
+          </a:prstGeom>
+          <a:noFill/>
+        </p:spPr>
+        <p:txBody>
+          <a:bodyPr wrap="none">
+            <a:spAutoFit/>
+          </a:bodyPr>
+          <a:lstStyle/>
+          <a:p>
+            <a:pPr algn="r"/>
+            <a:r>
+              <a:rPr sz="1000" b="0" i="0">
+                <a:solidFill>
+                  <a:srgbClr val="DD4444"/>
+                </a:solidFill>
+                <a:latin typeface="Calibri"/>
+              </a:rPr>
+              <a:t>$0</a:t>
+            </a:r>
+          </a:p>
+        </p:txBody>
+      </p:sp>
+      <p:sp>
+        <p:nvSpPr>
+          <p:cNvPr id="28" name="TextBox 27"/>
+          <p:cNvSpPr txBox="1"/>
+          <p:nvPr/>
+        </p:nvSpPr>
+        <p:spPr>
+          <a:xfrm>
+            <a:off x="4133087" y="1746504"/>
+            <a:ext cx="658368" cy="246888"/>
+          </a:xfrm>
+          <a:prstGeom prst="rect">
+            <a:avLst/>
+          </a:prstGeom>
+          <a:noFill/>
+        </p:spPr>
+        <p:txBody>
+          <a:bodyPr wrap="none">
+            <a:spAutoFit/>
+          </a:bodyPr>
+          <a:lstStyle/>
+          <a:p>
+            <a:pPr algn="r"/>
+            <a:r>
+              <a:rPr sz="1000" b="0" i="0">
+                <a:solidFill>
+                  <a:srgbClr val="DD4444"/>
+                </a:solidFill>
+                <a:latin typeface="Calibri"/>
+              </a:rPr>
+              <a:t>—</a:t>
+            </a:r>
+          </a:p>
+        </p:txBody>
+      </p:sp>
+      <p:sp>
+        <p:nvSpPr>
+          <p:cNvPr id="29" name="TextBox 28"/>
+          <p:cNvSpPr txBox="1"/>
+          <p:nvPr/>
+        </p:nvSpPr>
+        <p:spPr>
+          <a:xfrm>
+            <a:off x="256032" y="2029968"/>
+            <a:ext cx="4251960" cy="182880"/>
+          </a:xfrm>
+          <a:prstGeom prst="rect">
+            <a:avLst/>
+          </a:prstGeom>
+          <a:noFill/>
+        </p:spPr>
+        <p:txBody>
+          <a:bodyPr wrap="none">
+            <a:spAutoFit/>
+          </a:bodyPr>
+          <a:lstStyle/>
+          <a:p>
+            <a:pPr algn="l"/>
+            <a:r>
+              <a:rPr sz="1000" b="0" i="1">
+                <a:solidFill>
+                  <a:srgbClr val="CCCCCC"/>
+                </a:solidFill>
+                <a:latin typeface="Calibri"/>
+              </a:rPr>
+              <a:t>Per share (base):  $2.10 at close  ·  $7.22 over 5 years</a:t>
+            </a:r>
+          </a:p>
+        </p:txBody>
+      </p:sp>
+      <p:sp>
+        <p:nvSpPr>
+          <p:cNvPr id="30" name="TextBox 29"/>
+          <p:cNvSpPr txBox="1"/>
+          <p:nvPr/>
+        </p:nvSpPr>
+        <p:spPr>
+          <a:xfrm>
+            <a:off x="4736592" y="566928"/>
+            <a:ext cx="4160520" cy="201168"/>
+          </a:xfrm>
+          <a:prstGeom prst="rect">
+            <a:avLst/>
+          </a:prstGeom>
+          <a:noFill/>
+        </p:spPr>
+        <p:txBody>
+          <a:bodyPr wrap="none">
+            <a:spAutoFit/>
+          </a:bodyPr>
+          <a:lstStyle/>
+          <a:p>
+            <a:pPr algn="l"/>
+            <a:r>
+              <a:rPr sz="1100" b="1" i="0">
+                <a:solidFill>
+                  <a:srgbClr val="F26A21"/>
+                </a:solidFill>
+                <a:latin typeface="Calibri"/>
+              </a:rPr>
+              <a:t>Bob Conger — 73,000 shares</a:t>
+            </a:r>
+          </a:p>
+        </p:txBody>
+      </p:sp>
+      <p:sp>
+        <p:nvSpPr>
+          <p:cNvPr id="31" name="TextBox 30"/>
+          <p:cNvSpPr txBox="1"/>
+          <p:nvPr/>
+        </p:nvSpPr>
+        <p:spPr>
+          <a:xfrm>
+            <a:off x="4736592" y="795528"/>
+            <a:ext cx="4160520" cy="201168"/>
+          </a:xfrm>
+          <a:prstGeom prst="rect">
+            <a:avLst/>
+          </a:prstGeom>
+          <a:noFill/>
+        </p:spPr>
+        <p:txBody>
+          <a:bodyPr wrap="none">
+            <a:spAutoFit/>
+          </a:bodyPr>
+          <a:lstStyle/>
+          <a:p>
+            <a:pPr algn="l"/>
+            <a:r>
+              <a:rPr sz="1000" b="0" i="0">
+                <a:solidFill>
+                  <a:srgbClr val="CCCCCC"/>
+                </a:solidFill>
+                <a:latin typeface="Calibri"/>
+              </a:rPr>
+              <a:t>8.37% of SSLC  ·  10.21% of payout distributions</a:t>
+            </a:r>
+          </a:p>
+        </p:txBody>
+      </p:sp>
+      <p:sp>
+        <p:nvSpPr>
+          <p:cNvPr id="32" name="TextBox 31"/>
+          <p:cNvSpPr txBox="1"/>
+          <p:nvPr/>
+        </p:nvSpPr>
+        <p:spPr>
+          <a:xfrm>
+            <a:off x="4736592" y="932688"/>
+            <a:ext cx="4160520" cy="182880"/>
+          </a:xfrm>
+          <a:prstGeom prst="rect">
+            <a:avLst/>
+          </a:prstGeom>
+          <a:noFill/>
+        </p:spPr>
+        <p:txBody>
+          <a:bodyPr wrap="none">
+            <a:spAutoFit/>
+          </a:bodyPr>
+          <a:lstStyle/>
+          <a:p>
+            <a:pPr algn="l"/>
+            <a:r>
+              <a:rPr sz="1000" b="0" i="1">
+                <a:solidFill>
+                  <a:srgbClr val="888888"/>
+                </a:solidFill>
+                <a:latin typeface="Calibri"/>
+              </a:rPr>
+              <a:t>Cert #3 (44,000) + Cert #43 (29,000)</a:t>
+            </a:r>
+          </a:p>
+        </p:txBody>
+      </p:sp>
+      <p:sp>
+        <p:nvSpPr>
+          <p:cNvPr id="33" name="TextBox 32"/>
+          <p:cNvSpPr txBox="1"/>
+          <p:nvPr/>
+        </p:nvSpPr>
+        <p:spPr>
+          <a:xfrm>
+            <a:off x="4736592" y="1170432"/>
+            <a:ext cx="2286000" cy="219456"/>
+          </a:xfrm>
+          <a:prstGeom prst="rect">
+            <a:avLst/>
+          </a:prstGeom>
+          <a:noFill/>
+        </p:spPr>
+        <p:txBody>
+          <a:bodyPr wrap="none">
+            <a:spAutoFit/>
+          </a:bodyPr>
+          <a:lstStyle/>
+          <a:p>
+            <a:pPr algn="l"/>
+            <a:r>
+              <a:rPr sz="1000" b="0" i="0">
+                <a:solidFill>
+                  <a:srgbClr val="CCCCCC"/>
+                </a:solidFill>
+                <a:latin typeface="Calibri"/>
+              </a:rPr>
+              <a:t>At close  (as booked):</a:t>
+            </a:r>
+          </a:p>
+        </p:txBody>
+      </p:sp>
+      <p:sp>
+        <p:nvSpPr>
+          <p:cNvPr id="34" name="TextBox 33"/>
+          <p:cNvSpPr txBox="1"/>
+          <p:nvPr/>
+        </p:nvSpPr>
+        <p:spPr>
+          <a:xfrm>
+            <a:off x="7068312" y="1170432"/>
+            <a:ext cx="1828800" cy="219456"/>
+          </a:xfrm>
+          <a:prstGeom prst="rect">
+            <a:avLst/>
+          </a:prstGeom>
+          <a:noFill/>
+        </p:spPr>
+        <p:txBody>
+          <a:bodyPr wrap="none">
+            <a:spAutoFit/>
+          </a:bodyPr>
+          <a:lstStyle/>
+          <a:p>
+            <a:pPr algn="r"/>
+            <a:r>
+              <a:rPr sz="1000" b="1" i="0">
+                <a:solidFill>
+                  <a:srgbClr val="44BB44"/>
+                </a:solidFill>
+                <a:latin typeface="Calibri"/>
+              </a:rPr>
+              <a:t>~$153.7K</a:t>
+            </a:r>
+          </a:p>
+        </p:txBody>
+      </p:sp>
+      <p:sp>
+        <p:nvSpPr>
+          <p:cNvPr id="35" name="TextBox 34"/>
+          <p:cNvSpPr txBox="1"/>
+          <p:nvPr/>
+        </p:nvSpPr>
+        <p:spPr>
+          <a:xfrm>
+            <a:off x="4736592" y="1399032"/>
+            <a:ext cx="2286000" cy="219456"/>
+          </a:xfrm>
+          <a:prstGeom prst="rect">
+            <a:avLst/>
+          </a:prstGeom>
+          <a:noFill/>
+        </p:spPr>
+        <p:txBody>
+          <a:bodyPr wrap="none">
+            <a:spAutoFit/>
+          </a:bodyPr>
+          <a:lstStyle/>
+          <a:p>
+            <a:pPr algn="l"/>
+            <a:r>
+              <a:rPr sz="1000" b="0" i="0">
+                <a:solidFill>
+                  <a:srgbClr val="CCCCCC"/>
+                </a:solidFill>
+                <a:latin typeface="Calibri"/>
+              </a:rPr>
+              <a:t>At close  (books corrected):</a:t>
+            </a:r>
+          </a:p>
+        </p:txBody>
+      </p:sp>
+      <p:sp>
+        <p:nvSpPr>
+          <p:cNvPr id="36" name="TextBox 35"/>
+          <p:cNvSpPr txBox="1"/>
+          <p:nvPr/>
+        </p:nvSpPr>
+        <p:spPr>
+          <a:xfrm>
+            <a:off x="7068312" y="1399032"/>
+            <a:ext cx="1828800" cy="219456"/>
+          </a:xfrm>
+          <a:prstGeom prst="rect">
+            <a:avLst/>
+          </a:prstGeom>
+          <a:noFill/>
+        </p:spPr>
+        <p:txBody>
+          <a:bodyPr wrap="none">
+            <a:spAutoFit/>
+          </a:bodyPr>
+          <a:lstStyle/>
+          <a:p>
+            <a:pPr algn="r"/>
+            <a:r>
+              <a:rPr sz="1000" b="1" i="0">
+                <a:solidFill>
+                  <a:srgbClr val="FFCC44"/>
+                </a:solidFill>
+                <a:latin typeface="Calibri"/>
+              </a:rPr>
+              <a:t>~$189.5K</a:t>
+            </a:r>
+          </a:p>
+        </p:txBody>
+      </p:sp>
+      <p:sp>
+        <p:nvSpPr>
+          <p:cNvPr id="37" name="TextBox 36"/>
+          <p:cNvSpPr txBox="1"/>
+          <p:nvPr/>
+        </p:nvSpPr>
+        <p:spPr>
+          <a:xfrm>
+            <a:off x="4736592" y="1627632"/>
+            <a:ext cx="2286000" cy="219456"/>
+          </a:xfrm>
+          <a:prstGeom prst="rect">
+            <a:avLst/>
+          </a:prstGeom>
+          <a:noFill/>
+        </p:spPr>
+        <p:txBody>
+          <a:bodyPr wrap="none">
+            <a:spAutoFit/>
+          </a:bodyPr>
+          <a:lstStyle/>
+          <a:p>
+            <a:pPr algn="l"/>
+            <a:r>
+              <a:rPr sz="1000" b="0" i="0">
+                <a:solidFill>
+                  <a:srgbClr val="CCCCCC"/>
+                </a:solidFill>
+                <a:latin typeface="Calibri"/>
+              </a:rPr>
+              <a:t>5-year base:</a:t>
+            </a:r>
+          </a:p>
+        </p:txBody>
+      </p:sp>
+      <p:sp>
+        <p:nvSpPr>
+          <p:cNvPr id="38" name="TextBox 37"/>
+          <p:cNvSpPr txBox="1"/>
+          <p:nvPr/>
+        </p:nvSpPr>
+        <p:spPr>
+          <a:xfrm>
+            <a:off x="7068312" y="1627632"/>
+            <a:ext cx="1828800" cy="219456"/>
+          </a:xfrm>
+          <a:prstGeom prst="rect">
+            <a:avLst/>
+          </a:prstGeom>
+          <a:noFill/>
+        </p:spPr>
+        <p:txBody>
+          <a:bodyPr wrap="none">
+            <a:spAutoFit/>
+          </a:bodyPr>
+          <a:lstStyle/>
+          <a:p>
+            <a:pPr algn="r"/>
+            <a:r>
+              <a:rPr sz="1000" b="1" i="0">
+                <a:solidFill>
+                  <a:srgbClr val="FFCC44"/>
+                </a:solidFill>
+                <a:latin typeface="Calibri"/>
+              </a:rPr>
+              <a:t>~$527K</a:t>
+            </a:r>
+          </a:p>
+        </p:txBody>
+      </p:sp>
+      <p:sp>
+        <p:nvSpPr>
+          <p:cNvPr id="39" name="TextBox 38"/>
+          <p:cNvSpPr txBox="1"/>
+          <p:nvPr/>
+        </p:nvSpPr>
+        <p:spPr>
+          <a:xfrm>
+            <a:off x="4736592" y="1856232"/>
+            <a:ext cx="2286000" cy="219456"/>
+          </a:xfrm>
+          <a:prstGeom prst="rect">
+            <a:avLst/>
+          </a:prstGeom>
+          <a:noFill/>
+        </p:spPr>
+        <p:txBody>
+          <a:bodyPr wrap="none">
+            <a:spAutoFit/>
+          </a:bodyPr>
+          <a:lstStyle/>
+          <a:p>
+            <a:pPr algn="l"/>
+            <a:r>
+              <a:rPr sz="1000" b="0" i="0">
+                <a:solidFill>
+                  <a:srgbClr val="CCCCCC"/>
+                </a:solidFill>
+                <a:latin typeface="Calibri"/>
+              </a:rPr>
+              <a:t>Paid in (est., ~$49.1K):</a:t>
+            </a:r>
+          </a:p>
+        </p:txBody>
+      </p:sp>
+      <p:sp>
+        <p:nvSpPr>
+          <p:cNvPr id="40" name="TextBox 39"/>
+          <p:cNvSpPr txBox="1"/>
+          <p:nvPr/>
+        </p:nvSpPr>
+        <p:spPr>
+          <a:xfrm>
+            <a:off x="7068312" y="1856232"/>
+            <a:ext cx="1828800" cy="219456"/>
+          </a:xfrm>
+          <a:prstGeom prst="rect">
+            <a:avLst/>
+          </a:prstGeom>
+          <a:noFill/>
+        </p:spPr>
+        <p:txBody>
+          <a:bodyPr wrap="none">
+            <a:spAutoFit/>
+          </a:bodyPr>
+          <a:lstStyle/>
+          <a:p>
+            <a:pPr algn="r"/>
+            <a:r>
+              <a:rPr sz="1000" b="1" i="0">
+                <a:solidFill>
+                  <a:srgbClr val="CCCCCC"/>
+                </a:solidFill>
+                <a:latin typeface="Calibri"/>
+              </a:rPr>
+              <a:t>10.7× return at 5-yr base</a:t>
+            </a:r>
+          </a:p>
+        </p:txBody>
+      </p:sp>
+      <p:sp>
+        <p:nvSpPr>
+          <p:cNvPr id="41" name="TextBox 40"/>
+          <p:cNvSpPr txBox="1"/>
+          <p:nvPr/>
+        </p:nvSpPr>
+        <p:spPr>
+          <a:xfrm>
+            <a:off x="4736592" y="2121408"/>
+            <a:ext cx="4160520" cy="384048"/>
+          </a:xfrm>
+          <a:prstGeom prst="rect">
+            <a:avLst/>
+          </a:prstGeom>
+          <a:noFill/>
+        </p:spPr>
+        <p:txBody>
+          <a:bodyPr wrap="square">
+            <a:spAutoFit/>
+          </a:bodyPr>
+          <a:lstStyle/>
+          <a:p>
+            <a:pPr algn="l"/>
+            <a:r>
+              <a:rPr sz="1000" b="0" i="1">
+                <a:solidFill>
+                  <a:srgbClr val="FFCC44"/>
+                </a:solidFill>
+                <a:latin typeface="Calibri"/>
+              </a:rPr>
+              <a:t>⚠ SSLC’s 6/3/2026 ledger lists only 29K shares (cert #43); cert #3 (44K) is missing.
+Motion 2 corrects the share register.</a:t>
+            </a:r>
+          </a:p>
+        </p:txBody>
+      </p:sp>
+      <p:sp>
+        <p:nvSpPr>
+          <p:cNvPr id="42" name="Rectangle 41"/>
+          <p:cNvSpPr/>
+          <p:nvPr/>
+        </p:nvSpPr>
+        <p:spPr>
+          <a:xfrm>
+            <a:off x="0" y="2596896"/>
+            <a:ext cx="9144000" cy="877824"/>
+          </a:xfrm>
+          <a:prstGeom prst="rect">
+            <a:avLst/>
+          </a:prstGeom>
+          <a:solidFill>
+            <a:srgbClr val="2A1800"/>
+          </a:solidFill>
+          <a:ln>
+            <a:noFill/>
+          </a:ln>
+        </p:spPr>
+        <p:style>
+          <a:lnRef idx="1">
+            <a:schemeClr val="accent1"/>
+          </a:lnRef>
+          <a:fillRef idx="3">
+            <a:schemeClr val="accent1"/>
+          </a:fillRef>
+          <a:effectRef idx="2">
+            <a:schemeClr val="accent1"/>
+          </a:effectRef>
+          <a:fontRef idx="minor">
+            <a:schemeClr val="lt1"/>
+          </a:fontRef>
+        </p:style>
+        <p:txBody>
+          <a:bodyPr rtlCol="0" anchor="ctr"/>
+          <a:lstStyle/>
+          <a:p>
+            <a:pPr algn="ctr"/>
+          </a:p>
+        </p:txBody>
+      </p:sp>
+      <p:sp>
+        <p:nvSpPr>
+          <p:cNvPr id="43" name="Rectangle 42"/>
+          <p:cNvSpPr/>
+          <p:nvPr/>
+        </p:nvSpPr>
+        <p:spPr>
+          <a:xfrm>
+            <a:off x="0" y="2596896"/>
+            <a:ext cx="9144000" cy="18288"/>
+          </a:xfrm>
+          <a:prstGeom prst="rect">
+            <a:avLst/>
+          </a:prstGeom>
+          <a:solidFill>
+            <a:srgbClr val="CC8800"/>
+          </a:solidFill>
+          <a:ln>
+            <a:noFill/>
+          </a:ln>
+        </p:spPr>
+        <p:style>
+          <a:lnRef idx="1">
+            <a:schemeClr val="accent1"/>
+          </a:lnRef>
+          <a:fillRef idx="3">
+            <a:schemeClr val="accent1"/>
+          </a:fillRef>
+          <a:effectRef idx="2">
+            <a:schemeClr val="accent1"/>
+          </a:effectRef>
+          <a:fontRef idx="minor">
+            <a:schemeClr val="lt1"/>
+          </a:fontRef>
+        </p:style>
+        <p:txBody>
+          <a:bodyPr rtlCol="0" anchor="ctr"/>
+          <a:lstStyle/>
+          <a:p>
+            <a:pPr algn="ctr"/>
+          </a:p>
+        </p:txBody>
+      </p:sp>
+      <p:sp>
+        <p:nvSpPr>
+          <p:cNvPr id="44" name="TextBox 43"/>
+          <p:cNvSpPr txBox="1"/>
+          <p:nvPr/>
+        </p:nvSpPr>
+        <p:spPr>
+          <a:xfrm>
+            <a:off x="256032" y="2624327"/>
+            <a:ext cx="8631936" cy="182880"/>
+          </a:xfrm>
+          <a:prstGeom prst="rect">
+            <a:avLst/>
+          </a:prstGeom>
+          <a:noFill/>
+        </p:spPr>
+        <p:txBody>
+          <a:bodyPr wrap="none">
+            <a:spAutoFit/>
+          </a:bodyPr>
+          <a:lstStyle/>
+          <a:p>
+            <a:pPr algn="l"/>
+            <a:r>
+              <a:rPr sz="1000" b="1" i="0">
+                <a:solidFill>
+                  <a:srgbClr val="CC8800"/>
+                </a:solidFill>
+                <a:latin typeface="Calibri"/>
+              </a:rPr>
+              <a:t>IMPACT OF UNCORRECTED APRIL 30 ENTRIES  (negative to non-Wertz holders)</a:t>
+            </a:r>
+          </a:p>
+        </p:txBody>
+      </p:sp>
+      <p:sp>
+        <p:nvSpPr>
+          <p:cNvPr id="45" name="TextBox 44"/>
+          <p:cNvSpPr txBox="1"/>
+          <p:nvPr/>
+        </p:nvSpPr>
+        <p:spPr>
+          <a:xfrm>
+            <a:off x="256032" y="2834639"/>
+            <a:ext cx="4754880" cy="201168"/>
+          </a:xfrm>
+          <a:prstGeom prst="rect">
+            <a:avLst/>
+          </a:prstGeom>
+          <a:noFill/>
+        </p:spPr>
+        <p:txBody>
+          <a:bodyPr wrap="none">
+            <a:spAutoFit/>
+          </a:bodyPr>
+          <a:lstStyle/>
+          <a:p>
+            <a:pPr algn="l"/>
+            <a:r>
+              <a:rPr sz="1000" b="0" i="0">
+                <a:solidFill>
+                  <a:srgbClr val="CCCCCC"/>
+                </a:solidFill>
+                <a:latin typeface="Calibri"/>
+              </a:rPr>
+              <a:t>Step 1  —  Facility credit + capitalized interest ($448K not credited):</a:t>
+            </a:r>
+          </a:p>
+        </p:txBody>
+      </p:sp>
+      <p:sp>
+        <p:nvSpPr>
+          <p:cNvPr id="46" name="TextBox 45"/>
+          <p:cNvSpPr txBox="1"/>
+          <p:nvPr/>
+        </p:nvSpPr>
+        <p:spPr>
+          <a:xfrm>
+            <a:off x="5074920" y="2834639"/>
+            <a:ext cx="1645920" cy="201168"/>
+          </a:xfrm>
+          <a:prstGeom prst="rect">
+            <a:avLst/>
+          </a:prstGeom>
+          <a:noFill/>
+        </p:spPr>
+        <p:txBody>
+          <a:bodyPr wrap="none">
+            <a:spAutoFit/>
+          </a:bodyPr>
+          <a:lstStyle/>
+          <a:p>
+            <a:pPr algn="r"/>
+            <a:r>
+              <a:rPr sz="1000" b="1" i="0">
+                <a:solidFill>
+                  <a:srgbClr val="DD4444"/>
+                </a:solidFill>
+                <a:latin typeface="Calibri"/>
+              </a:rPr>
+              <a:t>Per 1%: −$5.5K</a:t>
+            </a:r>
+          </a:p>
+        </p:txBody>
+      </p:sp>
+      <p:sp>
+        <p:nvSpPr>
+          <p:cNvPr id="47" name="TextBox 46"/>
+          <p:cNvSpPr txBox="1"/>
+          <p:nvPr/>
+        </p:nvSpPr>
+        <p:spPr>
+          <a:xfrm>
+            <a:off x="6748272" y="2834639"/>
+            <a:ext cx="164592" cy="201168"/>
+          </a:xfrm>
+          <a:prstGeom prst="rect">
+            <a:avLst/>
+          </a:prstGeom>
+          <a:noFill/>
+        </p:spPr>
+        <p:txBody>
+          <a:bodyPr wrap="none">
+            <a:spAutoFit/>
+          </a:bodyPr>
+          <a:lstStyle/>
+          <a:p>
+            <a:pPr algn="ctr"/>
+            <a:r>
+              <a:rPr sz="1000" b="0" i="0">
+                <a:solidFill>
+                  <a:srgbClr val="888888"/>
+                </a:solidFill>
+                <a:latin typeface="Calibri"/>
+              </a:rPr>
+              <a:t>|</a:t>
+            </a:r>
+          </a:p>
+        </p:txBody>
+      </p:sp>
+      <p:sp>
+        <p:nvSpPr>
+          <p:cNvPr id="48" name="TextBox 47"/>
+          <p:cNvSpPr txBox="1"/>
+          <p:nvPr/>
+        </p:nvSpPr>
+        <p:spPr>
+          <a:xfrm>
+            <a:off x="6931152" y="2834639"/>
+            <a:ext cx="1920240" cy="201168"/>
+          </a:xfrm>
+          <a:prstGeom prst="rect">
+            <a:avLst/>
+          </a:prstGeom>
+          <a:noFill/>
+        </p:spPr>
+        <p:txBody>
+          <a:bodyPr wrap="none">
+            <a:spAutoFit/>
+          </a:bodyPr>
+          <a:lstStyle/>
+          <a:p>
+            <a:pPr algn="r"/>
+            <a:r>
+              <a:rPr sz="1000" b="1" i="0">
+                <a:solidFill>
+                  <a:srgbClr val="DD4444"/>
+                </a:solidFill>
+                <a:latin typeface="Calibri"/>
+              </a:rPr>
+              <a:t>Conger: −$45.8K</a:t>
+            </a:r>
+          </a:p>
+        </p:txBody>
+      </p:sp>
+      <p:sp>
+        <p:nvSpPr>
+          <p:cNvPr id="49" name="TextBox 48"/>
+          <p:cNvSpPr txBox="1"/>
+          <p:nvPr/>
+        </p:nvSpPr>
+        <p:spPr>
+          <a:xfrm>
+            <a:off x="256032" y="3090672"/>
+            <a:ext cx="4754880" cy="201168"/>
+          </a:xfrm>
+          <a:prstGeom prst="rect">
+            <a:avLst/>
+          </a:prstGeom>
+          <a:noFill/>
+        </p:spPr>
+        <p:txBody>
+          <a:bodyPr wrap="none">
+            <a:spAutoFit/>
+          </a:bodyPr>
+          <a:lstStyle/>
+          <a:p>
+            <a:pPr algn="l"/>
+            <a:r>
+              <a:rPr sz="1000" b="0" i="0">
+                <a:solidFill>
+                  <a:srgbClr val="CCCCCC"/>
+                </a:solidFill>
+                <a:latin typeface="Calibri"/>
+              </a:rPr>
+              <a:t>Step 1+2  —  + Unsupported offsets if unresolved ($967K):</a:t>
+            </a:r>
+          </a:p>
+        </p:txBody>
+      </p:sp>
+      <p:sp>
+        <p:nvSpPr>
+          <p:cNvPr id="50" name="TextBox 49"/>
+          <p:cNvSpPr txBox="1"/>
+          <p:nvPr/>
+        </p:nvSpPr>
+        <p:spPr>
+          <a:xfrm>
+            <a:off x="5074920" y="3090672"/>
+            <a:ext cx="1645920" cy="201168"/>
+          </a:xfrm>
+          <a:prstGeom prst="rect">
+            <a:avLst/>
+          </a:prstGeom>
+          <a:noFill/>
+        </p:spPr>
+        <p:txBody>
+          <a:bodyPr wrap="none">
+            <a:spAutoFit/>
+          </a:bodyPr>
+          <a:lstStyle/>
+          <a:p>
+            <a:pPr algn="r"/>
+            <a:r>
+              <a:rPr sz="1000" b="1" i="0">
+                <a:solidFill>
+                  <a:srgbClr val="DD4444"/>
+                </a:solidFill>
+                <a:latin typeface="Calibri"/>
+              </a:rPr>
+              <a:t>Per 1%: −$11.8K</a:t>
+            </a:r>
+          </a:p>
+        </p:txBody>
+      </p:sp>
+      <p:sp>
+        <p:nvSpPr>
+          <p:cNvPr id="51" name="TextBox 50"/>
+          <p:cNvSpPr txBox="1"/>
+          <p:nvPr/>
+        </p:nvSpPr>
+        <p:spPr>
+          <a:xfrm>
+            <a:off x="6748272" y="3090672"/>
+            <a:ext cx="164592" cy="201168"/>
+          </a:xfrm>
+          <a:prstGeom prst="rect">
+            <a:avLst/>
+          </a:prstGeom>
+          <a:noFill/>
+        </p:spPr>
+        <p:txBody>
+          <a:bodyPr wrap="none">
+            <a:spAutoFit/>
+          </a:bodyPr>
+          <a:lstStyle/>
+          <a:p>
+            <a:pPr algn="ctr"/>
+            <a:r>
+              <a:rPr sz="1000" b="0" i="0">
+                <a:solidFill>
+                  <a:srgbClr val="888888"/>
+                </a:solidFill>
+                <a:latin typeface="Calibri"/>
+              </a:rPr>
+              <a:t>|</a:t>
+            </a:r>
+          </a:p>
+        </p:txBody>
+      </p:sp>
+      <p:sp>
+        <p:nvSpPr>
+          <p:cNvPr id="52" name="TextBox 51"/>
+          <p:cNvSpPr txBox="1"/>
+          <p:nvPr/>
+        </p:nvSpPr>
+        <p:spPr>
+          <a:xfrm>
+            <a:off x="6931152" y="3090672"/>
+            <a:ext cx="1920240" cy="201168"/>
+          </a:xfrm>
+          <a:prstGeom prst="rect">
+            <a:avLst/>
+          </a:prstGeom>
+          <a:noFill/>
+        </p:spPr>
+        <p:txBody>
+          <a:bodyPr wrap="none">
+            <a:spAutoFit/>
+          </a:bodyPr>
+          <a:lstStyle/>
+          <a:p>
+            <a:pPr algn="r"/>
+            <a:r>
+              <a:rPr sz="1000" b="1" i="0">
+                <a:solidFill>
+                  <a:srgbClr val="DD4444"/>
+                </a:solidFill>
+                <a:latin typeface="Calibri"/>
+              </a:rPr>
+              <a:t>Conger: −$98.7K  (Microcosm would owe SSLC)</a:t>
+            </a:r>
+          </a:p>
+        </p:txBody>
+      </p:sp>
+      <p:sp>
+        <p:nvSpPr>
+          <p:cNvPr id="53" name="Rectangle 52"/>
+          <p:cNvSpPr/>
+          <p:nvPr/>
+        </p:nvSpPr>
+        <p:spPr>
+          <a:xfrm>
+            <a:off x="0" y="3529584"/>
+            <a:ext cx="4572000" cy="1207007"/>
+          </a:xfrm>
+          <a:prstGeom prst="rect">
+            <a:avLst/>
+          </a:prstGeom>
+          <a:solidFill>
+            <a:srgbClr val="0A1A0A"/>
+          </a:solidFill>
+          <a:ln>
+            <a:noFill/>
+          </a:ln>
+        </p:spPr>
+        <p:style>
+          <a:lnRef idx="1">
+            <a:schemeClr val="accent1"/>
+          </a:lnRef>
+          <a:fillRef idx="3">
+            <a:schemeClr val="accent1"/>
+          </a:fillRef>
+          <a:effectRef idx="2">
+            <a:schemeClr val="accent1"/>
+          </a:effectRef>
+          <a:fontRef idx="minor">
+            <a:schemeClr val="lt1"/>
+          </a:fontRef>
+        </p:style>
+        <p:txBody>
+          <a:bodyPr rtlCol="0" anchor="ctr"/>
+          <a:lstStyle/>
+          <a:p>
+            <a:pPr algn="ctr"/>
+          </a:p>
+        </p:txBody>
+      </p:sp>
+      <p:sp>
+        <p:nvSpPr>
+          <p:cNvPr id="54" name="Rectangle 53"/>
+          <p:cNvSpPr/>
+          <p:nvPr/>
+        </p:nvSpPr>
+        <p:spPr>
+          <a:xfrm>
+            <a:off x="4572000" y="3529584"/>
+            <a:ext cx="4572000" cy="1207007"/>
+          </a:xfrm>
+          <a:prstGeom prst="rect">
+            <a:avLst/>
+          </a:prstGeom>
+          <a:solidFill>
+            <a:srgbClr val="1A0808"/>
+          </a:solidFill>
+          <a:ln>
+            <a:noFill/>
+          </a:ln>
+        </p:spPr>
+        <p:style>
+          <a:lnRef idx="1">
+            <a:schemeClr val="accent1"/>
+          </a:lnRef>
+          <a:fillRef idx="3">
+            <a:schemeClr val="accent1"/>
+          </a:fillRef>
+          <a:effectRef idx="2">
+            <a:schemeClr val="accent1"/>
+          </a:effectRef>
+          <a:fontRef idx="minor">
+            <a:schemeClr val="lt1"/>
+          </a:fontRef>
+        </p:style>
+        <p:txBody>
+          <a:bodyPr rtlCol="0" anchor="ctr"/>
+          <a:lstStyle/>
+          <a:p>
+            <a:pPr algn="ctr"/>
+          </a:p>
+        </p:txBody>
+      </p:sp>
+      <p:sp>
+        <p:nvSpPr>
+          <p:cNvPr id="55" name="Rectangle 54"/>
+          <p:cNvSpPr/>
+          <p:nvPr/>
+        </p:nvSpPr>
+        <p:spPr>
+          <a:xfrm>
+            <a:off x="0" y="3529584"/>
+            <a:ext cx="9144000" cy="16459"/>
+          </a:xfrm>
+          <a:prstGeom prst="rect">
+            <a:avLst/>
+          </a:prstGeom>
+          <a:solidFill>
+            <a:srgbClr val="337733"/>
+          </a:solidFill>
+          <a:ln>
+            <a:noFill/>
+          </a:ln>
+        </p:spPr>
+        <p:style>
+          <a:lnRef idx="1">
+            <a:schemeClr val="accent1"/>
+          </a:lnRef>
+          <a:fillRef idx="3">
+            <a:schemeClr val="accent1"/>
+          </a:fillRef>
+          <a:effectRef idx="2">
+            <a:schemeClr val="accent1"/>
+          </a:effectRef>
+          <a:fontRef idx="minor">
+            <a:schemeClr val="lt1"/>
+          </a:fontRef>
+        </p:style>
+        <p:txBody>
+          <a:bodyPr rtlCol="0" anchor="ctr"/>
+          <a:lstStyle/>
+          <a:p>
+            <a:pPr algn="ctr"/>
+          </a:p>
+        </p:txBody>
+      </p:sp>
+      <p:sp>
+        <p:nvSpPr>
+          <p:cNvPr id="56" name="Rectangle 55"/>
+          <p:cNvSpPr/>
+          <p:nvPr/>
+        </p:nvSpPr>
+        <p:spPr>
+          <a:xfrm>
+            <a:off x="4572000" y="3529584"/>
+            <a:ext cx="10972" cy="1207007"/>
+          </a:xfrm>
+          <a:prstGeom prst="rect">
+            <a:avLst/>
+          </a:prstGeom>
+          <a:solidFill>
+            <a:srgbClr val="444444"/>
+          </a:solidFill>
+          <a:ln>
+            <a:noFill/>
+          </a:ln>
+        </p:spPr>
+        <p:style>
+          <a:lnRef idx="1">
+            <a:schemeClr val="accent1"/>
+          </a:lnRef>
+          <a:fillRef idx="3">
+            <a:schemeClr val="accent1"/>
+          </a:fillRef>
+          <a:effectRef idx="2">
+            <a:schemeClr val="accent1"/>
+          </a:effectRef>
+          <a:fontRef idx="minor">
+            <a:schemeClr val="lt1"/>
+          </a:fontRef>
+        </p:style>
+        <p:txBody>
+          <a:bodyPr rtlCol="0" anchor="ctr"/>
+          <a:lstStyle/>
+          <a:p>
+            <a:pPr algn="ctr"/>
+          </a:p>
+        </p:txBody>
+      </p:sp>
+      <p:sp>
+        <p:nvSpPr>
+          <p:cNvPr id="57" name="TextBox 56"/>
+          <p:cNvSpPr txBox="1"/>
+          <p:nvPr/>
+        </p:nvSpPr>
+        <p:spPr>
+          <a:xfrm>
+            <a:off x="256032" y="3566160"/>
+            <a:ext cx="4114800" cy="201168"/>
+          </a:xfrm>
+          <a:prstGeom prst="rect">
+            <a:avLst/>
+          </a:prstGeom>
+          <a:noFill/>
+        </p:spPr>
+        <p:txBody>
+          <a:bodyPr wrap="none">
+            <a:spAutoFit/>
+          </a:bodyPr>
+          <a:lstStyle/>
+          <a:p>
+            <a:pPr algn="l"/>
+            <a:r>
+              <a:rPr sz="1100" b="1" i="0">
+                <a:solidFill>
+                  <a:srgbClr val="44BB44"/>
+                </a:solidFill>
+                <a:latin typeface="Calibri"/>
+              </a:rPr>
+              <a:t>✔  SELL TO EXOS</a:t>
+            </a:r>
+          </a:p>
+        </p:txBody>
+      </p:sp>
+      <p:sp>
+        <p:nvSpPr>
+          <p:cNvPr id="58" name="TextBox 57"/>
+          <p:cNvSpPr txBox="1"/>
+          <p:nvPr/>
+        </p:nvSpPr>
+        <p:spPr>
+          <a:xfrm>
+            <a:off x="4736592" y="3566160"/>
+            <a:ext cx="4114800" cy="201168"/>
+          </a:xfrm>
+          <a:prstGeom prst="rect">
+            <a:avLst/>
+          </a:prstGeom>
+          <a:noFill/>
+        </p:spPr>
+        <p:txBody>
+          <a:bodyPr wrap="none">
+            <a:spAutoFit/>
+          </a:bodyPr>
+          <a:lstStyle/>
+          <a:p>
+            <a:pPr algn="l"/>
+            <a:r>
+              <a:rPr sz="1100" b="1" i="0">
+                <a:solidFill>
+                  <a:srgbClr val="DD4444"/>
+                </a:solidFill>
+                <a:latin typeface="Calibri"/>
+              </a:rPr>
+              <a:t>✘  DECLINE</a:t>
+            </a:r>
+          </a:p>
+        </p:txBody>
+      </p:sp>
+      <p:sp>
+        <p:nvSpPr>
+          <p:cNvPr id="59" name="TextBox 58"/>
+          <p:cNvSpPr txBox="1"/>
+          <p:nvPr/>
+        </p:nvSpPr>
+        <p:spPr>
+          <a:xfrm>
+            <a:off x="457200" y="3785615"/>
+            <a:ext cx="3977639" cy="201168"/>
+          </a:xfrm>
+          <a:prstGeom prst="rect">
+            <a:avLst/>
+          </a:prstGeom>
+          <a:noFill/>
+        </p:spPr>
+        <p:txBody>
+          <a:bodyPr wrap="none">
+            <a:spAutoFit/>
+          </a:bodyPr>
+          <a:lstStyle/>
+          <a:p>
+            <a:pPr algn="l"/>
+            <a:r>
+              <a:rPr sz="1000" b="0" i="0">
+                <a:solidFill>
+                  <a:srgbClr val="44BB44"/>
+                </a:solidFill>
+                <a:latin typeface="Calibri"/>
+              </a:rPr>
+              <a:t>~$18–23K per 1% in cash at close</a:t>
+            </a:r>
+          </a:p>
+        </p:txBody>
+      </p:sp>
+      <p:sp>
+        <p:nvSpPr>
+          <p:cNvPr id="60" name="TextBox 59"/>
+          <p:cNvSpPr txBox="1"/>
+          <p:nvPr/>
+        </p:nvSpPr>
+        <p:spPr>
+          <a:xfrm>
+            <a:off x="4736592" y="3785615"/>
+            <a:ext cx="4160520" cy="201168"/>
+          </a:xfrm>
+          <a:prstGeom prst="rect">
+            <a:avLst/>
+          </a:prstGeom>
+          <a:noFill/>
+        </p:spPr>
+        <p:txBody>
+          <a:bodyPr wrap="none">
+            <a:spAutoFit/>
+          </a:bodyPr>
+          <a:lstStyle/>
+          <a:p>
+            <a:pPr algn="l"/>
+            <a:r>
+              <a:rPr sz="1000" b="0" i="0">
+                <a:solidFill>
+                  <a:srgbClr val="DD4444"/>
+                </a:solidFill>
+                <a:latin typeface="Calibri"/>
+              </a:rPr>
+              <a:t>$0 per 1% at book value today (−$1.44M equity)</a:t>
+            </a:r>
+          </a:p>
+        </p:txBody>
+      </p:sp>
+      <p:sp>
+        <p:nvSpPr>
+          <p:cNvPr id="61" name="TextBox 60"/>
+          <p:cNvSpPr txBox="1"/>
+          <p:nvPr/>
+        </p:nvSpPr>
+        <p:spPr>
+          <a:xfrm>
+            <a:off x="457200" y="4005072"/>
+            <a:ext cx="3977639" cy="201168"/>
+          </a:xfrm>
+          <a:prstGeom prst="rect">
+            <a:avLst/>
+          </a:prstGeom>
+          <a:noFill/>
+        </p:spPr>
+        <p:txBody>
+          <a:bodyPr wrap="none">
+            <a:spAutoFit/>
+          </a:bodyPr>
+          <a:lstStyle/>
+          <a:p>
+            <a:pPr algn="l"/>
+            <a:r>
+              <a:rPr sz="1000" b="0" i="0">
+                <a:solidFill>
+                  <a:srgbClr val="44BB44"/>
+                </a:solidFill>
+                <a:latin typeface="Calibri"/>
+              </a:rPr>
+              <a:t>~$63K per 1% over 5 years (Structure A)</a:t>
+            </a:r>
+          </a:p>
+        </p:txBody>
+      </p:sp>
+      <p:sp>
+        <p:nvSpPr>
+          <p:cNvPr id="62" name="TextBox 61"/>
+          <p:cNvSpPr txBox="1"/>
+          <p:nvPr/>
+        </p:nvSpPr>
+        <p:spPr>
+          <a:xfrm>
+            <a:off x="4736592" y="4005072"/>
+            <a:ext cx="4160520" cy="201168"/>
+          </a:xfrm>
+          <a:prstGeom prst="rect">
+            <a:avLst/>
+          </a:prstGeom>
+          <a:noFill/>
+        </p:spPr>
+        <p:txBody>
+          <a:bodyPr wrap="none">
+            <a:spAutoFit/>
+          </a:bodyPr>
+          <a:lstStyle/>
+          <a:p>
+            <a:pPr algn="l"/>
+            <a:r>
+              <a:rPr sz="1000" b="0" i="0">
+                <a:solidFill>
+                  <a:srgbClr val="DD4444"/>
+                </a:solidFill>
+                <a:latin typeface="Calibri"/>
+              </a:rPr>
+              <a:t>$5.1M FY27 target still requires doubling last 3mo</a:t>
+            </a:r>
+          </a:p>
+        </p:txBody>
+      </p:sp>
+      <p:sp>
+        <p:nvSpPr>
+          <p:cNvPr id="63" name="TextBox 62"/>
+          <p:cNvSpPr txBox="1"/>
+          <p:nvPr/>
+        </p:nvSpPr>
+        <p:spPr>
+          <a:xfrm>
+            <a:off x="457200" y="4224528"/>
+            <a:ext cx="3977639" cy="201168"/>
+          </a:xfrm>
+          <a:prstGeom prst="rect">
+            <a:avLst/>
+          </a:prstGeom>
+          <a:noFill/>
+        </p:spPr>
+        <p:txBody>
+          <a:bodyPr wrap="none">
+            <a:spAutoFit/>
+          </a:bodyPr>
+          <a:lstStyle/>
+          <a:p>
+            <a:pPr algn="l"/>
+            <a:r>
+              <a:rPr sz="1000" b="0" i="0">
+                <a:solidFill>
+                  <a:srgbClr val="44BB44"/>
+                </a:solidFill>
+                <a:latin typeface="Calibri"/>
+              </a:rPr>
+              <a:t>Books corrected  ·  funding risk removed</a:t>
+            </a:r>
+          </a:p>
+        </p:txBody>
+      </p:sp>
+      <p:sp>
+        <p:nvSpPr>
+          <p:cNvPr id="64" name="TextBox 63"/>
+          <p:cNvSpPr txBox="1"/>
+          <p:nvPr/>
+        </p:nvSpPr>
+        <p:spPr>
+          <a:xfrm>
+            <a:off x="4736592" y="4224528"/>
+            <a:ext cx="4160520" cy="201168"/>
+          </a:xfrm>
+          <a:prstGeom prst="rect">
+            <a:avLst/>
+          </a:prstGeom>
+          <a:noFill/>
+        </p:spPr>
+        <p:txBody>
+          <a:bodyPr wrap="none">
+            <a:spAutoFit/>
+          </a:bodyPr>
+          <a:lstStyle/>
+          <a:p>
+            <a:pPr algn="l"/>
+            <a:r>
+              <a:rPr sz="1000" b="0" i="0">
+                <a:solidFill>
+                  <a:srgbClr val="DD4444"/>
+                </a:solidFill>
+                <a:latin typeface="Calibri"/>
+              </a:rPr>
+              <a:t>Insider balances ($864K as booked) paid first</a:t>
+            </a:r>
+          </a:p>
+        </p:txBody>
+      </p:sp>
+      <p:sp>
+        <p:nvSpPr>
+          <p:cNvPr id="65" name="TextBox 64"/>
+          <p:cNvSpPr txBox="1"/>
+          <p:nvPr/>
+        </p:nvSpPr>
+        <p:spPr>
+          <a:xfrm>
+            <a:off x="256032" y="4480560"/>
+            <a:ext cx="8631936" cy="182880"/>
+          </a:xfrm>
+          <a:prstGeom prst="rect">
+            <a:avLst/>
+          </a:prstGeom>
+          <a:noFill/>
+        </p:spPr>
+        <p:txBody>
+          <a:bodyPr wrap="none">
+            <a:spAutoFit/>
+          </a:bodyPr>
+          <a:lstStyle/>
+          <a:p>
+            <a:pPr algn="l"/>
+            <a:r>
+              <a:rPr sz="1000" b="0" i="1">
+                <a:solidFill>
+                  <a:srgbClr val="CCCCCC"/>
+                </a:solidFill>
+                <a:latin typeface="Calibri"/>
+              </a:rPr>
+              <a:t>Declining means believing SSLC alone beats this without new capital.</a:t>
+            </a:r>
+          </a:p>
+        </p:txBody>
+      </p:sp>
+      <p:sp>
+        <p:nvSpPr>
+          <p:cNvPr id="66" name="TextBox 65"/>
+          <p:cNvSpPr txBox="1"/>
+          <p:nvPr/>
+        </p:nvSpPr>
+        <p:spPr>
+          <a:xfrm>
+            <a:off x="256032" y="4736592"/>
+            <a:ext cx="8631936" cy="137160"/>
+          </a:xfrm>
+          <a:prstGeom prst="rect">
+            <a:avLst/>
+          </a:prstGeom>
+          <a:noFill/>
+        </p:spPr>
+        <p:txBody>
+          <a:bodyPr wrap="none">
+            <a:spAutoFit/>
+          </a:bodyPr>
+          <a:lstStyle/>
+          <a:p>
+            <a:pPr algn="l"/>
+            <a:r>
+              <a:rPr sz="1000" b="0" i="1">
+                <a:solidFill>
+                  <a:srgbClr val="888888"/>
+                </a:solidFill>
+                <a:latin typeface="Calibri"/>
+              </a:rPr>
+              <a:t>Projection, not a guarantee. Amounts estimated from SSLC QuickBooks (10/11/2026) and the 08-2024 share register.</a:t>
+            </a:r>
+          </a:p>
+        </p:txBody>
+      </p:sp>
+      <p:sp>
+        <p:nvSpPr>
+          <p:cNvPr id="67" name="TextBox 66"/>
+          <p:cNvSpPr txBox="1"/>
+          <p:nvPr/>
+        </p:nvSpPr>
+        <p:spPr>
+          <a:xfrm>
+            <a:off x="3200400" y="4910328"/>
+            <a:ext cx="2743200" cy="201168"/>
+          </a:xfrm>
+          <a:prstGeom prst="rect">
+            <a:avLst/>
+          </a:prstGeom>
+          <a:noFill/>
+        </p:spPr>
+        <p:txBody>
+          <a:bodyPr wrap="none">
+            <a:spAutoFit/>
+          </a:bodyPr>
+          <a:lstStyle/>
+          <a:p>
+            <a:pPr algn="ctr"/>
+            <a:r>
+              <a:rPr sz="1000" b="0" i="0">
+                <a:solidFill>
+                  <a:srgbClr val="888888"/>
+                </a:solidFill>
+                <a:latin typeface="Calibri"/>
+              </a:rPr>
+              <a:t>DRAFT — NEGOTIATING TERMS</a:t>
+            </a:r>
+          </a:p>
+        </p:txBody>
+      </p:sp>
+      <p:sp>
+        <p:nvSpPr>
+          <p:cNvPr id="68" name="TextBox 67"/>
+          <p:cNvSpPr txBox="1"/>
+          <p:nvPr/>
+        </p:nvSpPr>
+        <p:spPr>
+          <a:xfrm>
+            <a:off x="7863840" y="4910328"/>
+            <a:ext cx="1188720" cy="201168"/>
+          </a:xfrm>
+          <a:prstGeom prst="rect">
+            <a:avLst/>
+          </a:prstGeom>
+          <a:noFill/>
+        </p:spPr>
+        <p:txBody>
+          <a:bodyPr wrap="none">
+            <a:spAutoFit/>
+          </a:bodyPr>
+          <a:lstStyle/>
+          <a:p>
+            <a:pPr algn="r"/>
+            <a:r>
+              <a:rPr sz="1000" b="0" i="0">
+                <a:solidFill>
+                  <a:srgbClr val="888888"/>
+                </a:solidFill>
+                <a:latin typeface="Calibri"/>
+              </a:rPr>
+              <a:t>CONFIDENTIAL</a:t>
+            </a:r>
+          </a:p>
+        </p:txBody>
+      </p:sp>
+    </p:spTree>
+  </p:cSld>
+  <p:clrMapOvr>
+    <a:masterClrMapping/>
+  </p:clrMapOvr>
+</p:sld>
+</file>
+
 <file path=ppt/slides/slide2.xml><?xml version="1.0" encoding="utf-8"?>
 <p:sld xmlns:a="http://schemas.openxmlformats.org/drawingml/2006/main" xmlns:r="http://schemas.openxmlformats.org/officeDocument/2006/relationships" xmlns:p="http://schemas.openxmlformats.org/presentationml/2006/main">
   <p:cSld name="Slide 2">

</xml_diff>

<commit_message>
SSLC slide 6: QA fixes — fraction glyph + High column wrap
- Header: '1⁄82' glyph → plain '1/82'
- High column: moved to x=4.43, w=0.60", word_wrap=False
  (right edge 5.03" clears divider at 5.05")
- Rebuild PDF (16pp) + board package (24pp)
- MC #2414 v23/v18/v13
</commit_message>
<xml_diff>
--- a/drafts/Exos_SSLC_Board_Offer_Overview_2026-10-10_r2.pptx
+++ b/drafts/Exos_SSLC_Board_Offer_Overview_2026-10-10_r2.pptx
@@ -16644,7 +16644,7 @@
                 </a:solidFill>
                 <a:latin typeface="Calibri"/>
               </a:rPr>
-              <a:t>Value per 1% of SSLC  (= 8,725 shares; 1⁄82 of non-Exos pool)</a:t>
+              <a:t>Value per 1% of SSLC  (= 8,725 shares; 1/82 of non-Exos pool)</a:t>
             </a:r>
           </a:p>
         </p:txBody>
@@ -16762,8 +16762,8 @@
         </p:nvSpPr>
         <p:spPr>
           <a:xfrm>
-            <a:off x="4133087" y="795528"/>
-            <a:ext cx="658368" cy="182880"/>
+            <a:off x="4050791" y="795528"/>
+            <a:ext cx="548640" cy="182880"/>
           </a:xfrm>
           <a:prstGeom prst="rect">
             <a:avLst/>
@@ -16945,8 +16945,8 @@
         </p:nvSpPr>
         <p:spPr>
           <a:xfrm>
-            <a:off x="4133087" y="1005840"/>
-            <a:ext cx="658368" cy="246888"/>
+            <a:off x="4050791" y="1005840"/>
+            <a:ext cx="548640" cy="246888"/>
           </a:xfrm>
           <a:prstGeom prst="rect">
             <a:avLst/>
@@ -17085,8 +17085,8 @@
         </p:nvSpPr>
         <p:spPr>
           <a:xfrm>
-            <a:off x="4133087" y="1252728"/>
-            <a:ext cx="658368" cy="246888"/>
+            <a:off x="4050791" y="1252728"/>
+            <a:ext cx="548640" cy="246888"/>
           </a:xfrm>
           <a:prstGeom prst="rect">
             <a:avLst/>
@@ -17225,8 +17225,8 @@
         </p:nvSpPr>
         <p:spPr>
           <a:xfrm>
-            <a:off x="4133087" y="1499616"/>
-            <a:ext cx="658368" cy="246888"/>
+            <a:off x="4050791" y="1499616"/>
+            <a:ext cx="548640" cy="246888"/>
           </a:xfrm>
           <a:prstGeom prst="rect">
             <a:avLst/>
@@ -17365,8 +17365,8 @@
         </p:nvSpPr>
         <p:spPr>
           <a:xfrm>
-            <a:off x="4133087" y="1746504"/>
-            <a:ext cx="658368" cy="246888"/>
+            <a:off x="4050791" y="1746504"/>
+            <a:ext cx="548640" cy="246888"/>
           </a:xfrm>
           <a:prstGeom prst="rect">
             <a:avLst/>

</xml_diff>

<commit_message>
SSLC batch 6: K 1480-account disclosure + Step 3 + Q14
Slide 5:
- $812,699: rewritten — Workman's Comp acct (1480), not shown as
  receivable; netted 6/30/2025 (JEs #25925/#25926); reclassified
  4/30/2026 to 1481 which now shows $0
- Right panel Exos bullet: adds Microcosm 2026 repayment contrast
  (Microcosm repaid $154K within months; Exos $31K past due)
- Step 3 added: full $812K undocumented => $1.26M; non-Wertz ~$585K;
  Conger ~$129K; Rufer ~$160K

Slide 6:
- Impact band Step 3: Per 1% -$15.4K; Conger -$128.7K

Diligence DOCX+PDF:
- Q14 added: 1480 account rationale, 2019-23 transfers, JE approvals

Rebuild: 16pp deck, 24pp package
MC #2414 v24/v19/v14 + diligence v1
</commit_message>
<xml_diff>
--- a/drafts/Exos_SSLC_Board_Offer_Overview_2026-10-10_r2.pptx
+++ b/drafts/Exos_SSLC_Board_Offer_Overview_2026-10-10_r2.pptx
@@ -15315,57 +15315,64 @@
           <a:noFill/>
         </p:spPr>
         <p:txBody>
+          <a:bodyPr wrap="none">
+            <a:spAutoFit/>
+          </a:bodyPr>
+          <a:lstStyle/>
+          <a:p>
+            <a:r>
+              <a:rPr lang="en-US" b="1" sz="1000">
+                <a:solidFill>
+                  <a:srgbClr val="FFFFFF"/>
+                </a:solidFill>
+                <a:latin typeface="Calibri"/>
+              </a:rPr>
+              <a:t>Carried in Workman's Comp acct (1480); not shown as a receivable</a:t>
+            </a:r>
+          </a:p>
+        </p:txBody>
+      </p:sp>
+      <p:sp>
+        <p:nvSpPr>
+          <p:cNvPr id="17" name="TextBox 16"/>
+          <p:cNvSpPr txBox="1"/>
+          <p:nvPr/>
+        </p:nvSpPr>
+        <p:spPr>
+          <a:xfrm>
+            <a:off x="1152144" y="1947672"/>
+            <a:ext cx="3246120" cy="534924"/>
+          </a:xfrm>
+          <a:prstGeom prst="rect">
+            <a:avLst/>
+          </a:prstGeom>
+          <a:noFill/>
+        </p:spPr>
+        <p:txBody>
           <a:bodyPr wrap="square">
             <a:spAutoFit/>
           </a:bodyPr>
           <a:lstStyle/>
           <a:p>
-            <a:pPr algn="l"/>
-            <a:r>
-              <a:rPr sz="1000" b="1" i="0">
-                <a:solidFill>
-                  <a:srgbClr val="FFFFFF"/>
-                </a:solidFill>
-                <a:latin typeface="Calibri"/>
-              </a:rPr>
-              <a:t>SSLC loans to Microcosm fully netted against:</a:t>
-            </a:r>
-          </a:p>
-        </p:txBody>
-      </p:sp>
-      <p:sp>
-        <p:nvSpPr>
-          <p:cNvPr id="17" name="TextBox 16"/>
-          <p:cNvSpPr txBox="1"/>
-          <p:nvPr/>
-        </p:nvSpPr>
-        <p:spPr>
-          <a:xfrm>
-            <a:off x="1152144" y="1947672"/>
-            <a:ext cx="3246120" cy="534924"/>
-          </a:xfrm>
-          <a:prstGeom prst="rect">
-            <a:avLst/>
-          </a:prstGeom>
-          <a:noFill/>
-        </p:spPr>
-        <p:txBody>
-          <a:bodyPr wrap="square">
-            <a:spAutoFit/>
-          </a:bodyPr>
-          <a:lstStyle/>
-          <a:p>
-            <a:pPr algn="l"/>
-            <a:r>
-              <a:rPr sz="1000" b="0" i="1">
+            <a:r>
+              <a:rPr lang="en-US" i="1" sz="1000">
                 <a:solidFill>
                   <a:srgbClr val="CCCCCC"/>
                 </a:solidFill>
                 <a:latin typeface="Calibri"/>
               </a:rPr>
-              <a:t>$294,499 loan payable  ·  $423,965 “reimbursables”
-$61,290 “Judy’s time”  ·  $32,946 reimbursable  =  $518,201
-No invoices or agreements provided for these offsets</a:t>
+              <a:t>Netted 6/30/2025 (JEs #25925/#25926): $294,499 pre-2024 loan payable + $518,201 with no invoices</a:t>
+            </a:r>
+          </a:p>
+          <a:p>
+            <a:r>
+              <a:rPr lang="en-US" i="1" sz="1000">
+                <a:solidFill>
+                  <a:srgbClr val="CCCCCC"/>
+                </a:solidFill>
+                <a:latin typeface="Calibri"/>
+              </a:rPr>
+              <a:t>Reclassified 4/30/2026 to acct 1481 (‘Loan to Microcosm’); account now shows $0</a:t>
             </a:r>
           </a:p>
         </p:txBody>
@@ -15917,28 +15924,27 @@
         <p:spPr>
           <a:xfrm>
             <a:off x="4892040" y="2560320"/>
-            <a:ext cx="4023360" cy="384048"/>
-          </a:xfrm>
-          <a:prstGeom prst="rect">
-            <a:avLst/>
-          </a:prstGeom>
-          <a:noFill/>
-        </p:spPr>
-        <p:txBody>
-          <a:bodyPr wrap="square">
+            <a:ext cx="4023360" cy="530352"/>
+          </a:xfrm>
+          <a:prstGeom prst="rect">
+            <a:avLst/>
+          </a:prstGeom>
+          <a:noFill/>
+        </p:spPr>
+        <p:txBody>
+          <a:bodyPr wrap="none">
             <a:spAutoFit/>
           </a:bodyPr>
           <a:lstStyle/>
           <a:p>
-            <a:pPr algn="l"/>
-            <a:r>
-              <a:rPr sz="1000" b="0" i="0">
+            <a:r>
+              <a:rPr lang="en-US" sz="1000">
                 <a:solidFill>
                   <a:srgbClr val="FFFFFF"/>
                 </a:solidFill>
                 <a:latin typeface="Calibri"/>
               </a:rPr>
-              <a:t>Insider interest was capitalized while the one outside lender, Exos, went unpaid.</a:t>
+              <a:t>Insider interest was capitalized while Exos, the one outside lender, went unpaid — Microcosm’s 2026 short-term loans ($150K) were repaid within months; Exos’s $31K loan remains past due.</a:t>
             </a:r>
           </a:p>
         </p:txBody>
@@ -15951,7 +15957,7 @@
         </p:nvSpPr>
         <p:spPr>
           <a:xfrm>
-            <a:off x="4736592" y="3044951"/>
+            <a:off x="4736592" y="3145536"/>
             <a:ext cx="4160520" cy="365760"/>
           </a:xfrm>
           <a:prstGeom prst="rect">
@@ -16107,7 +16113,7 @@
         </p:nvSpPr>
         <p:spPr>
           <a:xfrm>
-            <a:off x="256032" y="3758183"/>
+            <a:off x="256032" y="3739896"/>
             <a:ext cx="8631936" cy="201168"/>
           </a:xfrm>
           <a:prstGeom prst="rect">
@@ -16142,7 +16148,7 @@
         </p:nvSpPr>
         <p:spPr>
           <a:xfrm>
-            <a:off x="256032" y="3977639"/>
+            <a:off x="256032" y="3931920"/>
             <a:ext cx="3749039" cy="201168"/>
           </a:xfrm>
           <a:prstGeom prst="rect">
@@ -16177,7 +16183,7 @@
         </p:nvSpPr>
         <p:spPr>
           <a:xfrm>
-            <a:off x="4069080" y="3977639"/>
+            <a:off x="4069080" y="3931920"/>
             <a:ext cx="4818888" cy="201168"/>
           </a:xfrm>
           <a:prstGeom prst="rect">
@@ -16212,29 +16218,28 @@
         </p:nvSpPr>
         <p:spPr>
           <a:xfrm>
-            <a:off x="256032" y="4197096"/>
-            <a:ext cx="8631936" cy="402336"/>
-          </a:xfrm>
-          <a:prstGeom prst="rect">
-            <a:avLst/>
-          </a:prstGeom>
-          <a:noFill/>
-        </p:spPr>
-        <p:txBody>
-          <a:bodyPr wrap="square">
+            <a:off x="256032" y="4123944"/>
+            <a:ext cx="3749039" cy="182880"/>
+          </a:xfrm>
+          <a:prstGeom prst="rect">
+            <a:avLst/>
+          </a:prstGeom>
+          <a:noFill/>
+        </p:spPr>
+        <p:txBody>
+          <a:bodyPr wrap="none">
             <a:spAutoFit/>
           </a:bodyPr>
           <a:lstStyle/>
           <a:p>
-            <a:pPr algn="l"/>
-            <a:r>
-              <a:rPr sz="1000" b="1" i="0">
-                <a:solidFill>
-                  <a:srgbClr val="FFCC44"/>
-                </a:solidFill>
-                <a:latin typeface="Calibri"/>
-              </a:rPr>
-              <a:t>Step 2  —  + Unsupported offsets if unresolved:    $967K total  ·  Non-Wertz holders lose ~$449K  (Conger ~$99K, Rufer ~$123K)  ·  Microcosm would owe SSLC</a:t>
+            <a:r>
+              <a:rPr lang="en-US" sz="1000">
+                <a:solidFill>
+                  <a:srgbClr val="FFFFFF"/>
+                </a:solidFill>
+                <a:latin typeface="Calibri"/>
+              </a:rPr>
+              <a:t>Step 2  —  + Unsupported offsets ($967K total):</a:t>
             </a:r>
           </a:p>
         </p:txBody>
@@ -16247,7 +16252,7 @@
         </p:nvSpPr>
         <p:spPr>
           <a:xfrm>
-            <a:off x="256032" y="4626864"/>
+            <a:off x="256032" y="4517136"/>
             <a:ext cx="8631936" cy="265176"/>
           </a:xfrm>
           <a:prstGeom prst="rect">
@@ -16292,7 +16297,7 @@
         </p:nvSpPr>
         <p:spPr>
           <a:xfrm>
-            <a:off x="457200" y="4672583"/>
+            <a:off x="457200" y="4562856"/>
             <a:ext cx="8229600" cy="182880"/>
           </a:xfrm>
           <a:prstGeom prst="rect">
@@ -16385,6 +16390,108 @@
                 <a:latin typeface="Calibri"/>
               </a:rPr>
               <a:t>CONFIDENTIAL</a:t>
+            </a:r>
+          </a:p>
+        </p:txBody>
+      </p:sp>
+      <p:sp>
+        <p:nvSpPr>
+          <p:cNvPr id="45" name="TextBox 44"/>
+          <p:cNvSpPr txBox="1"/>
+          <p:nvPr/>
+        </p:nvSpPr>
+        <p:spPr>
+          <a:xfrm>
+            <a:off x="4069080" y="4123944"/>
+            <a:ext cx="4818888" cy="182880"/>
+          </a:xfrm>
+          <a:prstGeom prst="rect">
+            <a:avLst/>
+          </a:prstGeom>
+          <a:noFill/>
+        </p:spPr>
+        <p:txBody>
+          <a:bodyPr wrap="none">
+            <a:spAutoFit/>
+          </a:bodyPr>
+          <a:lstStyle/>
+          <a:p>
+            <a:r>
+              <a:rPr lang="en-US" b="1" sz="1000">
+                <a:solidFill>
+                  <a:srgbClr val="FFCC44"/>
+                </a:solidFill>
+                <a:latin typeface="Calibri"/>
+              </a:rPr>
+              <a:t>Non-Wertz lose ~$449K  ·  Conger ~$99K  ·  Rufer ~$123K  ·  Microcosm would owe SSLC</a:t>
+            </a:r>
+          </a:p>
+        </p:txBody>
+      </p:sp>
+      <p:sp>
+        <p:nvSpPr>
+          <p:cNvPr id="46" name="TextBox 45"/>
+          <p:cNvSpPr txBox="1"/>
+          <p:nvPr/>
+        </p:nvSpPr>
+        <p:spPr>
+          <a:xfrm>
+            <a:off x="256032" y="4315968"/>
+            <a:ext cx="3749039" cy="182880"/>
+          </a:xfrm>
+          <a:prstGeom prst="rect">
+            <a:avLst/>
+          </a:prstGeom>
+          <a:noFill/>
+        </p:spPr>
+        <p:txBody>
+          <a:bodyPr wrap="none">
+            <a:spAutoFit/>
+          </a:bodyPr>
+          <a:lstStyle/>
+          <a:p>
+            <a:r>
+              <a:rPr lang="en-US" sz="1000">
+                <a:solidFill>
+                  <a:srgbClr val="FFFFFF"/>
+                </a:solidFill>
+                <a:latin typeface="Calibri"/>
+              </a:rPr>
+              <a:t>Step 3  —  Full $812K Microcosm loan undocumented ($1.26M):</a:t>
+            </a:r>
+          </a:p>
+        </p:txBody>
+      </p:sp>
+      <p:sp>
+        <p:nvSpPr>
+          <p:cNvPr id="47" name="TextBox 46"/>
+          <p:cNvSpPr txBox="1"/>
+          <p:nvPr/>
+        </p:nvSpPr>
+        <p:spPr>
+          <a:xfrm>
+            <a:off x="4069080" y="4315968"/>
+            <a:ext cx="4818888" cy="182880"/>
+          </a:xfrm>
+          <a:prstGeom prst="rect">
+            <a:avLst/>
+          </a:prstGeom>
+          <a:noFill/>
+        </p:spPr>
+        <p:txBody>
+          <a:bodyPr wrap="none">
+            <a:spAutoFit/>
+          </a:bodyPr>
+          <a:lstStyle/>
+          <a:p>
+            <a:r>
+              <a:rPr lang="en-US" b="1" sz="1000">
+                <a:solidFill>
+                  <a:srgbClr val="DD4444"/>
+                </a:solidFill>
+                <a:latin typeface="Calibri"/>
+              </a:rPr>
+              <a:t>Non-Wertz lose ~$585K  ·  Conger ~$129K  ·  Rufer ~$160K</a:t>
             </a:r>
           </a:p>
         </p:txBody>
@@ -17857,7 +17964,7 @@
         <p:spPr>
           <a:xfrm>
             <a:off x="0" y="2596896"/>
-            <a:ext cx="9144000" cy="877824"/>
+            <a:ext cx="9144000" cy="932688"/>
           </a:xfrm>
           <a:prstGeom prst="rect">
             <a:avLst/>
@@ -18837,6 +18944,142 @@
                 <a:latin typeface="Calibri"/>
               </a:rPr>
               <a:t>CONFIDENTIAL</a:t>
+            </a:r>
+          </a:p>
+        </p:txBody>
+      </p:sp>
+      <p:sp>
+        <p:nvSpPr>
+          <p:cNvPr id="69" name="TextBox 68"/>
+          <p:cNvSpPr txBox="1"/>
+          <p:nvPr/>
+        </p:nvSpPr>
+        <p:spPr>
+          <a:xfrm>
+            <a:off x="256032" y="3310128"/>
+            <a:ext cx="4754880" cy="201168"/>
+          </a:xfrm>
+          <a:prstGeom prst="rect">
+            <a:avLst/>
+          </a:prstGeom>
+          <a:noFill/>
+        </p:spPr>
+        <p:txBody>
+          <a:bodyPr wrap="none">
+            <a:spAutoFit/>
+          </a:bodyPr>
+          <a:lstStyle/>
+          <a:p>
+            <a:r>
+              <a:rPr lang="en-US" sz="1000">
+                <a:solidFill>
+                  <a:srgbClr val="CCCCCC"/>
+                </a:solidFill>
+                <a:latin typeface="Calibri"/>
+              </a:rPr>
+              <a:t>Step 3  —  If full $812K Microcosm loan undocumented ($1.26M total):</a:t>
+            </a:r>
+          </a:p>
+        </p:txBody>
+      </p:sp>
+      <p:sp>
+        <p:nvSpPr>
+          <p:cNvPr id="70" name="TextBox 69"/>
+          <p:cNvSpPr txBox="1"/>
+          <p:nvPr/>
+        </p:nvSpPr>
+        <p:spPr>
+          <a:xfrm>
+            <a:off x="5074920" y="3310128"/>
+            <a:ext cx="1645920" cy="201168"/>
+          </a:xfrm>
+          <a:prstGeom prst="rect">
+            <a:avLst/>
+          </a:prstGeom>
+          <a:noFill/>
+        </p:spPr>
+        <p:txBody>
+          <a:bodyPr wrap="none">
+            <a:spAutoFit/>
+          </a:bodyPr>
+          <a:lstStyle/>
+          <a:p>
+            <a:r>
+              <a:rPr lang="en-US" b="1" sz="1000">
+                <a:solidFill>
+                  <a:srgbClr val="DD4444"/>
+                </a:solidFill>
+                <a:latin typeface="Calibri"/>
+              </a:rPr>
+              <a:t>Per 1%: −$15.4K</a:t>
+            </a:r>
+          </a:p>
+        </p:txBody>
+      </p:sp>
+      <p:sp>
+        <p:nvSpPr>
+          <p:cNvPr id="71" name="TextBox 70"/>
+          <p:cNvSpPr txBox="1"/>
+          <p:nvPr/>
+        </p:nvSpPr>
+        <p:spPr>
+          <a:xfrm>
+            <a:off x="6748272" y="3310128"/>
+            <a:ext cx="164592" cy="201168"/>
+          </a:xfrm>
+          <a:prstGeom prst="rect">
+            <a:avLst/>
+          </a:prstGeom>
+          <a:noFill/>
+        </p:spPr>
+        <p:txBody>
+          <a:bodyPr wrap="none">
+            <a:spAutoFit/>
+          </a:bodyPr>
+          <a:lstStyle/>
+          <a:p>
+            <a:r>
+              <a:rPr lang="en-US" sz="1000">
+                <a:solidFill>
+                  <a:srgbClr val="CCCCCC"/>
+                </a:solidFill>
+                <a:latin typeface="Calibri"/>
+              </a:rPr>
+              <a:t>|</a:t>
+            </a:r>
+          </a:p>
+        </p:txBody>
+      </p:sp>
+      <p:sp>
+        <p:nvSpPr>
+          <p:cNvPr id="72" name="TextBox 71"/>
+          <p:cNvSpPr txBox="1"/>
+          <p:nvPr/>
+        </p:nvSpPr>
+        <p:spPr>
+          <a:xfrm>
+            <a:off x="6931152" y="3310128"/>
+            <a:ext cx="1920240" cy="201168"/>
+          </a:xfrm>
+          <a:prstGeom prst="rect">
+            <a:avLst/>
+          </a:prstGeom>
+          <a:noFill/>
+        </p:spPr>
+        <p:txBody>
+          <a:bodyPr wrap="none">
+            <a:spAutoFit/>
+          </a:bodyPr>
+          <a:lstStyle/>
+          <a:p>
+            <a:r>
+              <a:rPr lang="en-US" b="1" sz="1000">
+                <a:solidFill>
+                  <a:srgbClr val="DD4444"/>
+                </a:solidFill>
+                <a:latin typeface="Calibri"/>
+              </a:rPr>
+              <a:t>Conger: −$128.7K</a:t>
             </a:r>
           </a:p>
         </p:txBody>

</xml_diff>

<commit_message>
SSLC slide 5 QA: fix $812K heading overlap
- TB15 heading: 'Loans to Microcosm, booked in workers'-comp acct 1480'
  (single line, 53 chars)
- TB16 italic detail: 3 short paragraphs (<=47 chars each):
  'Not a receivable. Netted 6/30/2025 (#25925-26):'
  '$294,499 loan payable + $518,201 no invoices'
  'Reclassified to acct 1481 on 4/30/2026; now $0'
- Rectangle 17 / TB18 / TB19 nudged down to y=2.85/3.07 for clearance
- Rebuild PDF (16pp) + package (24pp)
- MC #2414 v25/v20/v15
</commit_message>
<xml_diff>
--- a/drafts/Exos_SSLC_Board_Offer_Overview_2026-10-10_r2.pptx
+++ b/drafts/Exos_SSLC_Board_Offer_Overview_2026-10-10_r2.pptx
@@ -15327,7 +15327,7 @@
                 </a:solidFill>
                 <a:latin typeface="Calibri"/>
               </a:rPr>
-              <a:t>Carried in Workman's Comp acct (1480); not shown as a receivable</a:t>
+              <a:t>Loans to Microcosm, booked in workers’-comp acct 1480</a:t>
             </a:r>
           </a:p>
         </p:txBody>
@@ -15341,15 +15341,15 @@
         <p:spPr>
           <a:xfrm>
             <a:off x="1152144" y="1947672"/>
-            <a:ext cx="3246120" cy="534924"/>
-          </a:xfrm>
-          <a:prstGeom prst="rect">
-            <a:avLst/>
-          </a:prstGeom>
-          <a:noFill/>
-        </p:spPr>
-        <p:txBody>
-          <a:bodyPr wrap="square">
+            <a:ext cx="3246120" cy="594360"/>
+          </a:xfrm>
+          <a:prstGeom prst="rect">
+            <a:avLst/>
+          </a:prstGeom>
+          <a:noFill/>
+        </p:spPr>
+        <p:txBody>
+          <a:bodyPr wrap="none">
             <a:spAutoFit/>
           </a:bodyPr>
           <a:lstStyle/>
@@ -15361,7 +15361,7 @@
                 </a:solidFill>
                 <a:latin typeface="Calibri"/>
               </a:rPr>
-              <a:t>Netted 6/30/2025 (JEs #25925/#25926): $294,499 pre-2024 loan payable + $518,201 with no invoices</a:t>
+              <a:t>Not a receivable. Netted 6/30/2025 (#25925-26):</a:t>
             </a:r>
           </a:p>
           <a:p>
@@ -15372,7 +15372,18 @@
                 </a:solidFill>
                 <a:latin typeface="Calibri"/>
               </a:rPr>
-              <a:t>Reclassified 4/30/2026 to acct 1481 (‘Loan to Microcosm’); account now shows $0</a:t>
+              <a:t>$294,499 loan payable + $518,201 no invoices</a:t>
+            </a:r>
+          </a:p>
+          <a:p>
+            <a:r>
+              <a:rPr lang="en-US" i="1" sz="1000">
+                <a:solidFill>
+                  <a:srgbClr val="CCCCCC"/>
+                </a:solidFill>
+                <a:latin typeface="Calibri"/>
+              </a:rPr>
+              <a:t>Reclassified to acct 1481 on 4/30/2026; now $0</a:t>
             </a:r>
           </a:p>
         </p:txBody>
@@ -15385,7 +15396,7 @@
         </p:nvSpPr>
         <p:spPr>
           <a:xfrm>
-            <a:off x="256032" y="2574036"/>
+            <a:off x="256032" y="2606040"/>
             <a:ext cx="50292" cy="182880"/>
           </a:xfrm>
           <a:prstGeom prst="rect">
@@ -15428,7 +15439,7 @@
         </p:nvSpPr>
         <p:spPr>
           <a:xfrm>
-            <a:off x="365760" y="2574036"/>
+            <a:off x="365760" y="2606040"/>
             <a:ext cx="4023360" cy="182880"/>
           </a:xfrm>
           <a:prstGeom prst="rect">
@@ -15463,7 +15474,7 @@
         </p:nvSpPr>
         <p:spPr>
           <a:xfrm>
-            <a:off x="1152144" y="2775204"/>
+            <a:off x="1152144" y="2807208"/>
             <a:ext cx="3246120" cy="178308"/>
           </a:xfrm>
           <a:prstGeom prst="rect">

</xml_diff>

<commit_message>
SSLC slide 2: normalize motion-summary box formatting
- Motion 1 body: sz 10pt -> 12pt (matched Motions 2-4)
- Motion 5: split from single white 10pt run into orange bold
  'Motion 5:' label + 12pt LGR body run (matching others)
- Removed 5 stray a:pPr elements from para 0 (malformed XML)
- All-slides scan: no other textboxes had run-size inconsistencies
- Rebuild PDF (16pp) + package (24pp); MC #2414 v26/v21/v16
</commit_message>
<xml_diff>
--- a/drafts/Exos_SSLC_Board_Offer_Overview_2026-10-10_r2.pptx
+++ b/drafts/Exos_SSLC_Board_Offer_Overview_2026-10-10_r2.pptx
@@ -11058,11 +11058,8 @@
               </a:rPr>
               <a:t>Motion 1: </a:t>
             </a:r>
-            <a:pPr indent="0" marL="0">
-              <a:buNone/>
-            </a:pPr>
-            <a:r>
-              <a:rPr lang="en-US" sz="1000" dirty="0">
+            <a:r>
+              <a:rPr lang="en-US" sz="1200" dirty="0">
                 <a:solidFill>
                   <a:srgbClr val="CCCCCC"/>
                 </a:solidFill>
@@ -11070,9 +11067,6 @@
               <a:t>Approve Exos offer (Option B) + §3 exclusivity (90-day) + ROFR on asset sale
 </a:t>
             </a:r>
-            <a:pPr indent="0" marL="0">
-              <a:buNone/>
-            </a:pPr>
             <a:r>
               <a:rPr lang="en-US" sz="1200" b="1" dirty="0">
                 <a:solidFill>
@@ -11081,9 +11075,6 @@
               </a:rPr>
               <a:t>Motion 2: </a:t>
             </a:r>
-            <a:pPr indent="0" marL="0">
-              <a:buNone/>
-            </a:pPr>
             <a:r>
               <a:rPr lang="en-US" sz="1200" dirty="0">
                 <a:solidFill>
@@ -11093,9 +11084,6 @@
               <a:t>Full read-only QB Online access for diligence (Cal. Corp. Code §1602 + AAA §4; under 7/27/2021 NDA)
 </a:t>
             </a:r>
-            <a:pPr indent="0" marL="0">
-              <a:buNone/>
-            </a:pPr>
             <a:r>
               <a:rPr lang="en-US" sz="1200" b="1" dirty="0">
                 <a:solidFill>
@@ -11121,9 +11109,6 @@
               </a:rPr>
               <a:t>Motion 4: </a:t>
             </a:r>
-            <a:pPr indent="0" marL="0">
-              <a:buNone/>
-            </a:pPr>
             <a:r>
               <a:rPr lang="en-US" sz="1200" dirty="0">
                 <a:solidFill>
@@ -11136,13 +11121,20 @@
           </a:p>
           <a:p>
             <a:r>
-              <a:rPr lang="en-US" sz="1000">
-                <a:solidFill>
-                  <a:srgbClr val="FFFFFF"/>
-                </a:solidFill>
-                <a:latin typeface="Calibri"/>
-              </a:rPr>
-              <a:t>Motion 5: Resolve related-party balances (4/30/2026 entries) — independent accountant; Microcosm/Wertz directors abstain</a:t>
+              <a:rPr lang="en-US" sz="1200" dirty="0" b="1">
+                <a:solidFill>
+                  <a:srgbClr val="F26A21"/>
+                </a:solidFill>
+              </a:rPr>
+              <a:t>Motion 5: </a:t>
+            </a:r>
+            <a:r>
+              <a:rPr lang="en-US" sz="1200" dirty="0">
+                <a:solidFill>
+                  <a:srgbClr val="CCCCCC"/>
+                </a:solidFill>
+              </a:rPr>
+              <a:t>Resolve related-party balances (4/30/2026 entries) — independent accountant; Microcosm/Wertz directors abstain</a:t>
             </a:r>
           </a:p>
         </p:txBody>

</xml_diff>

<commit_message>
SSLC Batch 7 fix: bump sub-10pt fonts to 10pt on new slides 5-6
</commit_message>
<xml_diff>
--- a/drafts/Exos_SSLC_Board_Offer_Overview_2026-10-10_r2.pptx
+++ b/drafts/Exos_SSLC_Board_Offer_Overview_2026-10-10_r2.pptx
@@ -19839,7 +19839,7 @@
           <a:lstStyle/>
           <a:p>
             <a:r>
-              <a:rPr lang="en-US" sz="900" dirty="0" b="1">
+              <a:rPr lang="en-US" sz="1000" dirty="0" b="1">
                 <a:solidFill>
                   <a:srgbClr val="F26A21"/>
                 </a:solidFill>
@@ -19873,7 +19873,7 @@
           <a:lstStyle/>
           <a:p>
             <a:r>
-              <a:rPr lang="en-US" sz="900" dirty="0">
+              <a:rPr lang="en-US" sz="1000" dirty="0">
                 <a:solidFill>
                   <a:srgbClr val="888888"/>
                 </a:solidFill>
@@ -19907,7 +19907,7 @@
           <a:lstStyle/>
           <a:p>
             <a:r>
-              <a:rPr lang="en-US" sz="900" dirty="0" b="1">
+              <a:rPr lang="en-US" sz="1000" dirty="0" b="1">
                 <a:solidFill>
                   <a:srgbClr val="F26A21"/>
                 </a:solidFill>
@@ -19941,7 +19941,7 @@
           <a:lstStyle/>
           <a:p>
             <a:r>
-              <a:rPr lang="en-US" sz="900" dirty="0" b="1">
+              <a:rPr lang="en-US" sz="1000" dirty="0" b="1">
                 <a:solidFill>
                   <a:srgbClr val="F26A21"/>
                 </a:solidFill>
@@ -19976,7 +19976,7 @@
           <a:lstStyle/>
           <a:p>
             <a:r>
-              <a:rPr lang="en-US" sz="900" dirty="0" b="1">
+              <a:rPr lang="en-US" sz="1000" dirty="0" b="1">
                 <a:solidFill>
                   <a:srgbClr val="F26A21"/>
                 </a:solidFill>
@@ -20011,7 +20011,7 @@
           <a:lstStyle/>
           <a:p>
             <a:r>
-              <a:rPr lang="en-US" sz="900" dirty="0" b="1">
+              <a:rPr lang="en-US" sz="1000" dirty="0" b="1">
                 <a:solidFill>
                   <a:srgbClr val="F26A21"/>
                 </a:solidFill>
@@ -20046,7 +20046,7 @@
           <a:lstStyle/>
           <a:p>
             <a:r>
-              <a:rPr lang="en-US" sz="900" dirty="0" b="1">
+              <a:rPr lang="en-US" sz="1000" dirty="0" b="1">
                 <a:solidFill>
                   <a:srgbClr val="F26A21"/>
                 </a:solidFill>
@@ -20123,7 +20123,7 @@
           <a:lstStyle/>
           <a:p>
             <a:r>
-              <a:rPr lang="en-US" sz="900" dirty="0">
+              <a:rPr lang="en-US" sz="1000" dirty="0">
                 <a:solidFill>
                   <a:srgbClr val="CCCCCC"/>
                 </a:solidFill>
@@ -20157,7 +20157,7 @@
           <a:lstStyle/>
           <a:p>
             <a:r>
-              <a:rPr lang="en-US" sz="900" dirty="0">
+              <a:rPr lang="en-US" sz="1000" dirty="0">
                 <a:solidFill>
                   <a:srgbClr val="CCCCCC"/>
                 </a:solidFill>
@@ -20191,7 +20191,7 @@
           <a:lstStyle/>
           <a:p>
             <a:r>
-              <a:rPr lang="en-US" sz="900" dirty="0">
+              <a:rPr lang="en-US" sz="1000" dirty="0">
                 <a:solidFill>
                   <a:srgbClr val="CCCCCC"/>
                 </a:solidFill>
@@ -20225,7 +20225,7 @@
           <a:lstStyle/>
           <a:p>
             <a:r>
-              <a:rPr lang="en-US" sz="900" dirty="0">
+              <a:rPr lang="en-US" sz="1000" dirty="0">
                 <a:solidFill>
                   <a:srgbClr val="44BB44"/>
                 </a:solidFill>
@@ -20259,7 +20259,7 @@
           <a:lstStyle/>
           <a:p>
             <a:r>
-              <a:rPr lang="en-US" sz="900" dirty="0">
+              <a:rPr lang="en-US" sz="1000" dirty="0">
                 <a:solidFill>
                   <a:srgbClr val="CCCCCC"/>
                 </a:solidFill>
@@ -20293,7 +20293,7 @@
           <a:lstStyle/>
           <a:p>
             <a:r>
-              <a:rPr lang="en-US" sz="700" dirty="0" b="1">
+              <a:rPr lang="en-US" sz="1000" dirty="0" b="1">
                 <a:solidFill>
                   <a:srgbClr val="F26A21"/>
                 </a:solidFill>
@@ -20327,7 +20327,7 @@
           <a:lstStyle/>
           <a:p>
             <a:r>
-              <a:rPr lang="en-US" sz="900" dirty="0">
+              <a:rPr lang="en-US" sz="1000" dirty="0">
                 <a:solidFill>
                   <a:srgbClr val="FFFFFF"/>
                 </a:solidFill>
@@ -20361,7 +20361,7 @@
           <a:lstStyle/>
           <a:p>
             <a:r>
-              <a:rPr lang="en-US" sz="900" dirty="0">
+              <a:rPr lang="en-US" sz="1000" dirty="0">
                 <a:solidFill>
                   <a:srgbClr val="FFFFFF"/>
                 </a:solidFill>
@@ -20395,7 +20395,7 @@
           <a:lstStyle/>
           <a:p>
             <a:r>
-              <a:rPr lang="en-US" sz="900" dirty="0">
+              <a:rPr lang="en-US" sz="1000" dirty="0">
                 <a:solidFill>
                   <a:srgbClr val="FFFFFF"/>
                 </a:solidFill>
@@ -20429,7 +20429,7 @@
           <a:lstStyle/>
           <a:p>
             <a:r>
-              <a:rPr lang="en-US" sz="900" dirty="0">
+              <a:rPr lang="en-US" sz="1000" dirty="0">
                 <a:solidFill>
                   <a:srgbClr val="44BB44"/>
                 </a:solidFill>
@@ -20463,7 +20463,7 @@
           <a:lstStyle/>
           <a:p>
             <a:r>
-              <a:rPr lang="en-US" sz="900" dirty="0">
+              <a:rPr lang="en-US" sz="1000" dirty="0">
                 <a:solidFill>
                   <a:srgbClr val="FFFFFF"/>
                 </a:solidFill>
@@ -20497,7 +20497,7 @@
           <a:lstStyle/>
           <a:p>
             <a:r>
-              <a:rPr lang="en-US" sz="700" dirty="0" b="1">
+              <a:rPr lang="en-US" sz="1000" dirty="0" b="1">
                 <a:solidFill>
                   <a:srgbClr val="F26A21"/>
                 </a:solidFill>
@@ -20531,7 +20531,7 @@
           <a:lstStyle/>
           <a:p>
             <a:r>
-              <a:rPr lang="en-US" sz="900" dirty="0">
+              <a:rPr lang="en-US" sz="1000" dirty="0">
                 <a:solidFill>
                   <a:srgbClr val="FFFFFF"/>
                 </a:solidFill>
@@ -20565,7 +20565,7 @@
           <a:lstStyle/>
           <a:p>
             <a:r>
-              <a:rPr lang="en-US" sz="900" dirty="0">
+              <a:rPr lang="en-US" sz="1000" dirty="0">
                 <a:solidFill>
                   <a:srgbClr val="FFFFFF"/>
                 </a:solidFill>
@@ -20599,7 +20599,7 @@
           <a:lstStyle/>
           <a:p>
             <a:r>
-              <a:rPr lang="en-US" sz="900" dirty="0">
+              <a:rPr lang="en-US" sz="1000" dirty="0">
                 <a:solidFill>
                   <a:srgbClr val="FFFFFF"/>
                 </a:solidFill>
@@ -20633,7 +20633,7 @@
           <a:lstStyle/>
           <a:p>
             <a:r>
-              <a:rPr lang="en-US" sz="900" dirty="0">
+              <a:rPr lang="en-US" sz="1000" dirty="0">
                 <a:solidFill>
                   <a:srgbClr val="44BB44"/>
                 </a:solidFill>
@@ -20667,7 +20667,7 @@
           <a:lstStyle/>
           <a:p>
             <a:r>
-              <a:rPr lang="en-US" sz="900" dirty="0">
+              <a:rPr lang="en-US" sz="1000" dirty="0">
                 <a:solidFill>
                   <a:srgbClr val="FFFFFF"/>
                 </a:solidFill>
@@ -20701,7 +20701,7 @@
           <a:lstStyle/>
           <a:p>
             <a:r>
-              <a:rPr lang="en-US" sz="700" dirty="0" b="1">
+              <a:rPr lang="en-US" sz="1000" dirty="0" b="1">
                 <a:solidFill>
                   <a:srgbClr val="F26A21"/>
                 </a:solidFill>
@@ -20735,7 +20735,7 @@
           <a:lstStyle/>
           <a:p>
             <a:r>
-              <a:rPr lang="en-US" sz="900" dirty="0">
+              <a:rPr lang="en-US" sz="1000" dirty="0">
                 <a:solidFill>
                   <a:srgbClr val="CCCCCC"/>
                 </a:solidFill>
@@ -20769,7 +20769,7 @@
           <a:lstStyle/>
           <a:p>
             <a:r>
-              <a:rPr lang="en-US" sz="900" dirty="0">
+              <a:rPr lang="en-US" sz="1000" dirty="0">
                 <a:solidFill>
                   <a:srgbClr val="CCCCCC"/>
                 </a:solidFill>
@@ -20803,7 +20803,7 @@
           <a:lstStyle/>
           <a:p>
             <a:r>
-              <a:rPr lang="en-US" sz="900" dirty="0">
+              <a:rPr lang="en-US" sz="1000" dirty="0">
                 <a:solidFill>
                   <a:srgbClr val="CCCCCC"/>
                 </a:solidFill>
@@ -20837,7 +20837,7 @@
           <a:lstStyle/>
           <a:p>
             <a:r>
-              <a:rPr lang="en-US" sz="900" dirty="0">
+              <a:rPr lang="en-US" sz="1000" dirty="0">
                 <a:solidFill>
                   <a:srgbClr val="FFCC44"/>
                 </a:solidFill>
@@ -20871,7 +20871,7 @@
           <a:lstStyle/>
           <a:p>
             <a:r>
-              <a:rPr lang="en-US" sz="900" dirty="0">
+              <a:rPr lang="en-US" sz="1000" dirty="0">
                 <a:solidFill>
                   <a:srgbClr val="CCCCCC"/>
                 </a:solidFill>
@@ -20905,7 +20905,7 @@
           <a:lstStyle/>
           <a:p>
             <a:r>
-              <a:rPr lang="en-US" sz="700" dirty="0" b="1">
+              <a:rPr lang="en-US" sz="1000" dirty="0" b="1">
                 <a:solidFill>
                   <a:srgbClr val="F26A21"/>
                 </a:solidFill>
@@ -20939,7 +20939,7 @@
           <a:lstStyle/>
           <a:p>
             <a:r>
-              <a:rPr lang="en-US" sz="900" dirty="0">
+              <a:rPr lang="en-US" sz="1000" dirty="0">
                 <a:solidFill>
                   <a:srgbClr val="CCCCCC"/>
                 </a:solidFill>
@@ -20973,7 +20973,7 @@
           <a:lstStyle/>
           <a:p>
             <a:r>
-              <a:rPr lang="en-US" sz="900" dirty="0">
+              <a:rPr lang="en-US" sz="1000" dirty="0">
                 <a:solidFill>
                   <a:srgbClr val="CCCCCC"/>
                 </a:solidFill>
@@ -21007,7 +21007,7 @@
           <a:lstStyle/>
           <a:p>
             <a:r>
-              <a:rPr lang="en-US" sz="900" dirty="0">
+              <a:rPr lang="en-US" sz="1000" dirty="0">
                 <a:solidFill>
                   <a:srgbClr val="CCCCCC"/>
                 </a:solidFill>
@@ -21041,7 +21041,7 @@
           <a:lstStyle/>
           <a:p>
             <a:r>
-              <a:rPr lang="en-US" sz="900" dirty="0">
+              <a:rPr lang="en-US" sz="1000" dirty="0">
                 <a:solidFill>
                   <a:srgbClr val="FFCC44"/>
                 </a:solidFill>
@@ -21075,7 +21075,7 @@
           <a:lstStyle/>
           <a:p>
             <a:r>
-              <a:rPr lang="en-US" sz="900" dirty="0">
+              <a:rPr lang="en-US" sz="1000" dirty="0">
                 <a:solidFill>
                   <a:srgbClr val="CCCCCC"/>
                 </a:solidFill>
@@ -21109,7 +21109,7 @@
           <a:lstStyle/>
           <a:p>
             <a:r>
-              <a:rPr lang="en-US" sz="900" dirty="0">
+              <a:rPr lang="en-US" sz="1000" dirty="0">
                 <a:solidFill>
                   <a:srgbClr val="888888"/>
                 </a:solidFill>
@@ -21143,7 +21143,7 @@
           <a:lstStyle/>
           <a:p>
             <a:r>
-              <a:rPr lang="en-US" sz="900" dirty="0">
+              <a:rPr lang="en-US" sz="1000" dirty="0">
                 <a:solidFill>
                   <a:srgbClr val="888888"/>
                 </a:solidFill>
@@ -21177,7 +21177,7 @@
           <a:lstStyle/>
           <a:p>
             <a:r>
-              <a:rPr lang="en-US" sz="900" dirty="0">
+              <a:rPr lang="en-US" sz="1000" dirty="0">
                 <a:solidFill>
                   <a:srgbClr val="888888"/>
                 </a:solidFill>
@@ -21211,7 +21211,7 @@
           <a:lstStyle/>
           <a:p>
             <a:r>
-              <a:rPr lang="en-US" sz="900" dirty="0">
+              <a:rPr lang="en-US" sz="1000" dirty="0">
                 <a:solidFill>
                   <a:srgbClr val="888888"/>
                 </a:solidFill>
@@ -21245,7 +21245,7 @@
           <a:lstStyle/>
           <a:p>
             <a:r>
-              <a:rPr lang="en-US" sz="900" dirty="0">
+              <a:rPr lang="en-US" sz="1000" dirty="0">
                 <a:solidFill>
                   <a:srgbClr val="888888"/>
                 </a:solidFill>
@@ -21279,7 +21279,7 @@
           <a:lstStyle/>
           <a:p>
             <a:r>
-              <a:rPr lang="en-US" sz="900" dirty="0">
+              <a:rPr lang="en-US" sz="1000" dirty="0">
                 <a:solidFill>
                   <a:srgbClr val="888888"/>
                 </a:solidFill>
@@ -21313,7 +21313,7 @@
           <a:lstStyle/>
           <a:p>
             <a:r>
-              <a:rPr lang="en-US" sz="900" dirty="0">
+              <a:rPr lang="en-US" sz="1000" dirty="0">
                 <a:solidFill>
                   <a:srgbClr val="888888"/>
                 </a:solidFill>
@@ -21347,7 +21347,7 @@
           <a:lstStyle/>
           <a:p>
             <a:r>
-              <a:rPr lang="en-US" sz="900" dirty="0">
+              <a:rPr lang="en-US" sz="1000" dirty="0">
                 <a:solidFill>
                   <a:srgbClr val="888888"/>
                 </a:solidFill>
@@ -21381,7 +21381,7 @@
           <a:lstStyle/>
           <a:p>
             <a:r>
-              <a:rPr lang="en-US" sz="900" dirty="0">
+              <a:rPr lang="en-US" sz="1000" dirty="0">
                 <a:solidFill>
                   <a:srgbClr val="888888"/>
                 </a:solidFill>
@@ -21415,7 +21415,7 @@
           <a:lstStyle/>
           <a:p>
             <a:r>
-              <a:rPr lang="en-US" sz="900" dirty="0">
+              <a:rPr lang="en-US" sz="1000" dirty="0">
                 <a:solidFill>
                   <a:srgbClr val="888888"/>
                 </a:solidFill>
@@ -21492,7 +21492,7 @@
           <a:lstStyle/>
           <a:p>
             <a:r>
-              <a:rPr lang="en-US" sz="900" dirty="0" b="1">
+              <a:rPr lang="en-US" sz="1000" dirty="0" b="1">
                 <a:solidFill>
                   <a:srgbClr val="CCCCCC"/>
                 </a:solidFill>
@@ -21560,7 +21560,7 @@
           <a:lstStyle/>
           <a:p>
             <a:r>
-              <a:rPr lang="en-US" sz="900" dirty="0">
+              <a:rPr lang="en-US" sz="1000" dirty="0">
                 <a:solidFill>
                   <a:srgbClr val="CCCCCC"/>
                 </a:solidFill>
@@ -21594,7 +21594,7 @@
           <a:lstStyle/>
           <a:p>
             <a:r>
-              <a:rPr lang="en-US" sz="900" dirty="0" b="1">
+              <a:rPr lang="en-US" sz="1000" dirty="0" b="1">
                 <a:solidFill>
                   <a:srgbClr val="F26A21"/>
                 </a:solidFill>
@@ -21628,7 +21628,7 @@
           <a:lstStyle/>
           <a:p>
             <a:r>
-              <a:rPr lang="en-US" sz="900" dirty="0">
+              <a:rPr lang="en-US" sz="1000" dirty="0">
                 <a:solidFill>
                   <a:srgbClr val="CCCCCC"/>
                 </a:solidFill>
@@ -21662,7 +21662,7 @@
           <a:lstStyle/>
           <a:p>
             <a:r>
-              <a:rPr lang="en-US" sz="900" dirty="0" b="1">
+              <a:rPr lang="en-US" sz="1000" dirty="0" b="1">
                 <a:solidFill>
                   <a:srgbClr val="F26A21"/>
                 </a:solidFill>
@@ -21696,7 +21696,7 @@
           <a:lstStyle/>
           <a:p>
             <a:r>
-              <a:rPr lang="en-US" sz="900" dirty="0">
+              <a:rPr lang="en-US" sz="1000" dirty="0">
                 <a:solidFill>
                   <a:srgbClr val="CCCCCC"/>
                 </a:solidFill>
@@ -21730,7 +21730,7 @@
           <a:lstStyle/>
           <a:p>
             <a:r>
-              <a:rPr lang="en-US" sz="900" dirty="0" b="1">
+              <a:rPr lang="en-US" sz="1000" dirty="0" b="1">
                 <a:solidFill>
                   <a:srgbClr val="44BB44"/>
                 </a:solidFill>
@@ -21764,7 +21764,7 @@
           <a:lstStyle/>
           <a:p>
             <a:r>
-              <a:rPr lang="en-US" sz="800" dirty="0" i="1">
+              <a:rPr lang="en-US" sz="1000" dirty="0" i="1">
                 <a:solidFill>
                   <a:srgbClr val="888888"/>
                 </a:solidFill>
@@ -22507,7 +22507,7 @@
           <a:lstStyle/>
           <a:p>
             <a:r>
-              <a:rPr lang="en-US" sz="900" dirty="0" b="1">
+              <a:rPr lang="en-US" sz="1000" dirty="0" b="1">
                 <a:solidFill>
                   <a:srgbClr val="F26A21"/>
                 </a:solidFill>
@@ -22541,7 +22541,7 @@
           <a:lstStyle/>
           <a:p>
             <a:r>
-              <a:rPr lang="en-US" sz="900" dirty="0">
+              <a:rPr lang="en-US" sz="1000" dirty="0">
                 <a:solidFill>
                   <a:srgbClr val="888888"/>
                 </a:solidFill>
@@ -22575,7 +22575,7 @@
           <a:lstStyle/>
           <a:p>
             <a:r>
-              <a:rPr lang="en-US" sz="900" dirty="0" i="1">
+              <a:rPr lang="en-US" sz="1000" dirty="0" i="1">
                 <a:solidFill>
                   <a:srgbClr val="888888"/>
                 </a:solidFill>
@@ -22686,7 +22686,7 @@
           <a:lstStyle/>
           <a:p>
             <a:r>
-              <a:rPr lang="en-US" sz="900" dirty="0">
+              <a:rPr lang="en-US" sz="1000" dirty="0">
                 <a:solidFill>
                   <a:srgbClr val="DD4444"/>
                 </a:solidFill>
@@ -22720,7 +22720,7 @@
           <a:lstStyle/>
           <a:p>
             <a:r>
-              <a:rPr lang="en-US" sz="900" dirty="0">
+              <a:rPr lang="en-US" sz="1000" dirty="0">
                 <a:solidFill>
                   <a:srgbClr val="DD4444"/>
                 </a:solidFill>
@@ -22789,7 +22789,7 @@
           <a:lstStyle/>
           <a:p>
             <a:r>
-              <a:rPr lang="en-US" sz="900" dirty="0">
+              <a:rPr lang="en-US" sz="1000" dirty="0">
                 <a:solidFill>
                   <a:srgbClr val="F26A21"/>
                 </a:solidFill>
@@ -22857,7 +22857,7 @@
           <a:lstStyle/>
           <a:p>
             <a:r>
-              <a:rPr lang="en-US" sz="900" dirty="0">
+              <a:rPr lang="en-US" sz="1000" dirty="0">
                 <a:solidFill>
                   <a:srgbClr val="CCCCCC"/>
                 </a:solidFill>
@@ -22891,7 +22891,7 @@
           <a:lstStyle/>
           <a:p>
             <a:r>
-              <a:rPr lang="en-US" sz="900" dirty="0">
+              <a:rPr lang="en-US" sz="1000" dirty="0">
                 <a:solidFill>
                   <a:srgbClr val="F26A21"/>
                 </a:solidFill>
@@ -22925,7 +22925,7 @@
           <a:lstStyle/>
           <a:p>
             <a:r>
-              <a:rPr lang="en-US" sz="900" dirty="0">
+              <a:rPr lang="en-US" sz="1000" dirty="0">
                 <a:solidFill>
                   <a:srgbClr val="CCCCCC"/>
                 </a:solidFill>
@@ -22959,7 +22959,7 @@
           <a:lstStyle/>
           <a:p>
             <a:r>
-              <a:rPr lang="en-US" sz="900" dirty="0">
+              <a:rPr lang="en-US" sz="1000" dirty="0">
                 <a:solidFill>
                   <a:srgbClr val="F26A21"/>
                 </a:solidFill>
@@ -22993,7 +22993,7 @@
           <a:lstStyle/>
           <a:p>
             <a:r>
-              <a:rPr lang="en-US" sz="900" dirty="0">
+              <a:rPr lang="en-US" sz="1000" dirty="0">
                 <a:solidFill>
                   <a:srgbClr val="CCCCCC"/>
                 </a:solidFill>
@@ -23027,7 +23027,7 @@
           <a:lstStyle/>
           <a:p>
             <a:r>
-              <a:rPr lang="en-US" sz="900" dirty="0">
+              <a:rPr lang="en-US" sz="1000" dirty="0">
                 <a:solidFill>
                   <a:srgbClr val="F26A21"/>
                 </a:solidFill>
@@ -23061,7 +23061,7 @@
           <a:lstStyle/>
           <a:p>
             <a:r>
-              <a:rPr lang="en-US" sz="900" dirty="0" b="1">
+              <a:rPr lang="en-US" sz="1000" dirty="0" b="1">
                 <a:solidFill>
                   <a:srgbClr val="FFFFFF"/>
                 </a:solidFill>
@@ -23095,7 +23095,7 @@
           <a:lstStyle/>
           <a:p>
             <a:r>
-              <a:rPr lang="en-US" sz="900" dirty="0" b="1">
+              <a:rPr lang="en-US" sz="1000" dirty="0" b="1">
                 <a:solidFill>
                   <a:srgbClr val="44BB44"/>
                 </a:solidFill>
@@ -23206,7 +23206,7 @@
           <a:lstStyle/>
           <a:p>
             <a:r>
-              <a:rPr lang="en-US" sz="900" dirty="0">
+              <a:rPr lang="en-US" sz="1000" dirty="0">
                 <a:solidFill>
                   <a:srgbClr val="CCCCCC"/>
                 </a:solidFill>
@@ -23240,7 +23240,7 @@
           <a:lstStyle/>
           <a:p>
             <a:r>
-              <a:rPr lang="en-US" sz="900" dirty="0">
+              <a:rPr lang="en-US" sz="1000" dirty="0">
                 <a:solidFill>
                   <a:srgbClr val="CCCCCC"/>
                 </a:solidFill>
@@ -23274,7 +23274,7 @@
           <a:lstStyle/>
           <a:p>
             <a:r>
-              <a:rPr lang="en-US" sz="900" dirty="0">
+              <a:rPr lang="en-US" sz="1000" dirty="0">
                 <a:solidFill>
                   <a:srgbClr val="CCCCCC"/>
                 </a:solidFill>
@@ -23308,7 +23308,7 @@
           <a:lstStyle/>
           <a:p>
             <a:r>
-              <a:rPr lang="en-US" sz="900" dirty="0">
+              <a:rPr lang="en-US" sz="1000" dirty="0">
                 <a:solidFill>
                   <a:srgbClr val="CCCCCC"/>
                 </a:solidFill>
@@ -23342,7 +23342,7 @@
           <a:lstStyle/>
           <a:p>
             <a:r>
-              <a:rPr lang="en-US" sz="900" dirty="0" b="1">
+              <a:rPr lang="en-US" sz="1000" dirty="0" b="1">
                 <a:solidFill>
                   <a:srgbClr val="CCCCCC"/>
                 </a:solidFill>
@@ -23376,7 +23376,7 @@
           <a:lstStyle/>
           <a:p>
             <a:r>
-              <a:rPr lang="en-US" sz="900" dirty="0" b="1">
+              <a:rPr lang="en-US" sz="1000" dirty="0" b="1">
                 <a:solidFill>
                   <a:srgbClr val="FFFFFF"/>
                 </a:solidFill>
@@ -23410,7 +23410,7 @@
           <a:lstStyle/>
           <a:p>
             <a:r>
-              <a:rPr lang="en-US" sz="900" dirty="0">
+              <a:rPr lang="en-US" sz="1000" dirty="0">
                 <a:solidFill>
                   <a:srgbClr val="CCCCCC"/>
                 </a:solidFill>
@@ -23444,7 +23444,7 @@
           <a:lstStyle/>
           <a:p>
             <a:r>
-              <a:rPr lang="en-US" sz="900" dirty="0">
+              <a:rPr lang="en-US" sz="1000" dirty="0">
                 <a:solidFill>
                   <a:srgbClr val="F26A21"/>
                 </a:solidFill>
@@ -23478,7 +23478,7 @@
           <a:lstStyle/>
           <a:p>
             <a:r>
-              <a:rPr lang="en-US" sz="900" dirty="0">
+              <a:rPr lang="en-US" sz="1000" dirty="0">
                 <a:solidFill>
                   <a:srgbClr val="CCCCCC"/>
                 </a:solidFill>
@@ -23512,7 +23512,7 @@
           <a:lstStyle/>
           <a:p>
             <a:r>
-              <a:rPr lang="en-US" sz="900" dirty="0">
+              <a:rPr lang="en-US" sz="1000" dirty="0">
                 <a:solidFill>
                   <a:srgbClr val="CCCCCC"/>
                 </a:solidFill>
@@ -23546,7 +23546,7 @@
           <a:lstStyle/>
           <a:p>
             <a:r>
-              <a:rPr lang="en-US" sz="900" dirty="0" b="1">
+              <a:rPr lang="en-US" sz="1000" dirty="0" b="1">
                 <a:solidFill>
                   <a:srgbClr val="CCCCCC"/>
                 </a:solidFill>
@@ -23580,7 +23580,7 @@
           <a:lstStyle/>
           <a:p>
             <a:r>
-              <a:rPr lang="en-US" sz="900" dirty="0" b="1">
+              <a:rPr lang="en-US" sz="1000" dirty="0" b="1">
                 <a:solidFill>
                   <a:srgbClr val="FFCC44"/>
                 </a:solidFill>
@@ -23614,7 +23614,7 @@
           <a:lstStyle/>
           <a:p>
             <a:r>
-              <a:rPr lang="en-US" sz="900" dirty="0" i="1">
+              <a:rPr lang="en-US" sz="1000" dirty="0" i="1">
                 <a:solidFill>
                   <a:srgbClr val="FFCC44"/>
                 </a:solidFill>
@@ -23734,7 +23734,7 @@
           <a:lstStyle/>
           <a:p>
             <a:r>
-              <a:rPr lang="en-US" sz="900" dirty="0" b="1">
+              <a:rPr lang="en-US" sz="1000" dirty="0" b="1">
                 <a:solidFill>
                   <a:srgbClr val="CCCCCC"/>
                 </a:solidFill>
@@ -23836,7 +23836,7 @@
           <a:lstStyle/>
           <a:p>
             <a:r>
-              <a:rPr lang="en-US" sz="900" dirty="0" b="1">
+              <a:rPr lang="en-US" sz="1000" dirty="0" b="1">
                 <a:solidFill>
                   <a:srgbClr val="F26A21"/>
                 </a:solidFill>
@@ -23870,7 +23870,7 @@
           <a:lstStyle/>
           <a:p>
             <a:r>
-              <a:rPr lang="en-US" sz="900" dirty="0" b="1">
+              <a:rPr lang="en-US" sz="1000" dirty="0" b="1">
                 <a:solidFill>
                   <a:srgbClr val="F26A21"/>
                 </a:solidFill>
@@ -23904,7 +23904,7 @@
           <a:lstStyle/>
           <a:p>
             <a:r>
-              <a:rPr lang="en-US" sz="900" dirty="0" b="1">
+              <a:rPr lang="en-US" sz="1000" dirty="0" b="1">
                 <a:solidFill>
                   <a:srgbClr val="F26A21"/>
                 </a:solidFill>
@@ -23938,7 +23938,7 @@
           <a:lstStyle/>
           <a:p>
             <a:r>
-              <a:rPr lang="en-US" sz="900" dirty="0" b="1">
+              <a:rPr lang="en-US" sz="1000" dirty="0" b="1">
                 <a:solidFill>
                   <a:srgbClr val="F26A21"/>
                 </a:solidFill>
@@ -23972,7 +23972,7 @@
           <a:lstStyle/>
           <a:p>
             <a:r>
-              <a:rPr lang="en-US" sz="900" dirty="0" b="1">
+              <a:rPr lang="en-US" sz="1000" dirty="0" b="1">
                 <a:solidFill>
                   <a:srgbClr val="F26A21"/>
                 </a:solidFill>
@@ -24006,7 +24006,7 @@
           <a:lstStyle/>
           <a:p>
             <a:r>
-              <a:rPr lang="en-US" sz="900" dirty="0" b="1">
+              <a:rPr lang="en-US" sz="1000" dirty="0" b="1">
                 <a:solidFill>
                   <a:srgbClr val="F26A21"/>
                 </a:solidFill>
@@ -24083,7 +24083,7 @@
           <a:lstStyle/>
           <a:p>
             <a:r>
-              <a:rPr lang="en-US" sz="900" dirty="0">
+              <a:rPr lang="en-US" sz="1000" dirty="0">
                 <a:solidFill>
                   <a:srgbClr val="CCCCCC"/>
                 </a:solidFill>
@@ -24117,7 +24117,7 @@
           <a:lstStyle/>
           <a:p>
             <a:r>
-              <a:rPr lang="en-US" sz="900" dirty="0">
+              <a:rPr lang="en-US" sz="1000" dirty="0">
                 <a:solidFill>
                   <a:srgbClr val="CCCCCC"/>
                 </a:solidFill>
@@ -24151,7 +24151,7 @@
           <a:lstStyle/>
           <a:p>
             <a:r>
-              <a:rPr lang="en-US" sz="900" dirty="0">
+              <a:rPr lang="en-US" sz="1000" dirty="0">
                 <a:solidFill>
                   <a:srgbClr val="CCCCCC"/>
                 </a:solidFill>
@@ -24185,7 +24185,7 @@
           <a:lstStyle/>
           <a:p>
             <a:r>
-              <a:rPr lang="en-US" sz="900" dirty="0">
+              <a:rPr lang="en-US" sz="1000" dirty="0">
                 <a:solidFill>
                   <a:srgbClr val="CCCCCC"/>
                 </a:solidFill>
@@ -24219,7 +24219,7 @@
           <a:lstStyle/>
           <a:p>
             <a:r>
-              <a:rPr lang="en-US" sz="900" dirty="0">
+              <a:rPr lang="en-US" sz="1000" dirty="0">
                 <a:solidFill>
                   <a:srgbClr val="CCCCCC"/>
                 </a:solidFill>
@@ -24253,7 +24253,7 @@
           <a:lstStyle/>
           <a:p>
             <a:r>
-              <a:rPr lang="en-US" sz="900" dirty="0">
+              <a:rPr lang="en-US" sz="1000" dirty="0">
                 <a:solidFill>
                   <a:srgbClr val="CCCCCC"/>
                 </a:solidFill>
@@ -24287,7 +24287,7 @@
           <a:lstStyle/>
           <a:p>
             <a:r>
-              <a:rPr lang="en-US" sz="900" dirty="0">
+              <a:rPr lang="en-US" sz="1000" dirty="0">
                 <a:solidFill>
                   <a:srgbClr val="CCCCCC"/>
                 </a:solidFill>
@@ -24321,7 +24321,7 @@
           <a:lstStyle/>
           <a:p>
             <a:r>
-              <a:rPr lang="en-US" sz="900" dirty="0">
+              <a:rPr lang="en-US" sz="1000" dirty="0">
                 <a:solidFill>
                   <a:srgbClr val="CCCCCC"/>
                 </a:solidFill>
@@ -24355,7 +24355,7 @@
           <a:lstStyle/>
           <a:p>
             <a:r>
-              <a:rPr lang="en-US" sz="900" dirty="0">
+              <a:rPr lang="en-US" sz="1000" dirty="0">
                 <a:solidFill>
                   <a:srgbClr val="CCCCCC"/>
                 </a:solidFill>
@@ -24389,7 +24389,7 @@
           <a:lstStyle/>
           <a:p>
             <a:r>
-              <a:rPr lang="en-US" sz="900" dirty="0">
+              <a:rPr lang="en-US" sz="1000" dirty="0">
                 <a:solidFill>
                   <a:srgbClr val="CCCCCC"/>
                 </a:solidFill>
@@ -24423,7 +24423,7 @@
           <a:lstStyle/>
           <a:p>
             <a:r>
-              <a:rPr lang="en-US" sz="900" dirty="0">
+              <a:rPr lang="en-US" sz="1000" dirty="0">
                 <a:solidFill>
                   <a:srgbClr val="CCCCCC"/>
                 </a:solidFill>
@@ -24457,7 +24457,7 @@
           <a:lstStyle/>
           <a:p>
             <a:r>
-              <a:rPr lang="en-US" sz="900" dirty="0">
+              <a:rPr lang="en-US" sz="1000" dirty="0">
                 <a:solidFill>
                   <a:srgbClr val="CCCCCC"/>
                 </a:solidFill>
@@ -24491,7 +24491,7 @@
           <a:lstStyle/>
           <a:p>
             <a:r>
-              <a:rPr lang="en-US" sz="900" dirty="0">
+              <a:rPr lang="en-US" sz="1000" dirty="0">
                 <a:solidFill>
                   <a:srgbClr val="DD4444"/>
                 </a:solidFill>
@@ -24525,7 +24525,7 @@
           <a:lstStyle/>
           <a:p>
             <a:r>
-              <a:rPr lang="en-US" sz="900" dirty="0">
+              <a:rPr lang="en-US" sz="1000" dirty="0">
                 <a:solidFill>
                   <a:srgbClr val="DD4444"/>
                 </a:solidFill>
@@ -24559,7 +24559,7 @@
           <a:lstStyle/>
           <a:p>
             <a:r>
-              <a:rPr lang="en-US" sz="900" dirty="0">
+              <a:rPr lang="en-US" sz="1000" dirty="0">
                 <a:solidFill>
                   <a:srgbClr val="DD4444"/>
                 </a:solidFill>
@@ -24593,7 +24593,7 @@
           <a:lstStyle/>
           <a:p>
             <a:r>
-              <a:rPr lang="en-US" sz="900" dirty="0">
+              <a:rPr lang="en-US" sz="1000" dirty="0">
                 <a:solidFill>
                   <a:srgbClr val="DD4444"/>
                 </a:solidFill>
@@ -24627,7 +24627,7 @@
           <a:lstStyle/>
           <a:p>
             <a:r>
-              <a:rPr lang="en-US" sz="900" dirty="0">
+              <a:rPr lang="en-US" sz="1000" dirty="0">
                 <a:solidFill>
                   <a:srgbClr val="DD4444"/>
                 </a:solidFill>
@@ -24661,7 +24661,7 @@
           <a:lstStyle/>
           <a:p>
             <a:r>
-              <a:rPr lang="en-US" sz="900" dirty="0">
+              <a:rPr lang="en-US" sz="1000" dirty="0">
                 <a:solidFill>
                   <a:srgbClr val="DD4444"/>
                 </a:solidFill>
@@ -24695,7 +24695,7 @@
           <a:lstStyle/>
           <a:p>
             <a:r>
-              <a:rPr lang="en-US" sz="900" dirty="0">
+              <a:rPr lang="en-US" sz="1000" dirty="0">
                 <a:solidFill>
                   <a:srgbClr val="DD4444"/>
                 </a:solidFill>
@@ -24729,7 +24729,7 @@
           <a:lstStyle/>
           <a:p>
             <a:r>
-              <a:rPr lang="en-US" sz="900" dirty="0">
+              <a:rPr lang="en-US" sz="1000" dirty="0">
                 <a:solidFill>
                   <a:srgbClr val="DD4444"/>
                 </a:solidFill>
@@ -24763,7 +24763,7 @@
           <a:lstStyle/>
           <a:p>
             <a:r>
-              <a:rPr lang="en-US" sz="900" dirty="0">
+              <a:rPr lang="en-US" sz="1000" dirty="0">
                 <a:solidFill>
                   <a:srgbClr val="DD4444"/>
                 </a:solidFill>
@@ -24797,7 +24797,7 @@
           <a:lstStyle/>
           <a:p>
             <a:r>
-              <a:rPr lang="en-US" sz="900" dirty="0">
+              <a:rPr lang="en-US" sz="1000" dirty="0">
                 <a:solidFill>
                   <a:srgbClr val="DD4444"/>
                 </a:solidFill>
@@ -24831,7 +24831,7 @@
           <a:lstStyle/>
           <a:p>
             <a:r>
-              <a:rPr lang="en-US" sz="900" dirty="0">
+              <a:rPr lang="en-US" sz="1000" dirty="0">
                 <a:solidFill>
                   <a:srgbClr val="DD4444"/>
                 </a:solidFill>
@@ -24865,7 +24865,7 @@
           <a:lstStyle/>
           <a:p>
             <a:r>
-              <a:rPr lang="en-US" sz="900" dirty="0">
+              <a:rPr lang="en-US" sz="1000" dirty="0">
                 <a:solidFill>
                   <a:srgbClr val="DD4444"/>
                 </a:solidFill>
@@ -24899,7 +24899,7 @@
           <a:lstStyle/>
           <a:p>
             <a:r>
-              <a:rPr lang="en-US" sz="900" dirty="0">
+              <a:rPr lang="en-US" sz="1000" dirty="0">
                 <a:solidFill>
                   <a:srgbClr val="CCCCCC"/>
                 </a:solidFill>
@@ -24933,7 +24933,7 @@
           <a:lstStyle/>
           <a:p>
             <a:r>
-              <a:rPr lang="en-US" sz="900" dirty="0">
+              <a:rPr lang="en-US" sz="1000" dirty="0">
                 <a:solidFill>
                   <a:srgbClr val="CCCCCC"/>
                 </a:solidFill>
@@ -24967,7 +24967,7 @@
           <a:lstStyle/>
           <a:p>
             <a:r>
-              <a:rPr lang="en-US" sz="900" dirty="0">
+              <a:rPr lang="en-US" sz="1000" dirty="0">
                 <a:solidFill>
                   <a:srgbClr val="CCCCCC"/>
                 </a:solidFill>
@@ -25001,7 +25001,7 @@
           <a:lstStyle/>
           <a:p>
             <a:r>
-              <a:rPr lang="en-US" sz="900" dirty="0">
+              <a:rPr lang="en-US" sz="1000" dirty="0">
                 <a:solidFill>
                   <a:srgbClr val="CCCCCC"/>
                 </a:solidFill>
@@ -25035,7 +25035,7 @@
           <a:lstStyle/>
           <a:p>
             <a:r>
-              <a:rPr lang="en-US" sz="900" dirty="0">
+              <a:rPr lang="en-US" sz="1000" dirty="0">
                 <a:solidFill>
                   <a:srgbClr val="CCCCCC"/>
                 </a:solidFill>
@@ -25069,7 +25069,7 @@
           <a:lstStyle/>
           <a:p>
             <a:r>
-              <a:rPr lang="en-US" sz="900" dirty="0">
+              <a:rPr lang="en-US" sz="1000" dirty="0">
                 <a:solidFill>
                   <a:srgbClr val="CCCCCC"/>
                 </a:solidFill>
@@ -25103,7 +25103,7 @@
           <a:lstStyle/>
           <a:p>
             <a:r>
-              <a:rPr lang="en-US" sz="900" dirty="0">
+              <a:rPr lang="en-US" sz="1000" dirty="0">
                 <a:solidFill>
                   <a:srgbClr val="CCCCCC"/>
                 </a:solidFill>
@@ -25137,7 +25137,7 @@
           <a:lstStyle/>
           <a:p>
             <a:r>
-              <a:rPr lang="en-US" sz="900" dirty="0">
+              <a:rPr lang="en-US" sz="1000" dirty="0">
                 <a:solidFill>
                   <a:srgbClr val="CCCCCC"/>
                 </a:solidFill>
@@ -25171,7 +25171,7 @@
           <a:lstStyle/>
           <a:p>
             <a:r>
-              <a:rPr lang="en-US" sz="900" dirty="0">
+              <a:rPr lang="en-US" sz="1000" dirty="0">
                 <a:solidFill>
                   <a:srgbClr val="CCCCCC"/>
                 </a:solidFill>
@@ -25205,7 +25205,7 @@
           <a:lstStyle/>
           <a:p>
             <a:r>
-              <a:rPr lang="en-US" sz="900" dirty="0">
+              <a:rPr lang="en-US" sz="1000" dirty="0">
                 <a:solidFill>
                   <a:srgbClr val="CCCCCC"/>
                 </a:solidFill>
@@ -25239,7 +25239,7 @@
           <a:lstStyle/>
           <a:p>
             <a:r>
-              <a:rPr lang="en-US" sz="900" dirty="0">
+              <a:rPr lang="en-US" sz="1000" dirty="0">
                 <a:solidFill>
                   <a:srgbClr val="CCCCCC"/>
                 </a:solidFill>
@@ -25273,7 +25273,7 @@
           <a:lstStyle/>
           <a:p>
             <a:r>
-              <a:rPr lang="en-US" sz="900" dirty="0">
+              <a:rPr lang="en-US" sz="1000" dirty="0">
                 <a:solidFill>
                   <a:srgbClr val="CCCCCC"/>
                 </a:solidFill>
@@ -25307,7 +25307,7 @@
           <a:lstStyle/>
           <a:p>
             <a:r>
-              <a:rPr lang="en-US" sz="900" dirty="0" b="1">
+              <a:rPr lang="en-US" sz="1000" dirty="0" b="1">
                 <a:solidFill>
                   <a:srgbClr val="FFFFFF"/>
                 </a:solidFill>
@@ -25341,7 +25341,7 @@
           <a:lstStyle/>
           <a:p>
             <a:r>
-              <a:rPr lang="en-US" sz="900" dirty="0" b="1">
+              <a:rPr lang="en-US" sz="1000" dirty="0" b="1">
                 <a:solidFill>
                   <a:srgbClr val="FFFFFF"/>
                 </a:solidFill>
@@ -25375,7 +25375,7 @@
           <a:lstStyle/>
           <a:p>
             <a:r>
-              <a:rPr lang="en-US" sz="900" dirty="0" b="1">
+              <a:rPr lang="en-US" sz="1000" dirty="0" b="1">
                 <a:solidFill>
                   <a:srgbClr val="FFFFFF"/>
                 </a:solidFill>
@@ -25409,7 +25409,7 @@
           <a:lstStyle/>
           <a:p>
             <a:r>
-              <a:rPr lang="en-US" sz="900" dirty="0" b="1">
+              <a:rPr lang="en-US" sz="1000" dirty="0" b="1">
                 <a:solidFill>
                   <a:srgbClr val="FFFFFF"/>
                 </a:solidFill>
@@ -25443,7 +25443,7 @@
           <a:lstStyle/>
           <a:p>
             <a:r>
-              <a:rPr lang="en-US" sz="900" dirty="0" b="1">
+              <a:rPr lang="en-US" sz="1000" dirty="0" b="1">
                 <a:solidFill>
                   <a:srgbClr val="FFFFFF"/>
                 </a:solidFill>
@@ -25477,7 +25477,7 @@
           <a:lstStyle/>
           <a:p>
             <a:r>
-              <a:rPr lang="en-US" sz="900" dirty="0" b="1">
+              <a:rPr lang="en-US" sz="1000" dirty="0" b="1">
                 <a:solidFill>
                   <a:srgbClr val="F26A21"/>
                 </a:solidFill>
@@ -25554,7 +25554,7 @@
           <a:lstStyle/>
           <a:p>
             <a:r>
-              <a:rPr lang="en-US" sz="900" dirty="0">
+              <a:rPr lang="en-US" sz="1000" dirty="0">
                 <a:solidFill>
                   <a:srgbClr val="CCCCCC"/>
                 </a:solidFill>
@@ -25588,7 +25588,7 @@
           <a:lstStyle/>
           <a:p>
             <a:r>
-              <a:rPr lang="en-US" sz="900" dirty="0">
+              <a:rPr lang="en-US" sz="1000" dirty="0">
                 <a:solidFill>
                   <a:srgbClr val="F26A21"/>
                 </a:solidFill>

</xml_diff>

<commit_message>
SSLC deck slide 5: fix step tags, Bookstore basis (no JE#), row label overlap
</commit_message>
<xml_diff>
--- a/drafts/Exos_SSLC_Board_Offer_Overview_2026-10-10_r2.pptx
+++ b/drafts/Exos_SSLC_Board_Offer_Overview_2026-10-10_r2.pptx
@@ -20299,7 +20299,7 @@
                 </a:solidFill>
                 <a:latin typeface="Calibri"/>
               </a:rPr>
-              <a:t>S1</a:t>
+              <a:t>M3</a:t>
             </a:r>
           </a:p>
         </p:txBody>
@@ -20537,7 +20537,7 @@
                 </a:solidFill>
                 <a:latin typeface="Calibri"/>
               </a:rPr>
-              <a:t>2700 Notes Pay.–Bookstore</a:t>
+              <a:t>2700 Bookstore note</a:t>
             </a:r>
           </a:p>
         </p:txBody>
@@ -20673,7 +20673,7 @@
                 </a:solidFill>
                 <a:latin typeface="Calibri"/>
               </a:rPr>
-              <a:t>Interest capitalized 4/30/26 (JE #25926)</a:t>
+              <a:t>Interest capitalized 4/30/26; no approval</a:t>
             </a:r>
           </a:p>
         </p:txBody>
@@ -20707,7 +20707,7 @@
                 </a:solidFill>
                 <a:latin typeface="Calibri"/>
               </a:rPr>
-              <a:t>S2</a:t>
+              <a:t>S1</a:t>
             </a:r>
           </a:p>
         </p:txBody>
@@ -20741,7 +20741,7 @@
                 </a:solidFill>
                 <a:latin typeface="Calibri"/>
               </a:rPr>
-              <a:t>1480→1481 Loan to Microcosm</a:t>
+              <a:t>1481 Loan to Microcosm</a:t>
             </a:r>
           </a:p>
         </p:txBody>
@@ -20911,7 +20911,7 @@
                 </a:solidFill>
                 <a:latin typeface="Calibri"/>
               </a:rPr>
-              <a:t>S3</a:t>
+              <a:t>S2</a:t>
             </a:r>
           </a:p>
         </p:txBody>
@@ -20945,7 +20945,7 @@
                 </a:solidFill>
                 <a:latin typeface="Calibri"/>
               </a:rPr>
-              <a:t>2701 Microcosm payable (pre-2024)</a:t>
+              <a:t>2701 Microcosm loan (pre-24)</a:t>
             </a:r>
           </a:p>
         </p:txBody>
@@ -21081,7 +21081,7 @@
                 </a:solidFill>
                 <a:latin typeface="Calibri"/>
               </a:rPr>
-              <a:t>No note; no board approval (Mot. 5)</a:t>
+              <a:t>Support not provided (Q14; Motion 5)</a:t>
             </a:r>
           </a:p>
         </p:txBody>
@@ -22299,6 +22299,40 @@
                 <a:latin typeface="Calibri"/>
               </a:rPr>
               <a:t>$33.7K</a:t>
+            </a:r>
+          </a:p>
+        </p:txBody>
+      </p:sp>
+      <p:sp>
+        <p:nvSpPr>
+          <p:cNvPr id="37" name="TextBox 36"/>
+          <p:cNvSpPr txBox="1"/>
+          <p:nvPr/>
+        </p:nvSpPr>
+        <p:spPr>
+          <a:xfrm>
+            <a:off x="91440" y="1700784"/>
+            <a:ext cx="137160" cy="155448"/>
+          </a:xfrm>
+          <a:prstGeom prst="rect">
+            <a:avLst/>
+          </a:prstGeom>
+          <a:noFill/>
+        </p:spPr>
+        <p:txBody>
+          <a:bodyPr wrap="none" anchor="ctr">
+            <a:spAutoFit/>
+          </a:bodyPr>
+          <a:lstStyle/>
+          <a:p>
+            <a:r>
+              <a:rPr lang="en-US" sz="1000" dirty="0" b="1">
+                <a:solidFill>
+                  <a:srgbClr val="F26A21"/>
+                </a:solidFill>
+                <a:latin typeface="Calibri"/>
+              </a:rPr>
+              <a:t>S3</a:t>
             </a:r>
           </a:p>
         </p:txBody>

</xml_diff>